<commit_message>
Fix investor deck divisions map layout
</commit_message>
<xml_diff>
--- a/assets/investor-deck/Tecnotitan-Investor-Deck-EN.pptx
+++ b/assets/investor-deck/Tecnotitan-Investor-Deck-EN.pptx
@@ -2,24 +2,24 @@
 <file path=ppt/presentation.xml><?xml version="1.0" encoding="utf-8"?>
 <p:presentation xmlns:p="http://schemas.openxmlformats.org/presentationml/2006/main">
   <p:sldMasterIdLst>
-    <p:sldMasterId xmlns:r="http://schemas.openxmlformats.org/officeDocument/2006/relationships" id="2147483648" r:id="Rbdd6d436113945a2"/>
+    <p:sldMasterId xmlns:r="http://schemas.openxmlformats.org/officeDocument/2006/relationships" id="2147483648" r:id="R2a6b809ee72e4814"/>
   </p:sldMasterIdLst>
   <p:notesMasterIdLst>
-    <p:notesMasterId xmlns:r="http://schemas.openxmlformats.org/officeDocument/2006/relationships" r:id="Rcacff1833e0e443d"/>
+    <p:notesMasterId xmlns:r="http://schemas.openxmlformats.org/officeDocument/2006/relationships" r:id="R6f53c768487b4ecd"/>
   </p:notesMasterIdLst>
   <p:sldIdLst>
-    <p:sldId xmlns:r="http://schemas.openxmlformats.org/officeDocument/2006/relationships" id="256" r:id="R87b537811e85493e"/>
-    <p:sldId xmlns:r="http://schemas.openxmlformats.org/officeDocument/2006/relationships" id="257" r:id="R35d33728939e41ba"/>
-    <p:sldId xmlns:r="http://schemas.openxmlformats.org/officeDocument/2006/relationships" id="258" r:id="R49c8bd9dbb214047"/>
-    <p:sldId xmlns:r="http://schemas.openxmlformats.org/officeDocument/2006/relationships" id="259" r:id="R34674823bbde48cb"/>
-    <p:sldId xmlns:r="http://schemas.openxmlformats.org/officeDocument/2006/relationships" id="260" r:id="Rcd0dfc8e494f444f"/>
-    <p:sldId xmlns:r="http://schemas.openxmlformats.org/officeDocument/2006/relationships" id="261" r:id="Rce94a6eda16846fe"/>
-    <p:sldId xmlns:r="http://schemas.openxmlformats.org/officeDocument/2006/relationships" id="262" r:id="R37cd296c564b4e4b"/>
-    <p:sldId xmlns:r="http://schemas.openxmlformats.org/officeDocument/2006/relationships" id="263" r:id="R1de9d78a64b4413d"/>
-    <p:sldId xmlns:r="http://schemas.openxmlformats.org/officeDocument/2006/relationships" id="264" r:id="R04221b7c5ecb44ae"/>
-    <p:sldId xmlns:r="http://schemas.openxmlformats.org/officeDocument/2006/relationships" id="265" r:id="R68315b8be2314ee1"/>
-    <p:sldId xmlns:r="http://schemas.openxmlformats.org/officeDocument/2006/relationships" id="266" r:id="Rd3a90f6b6fb948b5"/>
-    <p:sldId xmlns:r="http://schemas.openxmlformats.org/officeDocument/2006/relationships" id="267" r:id="R35f98506fbff49ea"/>
+    <p:sldId xmlns:r="http://schemas.openxmlformats.org/officeDocument/2006/relationships" id="256" r:id="R1e5eb8ac9d374db3"/>
+    <p:sldId xmlns:r="http://schemas.openxmlformats.org/officeDocument/2006/relationships" id="257" r:id="R3473569a82ee49cb"/>
+    <p:sldId xmlns:r="http://schemas.openxmlformats.org/officeDocument/2006/relationships" id="258" r:id="Rfa5e722c78c24385"/>
+    <p:sldId xmlns:r="http://schemas.openxmlformats.org/officeDocument/2006/relationships" id="259" r:id="R9d56e134a94e48aa"/>
+    <p:sldId xmlns:r="http://schemas.openxmlformats.org/officeDocument/2006/relationships" id="260" r:id="Rdd49e76da49e4fc5"/>
+    <p:sldId xmlns:r="http://schemas.openxmlformats.org/officeDocument/2006/relationships" id="261" r:id="R173043de6261493a"/>
+    <p:sldId xmlns:r="http://schemas.openxmlformats.org/officeDocument/2006/relationships" id="262" r:id="R6aafbd7d787548bf"/>
+    <p:sldId xmlns:r="http://schemas.openxmlformats.org/officeDocument/2006/relationships" id="263" r:id="Rc5e9b651c8ee4154"/>
+    <p:sldId xmlns:r="http://schemas.openxmlformats.org/officeDocument/2006/relationships" id="264" r:id="R935675b77cca4cab"/>
+    <p:sldId xmlns:r="http://schemas.openxmlformats.org/officeDocument/2006/relationships" id="265" r:id="Rb0fc462c26b44c97"/>
+    <p:sldId xmlns:r="http://schemas.openxmlformats.org/officeDocument/2006/relationships" id="266" r:id="R1bf1d7e2ac6a47da"/>
+    <p:sldId xmlns:r="http://schemas.openxmlformats.org/officeDocument/2006/relationships" id="267" r:id="R08883149d52e42ed"/>
   </p:sldIdLst>
   <p:sldSz cx="12192000" cy="6858000"/>
   <p:notesSz cx="6858000" cy="9144000"/>
@@ -1292,7 +1292,7 @@
   </p:cSld>
   <p:clrMap bg1="lt1" tx1="dk1" bg2="lt2" tx2="dk2" accent1="accent1" accent2="accent2" accent3="accent3" accent4="accent4" accent5="accent5" accent6="accent6" hlink="hlink" folHlink="folHlink"/>
   <p:sldLayoutIdLst>
-    <p:sldLayoutId xmlns:r="http://schemas.openxmlformats.org/officeDocument/2006/relationships" id="2147483649" r:id="R3b3c8406578c43cb"/>
+    <p:sldLayoutId xmlns:r="http://schemas.openxmlformats.org/officeDocument/2006/relationships" id="2147483649" r:id="Rda9209cac3704cab"/>
   </p:sldLayoutIdLst>
   <p:txStyles>
     <p:titleStyle>
@@ -1794,7 +1794,7 @@
           <p:nvPr/>
         </p:nvPicPr>
         <p:blipFill>
-          <a:blip xmlns:r="http://schemas.openxmlformats.org/officeDocument/2006/relationships" xmlns:a="http://schemas.openxmlformats.org/drawingml/2006/main" r:embed="R9b22d8d7d9eb439f"/>
+          <a:blip xmlns:r="http://schemas.openxmlformats.org/officeDocument/2006/relationships" xmlns:a="http://schemas.openxmlformats.org/drawingml/2006/main" r:embed="Rfb936ced7a904376"/>
           <a:srcRect xmlns:a="http://schemas.openxmlformats.org/drawingml/2006/main" l="0" t="7813" r="0" b="7813"/>
           <a:stretch xmlns:a="http://schemas.openxmlformats.org/drawingml/2006/main">
             <a:fillRect l="0" t="0" r="0" b="0"/>
@@ -1815,7 +1815,7 @@
           <p:cNvPr id="2" name="">
             <a:extLst xmlns:a="http://schemas.openxmlformats.org/drawingml/2006/main">
               <a:ext uri="{FF2B5EF4-FFF2-40B4-BE49-F238E27FC236}">
-                <a16:creationId xmlns:a16="http://schemas.microsoft.com/office/drawing/2014/main" id="{876E603A-9D7E-4362-B42B-15BA5A5FF0D7}"/>
+                <a16:creationId xmlns:a16="http://schemas.microsoft.com/office/drawing/2014/main" id="{2F45C579-D5BF-4431-9739-D94694985F74}"/>
               </a:ext>
             </a:extLst>
           </p:cNvPr>
@@ -1852,7 +1852,7 @@
           <p:cNvPr id="3" name="">
             <a:extLst xmlns:a="http://schemas.openxmlformats.org/drawingml/2006/main">
               <a:ext uri="{FF2B5EF4-FFF2-40B4-BE49-F238E27FC236}">
-                <a16:creationId xmlns:a16="http://schemas.microsoft.com/office/drawing/2014/main" id="{E7A9C834-BEF5-47B2-9872-8C6A2446E758}"/>
+                <a16:creationId xmlns:a16="http://schemas.microsoft.com/office/drawing/2014/main" id="{29FD8FAB-3114-4F6A-A51A-4CAABEB511B6}"/>
               </a:ext>
             </a:extLst>
           </p:cNvPr>
@@ -1889,7 +1889,7 @@
           <p:cNvPr id="4" name="">
             <a:extLst xmlns:a="http://schemas.openxmlformats.org/drawingml/2006/main">
               <a:ext uri="{FF2B5EF4-FFF2-40B4-BE49-F238E27FC236}">
-                <a16:creationId xmlns:a16="http://schemas.microsoft.com/office/drawing/2014/main" id="{765D164B-CEBB-4D63-8179-F0D0D59C4C03}"/>
+                <a16:creationId xmlns:a16="http://schemas.microsoft.com/office/drawing/2014/main" id="{2F64F6B2-2F1B-434C-9499-DD180D3DD635}"/>
               </a:ext>
             </a:extLst>
           </p:cNvPr>
@@ -1953,7 +1953,7 @@
           <p:cNvPr id="5" name="">
             <a:extLst xmlns:a="http://schemas.openxmlformats.org/drawingml/2006/main">
               <a:ext uri="{FF2B5EF4-FFF2-40B4-BE49-F238E27FC236}">
-                <a16:creationId xmlns:a16="http://schemas.microsoft.com/office/drawing/2014/main" id="{7B7262C8-D4C0-49FF-A579-D71F6D61BDA3}"/>
+                <a16:creationId xmlns:a16="http://schemas.microsoft.com/office/drawing/2014/main" id="{0986E351-8B0F-44BD-A708-5ED2F676B71B}"/>
               </a:ext>
             </a:extLst>
           </p:cNvPr>
@@ -2017,7 +2017,7 @@
           <p:cNvPr id="6" name="">
             <a:extLst xmlns:a="http://schemas.openxmlformats.org/drawingml/2006/main">
               <a:ext uri="{FF2B5EF4-FFF2-40B4-BE49-F238E27FC236}">
-                <a16:creationId xmlns:a16="http://schemas.microsoft.com/office/drawing/2014/main" id="{7AFCE2F0-1651-4714-A9E8-2E13DDB55B9B}"/>
+                <a16:creationId xmlns:a16="http://schemas.microsoft.com/office/drawing/2014/main" id="{A028D994-6B6F-4161-AD3E-8DC173F03762}"/>
               </a:ext>
             </a:extLst>
           </p:cNvPr>
@@ -2050,7 +2050,7 @@
           <p:cNvPr id="7" name="">
             <a:extLst xmlns:a="http://schemas.openxmlformats.org/drawingml/2006/main">
               <a:ext uri="{FF2B5EF4-FFF2-40B4-BE49-F238E27FC236}">
-                <a16:creationId xmlns:a16="http://schemas.microsoft.com/office/drawing/2014/main" id="{417E19B7-8BC7-4A64-9FE6-DE9140F09DDF}"/>
+                <a16:creationId xmlns:a16="http://schemas.microsoft.com/office/drawing/2014/main" id="{186562FC-8999-432E-A510-3D7AF4691D66}"/>
               </a:ext>
             </a:extLst>
           </p:cNvPr>
@@ -2114,7 +2114,7 @@
           <p:cNvPr id="8" name="">
             <a:extLst xmlns:a="http://schemas.openxmlformats.org/drawingml/2006/main">
               <a:ext uri="{FF2B5EF4-FFF2-40B4-BE49-F238E27FC236}">
-                <a16:creationId xmlns:a16="http://schemas.microsoft.com/office/drawing/2014/main" id="{F742AEC7-2C52-43DB-A73D-801938FF44B6}"/>
+                <a16:creationId xmlns:a16="http://schemas.microsoft.com/office/drawing/2014/main" id="{2874BB6C-7038-415B-A80A-D2912ED451ED}"/>
               </a:ext>
             </a:extLst>
           </p:cNvPr>
@@ -2178,7 +2178,7 @@
           <p:cNvPr id="9" name="">
             <a:extLst xmlns:a="http://schemas.openxmlformats.org/drawingml/2006/main">
               <a:ext uri="{FF2B5EF4-FFF2-40B4-BE49-F238E27FC236}">
-                <a16:creationId xmlns:a16="http://schemas.microsoft.com/office/drawing/2014/main" id="{2E81C247-87C5-494C-B55B-B14524196F56}"/>
+                <a16:creationId xmlns:a16="http://schemas.microsoft.com/office/drawing/2014/main" id="{EFEA260A-8624-4BDC-B2B2-06CEC1A997B2}"/>
               </a:ext>
             </a:extLst>
           </p:cNvPr>
@@ -2213,7 +2213,7 @@
           <p:cNvPr id="10" name="">
             <a:extLst xmlns:a="http://schemas.openxmlformats.org/drawingml/2006/main">
               <a:ext uri="{FF2B5EF4-FFF2-40B4-BE49-F238E27FC236}">
-                <a16:creationId xmlns:a16="http://schemas.microsoft.com/office/drawing/2014/main" id="{E284E26B-98DE-4591-8F0D-4C1AB2E553B3}"/>
+                <a16:creationId xmlns:a16="http://schemas.microsoft.com/office/drawing/2014/main" id="{1A18A926-6AAA-4F84-9007-818649DC3A93}"/>
               </a:ext>
             </a:extLst>
           </p:cNvPr>
@@ -2277,7 +2277,7 @@
           <p:cNvPr id="11" name="">
             <a:extLst xmlns:a="http://schemas.openxmlformats.org/drawingml/2006/main">
               <a:ext uri="{FF2B5EF4-FFF2-40B4-BE49-F238E27FC236}">
-                <a16:creationId xmlns:a16="http://schemas.microsoft.com/office/drawing/2014/main" id="{0B59E894-B7AE-4E8B-BCC1-5BD6860E8455}"/>
+                <a16:creationId xmlns:a16="http://schemas.microsoft.com/office/drawing/2014/main" id="{6513EA64-4313-4332-9205-F9FB3A9FAA28}"/>
               </a:ext>
             </a:extLst>
           </p:cNvPr>
@@ -2312,7 +2312,7 @@
           <p:cNvPr id="12" name="">
             <a:extLst xmlns:a="http://schemas.openxmlformats.org/drawingml/2006/main">
               <a:ext uri="{FF2B5EF4-FFF2-40B4-BE49-F238E27FC236}">
-                <a16:creationId xmlns:a16="http://schemas.microsoft.com/office/drawing/2014/main" id="{436380C2-23FA-42D8-BC0A-F7ECCE6DCDA9}"/>
+                <a16:creationId xmlns:a16="http://schemas.microsoft.com/office/drawing/2014/main" id="{AC0A3DB4-9C03-45A3-B532-65A75D9A5F09}"/>
               </a:ext>
             </a:extLst>
           </p:cNvPr>
@@ -2376,7 +2376,7 @@
           <p:cNvPr id="13" name="">
             <a:extLst xmlns:a="http://schemas.openxmlformats.org/drawingml/2006/main">
               <a:ext uri="{FF2B5EF4-FFF2-40B4-BE49-F238E27FC236}">
-                <a16:creationId xmlns:a16="http://schemas.microsoft.com/office/drawing/2014/main" id="{E7AF4C0F-53A2-493E-A4F5-DF3504AAE13B}"/>
+                <a16:creationId xmlns:a16="http://schemas.microsoft.com/office/drawing/2014/main" id="{7B7214D9-1214-4826-96B9-016B8CCF3E6A}"/>
               </a:ext>
             </a:extLst>
           </p:cNvPr>
@@ -2411,7 +2411,7 @@
           <p:cNvPr id="14" name="">
             <a:extLst xmlns:a="http://schemas.openxmlformats.org/drawingml/2006/main">
               <a:ext uri="{FF2B5EF4-FFF2-40B4-BE49-F238E27FC236}">
-                <a16:creationId xmlns:a16="http://schemas.microsoft.com/office/drawing/2014/main" id="{3E6CAF44-4C9F-464A-B1AC-3B1291600A31}"/>
+                <a16:creationId xmlns:a16="http://schemas.microsoft.com/office/drawing/2014/main" id="{A5EB5451-DBB0-41D3-BE20-C018F4EAF941}"/>
               </a:ext>
             </a:extLst>
           </p:cNvPr>
@@ -2475,7 +2475,7 @@
           <p:cNvPr id="15" name="">
             <a:extLst xmlns:a="http://schemas.openxmlformats.org/drawingml/2006/main">
               <a:ext uri="{FF2B5EF4-FFF2-40B4-BE49-F238E27FC236}">
-                <a16:creationId xmlns:a16="http://schemas.microsoft.com/office/drawing/2014/main" id="{F1C32421-89CC-49E7-B198-E3BCA7BBA4C2}"/>
+                <a16:creationId xmlns:a16="http://schemas.microsoft.com/office/drawing/2014/main" id="{B26B4BB0-8FD6-4106-A33F-A5AEC98076C3}"/>
               </a:ext>
             </a:extLst>
           </p:cNvPr>
@@ -2539,7 +2539,7 @@
           <p:cNvPr id="16" name="">
             <a:extLst xmlns:a="http://schemas.openxmlformats.org/drawingml/2006/main">
               <a:ext uri="{FF2B5EF4-FFF2-40B4-BE49-F238E27FC236}">
-                <a16:creationId xmlns:a16="http://schemas.microsoft.com/office/drawing/2014/main" id="{2D21ECAA-5126-4633-B9F3-CFE79CA86074}"/>
+                <a16:creationId xmlns:a16="http://schemas.microsoft.com/office/drawing/2014/main" id="{CF4EA0F5-7530-4ED6-B01E-08E34A0F871E}"/>
               </a:ext>
             </a:extLst>
           </p:cNvPr>
@@ -2574,7 +2574,7 @@
           <p:cNvPr id="17" name="">
             <a:extLst xmlns:a="http://schemas.openxmlformats.org/drawingml/2006/main">
               <a:ext uri="{FF2B5EF4-FFF2-40B4-BE49-F238E27FC236}">
-                <a16:creationId xmlns:a16="http://schemas.microsoft.com/office/drawing/2014/main" id="{12EC7965-4523-4BA1-91AD-1388D9E71E6A}"/>
+                <a16:creationId xmlns:a16="http://schemas.microsoft.com/office/drawing/2014/main" id="{F5044D08-CD4F-48B5-8EA0-235D783B3A28}"/>
               </a:ext>
             </a:extLst>
           </p:cNvPr>
@@ -2638,7 +2638,7 @@
           <p:cNvPr id="18" name="">
             <a:extLst xmlns:a="http://schemas.openxmlformats.org/drawingml/2006/main">
               <a:ext uri="{FF2B5EF4-FFF2-40B4-BE49-F238E27FC236}">
-                <a16:creationId xmlns:a16="http://schemas.microsoft.com/office/drawing/2014/main" id="{ECCC5DF5-A1F9-4994-807E-80B46C603F42}"/>
+                <a16:creationId xmlns:a16="http://schemas.microsoft.com/office/drawing/2014/main" id="{B2F7A22A-B488-4CC2-979F-35FB2D2A29EC}"/>
               </a:ext>
             </a:extLst>
           </p:cNvPr>
@@ -2702,7 +2702,7 @@
           <p:cNvPr id="19" name="">
             <a:extLst xmlns:a="http://schemas.openxmlformats.org/drawingml/2006/main">
               <a:ext uri="{FF2B5EF4-FFF2-40B4-BE49-F238E27FC236}">
-                <a16:creationId xmlns:a16="http://schemas.microsoft.com/office/drawing/2014/main" id="{2D653A8D-2B4A-480B-80CE-2D63EF25BA03}"/>
+                <a16:creationId xmlns:a16="http://schemas.microsoft.com/office/drawing/2014/main" id="{B646C760-5410-4157-AA21-EBE77216111E}"/>
               </a:ext>
             </a:extLst>
           </p:cNvPr>
@@ -2737,7 +2737,7 @@
           <p:cNvPr id="20" name="">
             <a:extLst xmlns:a="http://schemas.openxmlformats.org/drawingml/2006/main">
               <a:ext uri="{FF2B5EF4-FFF2-40B4-BE49-F238E27FC236}">
-                <a16:creationId xmlns:a16="http://schemas.microsoft.com/office/drawing/2014/main" id="{24839FDE-83D3-4D1C-9A38-06300B7DF8B9}"/>
+                <a16:creationId xmlns:a16="http://schemas.microsoft.com/office/drawing/2014/main" id="{72EB14CB-EE6A-4AE3-91BC-3B326E8062CA}"/>
               </a:ext>
             </a:extLst>
           </p:cNvPr>
@@ -2801,7 +2801,7 @@
           <p:cNvPr id="21" name="">
             <a:extLst xmlns:a="http://schemas.openxmlformats.org/drawingml/2006/main">
               <a:ext uri="{FF2B5EF4-FFF2-40B4-BE49-F238E27FC236}">
-                <a16:creationId xmlns:a16="http://schemas.microsoft.com/office/drawing/2014/main" id="{16E41A48-9208-463D-8277-6200B0F36610}"/>
+                <a16:creationId xmlns:a16="http://schemas.microsoft.com/office/drawing/2014/main" id="{B17BCF2B-796E-43D6-ACF4-EEE870758285}"/>
               </a:ext>
             </a:extLst>
           </p:cNvPr>
@@ -2865,7 +2865,7 @@
           <p:cNvPr id="22" name="">
             <a:extLst xmlns:a="http://schemas.openxmlformats.org/drawingml/2006/main">
               <a:ext uri="{FF2B5EF4-FFF2-40B4-BE49-F238E27FC236}">
-                <a16:creationId xmlns:a16="http://schemas.microsoft.com/office/drawing/2014/main" id="{9077B27F-EDC5-4F42-A241-5410D5C459C3}"/>
+                <a16:creationId xmlns:a16="http://schemas.microsoft.com/office/drawing/2014/main" id="{A3C4F0C2-21F8-424E-AA16-CD813E0E6C3F}"/>
               </a:ext>
             </a:extLst>
           </p:cNvPr>
@@ -2929,7 +2929,7 @@
           <p:cNvPr id="23" name="">
             <a:extLst xmlns:a="http://schemas.openxmlformats.org/drawingml/2006/main">
               <a:ext uri="{FF2B5EF4-FFF2-40B4-BE49-F238E27FC236}">
-                <a16:creationId xmlns:a16="http://schemas.microsoft.com/office/drawing/2014/main" id="{ABA95201-0FDB-460F-8BBA-42896FD34B7F}"/>
+                <a16:creationId xmlns:a16="http://schemas.microsoft.com/office/drawing/2014/main" id="{36DD38EC-9718-4C9E-B1CA-AF64551083ED}"/>
               </a:ext>
             </a:extLst>
           </p:cNvPr>
@@ -2962,7 +2962,7 @@
           <p:cNvPr id="24" name="">
             <a:extLst xmlns:a="http://schemas.openxmlformats.org/drawingml/2006/main">
               <a:ext uri="{FF2B5EF4-FFF2-40B4-BE49-F238E27FC236}">
-                <a16:creationId xmlns:a16="http://schemas.microsoft.com/office/drawing/2014/main" id="{0EDA829E-1782-4865-873D-15515766BBED}"/>
+                <a16:creationId xmlns:a16="http://schemas.microsoft.com/office/drawing/2014/main" id="{4582D226-7163-4491-BFE5-3B7507DE44CC}"/>
               </a:ext>
             </a:extLst>
           </p:cNvPr>
@@ -3026,7 +3026,7 @@
           <p:cNvPr id="25" name="">
             <a:extLst xmlns:a="http://schemas.openxmlformats.org/drawingml/2006/main">
               <a:ext uri="{FF2B5EF4-FFF2-40B4-BE49-F238E27FC236}">
-                <a16:creationId xmlns:a16="http://schemas.microsoft.com/office/drawing/2014/main" id="{AC6AE8D0-4AA4-467C-BA37-49B848F9D6B8}"/>
+                <a16:creationId xmlns:a16="http://schemas.microsoft.com/office/drawing/2014/main" id="{FD370C31-A326-4B4C-B87B-255328446342}"/>
               </a:ext>
             </a:extLst>
           </p:cNvPr>
@@ -3088,7 +3088,7 @@
     </p:spTree>
     <p:extLst>
       <p:ext uri="{BB962C8B-B14F-4D97-AF65-F5344CB8AC3E}">
-        <p14:creationId xmlns:p14="http://schemas.microsoft.com/office/powerpoint/2010/main" val="1487634157"/>
+        <p14:creationId xmlns:p14="http://schemas.microsoft.com/office/powerpoint/2010/main" val="333568612"/>
       </p:ext>
     </p:extLst>
   </p:cSld>
@@ -3116,7 +3116,7 @@
           <p:nvPr/>
         </p:nvPicPr>
         <p:blipFill>
-          <a:blip xmlns:r="http://schemas.openxmlformats.org/officeDocument/2006/relationships" xmlns:a="http://schemas.openxmlformats.org/drawingml/2006/main" r:embed="R8a83a1ade6c148ed"/>
+          <a:blip xmlns:r="http://schemas.openxmlformats.org/officeDocument/2006/relationships" xmlns:a="http://schemas.openxmlformats.org/drawingml/2006/main" r:embed="R2d7f7afc6adb417b"/>
           <a:srcRect xmlns:a="http://schemas.openxmlformats.org/drawingml/2006/main" l="0" t="27" r="0" b="27"/>
           <a:stretch xmlns:a="http://schemas.openxmlformats.org/drawingml/2006/main">
             <a:fillRect l="0" t="0" r="0" b="0"/>
@@ -3137,7 +3137,7 @@
           <p:cNvPr id="2" name="">
             <a:extLst xmlns:a="http://schemas.openxmlformats.org/drawingml/2006/main">
               <a:ext uri="{FF2B5EF4-FFF2-40B4-BE49-F238E27FC236}">
-                <a16:creationId xmlns:a16="http://schemas.microsoft.com/office/drawing/2014/main" id="{5E27F79E-E467-4F43-8B34-C3B209850278}"/>
+                <a16:creationId xmlns:a16="http://schemas.microsoft.com/office/drawing/2014/main" id="{8F7D3A9D-302D-4BCE-9332-D161FC13E4D6}"/>
               </a:ext>
             </a:extLst>
           </p:cNvPr>
@@ -3174,7 +3174,7 @@
           <p:cNvPr id="3" name="">
             <a:extLst xmlns:a="http://schemas.openxmlformats.org/drawingml/2006/main">
               <a:ext uri="{FF2B5EF4-FFF2-40B4-BE49-F238E27FC236}">
-                <a16:creationId xmlns:a16="http://schemas.microsoft.com/office/drawing/2014/main" id="{3BF225D8-2FFD-4CE3-9929-79F5153C16FF}"/>
+                <a16:creationId xmlns:a16="http://schemas.microsoft.com/office/drawing/2014/main" id="{589323BE-D0D4-41A5-A887-603AAA6F7407}"/>
               </a:ext>
             </a:extLst>
           </p:cNvPr>
@@ -3211,7 +3211,7 @@
           <p:cNvPr id="4" name="">
             <a:extLst xmlns:a="http://schemas.openxmlformats.org/drawingml/2006/main">
               <a:ext uri="{FF2B5EF4-FFF2-40B4-BE49-F238E27FC236}">
-                <a16:creationId xmlns:a16="http://schemas.microsoft.com/office/drawing/2014/main" id="{8B2BB3DE-92DD-49FD-9C94-F0D30627C87E}"/>
+                <a16:creationId xmlns:a16="http://schemas.microsoft.com/office/drawing/2014/main" id="{B5492AA5-1135-485E-B81C-54605EA01364}"/>
               </a:ext>
             </a:extLst>
           </p:cNvPr>
@@ -3275,7 +3275,7 @@
           <p:cNvPr id="5" name="">
             <a:extLst xmlns:a="http://schemas.openxmlformats.org/drawingml/2006/main">
               <a:ext uri="{FF2B5EF4-FFF2-40B4-BE49-F238E27FC236}">
-                <a16:creationId xmlns:a16="http://schemas.microsoft.com/office/drawing/2014/main" id="{8152BADD-3901-4974-A5C9-A86F75DF013E}"/>
+                <a16:creationId xmlns:a16="http://schemas.microsoft.com/office/drawing/2014/main" id="{B0DD19AE-8928-4D23-A607-D250E602957D}"/>
               </a:ext>
             </a:extLst>
           </p:cNvPr>
@@ -3339,7 +3339,7 @@
           <p:cNvPr id="6" name="">
             <a:extLst xmlns:a="http://schemas.openxmlformats.org/drawingml/2006/main">
               <a:ext uri="{FF2B5EF4-FFF2-40B4-BE49-F238E27FC236}">
-                <a16:creationId xmlns:a16="http://schemas.microsoft.com/office/drawing/2014/main" id="{C997A7D9-2466-4A7F-9B2E-16753221B9B1}"/>
+                <a16:creationId xmlns:a16="http://schemas.microsoft.com/office/drawing/2014/main" id="{C3C88E91-73BE-4E8E-80B6-53CE2CA76E94}"/>
               </a:ext>
             </a:extLst>
           </p:cNvPr>
@@ -3403,7 +3403,7 @@
           <p:cNvPr id="7" name="">
             <a:extLst xmlns:a="http://schemas.openxmlformats.org/drawingml/2006/main">
               <a:ext uri="{FF2B5EF4-FFF2-40B4-BE49-F238E27FC236}">
-                <a16:creationId xmlns:a16="http://schemas.microsoft.com/office/drawing/2014/main" id="{7D7CAB32-FC29-422F-8254-DF9A800D3A54}"/>
+                <a16:creationId xmlns:a16="http://schemas.microsoft.com/office/drawing/2014/main" id="{CAF91035-7590-4ACB-949F-CC08D77B5180}"/>
               </a:ext>
             </a:extLst>
           </p:cNvPr>
@@ -3438,7 +3438,7 @@
           <p:cNvPr id="8" name="">
             <a:extLst xmlns:a="http://schemas.openxmlformats.org/drawingml/2006/main">
               <a:ext uri="{FF2B5EF4-FFF2-40B4-BE49-F238E27FC236}">
-                <a16:creationId xmlns:a16="http://schemas.microsoft.com/office/drawing/2014/main" id="{D7EA3F76-8C57-4730-BA18-72AE9A68A3A3}"/>
+                <a16:creationId xmlns:a16="http://schemas.microsoft.com/office/drawing/2014/main" id="{DDA73455-6626-448B-8B16-C2ECE97B37EE}"/>
               </a:ext>
             </a:extLst>
           </p:cNvPr>
@@ -3502,7 +3502,7 @@
           <p:cNvPr id="9" name="">
             <a:extLst xmlns:a="http://schemas.openxmlformats.org/drawingml/2006/main">
               <a:ext uri="{FF2B5EF4-FFF2-40B4-BE49-F238E27FC236}">
-                <a16:creationId xmlns:a16="http://schemas.microsoft.com/office/drawing/2014/main" id="{687EEBA2-84E2-4671-BE0F-FF80B1BA498D}"/>
+                <a16:creationId xmlns:a16="http://schemas.microsoft.com/office/drawing/2014/main" id="{1572A38F-9C83-4403-B3F5-EB9AD963ECAC}"/>
               </a:ext>
             </a:extLst>
           </p:cNvPr>
@@ -3537,7 +3537,7 @@
           <p:cNvPr id="10" name="">
             <a:extLst xmlns:a="http://schemas.openxmlformats.org/drawingml/2006/main">
               <a:ext uri="{FF2B5EF4-FFF2-40B4-BE49-F238E27FC236}">
-                <a16:creationId xmlns:a16="http://schemas.microsoft.com/office/drawing/2014/main" id="{163BDCC3-399C-4B35-AC80-8B98F9E8D33A}"/>
+                <a16:creationId xmlns:a16="http://schemas.microsoft.com/office/drawing/2014/main" id="{43A41087-6F20-49FE-A133-431249A13095}"/>
               </a:ext>
             </a:extLst>
           </p:cNvPr>
@@ -3601,7 +3601,7 @@
           <p:cNvPr id="11" name="">
             <a:extLst xmlns:a="http://schemas.openxmlformats.org/drawingml/2006/main">
               <a:ext uri="{FF2B5EF4-FFF2-40B4-BE49-F238E27FC236}">
-                <a16:creationId xmlns:a16="http://schemas.microsoft.com/office/drawing/2014/main" id="{6B269BB3-A7E7-46DD-AC66-4CAD8CD2A981}"/>
+                <a16:creationId xmlns:a16="http://schemas.microsoft.com/office/drawing/2014/main" id="{08680A12-1722-48B0-A895-E8D94838EDEE}"/>
               </a:ext>
             </a:extLst>
           </p:cNvPr>
@@ -3636,7 +3636,7 @@
           <p:cNvPr id="12" name="">
             <a:extLst xmlns:a="http://schemas.openxmlformats.org/drawingml/2006/main">
               <a:ext uri="{FF2B5EF4-FFF2-40B4-BE49-F238E27FC236}">
-                <a16:creationId xmlns:a16="http://schemas.microsoft.com/office/drawing/2014/main" id="{E0C9837B-0EE9-4F7A-9278-3CEC63FDFEC9}"/>
+                <a16:creationId xmlns:a16="http://schemas.microsoft.com/office/drawing/2014/main" id="{A9B348EE-A3C7-4287-9292-65637EAE21F9}"/>
               </a:ext>
             </a:extLst>
           </p:cNvPr>
@@ -3700,7 +3700,7 @@
           <p:cNvPr id="13" name="">
             <a:extLst xmlns:a="http://schemas.openxmlformats.org/drawingml/2006/main">
               <a:ext uri="{FF2B5EF4-FFF2-40B4-BE49-F238E27FC236}">
-                <a16:creationId xmlns:a16="http://schemas.microsoft.com/office/drawing/2014/main" id="{6BACD95F-B216-4915-A364-973C2F0C99C7}"/>
+                <a16:creationId xmlns:a16="http://schemas.microsoft.com/office/drawing/2014/main" id="{33C8CEC4-DB68-4FAC-8211-8EA5C2B42D01}"/>
               </a:ext>
             </a:extLst>
           </p:cNvPr>
@@ -3735,7 +3735,7 @@
           <p:cNvPr id="14" name="">
             <a:extLst xmlns:a="http://schemas.openxmlformats.org/drawingml/2006/main">
               <a:ext uri="{FF2B5EF4-FFF2-40B4-BE49-F238E27FC236}">
-                <a16:creationId xmlns:a16="http://schemas.microsoft.com/office/drawing/2014/main" id="{DBE71153-05C3-439B-B501-B56906A74C9E}"/>
+                <a16:creationId xmlns:a16="http://schemas.microsoft.com/office/drawing/2014/main" id="{F4B1D2F9-6F10-4058-A56A-0534688A558F}"/>
               </a:ext>
             </a:extLst>
           </p:cNvPr>
@@ -3799,7 +3799,7 @@
           <p:cNvPr id="15" name="">
             <a:extLst xmlns:a="http://schemas.openxmlformats.org/drawingml/2006/main">
               <a:ext uri="{FF2B5EF4-FFF2-40B4-BE49-F238E27FC236}">
-                <a16:creationId xmlns:a16="http://schemas.microsoft.com/office/drawing/2014/main" id="{84B97987-D17C-4653-BD49-CC2F49FB7ED8}"/>
+                <a16:creationId xmlns:a16="http://schemas.microsoft.com/office/drawing/2014/main" id="{984C69A4-A8E8-4E8A-A677-A3E0C697675F}"/>
               </a:ext>
             </a:extLst>
           </p:cNvPr>
@@ -3863,7 +3863,7 @@
           <p:cNvPr id="16" name="">
             <a:extLst xmlns:a="http://schemas.openxmlformats.org/drawingml/2006/main">
               <a:ext uri="{FF2B5EF4-FFF2-40B4-BE49-F238E27FC236}">
-                <a16:creationId xmlns:a16="http://schemas.microsoft.com/office/drawing/2014/main" id="{6999AD51-1A8D-424A-AF1E-9FC10851F559}"/>
+                <a16:creationId xmlns:a16="http://schemas.microsoft.com/office/drawing/2014/main" id="{AE6709AD-21BF-454D-A6F4-ED919C09FE1E}"/>
               </a:ext>
             </a:extLst>
           </p:cNvPr>
@@ -3927,7 +3927,7 @@
           <p:cNvPr id="17" name="">
             <a:extLst xmlns:a="http://schemas.openxmlformats.org/drawingml/2006/main">
               <a:ext uri="{FF2B5EF4-FFF2-40B4-BE49-F238E27FC236}">
-                <a16:creationId xmlns:a16="http://schemas.microsoft.com/office/drawing/2014/main" id="{D01C321C-A896-4E23-A063-867CB7184B9A}"/>
+                <a16:creationId xmlns:a16="http://schemas.microsoft.com/office/drawing/2014/main" id="{8716E326-8D90-47FC-A722-99585117C63D}"/>
               </a:ext>
             </a:extLst>
           </p:cNvPr>
@@ -3960,7 +3960,7 @@
           <p:cNvPr id="18" name="">
             <a:extLst xmlns:a="http://schemas.openxmlformats.org/drawingml/2006/main">
               <a:ext uri="{FF2B5EF4-FFF2-40B4-BE49-F238E27FC236}">
-                <a16:creationId xmlns:a16="http://schemas.microsoft.com/office/drawing/2014/main" id="{5BB18495-A394-4FEE-95FF-1425F1764F9A}"/>
+                <a16:creationId xmlns:a16="http://schemas.microsoft.com/office/drawing/2014/main" id="{30508320-8341-4FAE-84C8-279FD9F9B4BA}"/>
               </a:ext>
             </a:extLst>
           </p:cNvPr>
@@ -4024,7 +4024,7 @@
           <p:cNvPr id="19" name="">
             <a:extLst xmlns:a="http://schemas.openxmlformats.org/drawingml/2006/main">
               <a:ext uri="{FF2B5EF4-FFF2-40B4-BE49-F238E27FC236}">
-                <a16:creationId xmlns:a16="http://schemas.microsoft.com/office/drawing/2014/main" id="{F6041825-C47D-4E60-9844-E8BF6DB0D8B6}"/>
+                <a16:creationId xmlns:a16="http://schemas.microsoft.com/office/drawing/2014/main" id="{77B1426C-1EEA-421E-9DA8-EBF74AF2C6A9}"/>
               </a:ext>
             </a:extLst>
           </p:cNvPr>
@@ -4086,7 +4086,7 @@
     </p:spTree>
     <p:extLst>
       <p:ext uri="{BB962C8B-B14F-4D97-AF65-F5344CB8AC3E}">
-        <p14:creationId xmlns:p14="http://schemas.microsoft.com/office/powerpoint/2010/main" val="815893651"/>
+        <p14:creationId xmlns:p14="http://schemas.microsoft.com/office/powerpoint/2010/main" val="529280487"/>
       </p:ext>
     </p:extLst>
   </p:cSld>
@@ -4114,7 +4114,7 @@
           <p:nvPr/>
         </p:nvPicPr>
         <p:blipFill>
-          <a:blip xmlns:r="http://schemas.openxmlformats.org/officeDocument/2006/relationships" xmlns:a="http://schemas.openxmlformats.org/drawingml/2006/main" r:embed="R5f84065f08b2465f"/>
+          <a:blip xmlns:r="http://schemas.openxmlformats.org/officeDocument/2006/relationships" xmlns:a="http://schemas.openxmlformats.org/drawingml/2006/main" r:embed="Rabe13197a4ad4213"/>
           <a:srcRect xmlns:a="http://schemas.openxmlformats.org/drawingml/2006/main" l="0" t="27" r="0" b="27"/>
           <a:stretch xmlns:a="http://schemas.openxmlformats.org/drawingml/2006/main">
             <a:fillRect l="0" t="0" r="0" b="0"/>
@@ -4135,7 +4135,7 @@
           <p:cNvPr id="2" name="">
             <a:extLst xmlns:a="http://schemas.openxmlformats.org/drawingml/2006/main">
               <a:ext uri="{FF2B5EF4-FFF2-40B4-BE49-F238E27FC236}">
-                <a16:creationId xmlns:a16="http://schemas.microsoft.com/office/drawing/2014/main" id="{4B46D025-524C-41A6-BC2A-F0E877C569A8}"/>
+                <a16:creationId xmlns:a16="http://schemas.microsoft.com/office/drawing/2014/main" id="{93910558-3B26-463E-8DD6-025912E73FC0}"/>
               </a:ext>
             </a:extLst>
           </p:cNvPr>
@@ -4172,7 +4172,7 @@
           <p:cNvPr id="3" name="">
             <a:extLst xmlns:a="http://schemas.openxmlformats.org/drawingml/2006/main">
               <a:ext uri="{FF2B5EF4-FFF2-40B4-BE49-F238E27FC236}">
-                <a16:creationId xmlns:a16="http://schemas.microsoft.com/office/drawing/2014/main" id="{FBCE94E0-7493-4780-AD88-E755CA2FB776}"/>
+                <a16:creationId xmlns:a16="http://schemas.microsoft.com/office/drawing/2014/main" id="{46FEF815-BDB5-441E-A501-116B9E3234E3}"/>
               </a:ext>
             </a:extLst>
           </p:cNvPr>
@@ -4209,7 +4209,7 @@
           <p:cNvPr id="4" name="">
             <a:extLst xmlns:a="http://schemas.openxmlformats.org/drawingml/2006/main">
               <a:ext uri="{FF2B5EF4-FFF2-40B4-BE49-F238E27FC236}">
-                <a16:creationId xmlns:a16="http://schemas.microsoft.com/office/drawing/2014/main" id="{DF3D3284-961A-4396-8CAF-7B16C5588CD2}"/>
+                <a16:creationId xmlns:a16="http://schemas.microsoft.com/office/drawing/2014/main" id="{7260D34E-9854-41EB-9D93-078BB7C9479F}"/>
               </a:ext>
             </a:extLst>
           </p:cNvPr>
@@ -4273,7 +4273,7 @@
           <p:cNvPr id="5" name="">
             <a:extLst xmlns:a="http://schemas.openxmlformats.org/drawingml/2006/main">
               <a:ext uri="{FF2B5EF4-FFF2-40B4-BE49-F238E27FC236}">
-                <a16:creationId xmlns:a16="http://schemas.microsoft.com/office/drawing/2014/main" id="{688FB835-2CE2-4B9D-B7BD-20EEBF8034DF}"/>
+                <a16:creationId xmlns:a16="http://schemas.microsoft.com/office/drawing/2014/main" id="{079F4333-C0BC-4723-B1FF-96733A6F402D}"/>
               </a:ext>
             </a:extLst>
           </p:cNvPr>
@@ -4337,7 +4337,7 @@
           <p:cNvPr id="6" name="">
             <a:extLst xmlns:a="http://schemas.openxmlformats.org/drawingml/2006/main">
               <a:ext uri="{FF2B5EF4-FFF2-40B4-BE49-F238E27FC236}">
-                <a16:creationId xmlns:a16="http://schemas.microsoft.com/office/drawing/2014/main" id="{A54996B1-6B1A-4613-A4D6-3BA44368632E}"/>
+                <a16:creationId xmlns:a16="http://schemas.microsoft.com/office/drawing/2014/main" id="{EB8E8B55-5304-44D8-AF08-A1330A7C9638}"/>
               </a:ext>
             </a:extLst>
           </p:cNvPr>
@@ -4401,7 +4401,7 @@
           <p:cNvPr id="7" name="">
             <a:extLst xmlns:a="http://schemas.openxmlformats.org/drawingml/2006/main">
               <a:ext uri="{FF2B5EF4-FFF2-40B4-BE49-F238E27FC236}">
-                <a16:creationId xmlns:a16="http://schemas.microsoft.com/office/drawing/2014/main" id="{FF03AD46-623C-4313-AFF4-C5C3E3CC9147}"/>
+                <a16:creationId xmlns:a16="http://schemas.microsoft.com/office/drawing/2014/main" id="{C8C5E6C2-1459-4314-8E35-A58E58A1F08C}"/>
               </a:ext>
             </a:extLst>
           </p:cNvPr>
@@ -4436,7 +4436,7 @@
           <p:cNvPr id="8" name="">
             <a:extLst xmlns:a="http://schemas.openxmlformats.org/drawingml/2006/main">
               <a:ext uri="{FF2B5EF4-FFF2-40B4-BE49-F238E27FC236}">
-                <a16:creationId xmlns:a16="http://schemas.microsoft.com/office/drawing/2014/main" id="{8663EE29-89C4-4895-83EA-2C7CC4F62495}"/>
+                <a16:creationId xmlns:a16="http://schemas.microsoft.com/office/drawing/2014/main" id="{B6576794-E4E5-487C-913D-304AF2C706B8}"/>
               </a:ext>
             </a:extLst>
           </p:cNvPr>
@@ -4500,7 +4500,7 @@
           <p:cNvPr id="9" name="">
             <a:extLst xmlns:a="http://schemas.openxmlformats.org/drawingml/2006/main">
               <a:ext uri="{FF2B5EF4-FFF2-40B4-BE49-F238E27FC236}">
-                <a16:creationId xmlns:a16="http://schemas.microsoft.com/office/drawing/2014/main" id="{B8B90269-FD74-4014-8C3B-BBB33B78903B}"/>
+                <a16:creationId xmlns:a16="http://schemas.microsoft.com/office/drawing/2014/main" id="{697150BF-D8C1-4F2E-8438-CF08854708B9}"/>
               </a:ext>
             </a:extLst>
           </p:cNvPr>
@@ -4564,7 +4564,7 @@
           <p:cNvPr id="10" name="">
             <a:extLst xmlns:a="http://schemas.openxmlformats.org/drawingml/2006/main">
               <a:ext uri="{FF2B5EF4-FFF2-40B4-BE49-F238E27FC236}">
-                <a16:creationId xmlns:a16="http://schemas.microsoft.com/office/drawing/2014/main" id="{EB911838-E539-4700-A5C6-AEF948363610}"/>
+                <a16:creationId xmlns:a16="http://schemas.microsoft.com/office/drawing/2014/main" id="{20EF6D4B-6D98-476D-BA14-3C2194085908}"/>
               </a:ext>
             </a:extLst>
           </p:cNvPr>
@@ -4597,7 +4597,7 @@
           <p:cNvPr id="11" name="">
             <a:extLst xmlns:a="http://schemas.openxmlformats.org/drawingml/2006/main">
               <a:ext uri="{FF2B5EF4-FFF2-40B4-BE49-F238E27FC236}">
-                <a16:creationId xmlns:a16="http://schemas.microsoft.com/office/drawing/2014/main" id="{A7869E75-177C-4A05-9346-5DF1FA4347C5}"/>
+                <a16:creationId xmlns:a16="http://schemas.microsoft.com/office/drawing/2014/main" id="{E8D9E921-5309-4819-9684-AFE913C86C40}"/>
               </a:ext>
             </a:extLst>
           </p:cNvPr>
@@ -4632,7 +4632,7 @@
           <p:cNvPr id="12" name="">
             <a:extLst xmlns:a="http://schemas.openxmlformats.org/drawingml/2006/main">
               <a:ext uri="{FF2B5EF4-FFF2-40B4-BE49-F238E27FC236}">
-                <a16:creationId xmlns:a16="http://schemas.microsoft.com/office/drawing/2014/main" id="{6851AC6B-0A75-43B2-B6F6-15AE5A314AD0}"/>
+                <a16:creationId xmlns:a16="http://schemas.microsoft.com/office/drawing/2014/main" id="{77E10E55-1A27-412C-ABB9-393704D652A6}"/>
               </a:ext>
             </a:extLst>
           </p:cNvPr>
@@ -4696,7 +4696,7 @@
           <p:cNvPr id="13" name="">
             <a:extLst xmlns:a="http://schemas.openxmlformats.org/drawingml/2006/main">
               <a:ext uri="{FF2B5EF4-FFF2-40B4-BE49-F238E27FC236}">
-                <a16:creationId xmlns:a16="http://schemas.microsoft.com/office/drawing/2014/main" id="{833ABECC-9D7D-449E-9E6F-844205C38580}"/>
+                <a16:creationId xmlns:a16="http://schemas.microsoft.com/office/drawing/2014/main" id="{8768A004-1ADA-4040-A6D2-7F840C2B37EF}"/>
               </a:ext>
             </a:extLst>
           </p:cNvPr>
@@ -4760,7 +4760,7 @@
           <p:cNvPr id="14" name="">
             <a:extLst xmlns:a="http://schemas.openxmlformats.org/drawingml/2006/main">
               <a:ext uri="{FF2B5EF4-FFF2-40B4-BE49-F238E27FC236}">
-                <a16:creationId xmlns:a16="http://schemas.microsoft.com/office/drawing/2014/main" id="{1999BFDF-4C69-4FE1-B2B0-739AE6AD23AC}"/>
+                <a16:creationId xmlns:a16="http://schemas.microsoft.com/office/drawing/2014/main" id="{8938A43F-F1D0-42E3-ADA4-6A6567BDC542}"/>
               </a:ext>
             </a:extLst>
           </p:cNvPr>
@@ -4793,7 +4793,7 @@
           <p:cNvPr id="15" name="">
             <a:extLst xmlns:a="http://schemas.openxmlformats.org/drawingml/2006/main">
               <a:ext uri="{FF2B5EF4-FFF2-40B4-BE49-F238E27FC236}">
-                <a16:creationId xmlns:a16="http://schemas.microsoft.com/office/drawing/2014/main" id="{71C0F91B-2ECA-461D-8493-342EBCEA4ED1}"/>
+                <a16:creationId xmlns:a16="http://schemas.microsoft.com/office/drawing/2014/main" id="{7C776EC9-6CB3-4651-84FD-AF3C2121D48F}"/>
               </a:ext>
             </a:extLst>
           </p:cNvPr>
@@ -4828,7 +4828,7 @@
           <p:cNvPr id="16" name="">
             <a:extLst xmlns:a="http://schemas.openxmlformats.org/drawingml/2006/main">
               <a:ext uri="{FF2B5EF4-FFF2-40B4-BE49-F238E27FC236}">
-                <a16:creationId xmlns:a16="http://schemas.microsoft.com/office/drawing/2014/main" id="{11BBC912-81AC-4162-A18B-E1941BD109C6}"/>
+                <a16:creationId xmlns:a16="http://schemas.microsoft.com/office/drawing/2014/main" id="{675B59B2-2D60-45E6-9C85-2607A1D22038}"/>
               </a:ext>
             </a:extLst>
           </p:cNvPr>
@@ -4892,7 +4892,7 @@
           <p:cNvPr id="17" name="">
             <a:extLst xmlns:a="http://schemas.openxmlformats.org/drawingml/2006/main">
               <a:ext uri="{FF2B5EF4-FFF2-40B4-BE49-F238E27FC236}">
-                <a16:creationId xmlns:a16="http://schemas.microsoft.com/office/drawing/2014/main" id="{9EE92970-2068-432F-A643-4C261FEB96FB}"/>
+                <a16:creationId xmlns:a16="http://schemas.microsoft.com/office/drawing/2014/main" id="{360E82F1-5BF6-4D2C-8F9B-D797C08D2618}"/>
               </a:ext>
             </a:extLst>
           </p:cNvPr>
@@ -4956,7 +4956,7 @@
           <p:cNvPr id="18" name="">
             <a:extLst xmlns:a="http://schemas.openxmlformats.org/drawingml/2006/main">
               <a:ext uri="{FF2B5EF4-FFF2-40B4-BE49-F238E27FC236}">
-                <a16:creationId xmlns:a16="http://schemas.microsoft.com/office/drawing/2014/main" id="{9925F8DF-1CD8-4FCA-8549-ECF75F8FE39D}"/>
+                <a16:creationId xmlns:a16="http://schemas.microsoft.com/office/drawing/2014/main" id="{F9D415EC-43CD-417C-B7E7-6FE50218D3A8}"/>
               </a:ext>
             </a:extLst>
           </p:cNvPr>
@@ -5020,7 +5020,7 @@
           <p:cNvPr id="19" name="">
             <a:extLst xmlns:a="http://schemas.openxmlformats.org/drawingml/2006/main">
               <a:ext uri="{FF2B5EF4-FFF2-40B4-BE49-F238E27FC236}">
-                <a16:creationId xmlns:a16="http://schemas.microsoft.com/office/drawing/2014/main" id="{1AEB2DA3-16C1-441A-B2EE-B806E1F95200}"/>
+                <a16:creationId xmlns:a16="http://schemas.microsoft.com/office/drawing/2014/main" id="{F508C45B-86AA-40FA-B141-32B0F25FDD6D}"/>
               </a:ext>
             </a:extLst>
           </p:cNvPr>
@@ -5053,7 +5053,7 @@
           <p:cNvPr id="20" name="">
             <a:extLst xmlns:a="http://schemas.openxmlformats.org/drawingml/2006/main">
               <a:ext uri="{FF2B5EF4-FFF2-40B4-BE49-F238E27FC236}">
-                <a16:creationId xmlns:a16="http://schemas.microsoft.com/office/drawing/2014/main" id="{9638B7BF-23C8-4BE6-A111-9AFF331B4F4A}"/>
+                <a16:creationId xmlns:a16="http://schemas.microsoft.com/office/drawing/2014/main" id="{EEF40FB1-ECEE-4C7F-AEE5-239C1746E458}"/>
               </a:ext>
             </a:extLst>
           </p:cNvPr>
@@ -5117,7 +5117,7 @@
           <p:cNvPr id="21" name="">
             <a:extLst xmlns:a="http://schemas.openxmlformats.org/drawingml/2006/main">
               <a:ext uri="{FF2B5EF4-FFF2-40B4-BE49-F238E27FC236}">
-                <a16:creationId xmlns:a16="http://schemas.microsoft.com/office/drawing/2014/main" id="{0F4CB6AB-0E49-4536-83E9-8E650F16919E}"/>
+                <a16:creationId xmlns:a16="http://schemas.microsoft.com/office/drawing/2014/main" id="{678C9301-B7E2-44BA-B44B-723F18380FB4}"/>
               </a:ext>
             </a:extLst>
           </p:cNvPr>
@@ -5179,7 +5179,7 @@
     </p:spTree>
     <p:extLst>
       <p:ext uri="{BB962C8B-B14F-4D97-AF65-F5344CB8AC3E}">
-        <p14:creationId xmlns:p14="http://schemas.microsoft.com/office/powerpoint/2010/main" val="217152678"/>
+        <p14:creationId xmlns:p14="http://schemas.microsoft.com/office/powerpoint/2010/main" val="386934420"/>
       </p:ext>
     </p:extLst>
   </p:cSld>
@@ -5207,7 +5207,7 @@
           <p:nvPr/>
         </p:nvPicPr>
         <p:blipFill>
-          <a:blip xmlns:r="http://schemas.openxmlformats.org/officeDocument/2006/relationships" xmlns:a="http://schemas.openxmlformats.org/drawingml/2006/main" r:embed="Rf2afa305f6ce4a31"/>
+          <a:blip xmlns:r="http://schemas.openxmlformats.org/officeDocument/2006/relationships" xmlns:a="http://schemas.openxmlformats.org/drawingml/2006/main" r:embed="Ra2e8a2cab6404ecd"/>
           <a:srcRect xmlns:a="http://schemas.openxmlformats.org/drawingml/2006/main" l="0" t="27" r="0" b="27"/>
           <a:stretch xmlns:a="http://schemas.openxmlformats.org/drawingml/2006/main">
             <a:fillRect l="0" t="0" r="0" b="0"/>
@@ -5228,7 +5228,7 @@
           <p:cNvPr id="2" name="">
             <a:extLst xmlns:a="http://schemas.openxmlformats.org/drawingml/2006/main">
               <a:ext uri="{FF2B5EF4-FFF2-40B4-BE49-F238E27FC236}">
-                <a16:creationId xmlns:a16="http://schemas.microsoft.com/office/drawing/2014/main" id="{C71C0C5B-7F3E-46D3-86DD-A258CB1B2610}"/>
+                <a16:creationId xmlns:a16="http://schemas.microsoft.com/office/drawing/2014/main" id="{61643679-49A6-40D1-BF4C-1B8CE0D6948D}"/>
               </a:ext>
             </a:extLst>
           </p:cNvPr>
@@ -5265,7 +5265,7 @@
           <p:cNvPr id="3" name="">
             <a:extLst xmlns:a="http://schemas.openxmlformats.org/drawingml/2006/main">
               <a:ext uri="{FF2B5EF4-FFF2-40B4-BE49-F238E27FC236}">
-                <a16:creationId xmlns:a16="http://schemas.microsoft.com/office/drawing/2014/main" id="{20737144-FE88-427F-B2CE-C0B0C46E8651}"/>
+                <a16:creationId xmlns:a16="http://schemas.microsoft.com/office/drawing/2014/main" id="{A6A763F6-1E03-4AF7-84EE-A144E9156810}"/>
               </a:ext>
             </a:extLst>
           </p:cNvPr>
@@ -5302,7 +5302,7 @@
           <p:cNvPr id="4" name="">
             <a:extLst xmlns:a="http://schemas.openxmlformats.org/drawingml/2006/main">
               <a:ext uri="{FF2B5EF4-FFF2-40B4-BE49-F238E27FC236}">
-                <a16:creationId xmlns:a16="http://schemas.microsoft.com/office/drawing/2014/main" id="{4825A5D3-0AC9-4D3A-AFD2-42AF11CA4115}"/>
+                <a16:creationId xmlns:a16="http://schemas.microsoft.com/office/drawing/2014/main" id="{99280814-74F3-49B0-A17E-83DE5F579F19}"/>
               </a:ext>
             </a:extLst>
           </p:cNvPr>
@@ -5366,7 +5366,7 @@
           <p:cNvPr id="5" name="">
             <a:extLst xmlns:a="http://schemas.openxmlformats.org/drawingml/2006/main">
               <a:ext uri="{FF2B5EF4-FFF2-40B4-BE49-F238E27FC236}">
-                <a16:creationId xmlns:a16="http://schemas.microsoft.com/office/drawing/2014/main" id="{ADF5CD0E-FB11-4517-B064-FBA769011384}"/>
+                <a16:creationId xmlns:a16="http://schemas.microsoft.com/office/drawing/2014/main" id="{D58FE2C5-D157-4BDB-AC22-F37E9476D50D}"/>
               </a:ext>
             </a:extLst>
           </p:cNvPr>
@@ -5430,7 +5430,7 @@
           <p:cNvPr id="6" name="">
             <a:extLst xmlns:a="http://schemas.openxmlformats.org/drawingml/2006/main">
               <a:ext uri="{FF2B5EF4-FFF2-40B4-BE49-F238E27FC236}">
-                <a16:creationId xmlns:a16="http://schemas.microsoft.com/office/drawing/2014/main" id="{F4D6FDF8-FC97-4C89-8DA6-A673E05BAC20}"/>
+                <a16:creationId xmlns:a16="http://schemas.microsoft.com/office/drawing/2014/main" id="{1FEE7966-358B-42CA-9188-41C0E4CAEC1F}"/>
               </a:ext>
             </a:extLst>
           </p:cNvPr>
@@ -5494,7 +5494,7 @@
           <p:cNvPr id="7" name="">
             <a:extLst xmlns:a="http://schemas.openxmlformats.org/drawingml/2006/main">
               <a:ext uri="{FF2B5EF4-FFF2-40B4-BE49-F238E27FC236}">
-                <a16:creationId xmlns:a16="http://schemas.microsoft.com/office/drawing/2014/main" id="{5DE06F4D-9D7B-464A-974B-F0D9D338CA2B}"/>
+                <a16:creationId xmlns:a16="http://schemas.microsoft.com/office/drawing/2014/main" id="{1938BC7E-F0A1-4340-8B60-7C8D3A359197}"/>
               </a:ext>
             </a:extLst>
           </p:cNvPr>
@@ -5529,7 +5529,7 @@
           <p:cNvPr id="8" name="">
             <a:extLst xmlns:a="http://schemas.openxmlformats.org/drawingml/2006/main">
               <a:ext uri="{FF2B5EF4-FFF2-40B4-BE49-F238E27FC236}">
-                <a16:creationId xmlns:a16="http://schemas.microsoft.com/office/drawing/2014/main" id="{56DE56C5-BAE6-41A0-9564-CABD17DD054D}"/>
+                <a16:creationId xmlns:a16="http://schemas.microsoft.com/office/drawing/2014/main" id="{310526B2-79F4-4E5C-A7D1-5C104162C31D}"/>
               </a:ext>
             </a:extLst>
           </p:cNvPr>
@@ -5593,7 +5593,7 @@
           <p:cNvPr id="9" name="">
             <a:extLst xmlns:a="http://schemas.openxmlformats.org/drawingml/2006/main">
               <a:ext uri="{FF2B5EF4-FFF2-40B4-BE49-F238E27FC236}">
-                <a16:creationId xmlns:a16="http://schemas.microsoft.com/office/drawing/2014/main" id="{10B23962-6785-484A-933A-B1D180CEF6B4}"/>
+                <a16:creationId xmlns:a16="http://schemas.microsoft.com/office/drawing/2014/main" id="{789F7A88-67AF-41B8-9332-FFC3B41202A8}"/>
               </a:ext>
             </a:extLst>
           </p:cNvPr>
@@ -5657,7 +5657,7 @@
           <p:cNvPr id="10" name="">
             <a:extLst xmlns:a="http://schemas.openxmlformats.org/drawingml/2006/main">
               <a:ext uri="{FF2B5EF4-FFF2-40B4-BE49-F238E27FC236}">
-                <a16:creationId xmlns:a16="http://schemas.microsoft.com/office/drawing/2014/main" id="{9BEADDFD-206A-4CAF-8146-8DAB7332CE61}"/>
+                <a16:creationId xmlns:a16="http://schemas.microsoft.com/office/drawing/2014/main" id="{A384DAD6-BCB5-493D-BF95-2C54DF144BDF}"/>
               </a:ext>
             </a:extLst>
           </p:cNvPr>
@@ -5692,7 +5692,7 @@
           <p:cNvPr id="11" name="">
             <a:extLst xmlns:a="http://schemas.openxmlformats.org/drawingml/2006/main">
               <a:ext uri="{FF2B5EF4-FFF2-40B4-BE49-F238E27FC236}">
-                <a16:creationId xmlns:a16="http://schemas.microsoft.com/office/drawing/2014/main" id="{4C4E1C44-0F4E-41BD-8866-65A000237B4F}"/>
+                <a16:creationId xmlns:a16="http://schemas.microsoft.com/office/drawing/2014/main" id="{6F376FE0-EA08-43E2-AB5E-3FA749D8F6C6}"/>
               </a:ext>
             </a:extLst>
           </p:cNvPr>
@@ -5756,7 +5756,7 @@
           <p:cNvPr id="12" name="">
             <a:extLst xmlns:a="http://schemas.openxmlformats.org/drawingml/2006/main">
               <a:ext uri="{FF2B5EF4-FFF2-40B4-BE49-F238E27FC236}">
-                <a16:creationId xmlns:a16="http://schemas.microsoft.com/office/drawing/2014/main" id="{9AE4AC3B-A664-413F-8A87-54C2AE1475D4}"/>
+                <a16:creationId xmlns:a16="http://schemas.microsoft.com/office/drawing/2014/main" id="{52229DD7-EABD-43F1-A702-0C40818773D2}"/>
               </a:ext>
             </a:extLst>
           </p:cNvPr>
@@ -5820,7 +5820,7 @@
           <p:cNvPr id="13" name="">
             <a:extLst xmlns:a="http://schemas.openxmlformats.org/drawingml/2006/main">
               <a:ext uri="{FF2B5EF4-FFF2-40B4-BE49-F238E27FC236}">
-                <a16:creationId xmlns:a16="http://schemas.microsoft.com/office/drawing/2014/main" id="{6493EDEB-D637-46EB-9A65-71D6ADD79508}"/>
+                <a16:creationId xmlns:a16="http://schemas.microsoft.com/office/drawing/2014/main" id="{9121CF96-EE60-4250-93F4-48E3498AFBEC}"/>
               </a:ext>
             </a:extLst>
           </p:cNvPr>
@@ -5855,7 +5855,7 @@
           <p:cNvPr id="14" name="">
             <a:extLst xmlns:a="http://schemas.openxmlformats.org/drawingml/2006/main">
               <a:ext uri="{FF2B5EF4-FFF2-40B4-BE49-F238E27FC236}">
-                <a16:creationId xmlns:a16="http://schemas.microsoft.com/office/drawing/2014/main" id="{14E35299-21AB-428F-A3C1-A63ECE62C292}"/>
+                <a16:creationId xmlns:a16="http://schemas.microsoft.com/office/drawing/2014/main" id="{D40A3202-3AB3-4E7E-82C3-65BF53D553AF}"/>
               </a:ext>
             </a:extLst>
           </p:cNvPr>
@@ -5919,7 +5919,7 @@
           <p:cNvPr id="15" name="">
             <a:extLst xmlns:a="http://schemas.openxmlformats.org/drawingml/2006/main">
               <a:ext uri="{FF2B5EF4-FFF2-40B4-BE49-F238E27FC236}">
-                <a16:creationId xmlns:a16="http://schemas.microsoft.com/office/drawing/2014/main" id="{33935A57-4E32-433D-9983-F6805D535CD9}"/>
+                <a16:creationId xmlns:a16="http://schemas.microsoft.com/office/drawing/2014/main" id="{51610230-957F-44B9-B98D-094961D65F7A}"/>
               </a:ext>
             </a:extLst>
           </p:cNvPr>
@@ -5983,7 +5983,7 @@
           <p:cNvPr id="16" name="">
             <a:extLst xmlns:a="http://schemas.openxmlformats.org/drawingml/2006/main">
               <a:ext uri="{FF2B5EF4-FFF2-40B4-BE49-F238E27FC236}">
-                <a16:creationId xmlns:a16="http://schemas.microsoft.com/office/drawing/2014/main" id="{1395C740-6CC6-460E-AA76-BB7981B5F74A}"/>
+                <a16:creationId xmlns:a16="http://schemas.microsoft.com/office/drawing/2014/main" id="{82933F91-10AF-4C88-862E-41113CE6BB1E}"/>
               </a:ext>
             </a:extLst>
           </p:cNvPr>
@@ -6018,7 +6018,7 @@
           <p:cNvPr id="17" name="">
             <a:extLst xmlns:a="http://schemas.openxmlformats.org/drawingml/2006/main">
               <a:ext uri="{FF2B5EF4-FFF2-40B4-BE49-F238E27FC236}">
-                <a16:creationId xmlns:a16="http://schemas.microsoft.com/office/drawing/2014/main" id="{F3888830-BBC4-4886-A744-E4CE8B8CE34B}"/>
+                <a16:creationId xmlns:a16="http://schemas.microsoft.com/office/drawing/2014/main" id="{6C7EB154-BA55-4067-A3D1-E5FA0B7F8339}"/>
               </a:ext>
             </a:extLst>
           </p:cNvPr>
@@ -6082,7 +6082,7 @@
           <p:cNvPr id="18" name="">
             <a:extLst xmlns:a="http://schemas.openxmlformats.org/drawingml/2006/main">
               <a:ext uri="{FF2B5EF4-FFF2-40B4-BE49-F238E27FC236}">
-                <a16:creationId xmlns:a16="http://schemas.microsoft.com/office/drawing/2014/main" id="{548A9813-F1D1-455F-ADDC-108F4284D765}"/>
+                <a16:creationId xmlns:a16="http://schemas.microsoft.com/office/drawing/2014/main" id="{9915DE0E-B55A-426E-835D-2D9588AC6C89}"/>
               </a:ext>
             </a:extLst>
           </p:cNvPr>
@@ -6146,7 +6146,7 @@
           <p:cNvPr id="19" name="">
             <a:extLst xmlns:a="http://schemas.openxmlformats.org/drawingml/2006/main">
               <a:ext uri="{FF2B5EF4-FFF2-40B4-BE49-F238E27FC236}">
-                <a16:creationId xmlns:a16="http://schemas.microsoft.com/office/drawing/2014/main" id="{3329FE91-35E5-428F-9FC1-31DDF32EDA71}"/>
+                <a16:creationId xmlns:a16="http://schemas.microsoft.com/office/drawing/2014/main" id="{E658273F-D614-482A-950F-88533F7A0151}"/>
               </a:ext>
             </a:extLst>
           </p:cNvPr>
@@ -6181,7 +6181,7 @@
           <p:cNvPr id="20" name="">
             <a:extLst xmlns:a="http://schemas.openxmlformats.org/drawingml/2006/main">
               <a:ext uri="{FF2B5EF4-FFF2-40B4-BE49-F238E27FC236}">
-                <a16:creationId xmlns:a16="http://schemas.microsoft.com/office/drawing/2014/main" id="{C6D8BC05-B631-4D9A-A09D-B5510DB1E45C}"/>
+                <a16:creationId xmlns:a16="http://schemas.microsoft.com/office/drawing/2014/main" id="{B3F255A7-D91F-4946-B3A3-C281E244246F}"/>
               </a:ext>
             </a:extLst>
           </p:cNvPr>
@@ -6245,7 +6245,7 @@
           <p:cNvPr id="21" name="">
             <a:extLst xmlns:a="http://schemas.openxmlformats.org/drawingml/2006/main">
               <a:ext uri="{FF2B5EF4-FFF2-40B4-BE49-F238E27FC236}">
-                <a16:creationId xmlns:a16="http://schemas.microsoft.com/office/drawing/2014/main" id="{4DD0DAA8-1691-4C59-AC8A-B00FADAB9160}"/>
+                <a16:creationId xmlns:a16="http://schemas.microsoft.com/office/drawing/2014/main" id="{45131DDF-821D-455D-B1AF-F320A2C77E86}"/>
               </a:ext>
             </a:extLst>
           </p:cNvPr>
@@ -6309,7 +6309,7 @@
           <p:cNvPr id="22" name="">
             <a:extLst xmlns:a="http://schemas.openxmlformats.org/drawingml/2006/main">
               <a:ext uri="{FF2B5EF4-FFF2-40B4-BE49-F238E27FC236}">
-                <a16:creationId xmlns:a16="http://schemas.microsoft.com/office/drawing/2014/main" id="{443BC5BE-9F75-4877-B13C-5E2CBF054C06}"/>
+                <a16:creationId xmlns:a16="http://schemas.microsoft.com/office/drawing/2014/main" id="{32BA6FC1-A526-47FF-A8A4-B1DB7583A8E6}"/>
               </a:ext>
             </a:extLst>
           </p:cNvPr>
@@ -6342,7 +6342,7 @@
           <p:cNvPr id="23" name="">
             <a:extLst xmlns:a="http://schemas.openxmlformats.org/drawingml/2006/main">
               <a:ext uri="{FF2B5EF4-FFF2-40B4-BE49-F238E27FC236}">
-                <a16:creationId xmlns:a16="http://schemas.microsoft.com/office/drawing/2014/main" id="{88D518E7-5151-4901-B1DE-A267555962D0}"/>
+                <a16:creationId xmlns:a16="http://schemas.microsoft.com/office/drawing/2014/main" id="{6607839E-3C89-44DD-B784-D9922FD13D31}"/>
               </a:ext>
             </a:extLst>
           </p:cNvPr>
@@ -6406,7 +6406,7 @@
           <p:cNvPr id="24" name="">
             <a:extLst xmlns:a="http://schemas.openxmlformats.org/drawingml/2006/main">
               <a:ext uri="{FF2B5EF4-FFF2-40B4-BE49-F238E27FC236}">
-                <a16:creationId xmlns:a16="http://schemas.microsoft.com/office/drawing/2014/main" id="{41E6161A-6C95-47FB-A139-5E519FF8656F}"/>
+                <a16:creationId xmlns:a16="http://schemas.microsoft.com/office/drawing/2014/main" id="{C86627F2-5087-4512-B348-3FFBB352962E}"/>
               </a:ext>
             </a:extLst>
           </p:cNvPr>
@@ -6468,7 +6468,7 @@
     </p:spTree>
     <p:extLst>
       <p:ext uri="{BB962C8B-B14F-4D97-AF65-F5344CB8AC3E}">
-        <p14:creationId xmlns:p14="http://schemas.microsoft.com/office/powerpoint/2010/main" val="1268318190"/>
+        <p14:creationId xmlns:p14="http://schemas.microsoft.com/office/powerpoint/2010/main" val="253448718"/>
       </p:ext>
     </p:extLst>
   </p:cSld>
@@ -6496,7 +6496,7 @@
           <p:nvPr/>
         </p:nvPicPr>
         <p:blipFill>
-          <a:blip xmlns:r="http://schemas.openxmlformats.org/officeDocument/2006/relationships" xmlns:a="http://schemas.openxmlformats.org/drawingml/2006/main" r:embed="Rff4e7479c475433b"/>
+          <a:blip xmlns:r="http://schemas.openxmlformats.org/officeDocument/2006/relationships" xmlns:a="http://schemas.openxmlformats.org/drawingml/2006/main" r:embed="R4318e5283658473a"/>
           <a:srcRect xmlns:a="http://schemas.openxmlformats.org/drawingml/2006/main" l="0" t="27" r="0" b="27"/>
           <a:stretch xmlns:a="http://schemas.openxmlformats.org/drawingml/2006/main">
             <a:fillRect l="0" t="0" r="0" b="0"/>
@@ -6517,7 +6517,7 @@
           <p:cNvPr id="2" name="">
             <a:extLst xmlns:a="http://schemas.openxmlformats.org/drawingml/2006/main">
               <a:ext uri="{FF2B5EF4-FFF2-40B4-BE49-F238E27FC236}">
-                <a16:creationId xmlns:a16="http://schemas.microsoft.com/office/drawing/2014/main" id="{84146790-18BE-4696-9BB6-1B7AD3A9700F}"/>
+                <a16:creationId xmlns:a16="http://schemas.microsoft.com/office/drawing/2014/main" id="{4BBEA7E2-6B3F-43FA-9433-92F0E13BE14F}"/>
               </a:ext>
             </a:extLst>
           </p:cNvPr>
@@ -6554,7 +6554,7 @@
           <p:cNvPr id="3" name="">
             <a:extLst xmlns:a="http://schemas.openxmlformats.org/drawingml/2006/main">
               <a:ext uri="{FF2B5EF4-FFF2-40B4-BE49-F238E27FC236}">
-                <a16:creationId xmlns:a16="http://schemas.microsoft.com/office/drawing/2014/main" id="{2094F741-25D3-474E-8A1F-ABC4632E13E5}"/>
+                <a16:creationId xmlns:a16="http://schemas.microsoft.com/office/drawing/2014/main" id="{7ED2E186-23C7-4F24-BB85-93D332285C21}"/>
               </a:ext>
             </a:extLst>
           </p:cNvPr>
@@ -6591,7 +6591,7 @@
           <p:cNvPr id="4" name="">
             <a:extLst xmlns:a="http://schemas.openxmlformats.org/drawingml/2006/main">
               <a:ext uri="{FF2B5EF4-FFF2-40B4-BE49-F238E27FC236}">
-                <a16:creationId xmlns:a16="http://schemas.microsoft.com/office/drawing/2014/main" id="{5BB7944C-A76F-4663-9F7D-338FC389C521}"/>
+                <a16:creationId xmlns:a16="http://schemas.microsoft.com/office/drawing/2014/main" id="{192C9397-7EC2-4801-9FFB-2B5A4250B987}"/>
               </a:ext>
             </a:extLst>
           </p:cNvPr>
@@ -6655,7 +6655,7 @@
           <p:cNvPr id="5" name="">
             <a:extLst xmlns:a="http://schemas.openxmlformats.org/drawingml/2006/main">
               <a:ext uri="{FF2B5EF4-FFF2-40B4-BE49-F238E27FC236}">
-                <a16:creationId xmlns:a16="http://schemas.microsoft.com/office/drawing/2014/main" id="{13D08B4D-5533-4036-A50C-785A4AFB47F7}"/>
+                <a16:creationId xmlns:a16="http://schemas.microsoft.com/office/drawing/2014/main" id="{A8669E8C-315B-4032-B9E8-DD423BE69483}"/>
               </a:ext>
             </a:extLst>
           </p:cNvPr>
@@ -6719,7 +6719,7 @@
           <p:cNvPr id="6" name="">
             <a:extLst xmlns:a="http://schemas.openxmlformats.org/drawingml/2006/main">
               <a:ext uri="{FF2B5EF4-FFF2-40B4-BE49-F238E27FC236}">
-                <a16:creationId xmlns:a16="http://schemas.microsoft.com/office/drawing/2014/main" id="{DAEE38D4-B0E3-4718-B51A-32A2F72036E8}"/>
+                <a16:creationId xmlns:a16="http://schemas.microsoft.com/office/drawing/2014/main" id="{2CFA9174-7F0E-4972-8466-25836227B230}"/>
               </a:ext>
             </a:extLst>
           </p:cNvPr>
@@ -6783,7 +6783,7 @@
           <p:cNvPr id="7" name="">
             <a:extLst xmlns:a="http://schemas.openxmlformats.org/drawingml/2006/main">
               <a:ext uri="{FF2B5EF4-FFF2-40B4-BE49-F238E27FC236}">
-                <a16:creationId xmlns:a16="http://schemas.microsoft.com/office/drawing/2014/main" id="{B5665720-BC6C-43BB-B93B-47BB2283E9CB}"/>
+                <a16:creationId xmlns:a16="http://schemas.microsoft.com/office/drawing/2014/main" id="{B9C858AA-5109-4847-84F5-E02312D12C69}"/>
               </a:ext>
             </a:extLst>
           </p:cNvPr>
@@ -6818,7 +6818,7 @@
           <p:cNvPr id="8" name="">
             <a:extLst xmlns:a="http://schemas.openxmlformats.org/drawingml/2006/main">
               <a:ext uri="{FF2B5EF4-FFF2-40B4-BE49-F238E27FC236}">
-                <a16:creationId xmlns:a16="http://schemas.microsoft.com/office/drawing/2014/main" id="{2A35C177-3F23-4CE0-B278-55FA81D447EB}"/>
+                <a16:creationId xmlns:a16="http://schemas.microsoft.com/office/drawing/2014/main" id="{5A9A6044-F009-4AF1-B75E-135BDBC9BA35}"/>
               </a:ext>
             </a:extLst>
           </p:cNvPr>
@@ -6882,7 +6882,7 @@
           <p:cNvPr id="9" name="">
             <a:extLst xmlns:a="http://schemas.openxmlformats.org/drawingml/2006/main">
               <a:ext uri="{FF2B5EF4-FFF2-40B4-BE49-F238E27FC236}">
-                <a16:creationId xmlns:a16="http://schemas.microsoft.com/office/drawing/2014/main" id="{9664E33A-A6F1-46F1-A984-B2FAD63F8E68}"/>
+                <a16:creationId xmlns:a16="http://schemas.microsoft.com/office/drawing/2014/main" id="{D25831C8-D164-4B16-8A7C-BD43DCAC2E53}"/>
               </a:ext>
             </a:extLst>
           </p:cNvPr>
@@ -6946,7 +6946,7 @@
           <p:cNvPr id="10" name="">
             <a:extLst xmlns:a="http://schemas.openxmlformats.org/drawingml/2006/main">
               <a:ext uri="{FF2B5EF4-FFF2-40B4-BE49-F238E27FC236}">
-                <a16:creationId xmlns:a16="http://schemas.microsoft.com/office/drawing/2014/main" id="{1B57069A-6813-4203-950C-5A0D9FD13D4A}"/>
+                <a16:creationId xmlns:a16="http://schemas.microsoft.com/office/drawing/2014/main" id="{50C53170-E3BE-4CD3-A3B4-7C4032D1324C}"/>
               </a:ext>
             </a:extLst>
           </p:cNvPr>
@@ -6979,7 +6979,7 @@
           <p:cNvPr id="11" name="">
             <a:extLst xmlns:a="http://schemas.openxmlformats.org/drawingml/2006/main">
               <a:ext uri="{FF2B5EF4-FFF2-40B4-BE49-F238E27FC236}">
-                <a16:creationId xmlns:a16="http://schemas.microsoft.com/office/drawing/2014/main" id="{70936065-B757-422C-9898-D073CE4AA5F7}"/>
+                <a16:creationId xmlns:a16="http://schemas.microsoft.com/office/drawing/2014/main" id="{38654184-9D86-4004-8175-A63AD3CB717B}"/>
               </a:ext>
             </a:extLst>
           </p:cNvPr>
@@ -7014,7 +7014,7 @@
           <p:cNvPr id="12" name="">
             <a:extLst xmlns:a="http://schemas.openxmlformats.org/drawingml/2006/main">
               <a:ext uri="{FF2B5EF4-FFF2-40B4-BE49-F238E27FC236}">
-                <a16:creationId xmlns:a16="http://schemas.microsoft.com/office/drawing/2014/main" id="{3316C418-E099-4FB7-BEEB-7CE283452D2C}"/>
+                <a16:creationId xmlns:a16="http://schemas.microsoft.com/office/drawing/2014/main" id="{2B94F53A-CE3E-41C5-889C-1D0690DCA543}"/>
               </a:ext>
             </a:extLst>
           </p:cNvPr>
@@ -7078,7 +7078,7 @@
           <p:cNvPr id="13" name="">
             <a:extLst xmlns:a="http://schemas.openxmlformats.org/drawingml/2006/main">
               <a:ext uri="{FF2B5EF4-FFF2-40B4-BE49-F238E27FC236}">
-                <a16:creationId xmlns:a16="http://schemas.microsoft.com/office/drawing/2014/main" id="{FC9F432C-80DB-4725-A18F-44798D0AB16C}"/>
+                <a16:creationId xmlns:a16="http://schemas.microsoft.com/office/drawing/2014/main" id="{525D0F51-DCF0-4F4C-B57C-AF831C4EDADC}"/>
               </a:ext>
             </a:extLst>
           </p:cNvPr>
@@ -7142,7 +7142,7 @@
           <p:cNvPr id="14" name="">
             <a:extLst xmlns:a="http://schemas.openxmlformats.org/drawingml/2006/main">
               <a:ext uri="{FF2B5EF4-FFF2-40B4-BE49-F238E27FC236}">
-                <a16:creationId xmlns:a16="http://schemas.microsoft.com/office/drawing/2014/main" id="{513DA59E-AC89-4D14-A2C6-99475F121E2D}"/>
+                <a16:creationId xmlns:a16="http://schemas.microsoft.com/office/drawing/2014/main" id="{9F2AF909-8FC4-45BA-91DC-9A221F411F50}"/>
               </a:ext>
             </a:extLst>
           </p:cNvPr>
@@ -7175,7 +7175,7 @@
           <p:cNvPr id="15" name="">
             <a:extLst xmlns:a="http://schemas.openxmlformats.org/drawingml/2006/main">
               <a:ext uri="{FF2B5EF4-FFF2-40B4-BE49-F238E27FC236}">
-                <a16:creationId xmlns:a16="http://schemas.microsoft.com/office/drawing/2014/main" id="{F6C8E39C-CD60-4868-8129-E3C730A2052B}"/>
+                <a16:creationId xmlns:a16="http://schemas.microsoft.com/office/drawing/2014/main" id="{B322AB35-BC8A-4452-9C5C-876DBE602A97}"/>
               </a:ext>
             </a:extLst>
           </p:cNvPr>
@@ -7210,7 +7210,7 @@
           <p:cNvPr id="16" name="">
             <a:extLst xmlns:a="http://schemas.openxmlformats.org/drawingml/2006/main">
               <a:ext uri="{FF2B5EF4-FFF2-40B4-BE49-F238E27FC236}">
-                <a16:creationId xmlns:a16="http://schemas.microsoft.com/office/drawing/2014/main" id="{7A0918CF-B3B8-4631-A599-3F6B1C794567}"/>
+                <a16:creationId xmlns:a16="http://schemas.microsoft.com/office/drawing/2014/main" id="{CBA065A7-F099-4F27-B64D-45FD801C8B26}"/>
               </a:ext>
             </a:extLst>
           </p:cNvPr>
@@ -7274,7 +7274,7 @@
           <p:cNvPr id="17" name="">
             <a:extLst xmlns:a="http://schemas.openxmlformats.org/drawingml/2006/main">
               <a:ext uri="{FF2B5EF4-FFF2-40B4-BE49-F238E27FC236}">
-                <a16:creationId xmlns:a16="http://schemas.microsoft.com/office/drawing/2014/main" id="{FFFD6FDA-C4C5-42BB-BA1D-3F60E63B7E78}"/>
+                <a16:creationId xmlns:a16="http://schemas.microsoft.com/office/drawing/2014/main" id="{F2EBE1AD-018B-4073-9548-171A81C10A21}"/>
               </a:ext>
             </a:extLst>
           </p:cNvPr>
@@ -7338,7 +7338,7 @@
           <p:cNvPr id="18" name="">
             <a:extLst xmlns:a="http://schemas.openxmlformats.org/drawingml/2006/main">
               <a:ext uri="{FF2B5EF4-FFF2-40B4-BE49-F238E27FC236}">
-                <a16:creationId xmlns:a16="http://schemas.microsoft.com/office/drawing/2014/main" id="{9E80829A-63EB-422F-B4EE-3A3F1C2557A6}"/>
+                <a16:creationId xmlns:a16="http://schemas.microsoft.com/office/drawing/2014/main" id="{A3290D69-F5E1-4BA1-8505-08E7417EAD77}"/>
               </a:ext>
             </a:extLst>
           </p:cNvPr>
@@ -7402,7 +7402,7 @@
           <p:cNvPr id="19" name="">
             <a:extLst xmlns:a="http://schemas.openxmlformats.org/drawingml/2006/main">
               <a:ext uri="{FF2B5EF4-FFF2-40B4-BE49-F238E27FC236}">
-                <a16:creationId xmlns:a16="http://schemas.microsoft.com/office/drawing/2014/main" id="{0103E88A-1B07-4530-9C03-1BF9E04FA0BC}"/>
+                <a16:creationId xmlns:a16="http://schemas.microsoft.com/office/drawing/2014/main" id="{6E39A189-D8AF-4AD9-BD6A-F93F03027233}"/>
               </a:ext>
             </a:extLst>
           </p:cNvPr>
@@ -7435,7 +7435,7 @@
           <p:cNvPr id="20" name="">
             <a:extLst xmlns:a="http://schemas.openxmlformats.org/drawingml/2006/main">
               <a:ext uri="{FF2B5EF4-FFF2-40B4-BE49-F238E27FC236}">
-                <a16:creationId xmlns:a16="http://schemas.microsoft.com/office/drawing/2014/main" id="{509F4EFD-B923-4976-9D9D-A61D0F79A14D}"/>
+                <a16:creationId xmlns:a16="http://schemas.microsoft.com/office/drawing/2014/main" id="{A23E2901-17AE-49B4-998B-32E4BFD34588}"/>
               </a:ext>
             </a:extLst>
           </p:cNvPr>
@@ -7499,7 +7499,7 @@
           <p:cNvPr id="21" name="">
             <a:extLst xmlns:a="http://schemas.openxmlformats.org/drawingml/2006/main">
               <a:ext uri="{FF2B5EF4-FFF2-40B4-BE49-F238E27FC236}">
-                <a16:creationId xmlns:a16="http://schemas.microsoft.com/office/drawing/2014/main" id="{ADCBB52F-05A7-494A-AF1B-54D6BF2D6B1B}"/>
+                <a16:creationId xmlns:a16="http://schemas.microsoft.com/office/drawing/2014/main" id="{0AA8C8E1-7184-4A18-843D-3C4F7F4D3972}"/>
               </a:ext>
             </a:extLst>
           </p:cNvPr>
@@ -7561,7 +7561,7 @@
     </p:spTree>
     <p:extLst>
       <p:ext uri="{BB962C8B-B14F-4D97-AF65-F5344CB8AC3E}">
-        <p14:creationId xmlns:p14="http://schemas.microsoft.com/office/powerpoint/2010/main" val="1080261647"/>
+        <p14:creationId xmlns:p14="http://schemas.microsoft.com/office/powerpoint/2010/main" val="217937463"/>
       </p:ext>
     </p:extLst>
   </p:cSld>
@@ -7589,7 +7589,7 @@
           <p:nvPr/>
         </p:nvPicPr>
         <p:blipFill>
-          <a:blip xmlns:r="http://schemas.openxmlformats.org/officeDocument/2006/relationships" xmlns:a="http://schemas.openxmlformats.org/drawingml/2006/main" r:embed="Rff0193b9bffd4577"/>
+          <a:blip xmlns:r="http://schemas.openxmlformats.org/officeDocument/2006/relationships" xmlns:a="http://schemas.openxmlformats.org/drawingml/2006/main" r:embed="Re98c9cb7ddae46af"/>
           <a:srcRect xmlns:a="http://schemas.openxmlformats.org/drawingml/2006/main" l="0" t="27" r="0" b="27"/>
           <a:stretch xmlns:a="http://schemas.openxmlformats.org/drawingml/2006/main">
             <a:fillRect l="0" t="0" r="0" b="0"/>
@@ -7610,7 +7610,7 @@
           <p:cNvPr id="2" name="">
             <a:extLst xmlns:a="http://schemas.openxmlformats.org/drawingml/2006/main">
               <a:ext uri="{FF2B5EF4-FFF2-40B4-BE49-F238E27FC236}">
-                <a16:creationId xmlns:a16="http://schemas.microsoft.com/office/drawing/2014/main" id="{B56D48F3-8D76-4D6E-AF4C-013A3E90945D}"/>
+                <a16:creationId xmlns:a16="http://schemas.microsoft.com/office/drawing/2014/main" id="{FC1691F6-1FA1-460A-929D-1BAA4B617F42}"/>
               </a:ext>
             </a:extLst>
           </p:cNvPr>
@@ -7647,7 +7647,7 @@
           <p:cNvPr id="3" name="">
             <a:extLst xmlns:a="http://schemas.openxmlformats.org/drawingml/2006/main">
               <a:ext uri="{FF2B5EF4-FFF2-40B4-BE49-F238E27FC236}">
-                <a16:creationId xmlns:a16="http://schemas.microsoft.com/office/drawing/2014/main" id="{248766ED-BCE1-417A-984C-10CBA60B066F}"/>
+                <a16:creationId xmlns:a16="http://schemas.microsoft.com/office/drawing/2014/main" id="{9037F00A-11A0-4045-B3E5-F54D17F601E5}"/>
               </a:ext>
             </a:extLst>
           </p:cNvPr>
@@ -7684,7 +7684,7 @@
           <p:cNvPr id="4" name="">
             <a:extLst xmlns:a="http://schemas.openxmlformats.org/drawingml/2006/main">
               <a:ext uri="{FF2B5EF4-FFF2-40B4-BE49-F238E27FC236}">
-                <a16:creationId xmlns:a16="http://schemas.microsoft.com/office/drawing/2014/main" id="{FEEA43E3-C70C-4BB0-86DC-960D5D762287}"/>
+                <a16:creationId xmlns:a16="http://schemas.microsoft.com/office/drawing/2014/main" id="{817C2FF6-808E-4D3A-BD03-A1A8E2F0990B}"/>
               </a:ext>
             </a:extLst>
           </p:cNvPr>
@@ -7748,7 +7748,7 @@
           <p:cNvPr id="5" name="">
             <a:extLst xmlns:a="http://schemas.openxmlformats.org/drawingml/2006/main">
               <a:ext uri="{FF2B5EF4-FFF2-40B4-BE49-F238E27FC236}">
-                <a16:creationId xmlns:a16="http://schemas.microsoft.com/office/drawing/2014/main" id="{F250167A-C61C-4F86-8D75-1D3E28B8572A}"/>
+                <a16:creationId xmlns:a16="http://schemas.microsoft.com/office/drawing/2014/main" id="{720980F4-52E9-4576-84AB-730F2B6DDA14}"/>
               </a:ext>
             </a:extLst>
           </p:cNvPr>
@@ -7812,7 +7812,7 @@
           <p:cNvPr id="6" name="">
             <a:extLst xmlns:a="http://schemas.openxmlformats.org/drawingml/2006/main">
               <a:ext uri="{FF2B5EF4-FFF2-40B4-BE49-F238E27FC236}">
-                <a16:creationId xmlns:a16="http://schemas.microsoft.com/office/drawing/2014/main" id="{F128E970-BC9C-46F2-A9DB-F5CD0C3D8021}"/>
+                <a16:creationId xmlns:a16="http://schemas.microsoft.com/office/drawing/2014/main" id="{7CF7D068-0672-4EAC-8051-39DF2C0AD9C3}"/>
               </a:ext>
             </a:extLst>
           </p:cNvPr>
@@ -7876,7 +7876,7 @@
           <p:cNvPr id="7" name="">
             <a:extLst xmlns:a="http://schemas.openxmlformats.org/drawingml/2006/main">
               <a:ext uri="{FF2B5EF4-FFF2-40B4-BE49-F238E27FC236}">
-                <a16:creationId xmlns:a16="http://schemas.microsoft.com/office/drawing/2014/main" id="{FBD013B6-C0A2-48C3-A74A-A4E64BE46EF1}"/>
+                <a16:creationId xmlns:a16="http://schemas.microsoft.com/office/drawing/2014/main" id="{4B3F43B2-04B1-4E89-A25E-19F420FB5FEA}"/>
               </a:ext>
             </a:extLst>
           </p:cNvPr>
@@ -7911,7 +7911,7 @@
           <p:cNvPr id="8" name="">
             <a:extLst xmlns:a="http://schemas.openxmlformats.org/drawingml/2006/main">
               <a:ext uri="{FF2B5EF4-FFF2-40B4-BE49-F238E27FC236}">
-                <a16:creationId xmlns:a16="http://schemas.microsoft.com/office/drawing/2014/main" id="{CC7500D1-04C4-41AA-BC4C-23897F708CBD}"/>
+                <a16:creationId xmlns:a16="http://schemas.microsoft.com/office/drawing/2014/main" id="{C714246F-669E-450A-9681-5241B82E874B}"/>
               </a:ext>
             </a:extLst>
           </p:cNvPr>
@@ -7975,7 +7975,7 @@
           <p:cNvPr id="9" name="">
             <a:extLst xmlns:a="http://schemas.openxmlformats.org/drawingml/2006/main">
               <a:ext uri="{FF2B5EF4-FFF2-40B4-BE49-F238E27FC236}">
-                <a16:creationId xmlns:a16="http://schemas.microsoft.com/office/drawing/2014/main" id="{07B90AF6-91AE-421C-BB35-A9A70ACD48C5}"/>
+                <a16:creationId xmlns:a16="http://schemas.microsoft.com/office/drawing/2014/main" id="{B0C59B88-88E2-4B51-A78C-4F025B2C64BA}"/>
               </a:ext>
             </a:extLst>
           </p:cNvPr>
@@ -8039,7 +8039,7 @@
           <p:cNvPr id="10" name="">
             <a:extLst xmlns:a="http://schemas.openxmlformats.org/drawingml/2006/main">
               <a:ext uri="{FF2B5EF4-FFF2-40B4-BE49-F238E27FC236}">
-                <a16:creationId xmlns:a16="http://schemas.microsoft.com/office/drawing/2014/main" id="{7F7FAA18-C3C0-4996-AA64-764FA14A615E}"/>
+                <a16:creationId xmlns:a16="http://schemas.microsoft.com/office/drawing/2014/main" id="{FEC24179-E05C-4EA8-A2BB-76B885D026B1}"/>
               </a:ext>
             </a:extLst>
           </p:cNvPr>
@@ -8074,7 +8074,7 @@
           <p:cNvPr id="11" name="">
             <a:extLst xmlns:a="http://schemas.openxmlformats.org/drawingml/2006/main">
               <a:ext uri="{FF2B5EF4-FFF2-40B4-BE49-F238E27FC236}">
-                <a16:creationId xmlns:a16="http://schemas.microsoft.com/office/drawing/2014/main" id="{8A4B4DD0-E971-40F1-A445-2B9C0E8FC857}"/>
+                <a16:creationId xmlns:a16="http://schemas.microsoft.com/office/drawing/2014/main" id="{ABA5BB3E-E80A-4FB6-A0D1-41D235FCFC93}"/>
               </a:ext>
             </a:extLst>
           </p:cNvPr>
@@ -8138,7 +8138,7 @@
           <p:cNvPr id="12" name="">
             <a:extLst xmlns:a="http://schemas.openxmlformats.org/drawingml/2006/main">
               <a:ext uri="{FF2B5EF4-FFF2-40B4-BE49-F238E27FC236}">
-                <a16:creationId xmlns:a16="http://schemas.microsoft.com/office/drawing/2014/main" id="{BD9609F2-26D6-4385-95CC-258FD6266047}"/>
+                <a16:creationId xmlns:a16="http://schemas.microsoft.com/office/drawing/2014/main" id="{CDF55F57-A32D-4EC9-985C-2E43E071D947}"/>
               </a:ext>
             </a:extLst>
           </p:cNvPr>
@@ -8202,7 +8202,7 @@
           <p:cNvPr id="13" name="">
             <a:extLst xmlns:a="http://schemas.openxmlformats.org/drawingml/2006/main">
               <a:ext uri="{FF2B5EF4-FFF2-40B4-BE49-F238E27FC236}">
-                <a16:creationId xmlns:a16="http://schemas.microsoft.com/office/drawing/2014/main" id="{E0EC5703-88B4-46FA-B427-B60EDD092DA3}"/>
+                <a16:creationId xmlns:a16="http://schemas.microsoft.com/office/drawing/2014/main" id="{4A610AA6-20A9-4478-B464-202104DA7A31}"/>
               </a:ext>
             </a:extLst>
           </p:cNvPr>
@@ -8237,7 +8237,7 @@
           <p:cNvPr id="14" name="">
             <a:extLst xmlns:a="http://schemas.openxmlformats.org/drawingml/2006/main">
               <a:ext uri="{FF2B5EF4-FFF2-40B4-BE49-F238E27FC236}">
-                <a16:creationId xmlns:a16="http://schemas.microsoft.com/office/drawing/2014/main" id="{ED556214-3DB4-4822-9CBA-F95D6CA19107}"/>
+                <a16:creationId xmlns:a16="http://schemas.microsoft.com/office/drawing/2014/main" id="{6F172D46-998A-4DBA-84C5-F66824534ABB}"/>
               </a:ext>
             </a:extLst>
           </p:cNvPr>
@@ -8301,7 +8301,7 @@
           <p:cNvPr id="15" name="">
             <a:extLst xmlns:a="http://schemas.openxmlformats.org/drawingml/2006/main">
               <a:ext uri="{FF2B5EF4-FFF2-40B4-BE49-F238E27FC236}">
-                <a16:creationId xmlns:a16="http://schemas.microsoft.com/office/drawing/2014/main" id="{53A29C67-AB35-429B-81FF-7866295C0196}"/>
+                <a16:creationId xmlns:a16="http://schemas.microsoft.com/office/drawing/2014/main" id="{AA8E37C6-313F-4922-A1D6-8612466D9362}"/>
               </a:ext>
             </a:extLst>
           </p:cNvPr>
@@ -8365,7 +8365,7 @@
           <p:cNvPr id="16" name="">
             <a:extLst xmlns:a="http://schemas.openxmlformats.org/drawingml/2006/main">
               <a:ext uri="{FF2B5EF4-FFF2-40B4-BE49-F238E27FC236}">
-                <a16:creationId xmlns:a16="http://schemas.microsoft.com/office/drawing/2014/main" id="{8CDE64FE-FFA2-4E4E-AC6F-FE5B9F19EC12}"/>
+                <a16:creationId xmlns:a16="http://schemas.microsoft.com/office/drawing/2014/main" id="{C1CB6BD8-0A5F-4672-9D9F-2DA8C1B556CD}"/>
               </a:ext>
             </a:extLst>
           </p:cNvPr>
@@ -8400,7 +8400,7 @@
           <p:cNvPr id="17" name="">
             <a:extLst xmlns:a="http://schemas.openxmlformats.org/drawingml/2006/main">
               <a:ext uri="{FF2B5EF4-FFF2-40B4-BE49-F238E27FC236}">
-                <a16:creationId xmlns:a16="http://schemas.microsoft.com/office/drawing/2014/main" id="{40ABE72C-5136-4A23-8B82-037A97314D9D}"/>
+                <a16:creationId xmlns:a16="http://schemas.microsoft.com/office/drawing/2014/main" id="{D0DA6552-3905-4D06-AB5D-938929EBAC92}"/>
               </a:ext>
             </a:extLst>
           </p:cNvPr>
@@ -8464,7 +8464,7 @@
           <p:cNvPr id="18" name="">
             <a:extLst xmlns:a="http://schemas.openxmlformats.org/drawingml/2006/main">
               <a:ext uri="{FF2B5EF4-FFF2-40B4-BE49-F238E27FC236}">
-                <a16:creationId xmlns:a16="http://schemas.microsoft.com/office/drawing/2014/main" id="{2ABE8738-535A-45DA-8FD6-CD5D19972733}"/>
+                <a16:creationId xmlns:a16="http://schemas.microsoft.com/office/drawing/2014/main" id="{DA710D8B-695E-4234-96C9-7F40F46CF350}"/>
               </a:ext>
             </a:extLst>
           </p:cNvPr>
@@ -8528,7 +8528,7 @@
           <p:cNvPr id="19" name="">
             <a:extLst xmlns:a="http://schemas.openxmlformats.org/drawingml/2006/main">
               <a:ext uri="{FF2B5EF4-FFF2-40B4-BE49-F238E27FC236}">
-                <a16:creationId xmlns:a16="http://schemas.microsoft.com/office/drawing/2014/main" id="{6EC06660-D6A4-49B5-8306-1123815BCF5E}"/>
+                <a16:creationId xmlns:a16="http://schemas.microsoft.com/office/drawing/2014/main" id="{3E023C37-B0E2-4FE3-812C-8591956442A0}"/>
               </a:ext>
             </a:extLst>
           </p:cNvPr>
@@ -8592,7 +8592,7 @@
           <p:cNvPr id="20" name="">
             <a:extLst xmlns:a="http://schemas.openxmlformats.org/drawingml/2006/main">
               <a:ext uri="{FF2B5EF4-FFF2-40B4-BE49-F238E27FC236}">
-                <a16:creationId xmlns:a16="http://schemas.microsoft.com/office/drawing/2014/main" id="{A2085EFC-449D-41B1-87EF-AE16932E0BAB}"/>
+                <a16:creationId xmlns:a16="http://schemas.microsoft.com/office/drawing/2014/main" id="{9EFF4158-B7C9-4987-8C04-0BBAF80E446A}"/>
               </a:ext>
             </a:extLst>
           </p:cNvPr>
@@ -8625,7 +8625,7 @@
           <p:cNvPr id="21" name="">
             <a:extLst xmlns:a="http://schemas.openxmlformats.org/drawingml/2006/main">
               <a:ext uri="{FF2B5EF4-FFF2-40B4-BE49-F238E27FC236}">
-                <a16:creationId xmlns:a16="http://schemas.microsoft.com/office/drawing/2014/main" id="{ADDF3ACD-87D2-4B6B-8C56-882B8F340283}"/>
+                <a16:creationId xmlns:a16="http://schemas.microsoft.com/office/drawing/2014/main" id="{E33902B9-685B-465E-B264-1D3F50051365}"/>
               </a:ext>
             </a:extLst>
           </p:cNvPr>
@@ -8658,7 +8658,7 @@
           <p:cNvPr id="22" name="">
             <a:extLst xmlns:a="http://schemas.openxmlformats.org/drawingml/2006/main">
               <a:ext uri="{FF2B5EF4-FFF2-40B4-BE49-F238E27FC236}">
-                <a16:creationId xmlns:a16="http://schemas.microsoft.com/office/drawing/2014/main" id="{5F7B2A25-98CA-4855-B061-195A55A66AD3}"/>
+                <a16:creationId xmlns:a16="http://schemas.microsoft.com/office/drawing/2014/main" id="{F43B5D79-7052-45BE-ADDE-4DBD1C12B2D7}"/>
               </a:ext>
             </a:extLst>
           </p:cNvPr>
@@ -8722,7 +8722,7 @@
           <p:cNvPr id="23" name="">
             <a:extLst xmlns:a="http://schemas.openxmlformats.org/drawingml/2006/main">
               <a:ext uri="{FF2B5EF4-FFF2-40B4-BE49-F238E27FC236}">
-                <a16:creationId xmlns:a16="http://schemas.microsoft.com/office/drawing/2014/main" id="{5836AE24-3DC6-4DA1-A323-69ACE3204F28}"/>
+                <a16:creationId xmlns:a16="http://schemas.microsoft.com/office/drawing/2014/main" id="{9B506297-6852-4A87-9C5F-CA5606064FB4}"/>
               </a:ext>
             </a:extLst>
           </p:cNvPr>
@@ -8755,7 +8755,7 @@
           <p:cNvPr id="24" name="">
             <a:extLst xmlns:a="http://schemas.openxmlformats.org/drawingml/2006/main">
               <a:ext uri="{FF2B5EF4-FFF2-40B4-BE49-F238E27FC236}">
-                <a16:creationId xmlns:a16="http://schemas.microsoft.com/office/drawing/2014/main" id="{888744DC-E433-42C2-83F9-9733DB5AB2B0}"/>
+                <a16:creationId xmlns:a16="http://schemas.microsoft.com/office/drawing/2014/main" id="{512F593A-8D2D-4BDA-8E99-CCF3EB5CCCC3}"/>
               </a:ext>
             </a:extLst>
           </p:cNvPr>
@@ -8788,7 +8788,7 @@
           <p:cNvPr id="25" name="">
             <a:extLst xmlns:a="http://schemas.openxmlformats.org/drawingml/2006/main">
               <a:ext uri="{FF2B5EF4-FFF2-40B4-BE49-F238E27FC236}">
-                <a16:creationId xmlns:a16="http://schemas.microsoft.com/office/drawing/2014/main" id="{ECEAE800-912D-449D-86DB-8A31409ED311}"/>
+                <a16:creationId xmlns:a16="http://schemas.microsoft.com/office/drawing/2014/main" id="{87B647FA-BB52-47E0-88CB-57BD21F4FCBD}"/>
               </a:ext>
             </a:extLst>
           </p:cNvPr>
@@ -8852,7 +8852,7 @@
           <p:cNvPr id="26" name="">
             <a:extLst xmlns:a="http://schemas.openxmlformats.org/drawingml/2006/main">
               <a:ext uri="{FF2B5EF4-FFF2-40B4-BE49-F238E27FC236}">
-                <a16:creationId xmlns:a16="http://schemas.microsoft.com/office/drawing/2014/main" id="{40C80292-3E61-45D0-9AC1-61729BF9D7BF}"/>
+                <a16:creationId xmlns:a16="http://schemas.microsoft.com/office/drawing/2014/main" id="{C0A21B74-4B8E-4777-A6B9-46AAB35090C3}"/>
               </a:ext>
             </a:extLst>
           </p:cNvPr>
@@ -8885,7 +8885,7 @@
           <p:cNvPr id="27" name="">
             <a:extLst xmlns:a="http://schemas.openxmlformats.org/drawingml/2006/main">
               <a:ext uri="{FF2B5EF4-FFF2-40B4-BE49-F238E27FC236}">
-                <a16:creationId xmlns:a16="http://schemas.microsoft.com/office/drawing/2014/main" id="{3E73490E-C3CC-49EF-8726-90624C731BB0}"/>
+                <a16:creationId xmlns:a16="http://schemas.microsoft.com/office/drawing/2014/main" id="{E29853D6-4B88-42AC-B411-CE40286495CE}"/>
               </a:ext>
             </a:extLst>
           </p:cNvPr>
@@ -8918,7 +8918,7 @@
           <p:cNvPr id="28" name="">
             <a:extLst xmlns:a="http://schemas.openxmlformats.org/drawingml/2006/main">
               <a:ext uri="{FF2B5EF4-FFF2-40B4-BE49-F238E27FC236}">
-                <a16:creationId xmlns:a16="http://schemas.microsoft.com/office/drawing/2014/main" id="{43F858B8-0377-4CCC-B217-1B6E8C748EE7}"/>
+                <a16:creationId xmlns:a16="http://schemas.microsoft.com/office/drawing/2014/main" id="{E39859A8-A7AE-48CA-BD1B-6574B70C94EA}"/>
               </a:ext>
             </a:extLst>
           </p:cNvPr>
@@ -8982,7 +8982,7 @@
           <p:cNvPr id="29" name="">
             <a:extLst xmlns:a="http://schemas.openxmlformats.org/drawingml/2006/main">
               <a:ext uri="{FF2B5EF4-FFF2-40B4-BE49-F238E27FC236}">
-                <a16:creationId xmlns:a16="http://schemas.microsoft.com/office/drawing/2014/main" id="{C96119FE-6660-49B1-B994-3029D6B37156}"/>
+                <a16:creationId xmlns:a16="http://schemas.microsoft.com/office/drawing/2014/main" id="{37C58CF5-3D85-4A12-9DCB-5DDBE5B47B9C}"/>
               </a:ext>
             </a:extLst>
           </p:cNvPr>
@@ -9015,7 +9015,7 @@
           <p:cNvPr id="30" name="">
             <a:extLst xmlns:a="http://schemas.openxmlformats.org/drawingml/2006/main">
               <a:ext uri="{FF2B5EF4-FFF2-40B4-BE49-F238E27FC236}">
-                <a16:creationId xmlns:a16="http://schemas.microsoft.com/office/drawing/2014/main" id="{12315FFC-3E07-4CF5-9E63-32D2A10BEB15}"/>
+                <a16:creationId xmlns:a16="http://schemas.microsoft.com/office/drawing/2014/main" id="{D712F35C-7789-4DCE-9F17-AC8950A615D4}"/>
               </a:ext>
             </a:extLst>
           </p:cNvPr>
@@ -9079,7 +9079,7 @@
           <p:cNvPr id="31" name="">
             <a:extLst xmlns:a="http://schemas.openxmlformats.org/drawingml/2006/main">
               <a:ext uri="{FF2B5EF4-FFF2-40B4-BE49-F238E27FC236}">
-                <a16:creationId xmlns:a16="http://schemas.microsoft.com/office/drawing/2014/main" id="{D1A39DC7-03D6-4751-BE13-3A1F7DF9E14F}"/>
+                <a16:creationId xmlns:a16="http://schemas.microsoft.com/office/drawing/2014/main" id="{7CB6A78E-70FB-4D1A-82C2-360A818A59AC}"/>
               </a:ext>
             </a:extLst>
           </p:cNvPr>
@@ -9141,7 +9141,7 @@
     </p:spTree>
     <p:extLst>
       <p:ext uri="{BB962C8B-B14F-4D97-AF65-F5344CB8AC3E}">
-        <p14:creationId xmlns:p14="http://schemas.microsoft.com/office/powerpoint/2010/main" val="1256574371"/>
+        <p14:creationId xmlns:p14="http://schemas.microsoft.com/office/powerpoint/2010/main" val="1316377506"/>
       </p:ext>
     </p:extLst>
   </p:cSld>
@@ -9169,7 +9169,7 @@
           <p:nvPr/>
         </p:nvPicPr>
         <p:blipFill>
-          <a:blip xmlns:r="http://schemas.openxmlformats.org/officeDocument/2006/relationships" xmlns:a="http://schemas.openxmlformats.org/drawingml/2006/main" r:embed="R50d40108562c4479"/>
+          <a:blip xmlns:r="http://schemas.openxmlformats.org/officeDocument/2006/relationships" xmlns:a="http://schemas.openxmlformats.org/drawingml/2006/main" r:embed="R1f76bdfecb5b4725"/>
           <a:srcRect xmlns:a="http://schemas.openxmlformats.org/drawingml/2006/main" l="0" t="7813" r="0" b="7813"/>
           <a:stretch xmlns:a="http://schemas.openxmlformats.org/drawingml/2006/main">
             <a:fillRect l="0" t="0" r="0" b="0"/>
@@ -9190,7 +9190,7 @@
           <p:cNvPr id="2" name="">
             <a:extLst xmlns:a="http://schemas.openxmlformats.org/drawingml/2006/main">
               <a:ext uri="{FF2B5EF4-FFF2-40B4-BE49-F238E27FC236}">
-                <a16:creationId xmlns:a16="http://schemas.microsoft.com/office/drawing/2014/main" id="{572E8298-03BC-44D4-920C-ABAC36F28A78}"/>
+                <a16:creationId xmlns:a16="http://schemas.microsoft.com/office/drawing/2014/main" id="{6911B456-C345-4774-B56F-D1BB9D13775E}"/>
               </a:ext>
             </a:extLst>
           </p:cNvPr>
@@ -9227,7 +9227,7 @@
           <p:cNvPr id="3" name="">
             <a:extLst xmlns:a="http://schemas.openxmlformats.org/drawingml/2006/main">
               <a:ext uri="{FF2B5EF4-FFF2-40B4-BE49-F238E27FC236}">
-                <a16:creationId xmlns:a16="http://schemas.microsoft.com/office/drawing/2014/main" id="{D6459F03-E012-410F-8CA6-1DB3CE237290}"/>
+                <a16:creationId xmlns:a16="http://schemas.microsoft.com/office/drawing/2014/main" id="{9CF8CFC1-FF4C-4B68-B418-65536A4A5D6C}"/>
               </a:ext>
             </a:extLst>
           </p:cNvPr>
@@ -9264,7 +9264,7 @@
           <p:cNvPr id="4" name="">
             <a:extLst xmlns:a="http://schemas.openxmlformats.org/drawingml/2006/main">
               <a:ext uri="{FF2B5EF4-FFF2-40B4-BE49-F238E27FC236}">
-                <a16:creationId xmlns:a16="http://schemas.microsoft.com/office/drawing/2014/main" id="{BCF3DF95-81D9-4D78-A864-C559EBC24D2C}"/>
+                <a16:creationId xmlns:a16="http://schemas.microsoft.com/office/drawing/2014/main" id="{29103135-DADA-4DD4-B0B9-3AEDCC573083}"/>
               </a:ext>
             </a:extLst>
           </p:cNvPr>
@@ -9328,7 +9328,7 @@
           <p:cNvPr id="5" name="">
             <a:extLst xmlns:a="http://schemas.openxmlformats.org/drawingml/2006/main">
               <a:ext uri="{FF2B5EF4-FFF2-40B4-BE49-F238E27FC236}">
-                <a16:creationId xmlns:a16="http://schemas.microsoft.com/office/drawing/2014/main" id="{BB5B4F34-B384-4714-A3F0-4818E6A0B763}"/>
+                <a16:creationId xmlns:a16="http://schemas.microsoft.com/office/drawing/2014/main" id="{27D621BB-9FBD-4345-98E5-423FD6A3694C}"/>
               </a:ext>
             </a:extLst>
           </p:cNvPr>
@@ -9392,7 +9392,7 @@
           <p:cNvPr id="6" name="">
             <a:extLst xmlns:a="http://schemas.openxmlformats.org/drawingml/2006/main">
               <a:ext uri="{FF2B5EF4-FFF2-40B4-BE49-F238E27FC236}">
-                <a16:creationId xmlns:a16="http://schemas.microsoft.com/office/drawing/2014/main" id="{B912F4D4-1C73-48F9-BBBC-5973778847C2}"/>
+                <a16:creationId xmlns:a16="http://schemas.microsoft.com/office/drawing/2014/main" id="{21F996A2-9B20-4C68-92A4-F927E29D1454}"/>
               </a:ext>
             </a:extLst>
           </p:cNvPr>
@@ -9456,7 +9456,7 @@
           <p:cNvPr id="7" name="">
             <a:extLst xmlns:a="http://schemas.openxmlformats.org/drawingml/2006/main">
               <a:ext uri="{FF2B5EF4-FFF2-40B4-BE49-F238E27FC236}">
-                <a16:creationId xmlns:a16="http://schemas.microsoft.com/office/drawing/2014/main" id="{77F1CEFE-7DA5-4037-8BB1-A690A19DE76B}"/>
+                <a16:creationId xmlns:a16="http://schemas.microsoft.com/office/drawing/2014/main" id="{E080A98C-7BF4-4AE6-9D36-C70F9ED49FC7}"/>
               </a:ext>
             </a:extLst>
           </p:cNvPr>
@@ -9491,7 +9491,7 @@
           <p:cNvPr id="8" name="">
             <a:extLst xmlns:a="http://schemas.openxmlformats.org/drawingml/2006/main">
               <a:ext uri="{FF2B5EF4-FFF2-40B4-BE49-F238E27FC236}">
-                <a16:creationId xmlns:a16="http://schemas.microsoft.com/office/drawing/2014/main" id="{CAB0F00F-91DA-4740-BFD8-750155980B36}"/>
+                <a16:creationId xmlns:a16="http://schemas.microsoft.com/office/drawing/2014/main" id="{ABE1E036-27EA-4D8C-A0DA-F8FB61ACDFE1}"/>
               </a:ext>
             </a:extLst>
           </p:cNvPr>
@@ -9555,7 +9555,7 @@
           <p:cNvPr id="9" name="">
             <a:extLst xmlns:a="http://schemas.openxmlformats.org/drawingml/2006/main">
               <a:ext uri="{FF2B5EF4-FFF2-40B4-BE49-F238E27FC236}">
-                <a16:creationId xmlns:a16="http://schemas.microsoft.com/office/drawing/2014/main" id="{0951BE7A-B52E-4B7C-AD39-4C39449782AE}"/>
+                <a16:creationId xmlns:a16="http://schemas.microsoft.com/office/drawing/2014/main" id="{F594526F-2DD2-4F86-809E-9798DD4E9645}"/>
               </a:ext>
             </a:extLst>
           </p:cNvPr>
@@ -9619,7 +9619,7 @@
           <p:cNvPr id="10" name="">
             <a:extLst xmlns:a="http://schemas.openxmlformats.org/drawingml/2006/main">
               <a:ext uri="{FF2B5EF4-FFF2-40B4-BE49-F238E27FC236}">
-                <a16:creationId xmlns:a16="http://schemas.microsoft.com/office/drawing/2014/main" id="{E4A20800-7FE2-4F61-B519-1566F7E4896D}"/>
+                <a16:creationId xmlns:a16="http://schemas.microsoft.com/office/drawing/2014/main" id="{D7142A1C-A7F6-4804-9D0A-4D2FAF3D8DCB}"/>
               </a:ext>
             </a:extLst>
           </p:cNvPr>
@@ -9652,7 +9652,7 @@
           <p:cNvPr id="11" name="">
             <a:extLst xmlns:a="http://schemas.openxmlformats.org/drawingml/2006/main">
               <a:ext uri="{FF2B5EF4-FFF2-40B4-BE49-F238E27FC236}">
-                <a16:creationId xmlns:a16="http://schemas.microsoft.com/office/drawing/2014/main" id="{817DA7D7-F13E-4C95-814D-931CFBA15000}"/>
+                <a16:creationId xmlns:a16="http://schemas.microsoft.com/office/drawing/2014/main" id="{1D5C8847-0B9F-43DE-ABF4-ACC5D47B4F15}"/>
               </a:ext>
             </a:extLst>
           </p:cNvPr>
@@ -9687,7 +9687,7 @@
           <p:cNvPr id="12" name="">
             <a:extLst xmlns:a="http://schemas.openxmlformats.org/drawingml/2006/main">
               <a:ext uri="{FF2B5EF4-FFF2-40B4-BE49-F238E27FC236}">
-                <a16:creationId xmlns:a16="http://schemas.microsoft.com/office/drawing/2014/main" id="{E1751AB8-190F-4245-8E78-51D7AF40945B}"/>
+                <a16:creationId xmlns:a16="http://schemas.microsoft.com/office/drawing/2014/main" id="{AC154572-35C9-4650-AD49-4123C07BDAB5}"/>
               </a:ext>
             </a:extLst>
           </p:cNvPr>
@@ -9751,7 +9751,7 @@
           <p:cNvPr id="13" name="">
             <a:extLst xmlns:a="http://schemas.openxmlformats.org/drawingml/2006/main">
               <a:ext uri="{FF2B5EF4-FFF2-40B4-BE49-F238E27FC236}">
-                <a16:creationId xmlns:a16="http://schemas.microsoft.com/office/drawing/2014/main" id="{C3747CE8-AEF8-41AF-9914-DD9577501EA5}"/>
+                <a16:creationId xmlns:a16="http://schemas.microsoft.com/office/drawing/2014/main" id="{DDE96119-F16A-4CF1-8298-3A5644BC5C50}"/>
               </a:ext>
             </a:extLst>
           </p:cNvPr>
@@ -9815,7 +9815,7 @@
           <p:cNvPr id="14" name="">
             <a:extLst xmlns:a="http://schemas.openxmlformats.org/drawingml/2006/main">
               <a:ext uri="{FF2B5EF4-FFF2-40B4-BE49-F238E27FC236}">
-                <a16:creationId xmlns:a16="http://schemas.microsoft.com/office/drawing/2014/main" id="{A4568101-863F-40E5-9E1B-25405A3707AA}"/>
+                <a16:creationId xmlns:a16="http://schemas.microsoft.com/office/drawing/2014/main" id="{19E08D87-73BE-46D1-87FA-D8DA43AD1349}"/>
               </a:ext>
             </a:extLst>
           </p:cNvPr>
@@ -9848,7 +9848,7 @@
           <p:cNvPr id="15" name="">
             <a:extLst xmlns:a="http://schemas.openxmlformats.org/drawingml/2006/main">
               <a:ext uri="{FF2B5EF4-FFF2-40B4-BE49-F238E27FC236}">
-                <a16:creationId xmlns:a16="http://schemas.microsoft.com/office/drawing/2014/main" id="{595CD450-BB7C-4406-80AE-9DC70A90F6A4}"/>
+                <a16:creationId xmlns:a16="http://schemas.microsoft.com/office/drawing/2014/main" id="{82A12603-00A4-4817-A0DA-1ED86933B763}"/>
               </a:ext>
             </a:extLst>
           </p:cNvPr>
@@ -9883,7 +9883,7 @@
           <p:cNvPr id="16" name="">
             <a:extLst xmlns:a="http://schemas.openxmlformats.org/drawingml/2006/main">
               <a:ext uri="{FF2B5EF4-FFF2-40B4-BE49-F238E27FC236}">
-                <a16:creationId xmlns:a16="http://schemas.microsoft.com/office/drawing/2014/main" id="{5322AC48-EF3A-4742-835F-C7414233F386}"/>
+                <a16:creationId xmlns:a16="http://schemas.microsoft.com/office/drawing/2014/main" id="{55FD0933-2695-4E8D-8FB8-33A58106A916}"/>
               </a:ext>
             </a:extLst>
           </p:cNvPr>
@@ -9947,7 +9947,7 @@
           <p:cNvPr id="17" name="">
             <a:extLst xmlns:a="http://schemas.openxmlformats.org/drawingml/2006/main">
               <a:ext uri="{FF2B5EF4-FFF2-40B4-BE49-F238E27FC236}">
-                <a16:creationId xmlns:a16="http://schemas.microsoft.com/office/drawing/2014/main" id="{43747C1B-B317-4BBD-AD31-27CBD6BD94B9}"/>
+                <a16:creationId xmlns:a16="http://schemas.microsoft.com/office/drawing/2014/main" id="{29BC2D28-5D19-4C01-BAFF-A7A9227BA691}"/>
               </a:ext>
             </a:extLst>
           </p:cNvPr>
@@ -10011,7 +10011,7 @@
           <p:cNvPr id="18" name="">
             <a:extLst xmlns:a="http://schemas.openxmlformats.org/drawingml/2006/main">
               <a:ext uri="{FF2B5EF4-FFF2-40B4-BE49-F238E27FC236}">
-                <a16:creationId xmlns:a16="http://schemas.microsoft.com/office/drawing/2014/main" id="{8398CFC5-8CAD-4F99-8C73-C2CA401B2881}"/>
+                <a16:creationId xmlns:a16="http://schemas.microsoft.com/office/drawing/2014/main" id="{C081EF2F-E088-43AD-9336-A78063F42674}"/>
               </a:ext>
             </a:extLst>
           </p:cNvPr>
@@ -10044,7 +10044,7 @@
           <p:cNvPr id="19" name="">
             <a:extLst xmlns:a="http://schemas.openxmlformats.org/drawingml/2006/main">
               <a:ext uri="{FF2B5EF4-FFF2-40B4-BE49-F238E27FC236}">
-                <a16:creationId xmlns:a16="http://schemas.microsoft.com/office/drawing/2014/main" id="{5958DE38-E88A-423B-AC03-0E019754D173}"/>
+                <a16:creationId xmlns:a16="http://schemas.microsoft.com/office/drawing/2014/main" id="{60F0E619-6009-48C0-893E-57045E37DD1F}"/>
               </a:ext>
             </a:extLst>
           </p:cNvPr>
@@ -10079,7 +10079,7 @@
           <p:cNvPr id="20" name="">
             <a:extLst xmlns:a="http://schemas.openxmlformats.org/drawingml/2006/main">
               <a:ext uri="{FF2B5EF4-FFF2-40B4-BE49-F238E27FC236}">
-                <a16:creationId xmlns:a16="http://schemas.microsoft.com/office/drawing/2014/main" id="{676462C0-5E74-425A-B339-8DE076C2711A}"/>
+                <a16:creationId xmlns:a16="http://schemas.microsoft.com/office/drawing/2014/main" id="{11F72C5D-BA90-4223-B0A7-E1164B6D4711}"/>
               </a:ext>
             </a:extLst>
           </p:cNvPr>
@@ -10143,7 +10143,7 @@
           <p:cNvPr id="21" name="">
             <a:extLst xmlns:a="http://schemas.openxmlformats.org/drawingml/2006/main">
               <a:ext uri="{FF2B5EF4-FFF2-40B4-BE49-F238E27FC236}">
-                <a16:creationId xmlns:a16="http://schemas.microsoft.com/office/drawing/2014/main" id="{76A92B75-C4C9-499F-BE86-7BF7C402351D}"/>
+                <a16:creationId xmlns:a16="http://schemas.microsoft.com/office/drawing/2014/main" id="{2846EE3A-2D11-4DB2-9C37-3152BF3BD511}"/>
               </a:ext>
             </a:extLst>
           </p:cNvPr>
@@ -10207,7 +10207,7 @@
           <p:cNvPr id="22" name="">
             <a:extLst xmlns:a="http://schemas.openxmlformats.org/drawingml/2006/main">
               <a:ext uri="{FF2B5EF4-FFF2-40B4-BE49-F238E27FC236}">
-                <a16:creationId xmlns:a16="http://schemas.microsoft.com/office/drawing/2014/main" id="{DEAB6B6D-FA2C-4A93-A980-D073C3EA851B}"/>
+                <a16:creationId xmlns:a16="http://schemas.microsoft.com/office/drawing/2014/main" id="{ED453CCB-A734-497C-833F-C564E34E6D6E}"/>
               </a:ext>
             </a:extLst>
           </p:cNvPr>
@@ -10271,7 +10271,7 @@
           <p:cNvPr id="23" name="">
             <a:extLst xmlns:a="http://schemas.openxmlformats.org/drawingml/2006/main">
               <a:ext uri="{FF2B5EF4-FFF2-40B4-BE49-F238E27FC236}">
-                <a16:creationId xmlns:a16="http://schemas.microsoft.com/office/drawing/2014/main" id="{63995B6A-CD9A-49E3-A0C0-E60733B92DA8}"/>
+                <a16:creationId xmlns:a16="http://schemas.microsoft.com/office/drawing/2014/main" id="{C849E381-5950-468A-8C3D-90936CFC3319}"/>
               </a:ext>
             </a:extLst>
           </p:cNvPr>
@@ -10335,7 +10335,7 @@
           <p:cNvPr id="24" name="">
             <a:extLst xmlns:a="http://schemas.openxmlformats.org/drawingml/2006/main">
               <a:ext uri="{FF2B5EF4-FFF2-40B4-BE49-F238E27FC236}">
-                <a16:creationId xmlns:a16="http://schemas.microsoft.com/office/drawing/2014/main" id="{2721B322-685F-44C6-99B1-0784AAC39D01}"/>
+                <a16:creationId xmlns:a16="http://schemas.microsoft.com/office/drawing/2014/main" id="{D8813098-7C68-48D4-9077-C741887862A1}"/>
               </a:ext>
             </a:extLst>
           </p:cNvPr>
@@ -10368,7 +10368,7 @@
           <p:cNvPr id="25" name="">
             <a:extLst xmlns:a="http://schemas.openxmlformats.org/drawingml/2006/main">
               <a:ext uri="{FF2B5EF4-FFF2-40B4-BE49-F238E27FC236}">
-                <a16:creationId xmlns:a16="http://schemas.microsoft.com/office/drawing/2014/main" id="{292105A1-D790-4C1F-A292-39F8F2DEEF05}"/>
+                <a16:creationId xmlns:a16="http://schemas.microsoft.com/office/drawing/2014/main" id="{B730891D-CBD8-4081-AFF7-D8807F4528C8}"/>
               </a:ext>
             </a:extLst>
           </p:cNvPr>
@@ -10432,7 +10432,7 @@
           <p:cNvPr id="26" name="">
             <a:extLst xmlns:a="http://schemas.openxmlformats.org/drawingml/2006/main">
               <a:ext uri="{FF2B5EF4-FFF2-40B4-BE49-F238E27FC236}">
-                <a16:creationId xmlns:a16="http://schemas.microsoft.com/office/drawing/2014/main" id="{B2E157A0-3935-43BF-9C06-A6536D2D99F4}"/>
+                <a16:creationId xmlns:a16="http://schemas.microsoft.com/office/drawing/2014/main" id="{96D44B53-9075-460B-B75C-F0CACCEA881A}"/>
               </a:ext>
             </a:extLst>
           </p:cNvPr>
@@ -10494,7 +10494,7 @@
     </p:spTree>
     <p:extLst>
       <p:ext uri="{BB962C8B-B14F-4D97-AF65-F5344CB8AC3E}">
-        <p14:creationId xmlns:p14="http://schemas.microsoft.com/office/powerpoint/2010/main" val="423570983"/>
+        <p14:creationId xmlns:p14="http://schemas.microsoft.com/office/powerpoint/2010/main" val="1064008699"/>
       </p:ext>
     </p:extLst>
   </p:cSld>
@@ -10522,7 +10522,7 @@
           <p:nvPr/>
         </p:nvPicPr>
         <p:blipFill>
-          <a:blip xmlns:r="http://schemas.openxmlformats.org/officeDocument/2006/relationships" xmlns:a="http://schemas.openxmlformats.org/drawingml/2006/main" r:embed="R72bfefb53ada4d97"/>
+          <a:blip xmlns:r="http://schemas.openxmlformats.org/officeDocument/2006/relationships" xmlns:a="http://schemas.openxmlformats.org/drawingml/2006/main" r:embed="Rcbe0aa9acfb64ad3"/>
           <a:srcRect xmlns:a="http://schemas.openxmlformats.org/drawingml/2006/main" l="0" t="7813" r="0" b="7813"/>
           <a:stretch xmlns:a="http://schemas.openxmlformats.org/drawingml/2006/main">
             <a:fillRect l="0" t="0" r="0" b="0"/>
@@ -10543,7 +10543,7 @@
           <p:cNvPr id="2" name="">
             <a:extLst xmlns:a="http://schemas.openxmlformats.org/drawingml/2006/main">
               <a:ext uri="{FF2B5EF4-FFF2-40B4-BE49-F238E27FC236}">
-                <a16:creationId xmlns:a16="http://schemas.microsoft.com/office/drawing/2014/main" id="{7605CB5A-3FE3-4480-8914-E7066FD8D70A}"/>
+                <a16:creationId xmlns:a16="http://schemas.microsoft.com/office/drawing/2014/main" id="{B601BE71-8571-4272-A446-A990185890FB}"/>
               </a:ext>
             </a:extLst>
           </p:cNvPr>
@@ -10580,7 +10580,7 @@
           <p:cNvPr id="3" name="">
             <a:extLst xmlns:a="http://schemas.openxmlformats.org/drawingml/2006/main">
               <a:ext uri="{FF2B5EF4-FFF2-40B4-BE49-F238E27FC236}">
-                <a16:creationId xmlns:a16="http://schemas.microsoft.com/office/drawing/2014/main" id="{131D6A90-50E9-4EC8-87DB-377479D01B79}"/>
+                <a16:creationId xmlns:a16="http://schemas.microsoft.com/office/drawing/2014/main" id="{C9AA3B20-8ED8-4160-BF65-68E9D457F335}"/>
               </a:ext>
             </a:extLst>
           </p:cNvPr>
@@ -10617,7 +10617,7 @@
           <p:cNvPr id="4" name="">
             <a:extLst xmlns:a="http://schemas.openxmlformats.org/drawingml/2006/main">
               <a:ext uri="{FF2B5EF4-FFF2-40B4-BE49-F238E27FC236}">
-                <a16:creationId xmlns:a16="http://schemas.microsoft.com/office/drawing/2014/main" id="{A0EF116F-BDB4-4469-9F5C-4510CDB3C57C}"/>
+                <a16:creationId xmlns:a16="http://schemas.microsoft.com/office/drawing/2014/main" id="{B7875E7B-1369-405C-8157-31BA803AC1E8}"/>
               </a:ext>
             </a:extLst>
           </p:cNvPr>
@@ -10681,7 +10681,7 @@
           <p:cNvPr id="5" name="">
             <a:extLst xmlns:a="http://schemas.openxmlformats.org/drawingml/2006/main">
               <a:ext uri="{FF2B5EF4-FFF2-40B4-BE49-F238E27FC236}">
-                <a16:creationId xmlns:a16="http://schemas.microsoft.com/office/drawing/2014/main" id="{AE7A1EF9-1BB3-4922-A2A8-18AA95D53C79}"/>
+                <a16:creationId xmlns:a16="http://schemas.microsoft.com/office/drawing/2014/main" id="{9BEC3186-EF50-4668-86E0-274EC586F557}"/>
               </a:ext>
             </a:extLst>
           </p:cNvPr>
@@ -10745,7 +10745,7 @@
           <p:cNvPr id="6" name="">
             <a:extLst xmlns:a="http://schemas.openxmlformats.org/drawingml/2006/main">
               <a:ext uri="{FF2B5EF4-FFF2-40B4-BE49-F238E27FC236}">
-                <a16:creationId xmlns:a16="http://schemas.microsoft.com/office/drawing/2014/main" id="{90717F10-241A-46C3-9DBA-5566D412E9A1}"/>
+                <a16:creationId xmlns:a16="http://schemas.microsoft.com/office/drawing/2014/main" id="{A5538910-43E4-4D7C-8100-8FDB5CFB0EA2}"/>
               </a:ext>
             </a:extLst>
           </p:cNvPr>
@@ -10809,7 +10809,7 @@
           <p:cNvPr id="7" name="">
             <a:extLst xmlns:a="http://schemas.openxmlformats.org/drawingml/2006/main">
               <a:ext uri="{FF2B5EF4-FFF2-40B4-BE49-F238E27FC236}">
-                <a16:creationId xmlns:a16="http://schemas.microsoft.com/office/drawing/2014/main" id="{73CF7685-FADD-40DF-BE5E-2DB7DFF2B95B}"/>
+                <a16:creationId xmlns:a16="http://schemas.microsoft.com/office/drawing/2014/main" id="{2892CE69-F746-49CB-A9EE-98A646B27091}"/>
               </a:ext>
             </a:extLst>
           </p:cNvPr>
@@ -10844,7 +10844,7 @@
           <p:cNvPr id="8" name="">
             <a:extLst xmlns:a="http://schemas.openxmlformats.org/drawingml/2006/main">
               <a:ext uri="{FF2B5EF4-FFF2-40B4-BE49-F238E27FC236}">
-                <a16:creationId xmlns:a16="http://schemas.microsoft.com/office/drawing/2014/main" id="{26D80491-E6C8-42BC-81D7-C639288B366D}"/>
+                <a16:creationId xmlns:a16="http://schemas.microsoft.com/office/drawing/2014/main" id="{1965B7B5-CC71-4356-A187-393915F526CE}"/>
               </a:ext>
             </a:extLst>
           </p:cNvPr>
@@ -10908,7 +10908,7 @@
           <p:cNvPr id="9" name="">
             <a:extLst xmlns:a="http://schemas.openxmlformats.org/drawingml/2006/main">
               <a:ext uri="{FF2B5EF4-FFF2-40B4-BE49-F238E27FC236}">
-                <a16:creationId xmlns:a16="http://schemas.microsoft.com/office/drawing/2014/main" id="{7E2DC67A-45C9-4356-98CD-911C47E41819}"/>
+                <a16:creationId xmlns:a16="http://schemas.microsoft.com/office/drawing/2014/main" id="{70C8DBF3-927A-4B75-A341-28ACE9664D3B}"/>
               </a:ext>
             </a:extLst>
           </p:cNvPr>
@@ -10943,7 +10943,7 @@
           <p:cNvPr id="10" name="">
             <a:extLst xmlns:a="http://schemas.openxmlformats.org/drawingml/2006/main">
               <a:ext uri="{FF2B5EF4-FFF2-40B4-BE49-F238E27FC236}">
-                <a16:creationId xmlns:a16="http://schemas.microsoft.com/office/drawing/2014/main" id="{B1D4AD37-6DBC-4411-BE8E-78760DD83162}"/>
+                <a16:creationId xmlns:a16="http://schemas.microsoft.com/office/drawing/2014/main" id="{AD9EE698-6D3F-4FEB-B044-3CE2F3BF051D}"/>
               </a:ext>
             </a:extLst>
           </p:cNvPr>
@@ -11007,7 +11007,7 @@
           <p:cNvPr id="11" name="">
             <a:extLst xmlns:a="http://schemas.openxmlformats.org/drawingml/2006/main">
               <a:ext uri="{FF2B5EF4-FFF2-40B4-BE49-F238E27FC236}">
-                <a16:creationId xmlns:a16="http://schemas.microsoft.com/office/drawing/2014/main" id="{1853C177-E85D-4F7B-9F55-52199C24AA41}"/>
+                <a16:creationId xmlns:a16="http://schemas.microsoft.com/office/drawing/2014/main" id="{6B22DD1D-1872-474E-9587-1177FA7EB2CB}"/>
               </a:ext>
             </a:extLst>
           </p:cNvPr>
@@ -11042,7 +11042,7 @@
           <p:cNvPr id="12" name="">
             <a:extLst xmlns:a="http://schemas.openxmlformats.org/drawingml/2006/main">
               <a:ext uri="{FF2B5EF4-FFF2-40B4-BE49-F238E27FC236}">
-                <a16:creationId xmlns:a16="http://schemas.microsoft.com/office/drawing/2014/main" id="{C303DE1B-9A6D-4C16-9D1E-33BA15A0BF4F}"/>
+                <a16:creationId xmlns:a16="http://schemas.microsoft.com/office/drawing/2014/main" id="{865FEAF4-AC28-49A0-99F4-1D9C2A862273}"/>
               </a:ext>
             </a:extLst>
           </p:cNvPr>
@@ -11106,7 +11106,7 @@
           <p:cNvPr id="13" name="">
             <a:extLst xmlns:a="http://schemas.openxmlformats.org/drawingml/2006/main">
               <a:ext uri="{FF2B5EF4-FFF2-40B4-BE49-F238E27FC236}">
-                <a16:creationId xmlns:a16="http://schemas.microsoft.com/office/drawing/2014/main" id="{7D1FB191-716B-4C55-9B3C-3B822ECCF10D}"/>
+                <a16:creationId xmlns:a16="http://schemas.microsoft.com/office/drawing/2014/main" id="{6F71CD91-00C2-4B33-8612-8D25AC310E26}"/>
               </a:ext>
             </a:extLst>
           </p:cNvPr>
@@ -11141,7 +11141,7 @@
           <p:cNvPr id="14" name="">
             <a:extLst xmlns:a="http://schemas.openxmlformats.org/drawingml/2006/main">
               <a:ext uri="{FF2B5EF4-FFF2-40B4-BE49-F238E27FC236}">
-                <a16:creationId xmlns:a16="http://schemas.microsoft.com/office/drawing/2014/main" id="{EFB55741-C174-440F-B030-3827F1BDA68A}"/>
+                <a16:creationId xmlns:a16="http://schemas.microsoft.com/office/drawing/2014/main" id="{8B14DD45-3E3A-4B3B-80B7-58BE2277205D}"/>
               </a:ext>
             </a:extLst>
           </p:cNvPr>
@@ -11205,7 +11205,7 @@
           <p:cNvPr id="15" name="">
             <a:extLst xmlns:a="http://schemas.openxmlformats.org/drawingml/2006/main">
               <a:ext uri="{FF2B5EF4-FFF2-40B4-BE49-F238E27FC236}">
-                <a16:creationId xmlns:a16="http://schemas.microsoft.com/office/drawing/2014/main" id="{87748E7B-C1E8-408A-8655-283041DB8994}"/>
+                <a16:creationId xmlns:a16="http://schemas.microsoft.com/office/drawing/2014/main" id="{011560D4-A8BC-4F0C-944E-851D5BC8DDE9}"/>
               </a:ext>
             </a:extLst>
           </p:cNvPr>
@@ -11240,7 +11240,7 @@
           <p:cNvPr id="16" name="">
             <a:extLst xmlns:a="http://schemas.openxmlformats.org/drawingml/2006/main">
               <a:ext uri="{FF2B5EF4-FFF2-40B4-BE49-F238E27FC236}">
-                <a16:creationId xmlns:a16="http://schemas.microsoft.com/office/drawing/2014/main" id="{B274B472-639B-4E1D-BD1D-8A251284787B}"/>
+                <a16:creationId xmlns:a16="http://schemas.microsoft.com/office/drawing/2014/main" id="{86B4B6C3-8450-49C0-BAEB-2D0082CE1C91}"/>
               </a:ext>
             </a:extLst>
           </p:cNvPr>
@@ -11304,7 +11304,7 @@
           <p:cNvPr id="17" name="">
             <a:extLst xmlns:a="http://schemas.openxmlformats.org/drawingml/2006/main">
               <a:ext uri="{FF2B5EF4-FFF2-40B4-BE49-F238E27FC236}">
-                <a16:creationId xmlns:a16="http://schemas.microsoft.com/office/drawing/2014/main" id="{8A33D64E-FCCF-4512-9EA0-86574DB228A3}"/>
+                <a16:creationId xmlns:a16="http://schemas.microsoft.com/office/drawing/2014/main" id="{24C1ACDC-2CDC-4A20-949A-8F0EA42AD1FA}"/>
               </a:ext>
             </a:extLst>
           </p:cNvPr>
@@ -11339,7 +11339,7 @@
           <p:cNvPr id="18" name="">
             <a:extLst xmlns:a="http://schemas.openxmlformats.org/drawingml/2006/main">
               <a:ext uri="{FF2B5EF4-FFF2-40B4-BE49-F238E27FC236}">
-                <a16:creationId xmlns:a16="http://schemas.microsoft.com/office/drawing/2014/main" id="{8AF90E06-0D00-4714-B525-6A3F60A1740C}"/>
+                <a16:creationId xmlns:a16="http://schemas.microsoft.com/office/drawing/2014/main" id="{CB38D27A-AA9C-4C6A-A1CB-0ACFD3FC2EC2}"/>
               </a:ext>
             </a:extLst>
           </p:cNvPr>
@@ -11403,7 +11403,7 @@
           <p:cNvPr id="19" name="">
             <a:extLst xmlns:a="http://schemas.openxmlformats.org/drawingml/2006/main">
               <a:ext uri="{FF2B5EF4-FFF2-40B4-BE49-F238E27FC236}">
-                <a16:creationId xmlns:a16="http://schemas.microsoft.com/office/drawing/2014/main" id="{C2913F2D-09CF-4ECA-AB8C-69B43A2F84A6}"/>
+                <a16:creationId xmlns:a16="http://schemas.microsoft.com/office/drawing/2014/main" id="{05404DD8-5A2C-409F-99FE-7B0517D267C1}"/>
               </a:ext>
             </a:extLst>
           </p:cNvPr>
@@ -11467,7 +11467,7 @@
           <p:cNvPr id="20" name="">
             <a:extLst xmlns:a="http://schemas.openxmlformats.org/drawingml/2006/main">
               <a:ext uri="{FF2B5EF4-FFF2-40B4-BE49-F238E27FC236}">
-                <a16:creationId xmlns:a16="http://schemas.microsoft.com/office/drawing/2014/main" id="{8739ABD6-6A61-43D1-92BE-DDDCD8C885DD}"/>
+                <a16:creationId xmlns:a16="http://schemas.microsoft.com/office/drawing/2014/main" id="{D52080B7-3D45-4704-A282-AC0CD842C296}"/>
               </a:ext>
             </a:extLst>
           </p:cNvPr>
@@ -11500,7 +11500,7 @@
           <p:cNvPr id="21" name="">
             <a:extLst xmlns:a="http://schemas.openxmlformats.org/drawingml/2006/main">
               <a:ext uri="{FF2B5EF4-FFF2-40B4-BE49-F238E27FC236}">
-                <a16:creationId xmlns:a16="http://schemas.microsoft.com/office/drawing/2014/main" id="{0963C629-1CE5-4946-8F70-323CF454025E}"/>
+                <a16:creationId xmlns:a16="http://schemas.microsoft.com/office/drawing/2014/main" id="{ED977039-7582-46BF-8E70-F716DEF8C525}"/>
               </a:ext>
             </a:extLst>
           </p:cNvPr>
@@ -11564,7 +11564,7 @@
           <p:cNvPr id="22" name="">
             <a:extLst xmlns:a="http://schemas.openxmlformats.org/drawingml/2006/main">
               <a:ext uri="{FF2B5EF4-FFF2-40B4-BE49-F238E27FC236}">
-                <a16:creationId xmlns:a16="http://schemas.microsoft.com/office/drawing/2014/main" id="{5139C46D-3D8A-4866-BDBE-37F17779B9BE}"/>
+                <a16:creationId xmlns:a16="http://schemas.microsoft.com/office/drawing/2014/main" id="{214595A0-35F8-4ED9-A9FF-CF3D0C9514EA}"/>
               </a:ext>
             </a:extLst>
           </p:cNvPr>
@@ -11626,7 +11626,7 @@
     </p:spTree>
     <p:extLst>
       <p:ext uri="{BB962C8B-B14F-4D97-AF65-F5344CB8AC3E}">
-        <p14:creationId xmlns:p14="http://schemas.microsoft.com/office/powerpoint/2010/main" val="1938050111"/>
+        <p14:creationId xmlns:p14="http://schemas.microsoft.com/office/powerpoint/2010/main" val="140338930"/>
       </p:ext>
     </p:extLst>
   </p:cSld>
@@ -11654,7 +11654,7 @@
           <p:nvPr/>
         </p:nvPicPr>
         <p:blipFill>
-          <a:blip xmlns:r="http://schemas.openxmlformats.org/officeDocument/2006/relationships" xmlns:a="http://schemas.openxmlformats.org/drawingml/2006/main" r:embed="R199f10d09eda494e"/>
+          <a:blip xmlns:r="http://schemas.openxmlformats.org/officeDocument/2006/relationships" xmlns:a="http://schemas.openxmlformats.org/drawingml/2006/main" r:embed="R0d866b4c22a540d6"/>
           <a:srcRect xmlns:a="http://schemas.openxmlformats.org/drawingml/2006/main" l="0" t="27" r="0" b="27"/>
           <a:stretch xmlns:a="http://schemas.openxmlformats.org/drawingml/2006/main">
             <a:fillRect l="0" t="0" r="0" b="0"/>
@@ -11675,7 +11675,7 @@
           <p:cNvPr id="2" name="">
             <a:extLst xmlns:a="http://schemas.openxmlformats.org/drawingml/2006/main">
               <a:ext uri="{FF2B5EF4-FFF2-40B4-BE49-F238E27FC236}">
-                <a16:creationId xmlns:a16="http://schemas.microsoft.com/office/drawing/2014/main" id="{21D68621-20E7-4F4B-AF30-99934075687F}"/>
+                <a16:creationId xmlns:a16="http://schemas.microsoft.com/office/drawing/2014/main" id="{A2B69A38-AE44-4EE7-867A-165B4E50DA88}"/>
               </a:ext>
             </a:extLst>
           </p:cNvPr>
@@ -11712,7 +11712,7 @@
           <p:cNvPr id="3" name="">
             <a:extLst xmlns:a="http://schemas.openxmlformats.org/drawingml/2006/main">
               <a:ext uri="{FF2B5EF4-FFF2-40B4-BE49-F238E27FC236}">
-                <a16:creationId xmlns:a16="http://schemas.microsoft.com/office/drawing/2014/main" id="{DF86C9AD-513C-4D39-ACAC-480E0739C188}"/>
+                <a16:creationId xmlns:a16="http://schemas.microsoft.com/office/drawing/2014/main" id="{4B4AB4D7-742D-4192-BA39-FB72D16C91F8}"/>
               </a:ext>
             </a:extLst>
           </p:cNvPr>
@@ -11749,7 +11749,7 @@
           <p:cNvPr id="4" name="">
             <a:extLst xmlns:a="http://schemas.openxmlformats.org/drawingml/2006/main">
               <a:ext uri="{FF2B5EF4-FFF2-40B4-BE49-F238E27FC236}">
-                <a16:creationId xmlns:a16="http://schemas.microsoft.com/office/drawing/2014/main" id="{E2B788F5-1F4D-48EB-874D-DBBF8A9AEC7E}"/>
+                <a16:creationId xmlns:a16="http://schemas.microsoft.com/office/drawing/2014/main" id="{398CB0E6-B1C3-4640-ADB9-313517F3B3B8}"/>
               </a:ext>
             </a:extLst>
           </p:cNvPr>
@@ -11813,7 +11813,7 @@
           <p:cNvPr id="5" name="">
             <a:extLst xmlns:a="http://schemas.openxmlformats.org/drawingml/2006/main">
               <a:ext uri="{FF2B5EF4-FFF2-40B4-BE49-F238E27FC236}">
-                <a16:creationId xmlns:a16="http://schemas.microsoft.com/office/drawing/2014/main" id="{8B674923-2CF2-40F2-9044-DE9E7996BC03}"/>
+                <a16:creationId xmlns:a16="http://schemas.microsoft.com/office/drawing/2014/main" id="{2828129A-013D-4D6E-801E-319C5C8A6258}"/>
               </a:ext>
             </a:extLst>
           </p:cNvPr>
@@ -11877,7 +11877,7 @@
           <p:cNvPr id="6" name="">
             <a:extLst xmlns:a="http://schemas.openxmlformats.org/drawingml/2006/main">
               <a:ext uri="{FF2B5EF4-FFF2-40B4-BE49-F238E27FC236}">
-                <a16:creationId xmlns:a16="http://schemas.microsoft.com/office/drawing/2014/main" id="{A6034E27-5BA9-4A4F-9430-E72C300A07EF}"/>
+                <a16:creationId xmlns:a16="http://schemas.microsoft.com/office/drawing/2014/main" id="{CF98C863-8E89-4885-AF78-18EF2CD1B0D1}"/>
               </a:ext>
             </a:extLst>
           </p:cNvPr>
@@ -11941,7 +11941,7 @@
           <p:cNvPr id="7" name="">
             <a:extLst xmlns:a="http://schemas.openxmlformats.org/drawingml/2006/main">
               <a:ext uri="{FF2B5EF4-FFF2-40B4-BE49-F238E27FC236}">
-                <a16:creationId xmlns:a16="http://schemas.microsoft.com/office/drawing/2014/main" id="{79CDA037-6FB3-4264-90EE-6C19CBD0AAC8}"/>
+                <a16:creationId xmlns:a16="http://schemas.microsoft.com/office/drawing/2014/main" id="{61CFAEE0-F4C1-43DB-ABEF-E0D2C1854E8C}"/>
               </a:ext>
             </a:extLst>
           </p:cNvPr>
@@ -11976,7 +11976,7 @@
           <p:cNvPr id="8" name="">
             <a:extLst xmlns:a="http://schemas.openxmlformats.org/drawingml/2006/main">
               <a:ext uri="{FF2B5EF4-FFF2-40B4-BE49-F238E27FC236}">
-                <a16:creationId xmlns:a16="http://schemas.microsoft.com/office/drawing/2014/main" id="{F9D50BEE-3B74-4FD4-8FE5-FA200A2BF5B9}"/>
+                <a16:creationId xmlns:a16="http://schemas.microsoft.com/office/drawing/2014/main" id="{1BFB190A-EB4B-4E99-992E-6FC722C837F7}"/>
               </a:ext>
             </a:extLst>
           </p:cNvPr>
@@ -12040,7 +12040,7 @@
           <p:cNvPr id="9" name="">
             <a:extLst xmlns:a="http://schemas.openxmlformats.org/drawingml/2006/main">
               <a:ext uri="{FF2B5EF4-FFF2-40B4-BE49-F238E27FC236}">
-                <a16:creationId xmlns:a16="http://schemas.microsoft.com/office/drawing/2014/main" id="{E0EAAB82-4C5A-4EDE-BD7A-E8D0CD089033}"/>
+                <a16:creationId xmlns:a16="http://schemas.microsoft.com/office/drawing/2014/main" id="{71611CF4-055A-4467-A436-5B2C4D12B2C6}"/>
               </a:ext>
             </a:extLst>
           </p:cNvPr>
@@ -12104,7 +12104,7 @@
           <p:cNvPr id="10" name="">
             <a:extLst xmlns:a="http://schemas.openxmlformats.org/drawingml/2006/main">
               <a:ext uri="{FF2B5EF4-FFF2-40B4-BE49-F238E27FC236}">
-                <a16:creationId xmlns:a16="http://schemas.microsoft.com/office/drawing/2014/main" id="{26E83C34-93AA-4964-8AAB-F22292363403}"/>
+                <a16:creationId xmlns:a16="http://schemas.microsoft.com/office/drawing/2014/main" id="{31F085B9-687E-4869-AF62-F20CD74AFF5D}"/>
               </a:ext>
             </a:extLst>
           </p:cNvPr>
@@ -12137,7 +12137,7 @@
           <p:cNvPr id="11" name="">
             <a:extLst xmlns:a="http://schemas.openxmlformats.org/drawingml/2006/main">
               <a:ext uri="{FF2B5EF4-FFF2-40B4-BE49-F238E27FC236}">
-                <a16:creationId xmlns:a16="http://schemas.microsoft.com/office/drawing/2014/main" id="{C075DA67-9753-45BD-9417-C939945F6878}"/>
+                <a16:creationId xmlns:a16="http://schemas.microsoft.com/office/drawing/2014/main" id="{E825A765-6F68-427F-A7B4-D5CF2599D8D6}"/>
               </a:ext>
             </a:extLst>
           </p:cNvPr>
@@ -12172,7 +12172,7 @@
           <p:cNvPr id="12" name="">
             <a:extLst xmlns:a="http://schemas.openxmlformats.org/drawingml/2006/main">
               <a:ext uri="{FF2B5EF4-FFF2-40B4-BE49-F238E27FC236}">
-                <a16:creationId xmlns:a16="http://schemas.microsoft.com/office/drawing/2014/main" id="{F64E1E09-6B67-41BA-9239-F447D16610C9}"/>
+                <a16:creationId xmlns:a16="http://schemas.microsoft.com/office/drawing/2014/main" id="{BABADFE3-96A8-44E2-83E2-3AE0640CC32B}"/>
               </a:ext>
             </a:extLst>
           </p:cNvPr>
@@ -12236,7 +12236,7 @@
           <p:cNvPr id="13" name="">
             <a:extLst xmlns:a="http://schemas.openxmlformats.org/drawingml/2006/main">
               <a:ext uri="{FF2B5EF4-FFF2-40B4-BE49-F238E27FC236}">
-                <a16:creationId xmlns:a16="http://schemas.microsoft.com/office/drawing/2014/main" id="{3FB34050-3EC0-465D-A745-95C4C7556382}"/>
+                <a16:creationId xmlns:a16="http://schemas.microsoft.com/office/drawing/2014/main" id="{4CC4EE5C-143B-494B-9A05-137CCC98DD1B}"/>
               </a:ext>
             </a:extLst>
           </p:cNvPr>
@@ -12300,7 +12300,7 @@
           <p:cNvPr id="14" name="">
             <a:extLst xmlns:a="http://schemas.openxmlformats.org/drawingml/2006/main">
               <a:ext uri="{FF2B5EF4-FFF2-40B4-BE49-F238E27FC236}">
-                <a16:creationId xmlns:a16="http://schemas.microsoft.com/office/drawing/2014/main" id="{62F855B7-F397-4486-9296-9C0303FC6EE3}"/>
+                <a16:creationId xmlns:a16="http://schemas.microsoft.com/office/drawing/2014/main" id="{9173603B-A801-4C4C-AA12-8AAA253A0442}"/>
               </a:ext>
             </a:extLst>
           </p:cNvPr>
@@ -12333,7 +12333,7 @@
           <p:cNvPr id="15" name="">
             <a:extLst xmlns:a="http://schemas.openxmlformats.org/drawingml/2006/main">
               <a:ext uri="{FF2B5EF4-FFF2-40B4-BE49-F238E27FC236}">
-                <a16:creationId xmlns:a16="http://schemas.microsoft.com/office/drawing/2014/main" id="{B5F7F78D-801C-4A95-808B-0BC7A3889014}"/>
+                <a16:creationId xmlns:a16="http://schemas.microsoft.com/office/drawing/2014/main" id="{D16B0E89-1C13-4896-BEBC-03CD2AE389BB}"/>
               </a:ext>
             </a:extLst>
           </p:cNvPr>
@@ -12368,7 +12368,7 @@
           <p:cNvPr id="16" name="">
             <a:extLst xmlns:a="http://schemas.openxmlformats.org/drawingml/2006/main">
               <a:ext uri="{FF2B5EF4-FFF2-40B4-BE49-F238E27FC236}">
-                <a16:creationId xmlns:a16="http://schemas.microsoft.com/office/drawing/2014/main" id="{BE3EBAC5-C204-40AA-A35A-B2BFD9D5CEC4}"/>
+                <a16:creationId xmlns:a16="http://schemas.microsoft.com/office/drawing/2014/main" id="{E9F5D226-C69A-4E5D-9727-D43AFB9B3BB8}"/>
               </a:ext>
             </a:extLst>
           </p:cNvPr>
@@ -12432,7 +12432,7 @@
           <p:cNvPr id="17" name="">
             <a:extLst xmlns:a="http://schemas.openxmlformats.org/drawingml/2006/main">
               <a:ext uri="{FF2B5EF4-FFF2-40B4-BE49-F238E27FC236}">
-                <a16:creationId xmlns:a16="http://schemas.microsoft.com/office/drawing/2014/main" id="{771C4F70-61D8-4F82-A054-172859E6F73D}"/>
+                <a16:creationId xmlns:a16="http://schemas.microsoft.com/office/drawing/2014/main" id="{82F27AF9-73F7-4DA7-B1D4-42AAF1936E4D}"/>
               </a:ext>
             </a:extLst>
           </p:cNvPr>
@@ -12496,7 +12496,7 @@
           <p:cNvPr id="18" name="">
             <a:extLst xmlns:a="http://schemas.openxmlformats.org/drawingml/2006/main">
               <a:ext uri="{FF2B5EF4-FFF2-40B4-BE49-F238E27FC236}">
-                <a16:creationId xmlns:a16="http://schemas.microsoft.com/office/drawing/2014/main" id="{3946B483-6A12-43AB-B042-BFFEB627EAEC}"/>
+                <a16:creationId xmlns:a16="http://schemas.microsoft.com/office/drawing/2014/main" id="{0880BE61-6DE6-4281-B52C-5184B3C552DC}"/>
               </a:ext>
             </a:extLst>
           </p:cNvPr>
@@ -12529,7 +12529,7 @@
           <p:cNvPr id="19" name="">
             <a:extLst xmlns:a="http://schemas.openxmlformats.org/drawingml/2006/main">
               <a:ext uri="{FF2B5EF4-FFF2-40B4-BE49-F238E27FC236}">
-                <a16:creationId xmlns:a16="http://schemas.microsoft.com/office/drawing/2014/main" id="{505D75F2-C289-4A69-A928-7CA2B28339FB}"/>
+                <a16:creationId xmlns:a16="http://schemas.microsoft.com/office/drawing/2014/main" id="{D1E8B2C5-6589-4ADF-8FF0-E3CE91D6D339}"/>
               </a:ext>
             </a:extLst>
           </p:cNvPr>
@@ -12564,7 +12564,7 @@
           <p:cNvPr id="20" name="">
             <a:extLst xmlns:a="http://schemas.openxmlformats.org/drawingml/2006/main">
               <a:ext uri="{FF2B5EF4-FFF2-40B4-BE49-F238E27FC236}">
-                <a16:creationId xmlns:a16="http://schemas.microsoft.com/office/drawing/2014/main" id="{2662DD08-EF97-460A-862E-99F72831A750}"/>
+                <a16:creationId xmlns:a16="http://schemas.microsoft.com/office/drawing/2014/main" id="{DC792000-793F-4E2F-9AFD-7084F7FF0DB7}"/>
               </a:ext>
             </a:extLst>
           </p:cNvPr>
@@ -12628,7 +12628,7 @@
           <p:cNvPr id="21" name="">
             <a:extLst xmlns:a="http://schemas.openxmlformats.org/drawingml/2006/main">
               <a:ext uri="{FF2B5EF4-FFF2-40B4-BE49-F238E27FC236}">
-                <a16:creationId xmlns:a16="http://schemas.microsoft.com/office/drawing/2014/main" id="{AA9A0027-187B-42EC-9537-942CA83EBAB3}"/>
+                <a16:creationId xmlns:a16="http://schemas.microsoft.com/office/drawing/2014/main" id="{6C52805E-5F6F-4567-BA29-29C1B3B37CF4}"/>
               </a:ext>
             </a:extLst>
           </p:cNvPr>
@@ -12692,7 +12692,7 @@
           <p:cNvPr id="22" name="">
             <a:extLst xmlns:a="http://schemas.openxmlformats.org/drawingml/2006/main">
               <a:ext uri="{FF2B5EF4-FFF2-40B4-BE49-F238E27FC236}">
-                <a16:creationId xmlns:a16="http://schemas.microsoft.com/office/drawing/2014/main" id="{62151463-01DB-4099-B0AC-D9AC8B35BCAF}"/>
+                <a16:creationId xmlns:a16="http://schemas.microsoft.com/office/drawing/2014/main" id="{CBCF797C-F80F-4766-BB23-49CBA0FF2FC0}"/>
               </a:ext>
             </a:extLst>
           </p:cNvPr>
@@ -12756,7 +12756,7 @@
           <p:cNvPr id="23" name="">
             <a:extLst xmlns:a="http://schemas.openxmlformats.org/drawingml/2006/main">
               <a:ext uri="{FF2B5EF4-FFF2-40B4-BE49-F238E27FC236}">
-                <a16:creationId xmlns:a16="http://schemas.microsoft.com/office/drawing/2014/main" id="{F2855EAD-4E06-48E0-A1B2-DAFFCBF76D3F}"/>
+                <a16:creationId xmlns:a16="http://schemas.microsoft.com/office/drawing/2014/main" id="{A1BAEBDE-93D1-4CEF-9AC1-210F2446FA76}"/>
               </a:ext>
             </a:extLst>
           </p:cNvPr>
@@ -12820,7 +12820,7 @@
           <p:cNvPr id="24" name="">
             <a:extLst xmlns:a="http://schemas.openxmlformats.org/drawingml/2006/main">
               <a:ext uri="{FF2B5EF4-FFF2-40B4-BE49-F238E27FC236}">
-                <a16:creationId xmlns:a16="http://schemas.microsoft.com/office/drawing/2014/main" id="{A30980FE-8B50-42C0-B72F-A539BCD07593}"/>
+                <a16:creationId xmlns:a16="http://schemas.microsoft.com/office/drawing/2014/main" id="{8FEE5716-134F-4C81-B7F0-1B8CFA850CD1}"/>
               </a:ext>
             </a:extLst>
           </p:cNvPr>
@@ -12853,7 +12853,7 @@
           <p:cNvPr id="25" name="">
             <a:extLst xmlns:a="http://schemas.openxmlformats.org/drawingml/2006/main">
               <a:ext uri="{FF2B5EF4-FFF2-40B4-BE49-F238E27FC236}">
-                <a16:creationId xmlns:a16="http://schemas.microsoft.com/office/drawing/2014/main" id="{21E9B75A-E5BA-4C55-B577-E3708D69EBB1}"/>
+                <a16:creationId xmlns:a16="http://schemas.microsoft.com/office/drawing/2014/main" id="{07C103A2-BBE3-4D30-B734-5F67198FA2D8}"/>
               </a:ext>
             </a:extLst>
           </p:cNvPr>
@@ -12917,7 +12917,7 @@
           <p:cNvPr id="26" name="">
             <a:extLst xmlns:a="http://schemas.openxmlformats.org/drawingml/2006/main">
               <a:ext uri="{FF2B5EF4-FFF2-40B4-BE49-F238E27FC236}">
-                <a16:creationId xmlns:a16="http://schemas.microsoft.com/office/drawing/2014/main" id="{B1EFECBE-AD5E-478F-A88D-5AADF330485A}"/>
+                <a16:creationId xmlns:a16="http://schemas.microsoft.com/office/drawing/2014/main" id="{07BB1531-8497-49A0-82F1-10D2793D9A11}"/>
               </a:ext>
             </a:extLst>
           </p:cNvPr>
@@ -12979,7 +12979,7 @@
     </p:spTree>
     <p:extLst>
       <p:ext uri="{BB962C8B-B14F-4D97-AF65-F5344CB8AC3E}">
-        <p14:creationId xmlns:p14="http://schemas.microsoft.com/office/powerpoint/2010/main" val="410733541"/>
+        <p14:creationId xmlns:p14="http://schemas.microsoft.com/office/powerpoint/2010/main" val="328042313"/>
       </p:ext>
     </p:extLst>
   </p:cSld>
@@ -13007,7 +13007,7 @@
           <p:nvPr/>
         </p:nvPicPr>
         <p:blipFill>
-          <a:blip xmlns:r="http://schemas.openxmlformats.org/officeDocument/2006/relationships" xmlns:a="http://schemas.openxmlformats.org/drawingml/2006/main" r:embed="R481145097c62442a"/>
+          <a:blip xmlns:r="http://schemas.openxmlformats.org/officeDocument/2006/relationships" xmlns:a="http://schemas.openxmlformats.org/drawingml/2006/main" r:embed="Rad6fb19fffc14168"/>
           <a:srcRect xmlns:a="http://schemas.openxmlformats.org/drawingml/2006/main" l="0" t="27" r="0" b="27"/>
           <a:stretch xmlns:a="http://schemas.openxmlformats.org/drawingml/2006/main">
             <a:fillRect l="0" t="0" r="0" b="0"/>
@@ -13028,7 +13028,7 @@
           <p:cNvPr id="2" name="">
             <a:extLst xmlns:a="http://schemas.openxmlformats.org/drawingml/2006/main">
               <a:ext uri="{FF2B5EF4-FFF2-40B4-BE49-F238E27FC236}">
-                <a16:creationId xmlns:a16="http://schemas.microsoft.com/office/drawing/2014/main" id="{EEBD5440-C2D2-4C56-B7F6-D6052F4C8EF5}"/>
+                <a16:creationId xmlns:a16="http://schemas.microsoft.com/office/drawing/2014/main" id="{A7C861C1-0A61-4F2F-A137-82F047E9B1A9}"/>
               </a:ext>
             </a:extLst>
           </p:cNvPr>
@@ -13065,7 +13065,7 @@
           <p:cNvPr id="3" name="">
             <a:extLst xmlns:a="http://schemas.openxmlformats.org/drawingml/2006/main">
               <a:ext uri="{FF2B5EF4-FFF2-40B4-BE49-F238E27FC236}">
-                <a16:creationId xmlns:a16="http://schemas.microsoft.com/office/drawing/2014/main" id="{3E604238-8F14-47AC-A750-05F0476BAB2E}"/>
+                <a16:creationId xmlns:a16="http://schemas.microsoft.com/office/drawing/2014/main" id="{BAF03FE4-F9B4-46A3-A464-DE46B5319620}"/>
               </a:ext>
             </a:extLst>
           </p:cNvPr>
@@ -13102,7 +13102,7 @@
           <p:cNvPr id="4" name="">
             <a:extLst xmlns:a="http://schemas.openxmlformats.org/drawingml/2006/main">
               <a:ext uri="{FF2B5EF4-FFF2-40B4-BE49-F238E27FC236}">
-                <a16:creationId xmlns:a16="http://schemas.microsoft.com/office/drawing/2014/main" id="{76D7E1EC-2B39-417D-9FEF-C0ABCBF9C393}"/>
+                <a16:creationId xmlns:a16="http://schemas.microsoft.com/office/drawing/2014/main" id="{FF2ADE9C-D95C-4000-A521-1E6DD3906394}"/>
               </a:ext>
             </a:extLst>
           </p:cNvPr>
@@ -13166,7 +13166,7 @@
           <p:cNvPr id="5" name="">
             <a:extLst xmlns:a="http://schemas.openxmlformats.org/drawingml/2006/main">
               <a:ext uri="{FF2B5EF4-FFF2-40B4-BE49-F238E27FC236}">
-                <a16:creationId xmlns:a16="http://schemas.microsoft.com/office/drawing/2014/main" id="{8761F6BD-9836-497D-A064-7EA140A9B914}"/>
+                <a16:creationId xmlns:a16="http://schemas.microsoft.com/office/drawing/2014/main" id="{9438A923-7B93-4F0D-98A9-120D1956F05B}"/>
               </a:ext>
             </a:extLst>
           </p:cNvPr>
@@ -13230,7 +13230,7 @@
           <p:cNvPr id="6" name="">
             <a:extLst xmlns:a="http://schemas.openxmlformats.org/drawingml/2006/main">
               <a:ext uri="{FF2B5EF4-FFF2-40B4-BE49-F238E27FC236}">
-                <a16:creationId xmlns:a16="http://schemas.microsoft.com/office/drawing/2014/main" id="{476C7FD0-1EBE-4304-9184-C504C593C10B}"/>
+                <a16:creationId xmlns:a16="http://schemas.microsoft.com/office/drawing/2014/main" id="{66CEA40C-D552-4D3D-86C7-DA1DCD81AA94}"/>
               </a:ext>
             </a:extLst>
           </p:cNvPr>
@@ -13294,19 +13294,19 @@
           <p:cNvPr id="7" name="">
             <a:extLst xmlns:a="http://schemas.openxmlformats.org/drawingml/2006/main">
               <a:ext uri="{FF2B5EF4-FFF2-40B4-BE49-F238E27FC236}">
-                <a16:creationId xmlns:a16="http://schemas.microsoft.com/office/drawing/2014/main" id="{5DEF2E70-24EC-46AA-B5A2-DC3E4823F0D6}"/>
-              </a:ext>
-            </a:extLst>
-          </p:cNvPr>
-          <p:cNvSpPr>
-            <a:spLocks xmlns:a="http://schemas.openxmlformats.org/drawingml/2006/main" noGrp="1"/>
-          </p:cNvSpPr>
-          <p:nvPr/>
-        </p:nvSpPr>
-        <p:spPr>
-          <a:xfrm xmlns:a="http://schemas.openxmlformats.org/drawingml/2006/main">
-            <a:off x="4705350" y="3505200"/>
-            <a:ext cx="2247900" cy="990600"/>
+                <a16:creationId xmlns:a16="http://schemas.microsoft.com/office/drawing/2014/main" id="{24E29944-6B30-4857-85A8-14E35EB97F0B}"/>
+              </a:ext>
+            </a:extLst>
+          </p:cNvPr>
+          <p:cNvSpPr>
+            <a:spLocks xmlns:a="http://schemas.openxmlformats.org/drawingml/2006/main" noGrp="1"/>
+          </p:cNvSpPr>
+          <p:nvPr/>
+        </p:nvSpPr>
+        <p:spPr>
+          <a:xfrm xmlns:a="http://schemas.openxmlformats.org/drawingml/2006/main">
+            <a:off x="4514850" y="3371850"/>
+            <a:ext cx="3143250" cy="876300"/>
           </a:xfrm>
           <a:prstGeom xmlns:a="http://schemas.openxmlformats.org/drawingml/2006/main" prst="rect">
             <a:avLst/>
@@ -13316,7 +13316,7 @@
               <a:alpha val="93333"/>
             </a:srgbClr>
           </a:solidFill>
-          <a:ln xmlns:a="http://schemas.openxmlformats.org/drawingml/2006/main" w="9525">
+          <a:ln xmlns:a="http://schemas.openxmlformats.org/drawingml/2006/main" w="19050">
             <a:solidFill>
               <a:srgbClr val="55E6FF"/>
             </a:solidFill>
@@ -13329,19 +13329,19 @@
           <p:cNvPr id="8" name="">
             <a:extLst xmlns:a="http://schemas.openxmlformats.org/drawingml/2006/main">
               <a:ext uri="{FF2B5EF4-FFF2-40B4-BE49-F238E27FC236}">
-                <a16:creationId xmlns:a16="http://schemas.microsoft.com/office/drawing/2014/main" id="{935D05C6-8DC9-4CAF-9C54-5043589B61F8}"/>
-              </a:ext>
-            </a:extLst>
-          </p:cNvPr>
-          <p:cNvSpPr>
-            <a:spLocks xmlns:a="http://schemas.openxmlformats.org/drawingml/2006/main" noGrp="1"/>
-          </p:cNvSpPr>
-          <p:nvPr/>
-        </p:nvSpPr>
-        <p:spPr>
-          <a:xfrm xmlns:a="http://schemas.openxmlformats.org/drawingml/2006/main">
-            <a:off x="4991100" y="3676650"/>
-            <a:ext cx="1676400" cy="647700"/>
+                <a16:creationId xmlns:a16="http://schemas.microsoft.com/office/drawing/2014/main" id="{31159329-6EBB-4383-BBD8-11A86D66DC21}"/>
+              </a:ext>
+            </a:extLst>
+          </p:cNvPr>
+          <p:cNvSpPr>
+            <a:spLocks xmlns:a="http://schemas.openxmlformats.org/drawingml/2006/main" noGrp="1"/>
+          </p:cNvSpPr>
+          <p:nvPr/>
+        </p:nvSpPr>
+        <p:spPr>
+          <a:xfrm xmlns:a="http://schemas.openxmlformats.org/drawingml/2006/main">
+            <a:off x="4953000" y="3581400"/>
+            <a:ext cx="2266950" cy="514350"/>
           </a:xfrm>
           <a:prstGeom xmlns:a="http://schemas.openxmlformats.org/drawingml/2006/main" prst="rect">
             <a:avLst/>
@@ -13365,7 +13365,7 @@
           <a:lstStyle xmlns:a="http://schemas.openxmlformats.org/drawingml/2006/main"/>
           <a:p xmlns:a="http://schemas.openxmlformats.org/drawingml/2006/main">
             <a:pPr algn="ctr">
-              <a:defRPr sz="1650" b="1">
+              <a:defRPr sz="1800" b="1">
                 <a:solidFill>
                   <a:srgbClr val="EAF8FF"/>
                 </a:solidFill>
@@ -13375,7 +13375,7 @@
               </a:defRPr>
             </a:pPr>
             <a:r>
-              <a:rPr sz="1650" b="1">
+              <a:rPr sz="1800" b="1">
                 <a:solidFill>
                   <a:srgbClr val="EAF8FF"/>
                 </a:solidFill>
@@ -13388,7 +13388,7 @@
           </a:p>
           <a:p xmlns:a="http://schemas.openxmlformats.org/drawingml/2006/main">
             <a:pPr algn="ctr">
-              <a:defRPr sz="1650" b="1">
+              <a:defRPr sz="1800" b="1">
                 <a:solidFill>
                   <a:srgbClr val="EAF8FF"/>
                 </a:solidFill>
@@ -13398,7 +13398,7 @@
               </a:defRPr>
             </a:pPr>
             <a:r>
-              <a:rPr sz="1650" b="1">
+              <a:rPr sz="1800" b="1">
                 <a:solidFill>
                   <a:srgbClr val="EAF8FF"/>
                 </a:solidFill>
@@ -13416,19 +13416,83 @@
           <p:cNvPr id="9" name="">
             <a:extLst xmlns:a="http://schemas.openxmlformats.org/drawingml/2006/main">
               <a:ext uri="{FF2B5EF4-FFF2-40B4-BE49-F238E27FC236}">
-                <a16:creationId xmlns:a16="http://schemas.microsoft.com/office/drawing/2014/main" id="{5D25C8DC-83A8-4397-874F-EB7BF5DC8C30}"/>
-              </a:ext>
-            </a:extLst>
-          </p:cNvPr>
-          <p:cNvSpPr>
-            <a:spLocks xmlns:a="http://schemas.openxmlformats.org/drawingml/2006/main" noGrp="1"/>
-          </p:cNvSpPr>
-          <p:nvPr/>
-        </p:nvSpPr>
-        <p:spPr>
-          <a:xfrm xmlns:a="http://schemas.openxmlformats.org/drawingml/2006/main">
-            <a:off x="4781550" y="2133600"/>
-            <a:ext cx="2095500" cy="647700"/>
+                <a16:creationId xmlns:a16="http://schemas.microsoft.com/office/drawing/2014/main" id="{58514203-06AA-4B5E-AA20-AF174BC0E435}"/>
+              </a:ext>
+            </a:extLst>
+          </p:cNvPr>
+          <p:cNvSpPr>
+            <a:spLocks xmlns:a="http://schemas.openxmlformats.org/drawingml/2006/main" noGrp="1"/>
+          </p:cNvSpPr>
+          <p:nvPr/>
+        </p:nvSpPr>
+        <p:spPr>
+          <a:xfrm xmlns:a="http://schemas.openxmlformats.org/drawingml/2006/main">
+            <a:off x="4171950" y="4457700"/>
+            <a:ext cx="3848100" cy="228600"/>
+          </a:xfrm>
+          <a:prstGeom xmlns:a="http://schemas.openxmlformats.org/drawingml/2006/main" prst="rect">
+            <a:avLst/>
+          </a:prstGeom>
+          <a:solidFill xmlns:a="http://schemas.openxmlformats.org/drawingml/2006/main">
+            <a:srgbClr val="000000">
+              <a:alpha val="0"/>
+            </a:srgbClr>
+          </a:solidFill>
+          <a:ln xmlns:a="http://schemas.openxmlformats.org/drawingml/2006/main" w="0">
+            <a:solidFill>
+              <a:srgbClr val="000000">
+                <a:alpha val="0"/>
+              </a:srgbClr>
+            </a:solidFill>
+            <a:prstDash val="solid"/>
+          </a:ln>
+        </p:spPr>
+        <p:txBody>
+          <a:bodyPr xmlns:a="http://schemas.openxmlformats.org/drawingml/2006/main" lIns="0" tIns="0" rIns="0" bIns="0" anchor="t"/>
+          <a:lstStyle xmlns:a="http://schemas.openxmlformats.org/drawingml/2006/main"/>
+          <a:p xmlns:a="http://schemas.openxmlformats.org/drawingml/2006/main">
+            <a:pPr algn="ctr">
+              <a:defRPr sz="1125" b="1">
+                <a:solidFill>
+                  <a:srgbClr val="55E6FF"/>
+                </a:solidFill>
+                <a:latin typeface="Aptos"/>
+                <a:ea typeface="Aptos"/>
+                <a:cs typeface="Aptos"/>
+              </a:defRPr>
+            </a:pPr>
+            <a:r>
+              <a:rPr sz="1125" b="1">
+                <a:solidFill>
+                  <a:srgbClr val="55E6FF"/>
+                </a:solidFill>
+                <a:latin typeface="Aptos"/>
+                <a:ea typeface="Aptos"/>
+                <a:cs typeface="Aptos"/>
+              </a:rPr>
+              <a:t>Shared IP, data and reusable playbooks</a:t>
+            </a:r>
+          </a:p>
+        </p:txBody>
+      </p:sp>
+      <p:sp>
+        <p:nvSpPr>
+          <p:cNvPr id="10" name="">
+            <a:extLst xmlns:a="http://schemas.openxmlformats.org/drawingml/2006/main">
+              <a:ext uri="{FF2B5EF4-FFF2-40B4-BE49-F238E27FC236}">
+                <a16:creationId xmlns:a16="http://schemas.microsoft.com/office/drawing/2014/main" id="{F9F8C4D2-9A31-44E7-AEF1-912E6351D2F5}"/>
+              </a:ext>
+            </a:extLst>
+          </p:cNvPr>
+          <p:cNvSpPr>
+            <a:spLocks xmlns:a="http://schemas.openxmlformats.org/drawingml/2006/main" noGrp="1"/>
+          </p:cNvSpPr>
+          <p:nvPr/>
+        </p:nvSpPr>
+        <p:spPr>
+          <a:xfrm xmlns:a="http://schemas.openxmlformats.org/drawingml/2006/main">
+            <a:off x="723900" y="5143500"/>
+            <a:ext cx="2038350" cy="723900"/>
           </a:xfrm>
           <a:prstGeom xmlns:a="http://schemas.openxmlformats.org/drawingml/2006/main" prst="rect">
             <a:avLst/>
@@ -13448,22 +13512,22 @@
       </p:sp>
       <p:sp>
         <p:nvSpPr>
-          <p:cNvPr id="10" name="">
-            <a:extLst xmlns:a="http://schemas.openxmlformats.org/drawingml/2006/main">
-              <a:ext uri="{FF2B5EF4-FFF2-40B4-BE49-F238E27FC236}">
-                <a16:creationId xmlns:a16="http://schemas.microsoft.com/office/drawing/2014/main" id="{D481910D-DC5C-476D-8FFB-7BB53F9242DC}"/>
-              </a:ext>
-            </a:extLst>
-          </p:cNvPr>
-          <p:cNvSpPr>
-            <a:spLocks xmlns:a="http://schemas.openxmlformats.org/drawingml/2006/main" noGrp="1"/>
-          </p:cNvSpPr>
-          <p:nvPr/>
-        </p:nvSpPr>
-        <p:spPr>
-          <a:xfrm xmlns:a="http://schemas.openxmlformats.org/drawingml/2006/main">
-            <a:off x="4953000" y="2305050"/>
-            <a:ext cx="1752600" cy="247650"/>
+          <p:cNvPr id="11" name="">
+            <a:extLst xmlns:a="http://schemas.openxmlformats.org/drawingml/2006/main">
+              <a:ext uri="{FF2B5EF4-FFF2-40B4-BE49-F238E27FC236}">
+                <a16:creationId xmlns:a16="http://schemas.microsoft.com/office/drawing/2014/main" id="{8BF5DFCA-F0FA-41E8-9B72-0B0D6DB9C336}"/>
+              </a:ext>
+            </a:extLst>
+          </p:cNvPr>
+          <p:cNvSpPr>
+            <a:spLocks xmlns:a="http://schemas.openxmlformats.org/drawingml/2006/main" noGrp="1"/>
+          </p:cNvSpPr>
+          <p:nvPr/>
+        </p:nvSpPr>
+        <p:spPr>
+          <a:xfrm xmlns:a="http://schemas.openxmlformats.org/drawingml/2006/main">
+            <a:off x="857250" y="5353050"/>
+            <a:ext cx="1771650" cy="266700"/>
           </a:xfrm>
           <a:prstGeom xmlns:a="http://schemas.openxmlformats.org/drawingml/2006/main" prst="rect">
             <a:avLst/>
@@ -13512,22 +13576,22 @@
       </p:sp>
       <p:sp>
         <p:nvSpPr>
-          <p:cNvPr id="11" name="">
-            <a:extLst xmlns:a="http://schemas.openxmlformats.org/drawingml/2006/main">
-              <a:ext uri="{FF2B5EF4-FFF2-40B4-BE49-F238E27FC236}">
-                <a16:creationId xmlns:a16="http://schemas.microsoft.com/office/drawing/2014/main" id="{6DE3D2C9-397C-4757-82EC-3663CA07F49C}"/>
-              </a:ext>
-            </a:extLst>
-          </p:cNvPr>
-          <p:cNvSpPr>
-            <a:spLocks xmlns:a="http://schemas.openxmlformats.org/drawingml/2006/main" noGrp="1"/>
-          </p:cNvSpPr>
-          <p:nvPr/>
-        </p:nvSpPr>
-        <p:spPr>
-          <a:xfrm xmlns:a="http://schemas.openxmlformats.org/drawingml/2006/main">
-            <a:off x="5829300" y="2457450"/>
-            <a:ext cx="19050" cy="19050"/>
+          <p:cNvPr id="12" name="">
+            <a:extLst xmlns:a="http://schemas.openxmlformats.org/drawingml/2006/main">
+              <a:ext uri="{FF2B5EF4-FFF2-40B4-BE49-F238E27FC236}">
+                <a16:creationId xmlns:a16="http://schemas.microsoft.com/office/drawing/2014/main" id="{F1197852-A6AB-47CF-A367-B58E9D3DD063}"/>
+              </a:ext>
+            </a:extLst>
+          </p:cNvPr>
+          <p:cNvSpPr>
+            <a:spLocks xmlns:a="http://schemas.openxmlformats.org/drawingml/2006/main" noGrp="1"/>
+          </p:cNvSpPr>
+          <p:nvPr/>
+        </p:nvSpPr>
+        <p:spPr>
+          <a:xfrm xmlns:a="http://schemas.openxmlformats.org/drawingml/2006/main">
+            <a:off x="1733550" y="4762500"/>
+            <a:ext cx="19050" cy="381000"/>
           </a:xfrm>
           <a:prstGeom xmlns:a="http://schemas.openxmlformats.org/drawingml/2006/main" prst="rect">
             <a:avLst/>
@@ -13545,22 +13609,22 @@
       </p:sp>
       <p:sp>
         <p:nvSpPr>
-          <p:cNvPr id="12" name="">
-            <a:extLst xmlns:a="http://schemas.openxmlformats.org/drawingml/2006/main">
-              <a:ext uri="{FF2B5EF4-FFF2-40B4-BE49-F238E27FC236}">
-                <a16:creationId xmlns:a16="http://schemas.microsoft.com/office/drawing/2014/main" id="{5741D000-58CB-4A2D-B46A-39BC3245029B}"/>
-              </a:ext>
-            </a:extLst>
-          </p:cNvPr>
-          <p:cNvSpPr>
-            <a:spLocks xmlns:a="http://schemas.openxmlformats.org/drawingml/2006/main" noGrp="1"/>
-          </p:cNvSpPr>
-          <p:nvPr/>
-        </p:nvSpPr>
-        <p:spPr>
-          <a:xfrm xmlns:a="http://schemas.openxmlformats.org/drawingml/2006/main">
-            <a:off x="7879664" y="3199821"/>
-            <a:ext cx="2095500" cy="647700"/>
+          <p:cNvPr id="13" name="">
+            <a:extLst xmlns:a="http://schemas.openxmlformats.org/drawingml/2006/main">
+              <a:ext uri="{FF2B5EF4-FFF2-40B4-BE49-F238E27FC236}">
+                <a16:creationId xmlns:a16="http://schemas.microsoft.com/office/drawing/2014/main" id="{5150BAD5-A666-49F7-AA52-7D37E109FD29}"/>
+              </a:ext>
+            </a:extLst>
+          </p:cNvPr>
+          <p:cNvSpPr>
+            <a:spLocks xmlns:a="http://schemas.openxmlformats.org/drawingml/2006/main" noGrp="1"/>
+          </p:cNvSpPr>
+          <p:nvPr/>
+        </p:nvSpPr>
+        <p:spPr>
+          <a:xfrm xmlns:a="http://schemas.openxmlformats.org/drawingml/2006/main">
+            <a:off x="2895600" y="5143500"/>
+            <a:ext cx="2038350" cy="723900"/>
           </a:xfrm>
           <a:prstGeom xmlns:a="http://schemas.openxmlformats.org/drawingml/2006/main" prst="rect">
             <a:avLst/>
@@ -13580,22 +13644,154 @@
       </p:sp>
       <p:sp>
         <p:nvSpPr>
-          <p:cNvPr id="13" name="">
-            <a:extLst xmlns:a="http://schemas.openxmlformats.org/drawingml/2006/main">
-              <a:ext uri="{FF2B5EF4-FFF2-40B4-BE49-F238E27FC236}">
-                <a16:creationId xmlns:a16="http://schemas.microsoft.com/office/drawing/2014/main" id="{F4DBE17A-AEB3-4BCE-93F8-E72F7CCC78B6}"/>
-              </a:ext>
-            </a:extLst>
-          </p:cNvPr>
-          <p:cNvSpPr>
-            <a:spLocks xmlns:a="http://schemas.openxmlformats.org/drawingml/2006/main" noGrp="1"/>
-          </p:cNvSpPr>
-          <p:nvPr/>
-        </p:nvSpPr>
-        <p:spPr>
-          <a:xfrm xmlns:a="http://schemas.openxmlformats.org/drawingml/2006/main">
-            <a:off x="8051114" y="3371271"/>
-            <a:ext cx="1752600" cy="247650"/>
+          <p:cNvPr id="14" name="">
+            <a:extLst xmlns:a="http://schemas.openxmlformats.org/drawingml/2006/main">
+              <a:ext uri="{FF2B5EF4-FFF2-40B4-BE49-F238E27FC236}">
+                <a16:creationId xmlns:a16="http://schemas.microsoft.com/office/drawing/2014/main" id="{7A50FE18-1478-4A82-A318-99E490E2B0D5}"/>
+              </a:ext>
+            </a:extLst>
+          </p:cNvPr>
+          <p:cNvSpPr>
+            <a:spLocks xmlns:a="http://schemas.openxmlformats.org/drawingml/2006/main" noGrp="1"/>
+          </p:cNvSpPr>
+          <p:nvPr/>
+        </p:nvSpPr>
+        <p:spPr>
+          <a:xfrm xmlns:a="http://schemas.openxmlformats.org/drawingml/2006/main">
+            <a:off x="3028950" y="5353050"/>
+            <a:ext cx="1771650" cy="266700"/>
+          </a:xfrm>
+          <a:prstGeom xmlns:a="http://schemas.openxmlformats.org/drawingml/2006/main" prst="rect">
+            <a:avLst/>
+          </a:prstGeom>
+          <a:solidFill xmlns:a="http://schemas.openxmlformats.org/drawingml/2006/main">
+            <a:srgbClr val="000000">
+              <a:alpha val="0"/>
+            </a:srgbClr>
+          </a:solidFill>
+          <a:ln xmlns:a="http://schemas.openxmlformats.org/drawingml/2006/main" w="0">
+            <a:solidFill>
+              <a:srgbClr val="000000">
+                <a:alpha val="0"/>
+              </a:srgbClr>
+            </a:solidFill>
+            <a:prstDash val="solid"/>
+          </a:ln>
+        </p:spPr>
+        <p:txBody>
+          <a:bodyPr xmlns:a="http://schemas.openxmlformats.org/drawingml/2006/main" lIns="0" tIns="0" rIns="0" bIns="0" anchor="t"/>
+          <a:lstStyle xmlns:a="http://schemas.openxmlformats.org/drawingml/2006/main"/>
+          <a:p xmlns:a="http://schemas.openxmlformats.org/drawingml/2006/main">
+            <a:pPr algn="ctr">
+              <a:defRPr sz="1125" b="1">
+                <a:solidFill>
+                  <a:srgbClr val="EAF8FF"/>
+                </a:solidFill>
+                <a:latin typeface="Aptos"/>
+                <a:ea typeface="Aptos"/>
+                <a:cs typeface="Aptos"/>
+              </a:defRPr>
+            </a:pPr>
+            <a:r>
+              <a:rPr sz="1125" b="1">
+                <a:solidFill>
+                  <a:srgbClr val="EAF8FF"/>
+                </a:solidFill>
+                <a:latin typeface="Aptos"/>
+                <a:ea typeface="Aptos"/>
+                <a:cs typeface="Aptos"/>
+              </a:rPr>
+              <a:t>Artificial intelligence</a:t>
+            </a:r>
+          </a:p>
+        </p:txBody>
+      </p:sp>
+      <p:sp>
+        <p:nvSpPr>
+          <p:cNvPr id="15" name="">
+            <a:extLst xmlns:a="http://schemas.openxmlformats.org/drawingml/2006/main">
+              <a:ext uri="{FF2B5EF4-FFF2-40B4-BE49-F238E27FC236}">
+                <a16:creationId xmlns:a16="http://schemas.microsoft.com/office/drawing/2014/main" id="{C4033A3E-3456-4892-9FD1-F364FB5E7BE6}"/>
+              </a:ext>
+            </a:extLst>
+          </p:cNvPr>
+          <p:cNvSpPr>
+            <a:spLocks xmlns:a="http://schemas.openxmlformats.org/drawingml/2006/main" noGrp="1"/>
+          </p:cNvSpPr>
+          <p:nvPr/>
+        </p:nvSpPr>
+        <p:spPr>
+          <a:xfrm xmlns:a="http://schemas.openxmlformats.org/drawingml/2006/main">
+            <a:off x="3905250" y="4762500"/>
+            <a:ext cx="19050" cy="381000"/>
+          </a:xfrm>
+          <a:prstGeom xmlns:a="http://schemas.openxmlformats.org/drawingml/2006/main" prst="rect">
+            <a:avLst/>
+          </a:prstGeom>
+          <a:solidFill xmlns:a="http://schemas.openxmlformats.org/drawingml/2006/main">
+            <a:srgbClr val="285563"/>
+          </a:solidFill>
+          <a:ln xmlns:a="http://schemas.openxmlformats.org/drawingml/2006/main" w="0">
+            <a:solidFill>
+              <a:srgbClr val="285563"/>
+            </a:solidFill>
+            <a:prstDash val="solid"/>
+          </a:ln>
+        </p:spPr>
+      </p:sp>
+      <p:sp>
+        <p:nvSpPr>
+          <p:cNvPr id="16" name="">
+            <a:extLst xmlns:a="http://schemas.openxmlformats.org/drawingml/2006/main">
+              <a:ext uri="{FF2B5EF4-FFF2-40B4-BE49-F238E27FC236}">
+                <a16:creationId xmlns:a16="http://schemas.microsoft.com/office/drawing/2014/main" id="{2885E714-78A3-4DCA-AA43-029B6745991A}"/>
+              </a:ext>
+            </a:extLst>
+          </p:cNvPr>
+          <p:cNvSpPr>
+            <a:spLocks xmlns:a="http://schemas.openxmlformats.org/drawingml/2006/main" noGrp="1"/>
+          </p:cNvSpPr>
+          <p:nvPr/>
+        </p:nvSpPr>
+        <p:spPr>
+          <a:xfrm xmlns:a="http://schemas.openxmlformats.org/drawingml/2006/main">
+            <a:off x="5067300" y="5143500"/>
+            <a:ext cx="2038350" cy="723900"/>
+          </a:xfrm>
+          <a:prstGeom xmlns:a="http://schemas.openxmlformats.org/drawingml/2006/main" prst="rect">
+            <a:avLst/>
+          </a:prstGeom>
+          <a:solidFill xmlns:a="http://schemas.openxmlformats.org/drawingml/2006/main">
+            <a:srgbClr val="081A23">
+              <a:alpha val="86667"/>
+            </a:srgbClr>
+          </a:solidFill>
+          <a:ln xmlns:a="http://schemas.openxmlformats.org/drawingml/2006/main" w="9525">
+            <a:solidFill>
+              <a:srgbClr val="25505B"/>
+            </a:solidFill>
+            <a:prstDash val="solid"/>
+          </a:ln>
+        </p:spPr>
+      </p:sp>
+      <p:sp>
+        <p:nvSpPr>
+          <p:cNvPr id="17" name="">
+            <a:extLst xmlns:a="http://schemas.openxmlformats.org/drawingml/2006/main">
+              <a:ext uri="{FF2B5EF4-FFF2-40B4-BE49-F238E27FC236}">
+                <a16:creationId xmlns:a16="http://schemas.microsoft.com/office/drawing/2014/main" id="{C2E3544C-6EE0-4C19-9102-D2E578596B00}"/>
+              </a:ext>
+            </a:extLst>
+          </p:cNvPr>
+          <p:cNvSpPr>
+            <a:spLocks xmlns:a="http://schemas.openxmlformats.org/drawingml/2006/main" noGrp="1"/>
+          </p:cNvSpPr>
+          <p:nvPr/>
+        </p:nvSpPr>
+        <p:spPr>
+          <a:xfrm xmlns:a="http://schemas.openxmlformats.org/drawingml/2006/main">
+            <a:off x="5200650" y="5353050"/>
+            <a:ext cx="1771650" cy="266700"/>
           </a:xfrm>
           <a:prstGeom xmlns:a="http://schemas.openxmlformats.org/drawingml/2006/main" prst="rect">
             <a:avLst/>
@@ -13637,29 +13833,29 @@
                 <a:ea typeface="Aptos"/>
                 <a:cs typeface="Aptos"/>
               </a:rPr>
-              <a:t>Artificial intelligence</a:t>
+              <a:t>Video games</a:t>
             </a:r>
           </a:p>
         </p:txBody>
       </p:sp>
       <p:sp>
         <p:nvSpPr>
-          <p:cNvPr id="14" name="">
-            <a:extLst xmlns:a="http://schemas.openxmlformats.org/drawingml/2006/main">
-              <a:ext uri="{FF2B5EF4-FFF2-40B4-BE49-F238E27FC236}">
-                <a16:creationId xmlns:a16="http://schemas.microsoft.com/office/drawing/2014/main" id="{0D93EDB1-E8B5-4725-A2A4-3F0B3DFB2AC2}"/>
-              </a:ext>
-            </a:extLst>
-          </p:cNvPr>
-          <p:cNvSpPr>
-            <a:spLocks xmlns:a="http://schemas.openxmlformats.org/drawingml/2006/main" noGrp="1"/>
-          </p:cNvSpPr>
-          <p:nvPr/>
-        </p:nvSpPr>
-        <p:spPr>
-          <a:xfrm xmlns:a="http://schemas.openxmlformats.org/drawingml/2006/main">
-            <a:off x="5829300" y="3523671"/>
-            <a:ext cx="3098114" cy="19050"/>
+          <p:cNvPr id="18" name="">
+            <a:extLst xmlns:a="http://schemas.openxmlformats.org/drawingml/2006/main">
+              <a:ext uri="{FF2B5EF4-FFF2-40B4-BE49-F238E27FC236}">
+                <a16:creationId xmlns:a16="http://schemas.microsoft.com/office/drawing/2014/main" id="{64AA5AEB-9537-4D3F-BCE6-8FE878AD3179}"/>
+              </a:ext>
+            </a:extLst>
+          </p:cNvPr>
+          <p:cNvSpPr>
+            <a:spLocks xmlns:a="http://schemas.openxmlformats.org/drawingml/2006/main" noGrp="1"/>
+          </p:cNvSpPr>
+          <p:nvPr/>
+        </p:nvSpPr>
+        <p:spPr>
+          <a:xfrm xmlns:a="http://schemas.openxmlformats.org/drawingml/2006/main">
+            <a:off x="6076950" y="4762500"/>
+            <a:ext cx="19050" cy="381000"/>
           </a:xfrm>
           <a:prstGeom xmlns:a="http://schemas.openxmlformats.org/drawingml/2006/main" prst="rect">
             <a:avLst/>
@@ -13677,22 +13873,22 @@
       </p:sp>
       <p:sp>
         <p:nvSpPr>
-          <p:cNvPr id="15" name="">
-            <a:extLst xmlns:a="http://schemas.openxmlformats.org/drawingml/2006/main">
-              <a:ext uri="{FF2B5EF4-FFF2-40B4-BE49-F238E27FC236}">
-                <a16:creationId xmlns:a16="http://schemas.microsoft.com/office/drawing/2014/main" id="{FAEC3BCC-0847-47B9-BF12-6C5F708C6561}"/>
-              </a:ext>
-            </a:extLst>
-          </p:cNvPr>
-          <p:cNvSpPr>
-            <a:spLocks xmlns:a="http://schemas.openxmlformats.org/drawingml/2006/main" noGrp="1"/>
-          </p:cNvSpPr>
-          <p:nvPr/>
-        </p:nvSpPr>
-        <p:spPr>
-          <a:xfrm xmlns:a="http://schemas.openxmlformats.org/drawingml/2006/main">
-            <a:off x="6696290" y="4925004"/>
-            <a:ext cx="2095500" cy="647700"/>
+          <p:cNvPr id="19" name="">
+            <a:extLst xmlns:a="http://schemas.openxmlformats.org/drawingml/2006/main">
+              <a:ext uri="{FF2B5EF4-FFF2-40B4-BE49-F238E27FC236}">
+                <a16:creationId xmlns:a16="http://schemas.microsoft.com/office/drawing/2014/main" id="{09BB63FD-C3C1-4A57-9B20-E35E4AEFF2EC}"/>
+              </a:ext>
+            </a:extLst>
+          </p:cNvPr>
+          <p:cNvSpPr>
+            <a:spLocks xmlns:a="http://schemas.openxmlformats.org/drawingml/2006/main" noGrp="1"/>
+          </p:cNvSpPr>
+          <p:nvPr/>
+        </p:nvSpPr>
+        <p:spPr>
+          <a:xfrm xmlns:a="http://schemas.openxmlformats.org/drawingml/2006/main">
+            <a:off x="7239000" y="5143500"/>
+            <a:ext cx="2038350" cy="723900"/>
           </a:xfrm>
           <a:prstGeom xmlns:a="http://schemas.openxmlformats.org/drawingml/2006/main" prst="rect">
             <a:avLst/>
@@ -13712,22 +13908,22 @@
       </p:sp>
       <p:sp>
         <p:nvSpPr>
-          <p:cNvPr id="16" name="">
-            <a:extLst xmlns:a="http://schemas.openxmlformats.org/drawingml/2006/main">
-              <a:ext uri="{FF2B5EF4-FFF2-40B4-BE49-F238E27FC236}">
-                <a16:creationId xmlns:a16="http://schemas.microsoft.com/office/drawing/2014/main" id="{3F64DEA9-9143-4050-8118-DB557B9404D4}"/>
-              </a:ext>
-            </a:extLst>
-          </p:cNvPr>
-          <p:cNvSpPr>
-            <a:spLocks xmlns:a="http://schemas.openxmlformats.org/drawingml/2006/main" noGrp="1"/>
-          </p:cNvSpPr>
-          <p:nvPr/>
-        </p:nvSpPr>
-        <p:spPr>
-          <a:xfrm xmlns:a="http://schemas.openxmlformats.org/drawingml/2006/main">
-            <a:off x="6867740" y="5096454"/>
-            <a:ext cx="1752600" cy="247650"/>
+          <p:cNvPr id="20" name="">
+            <a:extLst xmlns:a="http://schemas.openxmlformats.org/drawingml/2006/main">
+              <a:ext uri="{FF2B5EF4-FFF2-40B4-BE49-F238E27FC236}">
+                <a16:creationId xmlns:a16="http://schemas.microsoft.com/office/drawing/2014/main" id="{D41FCE11-44DC-4E4C-BA7A-71CDABBB9A4A}"/>
+              </a:ext>
+            </a:extLst>
+          </p:cNvPr>
+          <p:cNvSpPr>
+            <a:spLocks xmlns:a="http://schemas.openxmlformats.org/drawingml/2006/main" noGrp="1"/>
+          </p:cNvSpPr>
+          <p:nvPr/>
+        </p:nvSpPr>
+        <p:spPr>
+          <a:xfrm xmlns:a="http://schemas.openxmlformats.org/drawingml/2006/main">
+            <a:off x="7372350" y="5353050"/>
+            <a:ext cx="1771650" cy="266700"/>
           </a:xfrm>
           <a:prstGeom xmlns:a="http://schemas.openxmlformats.org/drawingml/2006/main" prst="rect">
             <a:avLst/>
@@ -13769,29 +13965,29 @@
                 <a:ea typeface="Aptos"/>
                 <a:cs typeface="Aptos"/>
               </a:rPr>
-              <a:t>Video games</a:t>
+              <a:t>Robotics</a:t>
             </a:r>
           </a:p>
         </p:txBody>
       </p:sp>
       <p:sp>
         <p:nvSpPr>
-          <p:cNvPr id="17" name="">
-            <a:extLst xmlns:a="http://schemas.openxmlformats.org/drawingml/2006/main">
-              <a:ext uri="{FF2B5EF4-FFF2-40B4-BE49-F238E27FC236}">
-                <a16:creationId xmlns:a16="http://schemas.microsoft.com/office/drawing/2014/main" id="{65D45829-2287-413E-95BA-3D961BF611EB}"/>
-              </a:ext>
-            </a:extLst>
-          </p:cNvPr>
-          <p:cNvSpPr>
-            <a:spLocks xmlns:a="http://schemas.openxmlformats.org/drawingml/2006/main" noGrp="1"/>
-          </p:cNvSpPr>
-          <p:nvPr/>
-        </p:nvSpPr>
-        <p:spPr>
-          <a:xfrm xmlns:a="http://schemas.openxmlformats.org/drawingml/2006/main">
-            <a:off x="5829300" y="4000500"/>
-            <a:ext cx="1914740" cy="19050"/>
+          <p:cNvPr id="21" name="">
+            <a:extLst xmlns:a="http://schemas.openxmlformats.org/drawingml/2006/main">
+              <a:ext uri="{FF2B5EF4-FFF2-40B4-BE49-F238E27FC236}">
+                <a16:creationId xmlns:a16="http://schemas.microsoft.com/office/drawing/2014/main" id="{8B8D470A-6369-456E-95E7-D6D58CABA4B4}"/>
+              </a:ext>
+            </a:extLst>
+          </p:cNvPr>
+          <p:cNvSpPr>
+            <a:spLocks xmlns:a="http://schemas.openxmlformats.org/drawingml/2006/main" noGrp="1"/>
+          </p:cNvSpPr>
+          <p:nvPr/>
+        </p:nvSpPr>
+        <p:spPr>
+          <a:xfrm xmlns:a="http://schemas.openxmlformats.org/drawingml/2006/main">
+            <a:off x="8248650" y="4762500"/>
+            <a:ext cx="19050" cy="381000"/>
           </a:xfrm>
           <a:prstGeom xmlns:a="http://schemas.openxmlformats.org/drawingml/2006/main" prst="rect">
             <a:avLst/>
@@ -13809,22 +14005,22 @@
       </p:sp>
       <p:sp>
         <p:nvSpPr>
-          <p:cNvPr id="18" name="">
-            <a:extLst xmlns:a="http://schemas.openxmlformats.org/drawingml/2006/main">
-              <a:ext uri="{FF2B5EF4-FFF2-40B4-BE49-F238E27FC236}">
-                <a16:creationId xmlns:a16="http://schemas.microsoft.com/office/drawing/2014/main" id="{E14E4DB5-8A96-4B3B-B994-8454720F404F}"/>
-              </a:ext>
-            </a:extLst>
-          </p:cNvPr>
-          <p:cNvSpPr>
-            <a:spLocks xmlns:a="http://schemas.openxmlformats.org/drawingml/2006/main" noGrp="1"/>
-          </p:cNvSpPr>
-          <p:nvPr/>
-        </p:nvSpPr>
-        <p:spPr>
-          <a:xfrm xmlns:a="http://schemas.openxmlformats.org/drawingml/2006/main">
-            <a:off x="2866810" y="4925004"/>
-            <a:ext cx="2095500" cy="647700"/>
+          <p:cNvPr id="22" name="">
+            <a:extLst xmlns:a="http://schemas.openxmlformats.org/drawingml/2006/main">
+              <a:ext uri="{FF2B5EF4-FFF2-40B4-BE49-F238E27FC236}">
+                <a16:creationId xmlns:a16="http://schemas.microsoft.com/office/drawing/2014/main" id="{A4B2DFAA-3152-4264-A09D-A671C31DDC93}"/>
+              </a:ext>
+            </a:extLst>
+          </p:cNvPr>
+          <p:cNvSpPr>
+            <a:spLocks xmlns:a="http://schemas.openxmlformats.org/drawingml/2006/main" noGrp="1"/>
+          </p:cNvSpPr>
+          <p:nvPr/>
+        </p:nvSpPr>
+        <p:spPr>
+          <a:xfrm xmlns:a="http://schemas.openxmlformats.org/drawingml/2006/main">
+            <a:off x="9410700" y="5143500"/>
+            <a:ext cx="2038350" cy="723900"/>
           </a:xfrm>
           <a:prstGeom xmlns:a="http://schemas.openxmlformats.org/drawingml/2006/main" prst="rect">
             <a:avLst/>
@@ -13844,22 +14040,22 @@
       </p:sp>
       <p:sp>
         <p:nvSpPr>
-          <p:cNvPr id="19" name="">
-            <a:extLst xmlns:a="http://schemas.openxmlformats.org/drawingml/2006/main">
-              <a:ext uri="{FF2B5EF4-FFF2-40B4-BE49-F238E27FC236}">
-                <a16:creationId xmlns:a16="http://schemas.microsoft.com/office/drawing/2014/main" id="{D762C3B3-B496-4072-8879-D4C267926FDF}"/>
-              </a:ext>
-            </a:extLst>
-          </p:cNvPr>
-          <p:cNvSpPr>
-            <a:spLocks xmlns:a="http://schemas.openxmlformats.org/drawingml/2006/main" noGrp="1"/>
-          </p:cNvSpPr>
-          <p:nvPr/>
-        </p:nvSpPr>
-        <p:spPr>
-          <a:xfrm xmlns:a="http://schemas.openxmlformats.org/drawingml/2006/main">
-            <a:off x="3038260" y="5096454"/>
-            <a:ext cx="1752600" cy="247650"/>
+          <p:cNvPr id="23" name="">
+            <a:extLst xmlns:a="http://schemas.openxmlformats.org/drawingml/2006/main">
+              <a:ext uri="{FF2B5EF4-FFF2-40B4-BE49-F238E27FC236}">
+                <a16:creationId xmlns:a16="http://schemas.microsoft.com/office/drawing/2014/main" id="{4188E74A-9F9E-4E2B-9654-516F7979A150}"/>
+              </a:ext>
+            </a:extLst>
+          </p:cNvPr>
+          <p:cNvSpPr>
+            <a:spLocks xmlns:a="http://schemas.openxmlformats.org/drawingml/2006/main" noGrp="1"/>
+          </p:cNvSpPr>
+          <p:nvPr/>
+        </p:nvSpPr>
+        <p:spPr>
+          <a:xfrm xmlns:a="http://schemas.openxmlformats.org/drawingml/2006/main">
+            <a:off x="9544050" y="5353050"/>
+            <a:ext cx="1771650" cy="266700"/>
           </a:xfrm>
           <a:prstGeom xmlns:a="http://schemas.openxmlformats.org/drawingml/2006/main" prst="rect">
             <a:avLst/>
@@ -13901,138 +14097,6 @@
                 <a:ea typeface="Aptos"/>
                 <a:cs typeface="Aptos"/>
               </a:rPr>
-              <a:t>Robotics</a:t>
-            </a:r>
-          </a:p>
-        </p:txBody>
-      </p:sp>
-      <p:sp>
-        <p:nvSpPr>
-          <p:cNvPr id="20" name="">
-            <a:extLst xmlns:a="http://schemas.openxmlformats.org/drawingml/2006/main">
-              <a:ext uri="{FF2B5EF4-FFF2-40B4-BE49-F238E27FC236}">
-                <a16:creationId xmlns:a16="http://schemas.microsoft.com/office/drawing/2014/main" id="{93613B91-397B-4B5B-BE4C-C8F2FEE5B166}"/>
-              </a:ext>
-            </a:extLst>
-          </p:cNvPr>
-          <p:cNvSpPr>
-            <a:spLocks xmlns:a="http://schemas.openxmlformats.org/drawingml/2006/main" noGrp="1"/>
-          </p:cNvSpPr>
-          <p:nvPr/>
-        </p:nvSpPr>
-        <p:spPr>
-          <a:xfrm xmlns:a="http://schemas.openxmlformats.org/drawingml/2006/main">
-            <a:off x="3914560" y="4000500"/>
-            <a:ext cx="1914740" cy="19050"/>
-          </a:xfrm>
-          <a:prstGeom xmlns:a="http://schemas.openxmlformats.org/drawingml/2006/main" prst="rect">
-            <a:avLst/>
-          </a:prstGeom>
-          <a:solidFill xmlns:a="http://schemas.openxmlformats.org/drawingml/2006/main">
-            <a:srgbClr val="285563"/>
-          </a:solidFill>
-          <a:ln xmlns:a="http://schemas.openxmlformats.org/drawingml/2006/main" w="0">
-            <a:solidFill>
-              <a:srgbClr val="285563"/>
-            </a:solidFill>
-            <a:prstDash val="solid"/>
-          </a:ln>
-        </p:spPr>
-      </p:sp>
-      <p:sp>
-        <p:nvSpPr>
-          <p:cNvPr id="21" name="">
-            <a:extLst xmlns:a="http://schemas.openxmlformats.org/drawingml/2006/main">
-              <a:ext uri="{FF2B5EF4-FFF2-40B4-BE49-F238E27FC236}">
-                <a16:creationId xmlns:a16="http://schemas.microsoft.com/office/drawing/2014/main" id="{C8D04884-6E9B-4AE3-B333-A6A96DBE325C}"/>
-              </a:ext>
-            </a:extLst>
-          </p:cNvPr>
-          <p:cNvSpPr>
-            <a:spLocks xmlns:a="http://schemas.openxmlformats.org/drawingml/2006/main" noGrp="1"/>
-          </p:cNvSpPr>
-          <p:nvPr/>
-        </p:nvSpPr>
-        <p:spPr>
-          <a:xfrm xmlns:a="http://schemas.openxmlformats.org/drawingml/2006/main">
-            <a:off x="1683436" y="3199821"/>
-            <a:ext cx="2095500" cy="647700"/>
-          </a:xfrm>
-          <a:prstGeom xmlns:a="http://schemas.openxmlformats.org/drawingml/2006/main" prst="rect">
-            <a:avLst/>
-          </a:prstGeom>
-          <a:solidFill xmlns:a="http://schemas.openxmlformats.org/drawingml/2006/main">
-            <a:srgbClr val="081A23">
-              <a:alpha val="86667"/>
-            </a:srgbClr>
-          </a:solidFill>
-          <a:ln xmlns:a="http://schemas.openxmlformats.org/drawingml/2006/main" w="9525">
-            <a:solidFill>
-              <a:srgbClr val="25505B"/>
-            </a:solidFill>
-            <a:prstDash val="solid"/>
-          </a:ln>
-        </p:spPr>
-      </p:sp>
-      <p:sp>
-        <p:nvSpPr>
-          <p:cNvPr id="22" name="">
-            <a:extLst xmlns:a="http://schemas.openxmlformats.org/drawingml/2006/main">
-              <a:ext uri="{FF2B5EF4-FFF2-40B4-BE49-F238E27FC236}">
-                <a16:creationId xmlns:a16="http://schemas.microsoft.com/office/drawing/2014/main" id="{D596B787-3128-44C2-9AC8-8BEAB063F791}"/>
-              </a:ext>
-            </a:extLst>
-          </p:cNvPr>
-          <p:cNvSpPr>
-            <a:spLocks xmlns:a="http://schemas.openxmlformats.org/drawingml/2006/main" noGrp="1"/>
-          </p:cNvSpPr>
-          <p:nvPr/>
-        </p:nvSpPr>
-        <p:spPr>
-          <a:xfrm xmlns:a="http://schemas.openxmlformats.org/drawingml/2006/main">
-            <a:off x="1854886" y="3371271"/>
-            <a:ext cx="1752600" cy="247650"/>
-          </a:xfrm>
-          <a:prstGeom xmlns:a="http://schemas.openxmlformats.org/drawingml/2006/main" prst="rect">
-            <a:avLst/>
-          </a:prstGeom>
-          <a:solidFill xmlns:a="http://schemas.openxmlformats.org/drawingml/2006/main">
-            <a:srgbClr val="000000">
-              <a:alpha val="0"/>
-            </a:srgbClr>
-          </a:solidFill>
-          <a:ln xmlns:a="http://schemas.openxmlformats.org/drawingml/2006/main" w="0">
-            <a:solidFill>
-              <a:srgbClr val="000000">
-                <a:alpha val="0"/>
-              </a:srgbClr>
-            </a:solidFill>
-            <a:prstDash val="solid"/>
-          </a:ln>
-        </p:spPr>
-        <p:txBody>
-          <a:bodyPr xmlns:a="http://schemas.openxmlformats.org/drawingml/2006/main" lIns="0" tIns="0" rIns="0" bIns="0" anchor="t"/>
-          <a:lstStyle xmlns:a="http://schemas.openxmlformats.org/drawingml/2006/main"/>
-          <a:p xmlns:a="http://schemas.openxmlformats.org/drawingml/2006/main">
-            <a:pPr algn="ctr">
-              <a:defRPr sz="1275" b="1">
-                <a:solidFill>
-                  <a:srgbClr val="EAF8FF"/>
-                </a:solidFill>
-                <a:latin typeface="Aptos"/>
-                <a:ea typeface="Aptos"/>
-                <a:cs typeface="Aptos"/>
-              </a:defRPr>
-            </a:pPr>
-            <a:r>
-              <a:rPr sz="1275" b="1">
-                <a:solidFill>
-                  <a:srgbClr val="EAF8FF"/>
-                </a:solidFill>
-                <a:latin typeface="Aptos"/>
-                <a:ea typeface="Aptos"/>
-                <a:cs typeface="Aptos"/>
-              </a:rPr>
               <a:t>Technology consulting</a:t>
             </a:r>
           </a:p>
@@ -14040,22 +14104,22 @@
       </p:sp>
       <p:sp>
         <p:nvSpPr>
-          <p:cNvPr id="23" name="">
-            <a:extLst xmlns:a="http://schemas.openxmlformats.org/drawingml/2006/main">
-              <a:ext uri="{FF2B5EF4-FFF2-40B4-BE49-F238E27FC236}">
-                <a16:creationId xmlns:a16="http://schemas.microsoft.com/office/drawing/2014/main" id="{B4A75AC8-C630-433E-99A0-2A1ABD9DD37B}"/>
-              </a:ext>
-            </a:extLst>
-          </p:cNvPr>
-          <p:cNvSpPr>
-            <a:spLocks xmlns:a="http://schemas.openxmlformats.org/drawingml/2006/main" noGrp="1"/>
-          </p:cNvSpPr>
-          <p:nvPr/>
-        </p:nvSpPr>
-        <p:spPr>
-          <a:xfrm xmlns:a="http://schemas.openxmlformats.org/drawingml/2006/main">
-            <a:off x="2731186" y="3523671"/>
-            <a:ext cx="3098114" cy="19050"/>
+          <p:cNvPr id="24" name="">
+            <a:extLst xmlns:a="http://schemas.openxmlformats.org/drawingml/2006/main">
+              <a:ext uri="{FF2B5EF4-FFF2-40B4-BE49-F238E27FC236}">
+                <a16:creationId xmlns:a16="http://schemas.microsoft.com/office/drawing/2014/main" id="{2F3C58A8-21B2-4C6F-94D1-8FBE73D8A7FB}"/>
+              </a:ext>
+            </a:extLst>
+          </p:cNvPr>
+          <p:cNvSpPr>
+            <a:spLocks xmlns:a="http://schemas.openxmlformats.org/drawingml/2006/main" noGrp="1"/>
+          </p:cNvSpPr>
+          <p:nvPr/>
+        </p:nvSpPr>
+        <p:spPr>
+          <a:xfrm xmlns:a="http://schemas.openxmlformats.org/drawingml/2006/main">
+            <a:off x="10420350" y="4762500"/>
+            <a:ext cx="19050" cy="381000"/>
           </a:xfrm>
           <a:prstGeom xmlns:a="http://schemas.openxmlformats.org/drawingml/2006/main" prst="rect">
             <a:avLst/>
@@ -14073,10 +14137,43 @@
       </p:sp>
       <p:sp>
         <p:nvSpPr>
-          <p:cNvPr id="24" name="">
-            <a:extLst xmlns:a="http://schemas.openxmlformats.org/drawingml/2006/main">
-              <a:ext uri="{FF2B5EF4-FFF2-40B4-BE49-F238E27FC236}">
-                <a16:creationId xmlns:a16="http://schemas.microsoft.com/office/drawing/2014/main" id="{44AE25E2-FC5B-4DB6-B0A7-0D1DEFBD91B4}"/>
+          <p:cNvPr id="25" name="">
+            <a:extLst xmlns:a="http://schemas.openxmlformats.org/drawingml/2006/main">
+              <a:ext uri="{FF2B5EF4-FFF2-40B4-BE49-F238E27FC236}">
+                <a16:creationId xmlns:a16="http://schemas.microsoft.com/office/drawing/2014/main" id="{89B58E49-DF82-43FA-8603-90CC0C8BFE85}"/>
+              </a:ext>
+            </a:extLst>
+          </p:cNvPr>
+          <p:cNvSpPr>
+            <a:spLocks xmlns:a="http://schemas.openxmlformats.org/drawingml/2006/main" noGrp="1"/>
+          </p:cNvSpPr>
+          <p:nvPr/>
+        </p:nvSpPr>
+        <p:spPr>
+          <a:xfrm xmlns:a="http://schemas.openxmlformats.org/drawingml/2006/main">
+            <a:off x="1743075" y="4762500"/>
+            <a:ext cx="8686800" cy="19050"/>
+          </a:xfrm>
+          <a:prstGeom xmlns:a="http://schemas.openxmlformats.org/drawingml/2006/main" prst="rect">
+            <a:avLst/>
+          </a:prstGeom>
+          <a:solidFill xmlns:a="http://schemas.openxmlformats.org/drawingml/2006/main">
+            <a:srgbClr val="285563"/>
+          </a:solidFill>
+          <a:ln xmlns:a="http://schemas.openxmlformats.org/drawingml/2006/main" w="0">
+            <a:solidFill>
+              <a:srgbClr val="285563"/>
+            </a:solidFill>
+            <a:prstDash val="solid"/>
+          </a:ln>
+        </p:spPr>
+      </p:sp>
+      <p:sp>
+        <p:nvSpPr>
+          <p:cNvPr id="26" name="">
+            <a:extLst xmlns:a="http://schemas.openxmlformats.org/drawingml/2006/main">
+              <a:ext uri="{FF2B5EF4-FFF2-40B4-BE49-F238E27FC236}">
+                <a16:creationId xmlns:a16="http://schemas.microsoft.com/office/drawing/2014/main" id="{789EDA6C-615B-42BC-B142-93814E57B000}"/>
               </a:ext>
             </a:extLst>
           </p:cNvPr>
@@ -14137,10 +14234,10 @@
       </p:sp>
       <p:sp>
         <p:nvSpPr>
-          <p:cNvPr id="25" name="">
-            <a:extLst xmlns:a="http://schemas.openxmlformats.org/drawingml/2006/main">
-              <a:ext uri="{FF2B5EF4-FFF2-40B4-BE49-F238E27FC236}">
-                <a16:creationId xmlns:a16="http://schemas.microsoft.com/office/drawing/2014/main" id="{433571B9-43F6-487F-BCE7-399CD84A59B9}"/>
+          <p:cNvPr id="27" name="">
+            <a:extLst xmlns:a="http://schemas.openxmlformats.org/drawingml/2006/main">
+              <a:ext uri="{FF2B5EF4-FFF2-40B4-BE49-F238E27FC236}">
+                <a16:creationId xmlns:a16="http://schemas.microsoft.com/office/drawing/2014/main" id="{279C4EFC-25BB-40DD-B583-BD9A1C407D55}"/>
               </a:ext>
             </a:extLst>
           </p:cNvPr>
@@ -14170,10 +14267,10 @@
       </p:sp>
       <p:sp>
         <p:nvSpPr>
-          <p:cNvPr id="26" name="">
-            <a:extLst xmlns:a="http://schemas.openxmlformats.org/drawingml/2006/main">
-              <a:ext uri="{FF2B5EF4-FFF2-40B4-BE49-F238E27FC236}">
-                <a16:creationId xmlns:a16="http://schemas.microsoft.com/office/drawing/2014/main" id="{41605E81-F336-4114-8A44-72DA588422CF}"/>
+          <p:cNvPr id="28" name="">
+            <a:extLst xmlns:a="http://schemas.openxmlformats.org/drawingml/2006/main">
+              <a:ext uri="{FF2B5EF4-FFF2-40B4-BE49-F238E27FC236}">
+                <a16:creationId xmlns:a16="http://schemas.microsoft.com/office/drawing/2014/main" id="{E49FEEE9-71B0-4069-B8AB-91A987EE316F}"/>
               </a:ext>
             </a:extLst>
           </p:cNvPr>
@@ -14234,10 +14331,10 @@
       </p:sp>
       <p:sp>
         <p:nvSpPr>
-          <p:cNvPr id="27" name="">
-            <a:extLst xmlns:a="http://schemas.openxmlformats.org/drawingml/2006/main">
-              <a:ext uri="{FF2B5EF4-FFF2-40B4-BE49-F238E27FC236}">
-                <a16:creationId xmlns:a16="http://schemas.microsoft.com/office/drawing/2014/main" id="{2C0AE27D-D274-42F0-8ECF-5109238094ED}"/>
+          <p:cNvPr id="29" name="">
+            <a:extLst xmlns:a="http://schemas.openxmlformats.org/drawingml/2006/main">
+              <a:ext uri="{FF2B5EF4-FFF2-40B4-BE49-F238E27FC236}">
+                <a16:creationId xmlns:a16="http://schemas.microsoft.com/office/drawing/2014/main" id="{88ED960A-5D9C-47A4-B92B-3D211F6AEF95}"/>
               </a:ext>
             </a:extLst>
           </p:cNvPr>
@@ -14299,7 +14396,7 @@
     </p:spTree>
     <p:extLst>
       <p:ext uri="{BB962C8B-B14F-4D97-AF65-F5344CB8AC3E}">
-        <p14:creationId xmlns:p14="http://schemas.microsoft.com/office/powerpoint/2010/main" val="427726564"/>
+        <p14:creationId xmlns:p14="http://schemas.microsoft.com/office/powerpoint/2010/main" val="1364221588"/>
       </p:ext>
     </p:extLst>
   </p:cSld>
@@ -14327,7 +14424,7 @@
           <p:nvPr/>
         </p:nvPicPr>
         <p:blipFill>
-          <a:blip xmlns:r="http://schemas.openxmlformats.org/officeDocument/2006/relationships" xmlns:a="http://schemas.openxmlformats.org/drawingml/2006/main" r:embed="R849b71b857f44e8a"/>
+          <a:blip xmlns:r="http://schemas.openxmlformats.org/officeDocument/2006/relationships" xmlns:a="http://schemas.openxmlformats.org/drawingml/2006/main" r:embed="Rc9ee20fafd5f43bf"/>
           <a:srcRect xmlns:a="http://schemas.openxmlformats.org/drawingml/2006/main" l="0" t="27" r="0" b="27"/>
           <a:stretch xmlns:a="http://schemas.openxmlformats.org/drawingml/2006/main">
             <a:fillRect l="0" t="0" r="0" b="0"/>
@@ -14348,7 +14445,7 @@
           <p:cNvPr id="2" name="">
             <a:extLst xmlns:a="http://schemas.openxmlformats.org/drawingml/2006/main">
               <a:ext uri="{FF2B5EF4-FFF2-40B4-BE49-F238E27FC236}">
-                <a16:creationId xmlns:a16="http://schemas.microsoft.com/office/drawing/2014/main" id="{373ADD8B-BDE4-4EBB-AEF3-2D1B27CF0F66}"/>
+                <a16:creationId xmlns:a16="http://schemas.microsoft.com/office/drawing/2014/main" id="{04BEC5C6-4698-4ABC-A419-1CEED1EA241E}"/>
               </a:ext>
             </a:extLst>
           </p:cNvPr>
@@ -14385,7 +14482,7 @@
           <p:cNvPr id="3" name="">
             <a:extLst xmlns:a="http://schemas.openxmlformats.org/drawingml/2006/main">
               <a:ext uri="{FF2B5EF4-FFF2-40B4-BE49-F238E27FC236}">
-                <a16:creationId xmlns:a16="http://schemas.microsoft.com/office/drawing/2014/main" id="{07FDEA8F-AED5-4CC3-A9AF-EE63446C61CF}"/>
+                <a16:creationId xmlns:a16="http://schemas.microsoft.com/office/drawing/2014/main" id="{E50FC56C-F525-4869-999B-E8273CD9C36C}"/>
               </a:ext>
             </a:extLst>
           </p:cNvPr>
@@ -14422,7 +14519,7 @@
           <p:cNvPr id="4" name="">
             <a:extLst xmlns:a="http://schemas.openxmlformats.org/drawingml/2006/main">
               <a:ext uri="{FF2B5EF4-FFF2-40B4-BE49-F238E27FC236}">
-                <a16:creationId xmlns:a16="http://schemas.microsoft.com/office/drawing/2014/main" id="{A95EB4FA-DDEA-4131-9854-6344F75C5C40}"/>
+                <a16:creationId xmlns:a16="http://schemas.microsoft.com/office/drawing/2014/main" id="{9B658055-1880-40C6-BCEE-9BFC187B6CB2}"/>
               </a:ext>
             </a:extLst>
           </p:cNvPr>
@@ -14486,7 +14583,7 @@
           <p:cNvPr id="5" name="">
             <a:extLst xmlns:a="http://schemas.openxmlformats.org/drawingml/2006/main">
               <a:ext uri="{FF2B5EF4-FFF2-40B4-BE49-F238E27FC236}">
-                <a16:creationId xmlns:a16="http://schemas.microsoft.com/office/drawing/2014/main" id="{3231E8AE-B2BA-4813-9EE8-A2FC0F5CD69F}"/>
+                <a16:creationId xmlns:a16="http://schemas.microsoft.com/office/drawing/2014/main" id="{77B476FD-B1EE-4755-8519-01CDFBE39868}"/>
               </a:ext>
             </a:extLst>
           </p:cNvPr>
@@ -14550,7 +14647,7 @@
           <p:cNvPr id="6" name="">
             <a:extLst xmlns:a="http://schemas.openxmlformats.org/drawingml/2006/main">
               <a:ext uri="{FF2B5EF4-FFF2-40B4-BE49-F238E27FC236}">
-                <a16:creationId xmlns:a16="http://schemas.microsoft.com/office/drawing/2014/main" id="{8E02E940-C163-4D9A-9862-5C393763F16F}"/>
+                <a16:creationId xmlns:a16="http://schemas.microsoft.com/office/drawing/2014/main" id="{E85CB8D7-E2A5-401C-93B4-0719CAEC4494}"/>
               </a:ext>
             </a:extLst>
           </p:cNvPr>
@@ -14614,7 +14711,7 @@
           <p:cNvPr id="7" name="">
             <a:extLst xmlns:a="http://schemas.openxmlformats.org/drawingml/2006/main">
               <a:ext uri="{FF2B5EF4-FFF2-40B4-BE49-F238E27FC236}">
-                <a16:creationId xmlns:a16="http://schemas.microsoft.com/office/drawing/2014/main" id="{8249A056-CA4F-48F3-8CA3-FA847866D4A8}"/>
+                <a16:creationId xmlns:a16="http://schemas.microsoft.com/office/drawing/2014/main" id="{391A90D0-B430-49A2-B4E6-DCF04021DAD0}"/>
               </a:ext>
             </a:extLst>
           </p:cNvPr>
@@ -14649,7 +14746,7 @@
           <p:cNvPr id="8" name="">
             <a:extLst xmlns:a="http://schemas.openxmlformats.org/drawingml/2006/main">
               <a:ext uri="{FF2B5EF4-FFF2-40B4-BE49-F238E27FC236}">
-                <a16:creationId xmlns:a16="http://schemas.microsoft.com/office/drawing/2014/main" id="{6F201C13-8087-4028-B487-7552ED4AB201}"/>
+                <a16:creationId xmlns:a16="http://schemas.microsoft.com/office/drawing/2014/main" id="{00FF3DBB-965F-4C1A-B935-48C6704BABD2}"/>
               </a:ext>
             </a:extLst>
           </p:cNvPr>
@@ -14713,7 +14810,7 @@
           <p:cNvPr id="9" name="">
             <a:extLst xmlns:a="http://schemas.openxmlformats.org/drawingml/2006/main">
               <a:ext uri="{FF2B5EF4-FFF2-40B4-BE49-F238E27FC236}">
-                <a16:creationId xmlns:a16="http://schemas.microsoft.com/office/drawing/2014/main" id="{4B4D00E5-F501-4AA8-87C0-545644603FBB}"/>
+                <a16:creationId xmlns:a16="http://schemas.microsoft.com/office/drawing/2014/main" id="{F5530180-7B3F-41BF-9329-A21C7E6E8C07}"/>
               </a:ext>
             </a:extLst>
           </p:cNvPr>
@@ -14777,7 +14874,7 @@
           <p:cNvPr id="10" name="">
             <a:extLst xmlns:a="http://schemas.openxmlformats.org/drawingml/2006/main">
               <a:ext uri="{FF2B5EF4-FFF2-40B4-BE49-F238E27FC236}">
-                <a16:creationId xmlns:a16="http://schemas.microsoft.com/office/drawing/2014/main" id="{434D4C8D-F6BB-4472-B3E4-C1E33340059C}"/>
+                <a16:creationId xmlns:a16="http://schemas.microsoft.com/office/drawing/2014/main" id="{06CBBFDB-164A-4747-89F0-FA447E97F87D}"/>
               </a:ext>
             </a:extLst>
           </p:cNvPr>
@@ -14810,7 +14907,7 @@
           <p:cNvPr id="11" name="">
             <a:extLst xmlns:a="http://schemas.openxmlformats.org/drawingml/2006/main">
               <a:ext uri="{FF2B5EF4-FFF2-40B4-BE49-F238E27FC236}">
-                <a16:creationId xmlns:a16="http://schemas.microsoft.com/office/drawing/2014/main" id="{141283F8-9088-43D1-B6FD-B8390BF27D11}"/>
+                <a16:creationId xmlns:a16="http://schemas.microsoft.com/office/drawing/2014/main" id="{BA353077-E36C-4E5A-807F-DFF0E4AFF8BC}"/>
               </a:ext>
             </a:extLst>
           </p:cNvPr>
@@ -14845,7 +14942,7 @@
           <p:cNvPr id="12" name="">
             <a:extLst xmlns:a="http://schemas.openxmlformats.org/drawingml/2006/main">
               <a:ext uri="{FF2B5EF4-FFF2-40B4-BE49-F238E27FC236}">
-                <a16:creationId xmlns:a16="http://schemas.microsoft.com/office/drawing/2014/main" id="{EE3F7506-1900-4A34-B97E-AE8518F53C48}"/>
+                <a16:creationId xmlns:a16="http://schemas.microsoft.com/office/drawing/2014/main" id="{F4F95D22-C3C1-44BD-8C74-424C1F062B40}"/>
               </a:ext>
             </a:extLst>
           </p:cNvPr>
@@ -14909,7 +15006,7 @@
           <p:cNvPr id="13" name="">
             <a:extLst xmlns:a="http://schemas.openxmlformats.org/drawingml/2006/main">
               <a:ext uri="{FF2B5EF4-FFF2-40B4-BE49-F238E27FC236}">
-                <a16:creationId xmlns:a16="http://schemas.microsoft.com/office/drawing/2014/main" id="{7F77595A-C0FF-4EBF-905A-0D82665742D3}"/>
+                <a16:creationId xmlns:a16="http://schemas.microsoft.com/office/drawing/2014/main" id="{058D43C1-AE79-4936-A7A2-65BE17DE7047}"/>
               </a:ext>
             </a:extLst>
           </p:cNvPr>
@@ -14973,7 +15070,7 @@
           <p:cNvPr id="14" name="">
             <a:extLst xmlns:a="http://schemas.openxmlformats.org/drawingml/2006/main">
               <a:ext uri="{FF2B5EF4-FFF2-40B4-BE49-F238E27FC236}">
-                <a16:creationId xmlns:a16="http://schemas.microsoft.com/office/drawing/2014/main" id="{4327C796-D5E7-4860-927C-00FD82CF726E}"/>
+                <a16:creationId xmlns:a16="http://schemas.microsoft.com/office/drawing/2014/main" id="{F58A2176-001D-465D-ABFB-23B2CFD36151}"/>
               </a:ext>
             </a:extLst>
           </p:cNvPr>
@@ -15006,7 +15103,7 @@
           <p:cNvPr id="15" name="">
             <a:extLst xmlns:a="http://schemas.openxmlformats.org/drawingml/2006/main">
               <a:ext uri="{FF2B5EF4-FFF2-40B4-BE49-F238E27FC236}">
-                <a16:creationId xmlns:a16="http://schemas.microsoft.com/office/drawing/2014/main" id="{A33E79E1-D47B-4C27-B5B9-4F5F7F0B4245}"/>
+                <a16:creationId xmlns:a16="http://schemas.microsoft.com/office/drawing/2014/main" id="{3DBEF094-01D6-49DF-8C1D-198E7142CC0A}"/>
               </a:ext>
             </a:extLst>
           </p:cNvPr>
@@ -15041,7 +15138,7 @@
           <p:cNvPr id="16" name="">
             <a:extLst xmlns:a="http://schemas.openxmlformats.org/drawingml/2006/main">
               <a:ext uri="{FF2B5EF4-FFF2-40B4-BE49-F238E27FC236}">
-                <a16:creationId xmlns:a16="http://schemas.microsoft.com/office/drawing/2014/main" id="{B63F43AE-0F89-44DF-95BC-6C970EA00241}"/>
+                <a16:creationId xmlns:a16="http://schemas.microsoft.com/office/drawing/2014/main" id="{DB0704C0-A7D4-4DBD-BC3B-9203CE057EBC}"/>
               </a:ext>
             </a:extLst>
           </p:cNvPr>
@@ -15105,7 +15202,7 @@
           <p:cNvPr id="17" name="">
             <a:extLst xmlns:a="http://schemas.openxmlformats.org/drawingml/2006/main">
               <a:ext uri="{FF2B5EF4-FFF2-40B4-BE49-F238E27FC236}">
-                <a16:creationId xmlns:a16="http://schemas.microsoft.com/office/drawing/2014/main" id="{6E35C8A8-EA7D-40CF-8193-4F9B22FCE5BE}"/>
+                <a16:creationId xmlns:a16="http://schemas.microsoft.com/office/drawing/2014/main" id="{4B09FAF0-4D69-4914-A3BA-9BD1B25FDB2A}"/>
               </a:ext>
             </a:extLst>
           </p:cNvPr>
@@ -15169,7 +15266,7 @@
           <p:cNvPr id="18" name="">
             <a:extLst xmlns:a="http://schemas.openxmlformats.org/drawingml/2006/main">
               <a:ext uri="{FF2B5EF4-FFF2-40B4-BE49-F238E27FC236}">
-                <a16:creationId xmlns:a16="http://schemas.microsoft.com/office/drawing/2014/main" id="{DEC2F431-669A-4AAE-B3D9-00415D9DC948}"/>
+                <a16:creationId xmlns:a16="http://schemas.microsoft.com/office/drawing/2014/main" id="{F00CA3EC-00E7-4426-A1DD-4662DF45AB40}"/>
               </a:ext>
             </a:extLst>
           </p:cNvPr>
@@ -15202,7 +15299,7 @@
           <p:cNvPr id="19" name="">
             <a:extLst xmlns:a="http://schemas.openxmlformats.org/drawingml/2006/main">
               <a:ext uri="{FF2B5EF4-FFF2-40B4-BE49-F238E27FC236}">
-                <a16:creationId xmlns:a16="http://schemas.microsoft.com/office/drawing/2014/main" id="{CA6165E3-BA17-49DE-A0AD-30C41F298601}"/>
+                <a16:creationId xmlns:a16="http://schemas.microsoft.com/office/drawing/2014/main" id="{6588E873-EE39-4364-96FB-A8B9A8E6B0BF}"/>
               </a:ext>
             </a:extLst>
           </p:cNvPr>
@@ -15237,7 +15334,7 @@
           <p:cNvPr id="20" name="">
             <a:extLst xmlns:a="http://schemas.openxmlformats.org/drawingml/2006/main">
               <a:ext uri="{FF2B5EF4-FFF2-40B4-BE49-F238E27FC236}">
-                <a16:creationId xmlns:a16="http://schemas.microsoft.com/office/drawing/2014/main" id="{7AA96C6D-0F08-400D-A7A7-A3B2362C13FF}"/>
+                <a16:creationId xmlns:a16="http://schemas.microsoft.com/office/drawing/2014/main" id="{0FBECC94-1DB3-4CAF-9205-6132F8CF7F28}"/>
               </a:ext>
             </a:extLst>
           </p:cNvPr>
@@ -15301,7 +15398,7 @@
           <p:cNvPr id="21" name="">
             <a:extLst xmlns:a="http://schemas.openxmlformats.org/drawingml/2006/main">
               <a:ext uri="{FF2B5EF4-FFF2-40B4-BE49-F238E27FC236}">
-                <a16:creationId xmlns:a16="http://schemas.microsoft.com/office/drawing/2014/main" id="{AF05F393-A633-4157-AFBB-B4DBB1FA69E6}"/>
+                <a16:creationId xmlns:a16="http://schemas.microsoft.com/office/drawing/2014/main" id="{D0A6E6EE-6D4E-4056-830C-9A90F2DFE5ED}"/>
               </a:ext>
             </a:extLst>
           </p:cNvPr>
@@ -15365,7 +15462,7 @@
           <p:cNvPr id="22" name="">
             <a:extLst xmlns:a="http://schemas.openxmlformats.org/drawingml/2006/main">
               <a:ext uri="{FF2B5EF4-FFF2-40B4-BE49-F238E27FC236}">
-                <a16:creationId xmlns:a16="http://schemas.microsoft.com/office/drawing/2014/main" id="{68E0EF39-7ACE-4B9C-9EDB-F38EE0CE2517}"/>
+                <a16:creationId xmlns:a16="http://schemas.microsoft.com/office/drawing/2014/main" id="{60582F19-6503-4F82-B808-5A4C83F1E216}"/>
               </a:ext>
             </a:extLst>
           </p:cNvPr>
@@ -15429,7 +15526,7 @@
           <p:cNvPr id="23" name="">
             <a:extLst xmlns:a="http://schemas.openxmlformats.org/drawingml/2006/main">
               <a:ext uri="{FF2B5EF4-FFF2-40B4-BE49-F238E27FC236}">
-                <a16:creationId xmlns:a16="http://schemas.microsoft.com/office/drawing/2014/main" id="{B55D4CF5-7268-412C-A2CF-2ACDD774D9FE}"/>
+                <a16:creationId xmlns:a16="http://schemas.microsoft.com/office/drawing/2014/main" id="{C7ADCD0B-1A76-4060-B4BC-48DD227ED463}"/>
               </a:ext>
             </a:extLst>
           </p:cNvPr>
@@ -15493,7 +15590,7 @@
           <p:cNvPr id="24" name="">
             <a:extLst xmlns:a="http://schemas.openxmlformats.org/drawingml/2006/main">
               <a:ext uri="{FF2B5EF4-FFF2-40B4-BE49-F238E27FC236}">
-                <a16:creationId xmlns:a16="http://schemas.microsoft.com/office/drawing/2014/main" id="{445A4F8A-D4CE-41B1-9748-F13A3648978F}"/>
+                <a16:creationId xmlns:a16="http://schemas.microsoft.com/office/drawing/2014/main" id="{319B5B18-A5FE-4BE0-A8EB-994E165BAFE7}"/>
               </a:ext>
             </a:extLst>
           </p:cNvPr>
@@ -15526,7 +15623,7 @@
           <p:cNvPr id="25" name="">
             <a:extLst xmlns:a="http://schemas.openxmlformats.org/drawingml/2006/main">
               <a:ext uri="{FF2B5EF4-FFF2-40B4-BE49-F238E27FC236}">
-                <a16:creationId xmlns:a16="http://schemas.microsoft.com/office/drawing/2014/main" id="{0CD6A04C-2E05-4136-B8EC-69D1719357E6}"/>
+                <a16:creationId xmlns:a16="http://schemas.microsoft.com/office/drawing/2014/main" id="{230BCA4F-50FF-4E42-B52E-5E9FD35CD347}"/>
               </a:ext>
             </a:extLst>
           </p:cNvPr>
@@ -15590,7 +15687,7 @@
           <p:cNvPr id="26" name="">
             <a:extLst xmlns:a="http://schemas.openxmlformats.org/drawingml/2006/main">
               <a:ext uri="{FF2B5EF4-FFF2-40B4-BE49-F238E27FC236}">
-                <a16:creationId xmlns:a16="http://schemas.microsoft.com/office/drawing/2014/main" id="{964281D3-A68C-4E59-91B5-A7F2BB71BC66}"/>
+                <a16:creationId xmlns:a16="http://schemas.microsoft.com/office/drawing/2014/main" id="{7CD94B32-5758-43E9-BB2B-023A22D801F6}"/>
               </a:ext>
             </a:extLst>
           </p:cNvPr>
@@ -15652,7 +15749,7 @@
     </p:spTree>
     <p:extLst>
       <p:ext uri="{BB962C8B-B14F-4D97-AF65-F5344CB8AC3E}">
-        <p14:creationId xmlns:p14="http://schemas.microsoft.com/office/powerpoint/2010/main" val="374380078"/>
+        <p14:creationId xmlns:p14="http://schemas.microsoft.com/office/powerpoint/2010/main" val="780585432"/>
       </p:ext>
     </p:extLst>
   </p:cSld>
@@ -15680,7 +15777,7 @@
           <p:nvPr/>
         </p:nvPicPr>
         <p:blipFill>
-          <a:blip xmlns:r="http://schemas.openxmlformats.org/officeDocument/2006/relationships" xmlns:a="http://schemas.openxmlformats.org/drawingml/2006/main" r:embed="R1f900740180547e3"/>
+          <a:blip xmlns:r="http://schemas.openxmlformats.org/officeDocument/2006/relationships" xmlns:a="http://schemas.openxmlformats.org/drawingml/2006/main" r:embed="R6ab6c187ec6f4d7a"/>
           <a:srcRect xmlns:a="http://schemas.openxmlformats.org/drawingml/2006/main" l="0" t="7813" r="0" b="7813"/>
           <a:stretch xmlns:a="http://schemas.openxmlformats.org/drawingml/2006/main">
             <a:fillRect l="0" t="0" r="0" b="0"/>
@@ -15701,7 +15798,7 @@
           <p:cNvPr id="2" name="">
             <a:extLst xmlns:a="http://schemas.openxmlformats.org/drawingml/2006/main">
               <a:ext uri="{FF2B5EF4-FFF2-40B4-BE49-F238E27FC236}">
-                <a16:creationId xmlns:a16="http://schemas.microsoft.com/office/drawing/2014/main" id="{BD7C9D47-3E51-4A98-AE25-DD7B8FBCE631}"/>
+                <a16:creationId xmlns:a16="http://schemas.microsoft.com/office/drawing/2014/main" id="{9CCF58A0-F056-4B57-93D8-56B77B804AA2}"/>
               </a:ext>
             </a:extLst>
           </p:cNvPr>
@@ -15738,7 +15835,7 @@
           <p:cNvPr id="3" name="">
             <a:extLst xmlns:a="http://schemas.openxmlformats.org/drawingml/2006/main">
               <a:ext uri="{FF2B5EF4-FFF2-40B4-BE49-F238E27FC236}">
-                <a16:creationId xmlns:a16="http://schemas.microsoft.com/office/drawing/2014/main" id="{3E9EB7ED-89AC-4ED5-BC1D-AF1FCEAD24AF}"/>
+                <a16:creationId xmlns:a16="http://schemas.microsoft.com/office/drawing/2014/main" id="{E52BF351-2042-423C-971D-736C127CA547}"/>
               </a:ext>
             </a:extLst>
           </p:cNvPr>
@@ -15775,7 +15872,7 @@
           <p:cNvPr id="4" name="">
             <a:extLst xmlns:a="http://schemas.openxmlformats.org/drawingml/2006/main">
               <a:ext uri="{FF2B5EF4-FFF2-40B4-BE49-F238E27FC236}">
-                <a16:creationId xmlns:a16="http://schemas.microsoft.com/office/drawing/2014/main" id="{8C35A54D-B6EC-4ACA-86F6-0FAB2CE6FBA3}"/>
+                <a16:creationId xmlns:a16="http://schemas.microsoft.com/office/drawing/2014/main" id="{A7206497-4CD5-4D09-B4E1-A6B6650246A6}"/>
               </a:ext>
             </a:extLst>
           </p:cNvPr>
@@ -15839,7 +15936,7 @@
           <p:cNvPr id="5" name="">
             <a:extLst xmlns:a="http://schemas.openxmlformats.org/drawingml/2006/main">
               <a:ext uri="{FF2B5EF4-FFF2-40B4-BE49-F238E27FC236}">
-                <a16:creationId xmlns:a16="http://schemas.microsoft.com/office/drawing/2014/main" id="{5D671B3C-9802-459D-816B-813F9B528168}"/>
+                <a16:creationId xmlns:a16="http://schemas.microsoft.com/office/drawing/2014/main" id="{5C29C88A-B065-46DF-9ABB-8AE5B57E3742}"/>
               </a:ext>
             </a:extLst>
           </p:cNvPr>
@@ -15903,7 +16000,7 @@
           <p:cNvPr id="6" name="">
             <a:extLst xmlns:a="http://schemas.openxmlformats.org/drawingml/2006/main">
               <a:ext uri="{FF2B5EF4-FFF2-40B4-BE49-F238E27FC236}">
-                <a16:creationId xmlns:a16="http://schemas.microsoft.com/office/drawing/2014/main" id="{DCAB1C2E-A039-4717-AB14-D49B8DF8892E}"/>
+                <a16:creationId xmlns:a16="http://schemas.microsoft.com/office/drawing/2014/main" id="{EEE2FBE4-A530-4816-90D2-7CF45D6E9E19}"/>
               </a:ext>
             </a:extLst>
           </p:cNvPr>
@@ -15967,7 +16064,7 @@
           <p:cNvPr id="7" name="">
             <a:extLst xmlns:a="http://schemas.openxmlformats.org/drawingml/2006/main">
               <a:ext uri="{FF2B5EF4-FFF2-40B4-BE49-F238E27FC236}">
-                <a16:creationId xmlns:a16="http://schemas.microsoft.com/office/drawing/2014/main" id="{30EEDCB2-C0CF-4CC9-9F75-01B285BA473C}"/>
+                <a16:creationId xmlns:a16="http://schemas.microsoft.com/office/drawing/2014/main" id="{6D8EE0F6-DB27-42CA-83A5-B13488EE85C8}"/>
               </a:ext>
             </a:extLst>
           </p:cNvPr>
@@ -16002,7 +16099,7 @@
           <p:cNvPr id="8" name="">
             <a:extLst xmlns:a="http://schemas.openxmlformats.org/drawingml/2006/main">
               <a:ext uri="{FF2B5EF4-FFF2-40B4-BE49-F238E27FC236}">
-                <a16:creationId xmlns:a16="http://schemas.microsoft.com/office/drawing/2014/main" id="{170B186E-260E-45F4-BD67-84569ED03F48}"/>
+                <a16:creationId xmlns:a16="http://schemas.microsoft.com/office/drawing/2014/main" id="{632EA092-E86F-4181-9A65-F338FF4007BB}"/>
               </a:ext>
             </a:extLst>
           </p:cNvPr>
@@ -16066,7 +16163,7 @@
           <p:cNvPr id="9" name="">
             <a:extLst xmlns:a="http://schemas.openxmlformats.org/drawingml/2006/main">
               <a:ext uri="{FF2B5EF4-FFF2-40B4-BE49-F238E27FC236}">
-                <a16:creationId xmlns:a16="http://schemas.microsoft.com/office/drawing/2014/main" id="{C423C82F-C02C-4801-9A19-50830856C4C9}"/>
+                <a16:creationId xmlns:a16="http://schemas.microsoft.com/office/drawing/2014/main" id="{704237C5-75F6-44D3-A3EA-BFD966B0F735}"/>
               </a:ext>
             </a:extLst>
           </p:cNvPr>
@@ -16130,7 +16227,7 @@
           <p:cNvPr id="10" name="">
             <a:extLst xmlns:a="http://schemas.openxmlformats.org/drawingml/2006/main">
               <a:ext uri="{FF2B5EF4-FFF2-40B4-BE49-F238E27FC236}">
-                <a16:creationId xmlns:a16="http://schemas.microsoft.com/office/drawing/2014/main" id="{FDC1AC2D-9509-485D-B7D2-D03D8E43CB04}"/>
+                <a16:creationId xmlns:a16="http://schemas.microsoft.com/office/drawing/2014/main" id="{4F43FB8D-C795-4434-8028-040ABCA234B4}"/>
               </a:ext>
             </a:extLst>
           </p:cNvPr>
@@ -16165,7 +16262,7 @@
           <p:cNvPr id="11" name="">
             <a:extLst xmlns:a="http://schemas.openxmlformats.org/drawingml/2006/main">
               <a:ext uri="{FF2B5EF4-FFF2-40B4-BE49-F238E27FC236}">
-                <a16:creationId xmlns:a16="http://schemas.microsoft.com/office/drawing/2014/main" id="{98652FA7-A7E1-42C8-89CF-1AD02C70F0DF}"/>
+                <a16:creationId xmlns:a16="http://schemas.microsoft.com/office/drawing/2014/main" id="{E50F7B0E-7DEB-44FF-86F5-30A1C0570B59}"/>
               </a:ext>
             </a:extLst>
           </p:cNvPr>
@@ -16229,7 +16326,7 @@
           <p:cNvPr id="12" name="">
             <a:extLst xmlns:a="http://schemas.openxmlformats.org/drawingml/2006/main">
               <a:ext uri="{FF2B5EF4-FFF2-40B4-BE49-F238E27FC236}">
-                <a16:creationId xmlns:a16="http://schemas.microsoft.com/office/drawing/2014/main" id="{547DB694-634C-4881-BB5C-22ACAEB572DE}"/>
+                <a16:creationId xmlns:a16="http://schemas.microsoft.com/office/drawing/2014/main" id="{6FC43706-03C5-4051-B482-A7D202CA2983}"/>
               </a:ext>
             </a:extLst>
           </p:cNvPr>
@@ -16293,7 +16390,7 @@
           <p:cNvPr id="13" name="">
             <a:extLst xmlns:a="http://schemas.openxmlformats.org/drawingml/2006/main">
               <a:ext uri="{FF2B5EF4-FFF2-40B4-BE49-F238E27FC236}">
-                <a16:creationId xmlns:a16="http://schemas.microsoft.com/office/drawing/2014/main" id="{9878DE07-D1E6-46E0-AC13-98AAACCCEBC2}"/>
+                <a16:creationId xmlns:a16="http://schemas.microsoft.com/office/drawing/2014/main" id="{DCC190E6-53BF-4F5B-89CD-9D7607863018}"/>
               </a:ext>
             </a:extLst>
           </p:cNvPr>
@@ -16328,7 +16425,7 @@
           <p:cNvPr id="14" name="">
             <a:extLst xmlns:a="http://schemas.openxmlformats.org/drawingml/2006/main">
               <a:ext uri="{FF2B5EF4-FFF2-40B4-BE49-F238E27FC236}">
-                <a16:creationId xmlns:a16="http://schemas.microsoft.com/office/drawing/2014/main" id="{FF512A53-FFC9-4D1C-9C08-B9CA60C51ABC}"/>
+                <a16:creationId xmlns:a16="http://schemas.microsoft.com/office/drawing/2014/main" id="{6BDBEBBF-AF2B-4B4B-AFF2-E61628206D47}"/>
               </a:ext>
             </a:extLst>
           </p:cNvPr>
@@ -16392,7 +16489,7 @@
           <p:cNvPr id="15" name="">
             <a:extLst xmlns:a="http://schemas.openxmlformats.org/drawingml/2006/main">
               <a:ext uri="{FF2B5EF4-FFF2-40B4-BE49-F238E27FC236}">
-                <a16:creationId xmlns:a16="http://schemas.microsoft.com/office/drawing/2014/main" id="{84A785EC-EEF7-4D27-8285-E5FEF82DEDFC}"/>
+                <a16:creationId xmlns:a16="http://schemas.microsoft.com/office/drawing/2014/main" id="{2A91D0CD-45A0-4427-AADE-CF00D53B0B79}"/>
               </a:ext>
             </a:extLst>
           </p:cNvPr>
@@ -16456,7 +16553,7 @@
           <p:cNvPr id="16" name="">
             <a:extLst xmlns:a="http://schemas.openxmlformats.org/drawingml/2006/main">
               <a:ext uri="{FF2B5EF4-FFF2-40B4-BE49-F238E27FC236}">
-                <a16:creationId xmlns:a16="http://schemas.microsoft.com/office/drawing/2014/main" id="{A09BEED2-B4CC-4E84-A32B-D5A785FBF64D}"/>
+                <a16:creationId xmlns:a16="http://schemas.microsoft.com/office/drawing/2014/main" id="{5D72CA79-0A1F-47FC-87DC-4BE2C0495AE7}"/>
               </a:ext>
             </a:extLst>
           </p:cNvPr>
@@ -16491,7 +16588,7 @@
           <p:cNvPr id="17" name="">
             <a:extLst xmlns:a="http://schemas.openxmlformats.org/drawingml/2006/main">
               <a:ext uri="{FF2B5EF4-FFF2-40B4-BE49-F238E27FC236}">
-                <a16:creationId xmlns:a16="http://schemas.microsoft.com/office/drawing/2014/main" id="{E91E0A31-5044-4747-9411-55FF684CABCA}"/>
+                <a16:creationId xmlns:a16="http://schemas.microsoft.com/office/drawing/2014/main" id="{CF44AA9E-0DC9-474B-839A-A64389ECCC1F}"/>
               </a:ext>
             </a:extLst>
           </p:cNvPr>
@@ -16555,7 +16652,7 @@
           <p:cNvPr id="18" name="">
             <a:extLst xmlns:a="http://schemas.openxmlformats.org/drawingml/2006/main">
               <a:ext uri="{FF2B5EF4-FFF2-40B4-BE49-F238E27FC236}">
-                <a16:creationId xmlns:a16="http://schemas.microsoft.com/office/drawing/2014/main" id="{F8FAC461-116D-4024-B19E-094F60F3995B}"/>
+                <a16:creationId xmlns:a16="http://schemas.microsoft.com/office/drawing/2014/main" id="{A9474CE6-B5D8-477E-AF51-8BF8BEFBECBC}"/>
               </a:ext>
             </a:extLst>
           </p:cNvPr>
@@ -16619,7 +16716,7 @@
           <p:cNvPr id="19" name="">
             <a:extLst xmlns:a="http://schemas.openxmlformats.org/drawingml/2006/main">
               <a:ext uri="{FF2B5EF4-FFF2-40B4-BE49-F238E27FC236}">
-                <a16:creationId xmlns:a16="http://schemas.microsoft.com/office/drawing/2014/main" id="{A4817D04-A196-4903-8FFA-B2733DBDB267}"/>
+                <a16:creationId xmlns:a16="http://schemas.microsoft.com/office/drawing/2014/main" id="{AE552234-456D-4925-953A-9AABB9F2CBE0}"/>
               </a:ext>
             </a:extLst>
           </p:cNvPr>
@@ -16654,7 +16751,7 @@
           <p:cNvPr id="20" name="">
             <a:extLst xmlns:a="http://schemas.openxmlformats.org/drawingml/2006/main">
               <a:ext uri="{FF2B5EF4-FFF2-40B4-BE49-F238E27FC236}">
-                <a16:creationId xmlns:a16="http://schemas.microsoft.com/office/drawing/2014/main" id="{17F89694-0FE6-450C-8455-A1BB67F5F365}"/>
+                <a16:creationId xmlns:a16="http://schemas.microsoft.com/office/drawing/2014/main" id="{ED344630-F362-4834-ABF1-972C94D48751}"/>
               </a:ext>
             </a:extLst>
           </p:cNvPr>
@@ -16718,7 +16815,7 @@
           <p:cNvPr id="21" name="">
             <a:extLst xmlns:a="http://schemas.openxmlformats.org/drawingml/2006/main">
               <a:ext uri="{FF2B5EF4-FFF2-40B4-BE49-F238E27FC236}">
-                <a16:creationId xmlns:a16="http://schemas.microsoft.com/office/drawing/2014/main" id="{5837BA1F-2188-4388-A660-BA5910C6A449}"/>
+                <a16:creationId xmlns:a16="http://schemas.microsoft.com/office/drawing/2014/main" id="{49FBE5A5-C1F2-43E7-A478-197EBEECA823}"/>
               </a:ext>
             </a:extLst>
           </p:cNvPr>
@@ -16782,7 +16879,7 @@
           <p:cNvPr id="22" name="">
             <a:extLst xmlns:a="http://schemas.openxmlformats.org/drawingml/2006/main">
               <a:ext uri="{FF2B5EF4-FFF2-40B4-BE49-F238E27FC236}">
-                <a16:creationId xmlns:a16="http://schemas.microsoft.com/office/drawing/2014/main" id="{DADEAD9C-5CC1-4310-8A81-F8D93D5631A6}"/>
+                <a16:creationId xmlns:a16="http://schemas.microsoft.com/office/drawing/2014/main" id="{7495787D-ACA8-4161-BA6A-9C994CE10A55}"/>
               </a:ext>
             </a:extLst>
           </p:cNvPr>
@@ -16815,7 +16912,7 @@
           <p:cNvPr id="23" name="">
             <a:extLst xmlns:a="http://schemas.openxmlformats.org/drawingml/2006/main">
               <a:ext uri="{FF2B5EF4-FFF2-40B4-BE49-F238E27FC236}">
-                <a16:creationId xmlns:a16="http://schemas.microsoft.com/office/drawing/2014/main" id="{EB1A6A56-0341-4ED1-9764-6F76303DBA50}"/>
+                <a16:creationId xmlns:a16="http://schemas.microsoft.com/office/drawing/2014/main" id="{81E5F99C-5E78-4B8E-8D19-404F1F9513A4}"/>
               </a:ext>
             </a:extLst>
           </p:cNvPr>
@@ -16850,7 +16947,7 @@
           <p:cNvPr id="24" name="">
             <a:extLst xmlns:a="http://schemas.openxmlformats.org/drawingml/2006/main">
               <a:ext uri="{FF2B5EF4-FFF2-40B4-BE49-F238E27FC236}">
-                <a16:creationId xmlns:a16="http://schemas.microsoft.com/office/drawing/2014/main" id="{B1103120-4B01-4A5E-B3F7-592BD63C0CAE}"/>
+                <a16:creationId xmlns:a16="http://schemas.microsoft.com/office/drawing/2014/main" id="{8BF99DA8-F665-4ECA-842D-167A4B7ECF7D}"/>
               </a:ext>
             </a:extLst>
           </p:cNvPr>
@@ -16914,7 +17011,7 @@
           <p:cNvPr id="25" name="">
             <a:extLst xmlns:a="http://schemas.openxmlformats.org/drawingml/2006/main">
               <a:ext uri="{FF2B5EF4-FFF2-40B4-BE49-F238E27FC236}">
-                <a16:creationId xmlns:a16="http://schemas.microsoft.com/office/drawing/2014/main" id="{C596A69C-B5A1-4BD2-9689-1374A5AF7D8F}"/>
+                <a16:creationId xmlns:a16="http://schemas.microsoft.com/office/drawing/2014/main" id="{6975F4BC-F249-4199-BBEE-9BA6A52426F4}"/>
               </a:ext>
             </a:extLst>
           </p:cNvPr>
@@ -16978,7 +17075,7 @@
           <p:cNvPr id="26" name="">
             <a:extLst xmlns:a="http://schemas.openxmlformats.org/drawingml/2006/main">
               <a:ext uri="{FF2B5EF4-FFF2-40B4-BE49-F238E27FC236}">
-                <a16:creationId xmlns:a16="http://schemas.microsoft.com/office/drawing/2014/main" id="{4A1F16B3-3430-48D6-B1C1-77DC33EBC141}"/>
+                <a16:creationId xmlns:a16="http://schemas.microsoft.com/office/drawing/2014/main" id="{889E8277-61DE-46DE-9253-2F905E95024B}"/>
               </a:ext>
             </a:extLst>
           </p:cNvPr>
@@ -17011,7 +17108,7 @@
           <p:cNvPr id="27" name="">
             <a:extLst xmlns:a="http://schemas.openxmlformats.org/drawingml/2006/main">
               <a:ext uri="{FF2B5EF4-FFF2-40B4-BE49-F238E27FC236}">
-                <a16:creationId xmlns:a16="http://schemas.microsoft.com/office/drawing/2014/main" id="{62C44F51-5FBD-4ECF-8231-1874A17299ED}"/>
+                <a16:creationId xmlns:a16="http://schemas.microsoft.com/office/drawing/2014/main" id="{C248D63E-5ECA-404A-BB9C-E12E665CC2B2}"/>
               </a:ext>
             </a:extLst>
           </p:cNvPr>
@@ -17046,7 +17143,7 @@
           <p:cNvPr id="28" name="">
             <a:extLst xmlns:a="http://schemas.openxmlformats.org/drawingml/2006/main">
               <a:ext uri="{FF2B5EF4-FFF2-40B4-BE49-F238E27FC236}">
-                <a16:creationId xmlns:a16="http://schemas.microsoft.com/office/drawing/2014/main" id="{11D45806-655E-4F10-B745-60A9B79DC225}"/>
+                <a16:creationId xmlns:a16="http://schemas.microsoft.com/office/drawing/2014/main" id="{86F828FB-B1A0-42B4-8C83-66931EA2B23E}"/>
               </a:ext>
             </a:extLst>
           </p:cNvPr>
@@ -17110,7 +17207,7 @@
           <p:cNvPr id="29" name="">
             <a:extLst xmlns:a="http://schemas.openxmlformats.org/drawingml/2006/main">
               <a:ext uri="{FF2B5EF4-FFF2-40B4-BE49-F238E27FC236}">
-                <a16:creationId xmlns:a16="http://schemas.microsoft.com/office/drawing/2014/main" id="{B7A4C665-F0BC-411D-8C96-2205EE12A4F0}"/>
+                <a16:creationId xmlns:a16="http://schemas.microsoft.com/office/drawing/2014/main" id="{0C20E8B3-5F82-450C-B6A0-2FF2653708BE}"/>
               </a:ext>
             </a:extLst>
           </p:cNvPr>
@@ -17174,7 +17271,7 @@
           <p:cNvPr id="30" name="">
             <a:extLst xmlns:a="http://schemas.openxmlformats.org/drawingml/2006/main">
               <a:ext uri="{FF2B5EF4-FFF2-40B4-BE49-F238E27FC236}">
-                <a16:creationId xmlns:a16="http://schemas.microsoft.com/office/drawing/2014/main" id="{1985DB08-0CD7-4FF8-83F4-E57BE507C837}"/>
+                <a16:creationId xmlns:a16="http://schemas.microsoft.com/office/drawing/2014/main" id="{A2105933-85CC-4375-AB39-F7517FC86234}"/>
               </a:ext>
             </a:extLst>
           </p:cNvPr>
@@ -17207,7 +17304,7 @@
           <p:cNvPr id="31" name="">
             <a:extLst xmlns:a="http://schemas.openxmlformats.org/drawingml/2006/main">
               <a:ext uri="{FF2B5EF4-FFF2-40B4-BE49-F238E27FC236}">
-                <a16:creationId xmlns:a16="http://schemas.microsoft.com/office/drawing/2014/main" id="{4CC00B84-9D02-446A-B163-45C6E7D6C04B}"/>
+                <a16:creationId xmlns:a16="http://schemas.microsoft.com/office/drawing/2014/main" id="{E3EC9BC9-6C65-4C9D-B41E-87883C968196}"/>
               </a:ext>
             </a:extLst>
           </p:cNvPr>
@@ -17242,7 +17339,7 @@
           <p:cNvPr id="32" name="">
             <a:extLst xmlns:a="http://schemas.openxmlformats.org/drawingml/2006/main">
               <a:ext uri="{FF2B5EF4-FFF2-40B4-BE49-F238E27FC236}">
-                <a16:creationId xmlns:a16="http://schemas.microsoft.com/office/drawing/2014/main" id="{566E8564-115C-47D1-A714-0BBDC2EAB02A}"/>
+                <a16:creationId xmlns:a16="http://schemas.microsoft.com/office/drawing/2014/main" id="{DC93BE73-052C-4BCC-BBA5-B1631E34ED33}"/>
               </a:ext>
             </a:extLst>
           </p:cNvPr>
@@ -17306,7 +17403,7 @@
           <p:cNvPr id="33" name="">
             <a:extLst xmlns:a="http://schemas.openxmlformats.org/drawingml/2006/main">
               <a:ext uri="{FF2B5EF4-FFF2-40B4-BE49-F238E27FC236}">
-                <a16:creationId xmlns:a16="http://schemas.microsoft.com/office/drawing/2014/main" id="{C8222964-18D5-4235-B6B6-DD056010D5C3}"/>
+                <a16:creationId xmlns:a16="http://schemas.microsoft.com/office/drawing/2014/main" id="{32466882-1BF8-4397-BD3B-C4BE4526F111}"/>
               </a:ext>
             </a:extLst>
           </p:cNvPr>
@@ -17370,7 +17467,7 @@
           <p:cNvPr id="34" name="">
             <a:extLst xmlns:a="http://schemas.openxmlformats.org/drawingml/2006/main">
               <a:ext uri="{FF2B5EF4-FFF2-40B4-BE49-F238E27FC236}">
-                <a16:creationId xmlns:a16="http://schemas.microsoft.com/office/drawing/2014/main" id="{EAC801C8-5F5C-4C5B-9FF3-4D41D84B85A0}"/>
+                <a16:creationId xmlns:a16="http://schemas.microsoft.com/office/drawing/2014/main" id="{6222B951-0748-45C4-9F75-7316CA866C3A}"/>
               </a:ext>
             </a:extLst>
           </p:cNvPr>
@@ -17434,7 +17531,7 @@
           <p:cNvPr id="35" name="">
             <a:extLst xmlns:a="http://schemas.openxmlformats.org/drawingml/2006/main">
               <a:ext uri="{FF2B5EF4-FFF2-40B4-BE49-F238E27FC236}">
-                <a16:creationId xmlns:a16="http://schemas.microsoft.com/office/drawing/2014/main" id="{B3CD4C23-7789-4C2D-B721-B47A3682BE13}"/>
+                <a16:creationId xmlns:a16="http://schemas.microsoft.com/office/drawing/2014/main" id="{BB017F02-A54C-4014-89A4-593ED5D4C5D7}"/>
               </a:ext>
             </a:extLst>
           </p:cNvPr>
@@ -17467,7 +17564,7 @@
           <p:cNvPr id="36" name="">
             <a:extLst xmlns:a="http://schemas.openxmlformats.org/drawingml/2006/main">
               <a:ext uri="{FF2B5EF4-FFF2-40B4-BE49-F238E27FC236}">
-                <a16:creationId xmlns:a16="http://schemas.microsoft.com/office/drawing/2014/main" id="{B90A21BA-7608-4CE8-A858-24AD20EE0DCE}"/>
+                <a16:creationId xmlns:a16="http://schemas.microsoft.com/office/drawing/2014/main" id="{980A021B-40E9-4985-9963-D3AFCB92225C}"/>
               </a:ext>
             </a:extLst>
           </p:cNvPr>
@@ -17531,7 +17628,7 @@
           <p:cNvPr id="37" name="">
             <a:extLst xmlns:a="http://schemas.openxmlformats.org/drawingml/2006/main">
               <a:ext uri="{FF2B5EF4-FFF2-40B4-BE49-F238E27FC236}">
-                <a16:creationId xmlns:a16="http://schemas.microsoft.com/office/drawing/2014/main" id="{253A92BA-940E-446F-9762-6696FEB3EE7C}"/>
+                <a16:creationId xmlns:a16="http://schemas.microsoft.com/office/drawing/2014/main" id="{C3D00DA5-844C-4F66-890E-89390BA96B03}"/>
               </a:ext>
             </a:extLst>
           </p:cNvPr>
@@ -17593,7 +17690,7 @@
     </p:spTree>
     <p:extLst>
       <p:ext uri="{BB962C8B-B14F-4D97-AF65-F5344CB8AC3E}">
-        <p14:creationId xmlns:p14="http://schemas.microsoft.com/office/powerpoint/2010/main" val="1862397119"/>
+        <p14:creationId xmlns:p14="http://schemas.microsoft.com/office/powerpoint/2010/main" val="1118116218"/>
       </p:ext>
     </p:extLst>
   </p:cSld>

</xml_diff>

<commit_message>
Refine investor deck fundraising narrative
</commit_message>
<xml_diff>
--- a/assets/investor-deck/Tecnotitan-Investor-Deck-EN.pptx
+++ b/assets/investor-deck/Tecnotitan-Investor-Deck-EN.pptx
@@ -2,24 +2,24 @@
 <file path=ppt/presentation.xml><?xml version="1.0" encoding="utf-8"?>
 <p:presentation xmlns:p="http://schemas.openxmlformats.org/presentationml/2006/main">
   <p:sldMasterIdLst>
-    <p:sldMasterId xmlns:r="http://schemas.openxmlformats.org/officeDocument/2006/relationships" id="2147483648" r:id="R2a6b809ee72e4814"/>
+    <p:sldMasterId xmlns:r="http://schemas.openxmlformats.org/officeDocument/2006/relationships" id="2147483648" r:id="Rbd2160ce4a124a57"/>
   </p:sldMasterIdLst>
   <p:notesMasterIdLst>
-    <p:notesMasterId xmlns:r="http://schemas.openxmlformats.org/officeDocument/2006/relationships" r:id="R6f53c768487b4ecd"/>
+    <p:notesMasterId xmlns:r="http://schemas.openxmlformats.org/officeDocument/2006/relationships" r:id="R6260cd80a46a4d30"/>
   </p:notesMasterIdLst>
   <p:sldIdLst>
-    <p:sldId xmlns:r="http://schemas.openxmlformats.org/officeDocument/2006/relationships" id="256" r:id="R1e5eb8ac9d374db3"/>
-    <p:sldId xmlns:r="http://schemas.openxmlformats.org/officeDocument/2006/relationships" id="257" r:id="R3473569a82ee49cb"/>
-    <p:sldId xmlns:r="http://schemas.openxmlformats.org/officeDocument/2006/relationships" id="258" r:id="Rfa5e722c78c24385"/>
-    <p:sldId xmlns:r="http://schemas.openxmlformats.org/officeDocument/2006/relationships" id="259" r:id="R9d56e134a94e48aa"/>
-    <p:sldId xmlns:r="http://schemas.openxmlformats.org/officeDocument/2006/relationships" id="260" r:id="Rdd49e76da49e4fc5"/>
-    <p:sldId xmlns:r="http://schemas.openxmlformats.org/officeDocument/2006/relationships" id="261" r:id="R173043de6261493a"/>
-    <p:sldId xmlns:r="http://schemas.openxmlformats.org/officeDocument/2006/relationships" id="262" r:id="R6aafbd7d787548bf"/>
-    <p:sldId xmlns:r="http://schemas.openxmlformats.org/officeDocument/2006/relationships" id="263" r:id="Rc5e9b651c8ee4154"/>
-    <p:sldId xmlns:r="http://schemas.openxmlformats.org/officeDocument/2006/relationships" id="264" r:id="R935675b77cca4cab"/>
-    <p:sldId xmlns:r="http://schemas.openxmlformats.org/officeDocument/2006/relationships" id="265" r:id="Rb0fc462c26b44c97"/>
-    <p:sldId xmlns:r="http://schemas.openxmlformats.org/officeDocument/2006/relationships" id="266" r:id="R1bf1d7e2ac6a47da"/>
-    <p:sldId xmlns:r="http://schemas.openxmlformats.org/officeDocument/2006/relationships" id="267" r:id="R08883149d52e42ed"/>
+    <p:sldId xmlns:r="http://schemas.openxmlformats.org/officeDocument/2006/relationships" id="256" r:id="Ree1f60bf8dbd46a1"/>
+    <p:sldId xmlns:r="http://schemas.openxmlformats.org/officeDocument/2006/relationships" id="257" r:id="Rfc7e797937b34602"/>
+    <p:sldId xmlns:r="http://schemas.openxmlformats.org/officeDocument/2006/relationships" id="258" r:id="R229821f4ee2b4e12"/>
+    <p:sldId xmlns:r="http://schemas.openxmlformats.org/officeDocument/2006/relationships" id="259" r:id="R24ce5768a8c843b6"/>
+    <p:sldId xmlns:r="http://schemas.openxmlformats.org/officeDocument/2006/relationships" id="260" r:id="R3624dc1412b443b8"/>
+    <p:sldId xmlns:r="http://schemas.openxmlformats.org/officeDocument/2006/relationships" id="261" r:id="R79c75309d16a4180"/>
+    <p:sldId xmlns:r="http://schemas.openxmlformats.org/officeDocument/2006/relationships" id="262" r:id="Rca820dfcb40e4598"/>
+    <p:sldId xmlns:r="http://schemas.openxmlformats.org/officeDocument/2006/relationships" id="263" r:id="R0ca981556b4e4355"/>
+    <p:sldId xmlns:r="http://schemas.openxmlformats.org/officeDocument/2006/relationships" id="264" r:id="R83ee156757fc4f77"/>
+    <p:sldId xmlns:r="http://schemas.openxmlformats.org/officeDocument/2006/relationships" id="265" r:id="Red9ecd0c0cb44eb9"/>
+    <p:sldId xmlns:r="http://schemas.openxmlformats.org/officeDocument/2006/relationships" id="266" r:id="R61be1782682f41da"/>
+    <p:sldId xmlns:r="http://schemas.openxmlformats.org/officeDocument/2006/relationships" id="267" r:id="R5df339b4c37140e5"/>
   </p:sldIdLst>
   <p:sldSz cx="12192000" cy="6858000"/>
   <p:notesSz cx="6858000" cy="9144000"/>
@@ -1292,7 +1292,7 @@
   </p:cSld>
   <p:clrMap bg1="lt1" tx1="dk1" bg2="lt2" tx2="dk2" accent1="accent1" accent2="accent2" accent3="accent3" accent4="accent4" accent5="accent5" accent6="accent6" hlink="hlink" folHlink="folHlink"/>
   <p:sldLayoutIdLst>
-    <p:sldLayoutId xmlns:r="http://schemas.openxmlformats.org/officeDocument/2006/relationships" id="2147483649" r:id="Rda9209cac3704cab"/>
+    <p:sldLayoutId xmlns:r="http://schemas.openxmlformats.org/officeDocument/2006/relationships" id="2147483649" r:id="Rf1066b1b58b74560"/>
   </p:sldLayoutIdLst>
   <p:txStyles>
     <p:titleStyle>
@@ -1794,7 +1794,7 @@
           <p:nvPr/>
         </p:nvPicPr>
         <p:blipFill>
-          <a:blip xmlns:r="http://schemas.openxmlformats.org/officeDocument/2006/relationships" xmlns:a="http://schemas.openxmlformats.org/drawingml/2006/main" r:embed="Rfb936ced7a904376"/>
+          <a:blip xmlns:r="http://schemas.openxmlformats.org/officeDocument/2006/relationships" xmlns:a="http://schemas.openxmlformats.org/drawingml/2006/main" r:embed="R86ad641607664eef"/>
           <a:srcRect xmlns:a="http://schemas.openxmlformats.org/drawingml/2006/main" l="0" t="7813" r="0" b="7813"/>
           <a:stretch xmlns:a="http://schemas.openxmlformats.org/drawingml/2006/main">
             <a:fillRect l="0" t="0" r="0" b="0"/>
@@ -1815,7 +1815,7 @@
           <p:cNvPr id="2" name="">
             <a:extLst xmlns:a="http://schemas.openxmlformats.org/drawingml/2006/main">
               <a:ext uri="{FF2B5EF4-FFF2-40B4-BE49-F238E27FC236}">
-                <a16:creationId xmlns:a16="http://schemas.microsoft.com/office/drawing/2014/main" id="{2F45C579-D5BF-4431-9739-D94694985F74}"/>
+                <a16:creationId xmlns:a16="http://schemas.microsoft.com/office/drawing/2014/main" id="{CA244DFD-5D88-41BD-A3BB-8DCF04137579}"/>
               </a:ext>
             </a:extLst>
           </p:cNvPr>
@@ -1852,7 +1852,7 @@
           <p:cNvPr id="3" name="">
             <a:extLst xmlns:a="http://schemas.openxmlformats.org/drawingml/2006/main">
               <a:ext uri="{FF2B5EF4-FFF2-40B4-BE49-F238E27FC236}">
-                <a16:creationId xmlns:a16="http://schemas.microsoft.com/office/drawing/2014/main" id="{29FD8FAB-3114-4F6A-A51A-4CAABEB511B6}"/>
+                <a16:creationId xmlns:a16="http://schemas.microsoft.com/office/drawing/2014/main" id="{F011E20D-5E53-49BA-AA7C-5A2F85E9BFA0}"/>
               </a:ext>
             </a:extLst>
           </p:cNvPr>
@@ -1889,7 +1889,7 @@
           <p:cNvPr id="4" name="">
             <a:extLst xmlns:a="http://schemas.openxmlformats.org/drawingml/2006/main">
               <a:ext uri="{FF2B5EF4-FFF2-40B4-BE49-F238E27FC236}">
-                <a16:creationId xmlns:a16="http://schemas.microsoft.com/office/drawing/2014/main" id="{2F64F6B2-2F1B-434C-9499-DD180D3DD635}"/>
+                <a16:creationId xmlns:a16="http://schemas.microsoft.com/office/drawing/2014/main" id="{550C0280-5FC8-4369-899F-E4A36E4C31BE}"/>
               </a:ext>
             </a:extLst>
           </p:cNvPr>
@@ -1953,7 +1953,7 @@
           <p:cNvPr id="5" name="">
             <a:extLst xmlns:a="http://schemas.openxmlformats.org/drawingml/2006/main">
               <a:ext uri="{FF2B5EF4-FFF2-40B4-BE49-F238E27FC236}">
-                <a16:creationId xmlns:a16="http://schemas.microsoft.com/office/drawing/2014/main" id="{0986E351-8B0F-44BD-A708-5ED2F676B71B}"/>
+                <a16:creationId xmlns:a16="http://schemas.microsoft.com/office/drawing/2014/main" id="{799FEC12-CDD5-4995-ABF7-FDAE2C9DD7DA}"/>
               </a:ext>
             </a:extLst>
           </p:cNvPr>
@@ -2017,7 +2017,7 @@
           <p:cNvPr id="6" name="">
             <a:extLst xmlns:a="http://schemas.openxmlformats.org/drawingml/2006/main">
               <a:ext uri="{FF2B5EF4-FFF2-40B4-BE49-F238E27FC236}">
-                <a16:creationId xmlns:a16="http://schemas.microsoft.com/office/drawing/2014/main" id="{A028D994-6B6F-4161-AD3E-8DC173F03762}"/>
+                <a16:creationId xmlns:a16="http://schemas.microsoft.com/office/drawing/2014/main" id="{9C4A6355-DC12-4EFE-A06E-A117AF44616B}"/>
               </a:ext>
             </a:extLst>
           </p:cNvPr>
@@ -2050,7 +2050,7 @@
           <p:cNvPr id="7" name="">
             <a:extLst xmlns:a="http://schemas.openxmlformats.org/drawingml/2006/main">
               <a:ext uri="{FF2B5EF4-FFF2-40B4-BE49-F238E27FC236}">
-                <a16:creationId xmlns:a16="http://schemas.microsoft.com/office/drawing/2014/main" id="{186562FC-8999-432E-A510-3D7AF4691D66}"/>
+                <a16:creationId xmlns:a16="http://schemas.microsoft.com/office/drawing/2014/main" id="{56B3D017-E8C5-4AB0-A54E-BEFBA368A345}"/>
               </a:ext>
             </a:extLst>
           </p:cNvPr>
@@ -2114,7 +2114,7 @@
           <p:cNvPr id="8" name="">
             <a:extLst xmlns:a="http://schemas.openxmlformats.org/drawingml/2006/main">
               <a:ext uri="{FF2B5EF4-FFF2-40B4-BE49-F238E27FC236}">
-                <a16:creationId xmlns:a16="http://schemas.microsoft.com/office/drawing/2014/main" id="{2874BB6C-7038-415B-A80A-D2912ED451ED}"/>
+                <a16:creationId xmlns:a16="http://schemas.microsoft.com/office/drawing/2014/main" id="{DE00B37D-F090-4E22-AC13-C3ABD5F9FA52}"/>
               </a:ext>
             </a:extLst>
           </p:cNvPr>
@@ -2178,7 +2178,7 @@
           <p:cNvPr id="9" name="">
             <a:extLst xmlns:a="http://schemas.openxmlformats.org/drawingml/2006/main">
               <a:ext uri="{FF2B5EF4-FFF2-40B4-BE49-F238E27FC236}">
-                <a16:creationId xmlns:a16="http://schemas.microsoft.com/office/drawing/2014/main" id="{EFEA260A-8624-4BDC-B2B2-06CEC1A997B2}"/>
+                <a16:creationId xmlns:a16="http://schemas.microsoft.com/office/drawing/2014/main" id="{F5805130-D47D-459D-AFAA-B497A21616C5}"/>
               </a:ext>
             </a:extLst>
           </p:cNvPr>
@@ -2213,7 +2213,7 @@
           <p:cNvPr id="10" name="">
             <a:extLst xmlns:a="http://schemas.openxmlformats.org/drawingml/2006/main">
               <a:ext uri="{FF2B5EF4-FFF2-40B4-BE49-F238E27FC236}">
-                <a16:creationId xmlns:a16="http://schemas.microsoft.com/office/drawing/2014/main" id="{1A18A926-6AAA-4F84-9007-818649DC3A93}"/>
+                <a16:creationId xmlns:a16="http://schemas.microsoft.com/office/drawing/2014/main" id="{57EDB4CA-B769-4BA2-8266-CFA4691B9136}"/>
               </a:ext>
             </a:extLst>
           </p:cNvPr>
@@ -2277,7 +2277,7 @@
           <p:cNvPr id="11" name="">
             <a:extLst xmlns:a="http://schemas.openxmlformats.org/drawingml/2006/main">
               <a:ext uri="{FF2B5EF4-FFF2-40B4-BE49-F238E27FC236}">
-                <a16:creationId xmlns:a16="http://schemas.microsoft.com/office/drawing/2014/main" id="{6513EA64-4313-4332-9205-F9FB3A9FAA28}"/>
+                <a16:creationId xmlns:a16="http://schemas.microsoft.com/office/drawing/2014/main" id="{CF99A03C-5F4C-455F-B4C8-A6CAC7D53A7E}"/>
               </a:ext>
             </a:extLst>
           </p:cNvPr>
@@ -2312,7 +2312,7 @@
           <p:cNvPr id="12" name="">
             <a:extLst xmlns:a="http://schemas.openxmlformats.org/drawingml/2006/main">
               <a:ext uri="{FF2B5EF4-FFF2-40B4-BE49-F238E27FC236}">
-                <a16:creationId xmlns:a16="http://schemas.microsoft.com/office/drawing/2014/main" id="{AC0A3DB4-9C03-45A3-B532-65A75D9A5F09}"/>
+                <a16:creationId xmlns:a16="http://schemas.microsoft.com/office/drawing/2014/main" id="{F849FBC9-A2A7-4068-B332-D5291450C2C0}"/>
               </a:ext>
             </a:extLst>
           </p:cNvPr>
@@ -2376,7 +2376,7 @@
           <p:cNvPr id="13" name="">
             <a:extLst xmlns:a="http://schemas.openxmlformats.org/drawingml/2006/main">
               <a:ext uri="{FF2B5EF4-FFF2-40B4-BE49-F238E27FC236}">
-                <a16:creationId xmlns:a16="http://schemas.microsoft.com/office/drawing/2014/main" id="{7B7214D9-1214-4826-96B9-016B8CCF3E6A}"/>
+                <a16:creationId xmlns:a16="http://schemas.microsoft.com/office/drawing/2014/main" id="{43AD7C2E-6F14-4399-A4C1-D8886B134D5B}"/>
               </a:ext>
             </a:extLst>
           </p:cNvPr>
@@ -2411,7 +2411,7 @@
           <p:cNvPr id="14" name="">
             <a:extLst xmlns:a="http://schemas.openxmlformats.org/drawingml/2006/main">
               <a:ext uri="{FF2B5EF4-FFF2-40B4-BE49-F238E27FC236}">
-                <a16:creationId xmlns:a16="http://schemas.microsoft.com/office/drawing/2014/main" id="{A5EB5451-DBB0-41D3-BE20-C018F4EAF941}"/>
+                <a16:creationId xmlns:a16="http://schemas.microsoft.com/office/drawing/2014/main" id="{44455564-8B2B-4B90-9434-B7FA5E8163E2}"/>
               </a:ext>
             </a:extLst>
           </p:cNvPr>
@@ -2475,7 +2475,7 @@
           <p:cNvPr id="15" name="">
             <a:extLst xmlns:a="http://schemas.openxmlformats.org/drawingml/2006/main">
               <a:ext uri="{FF2B5EF4-FFF2-40B4-BE49-F238E27FC236}">
-                <a16:creationId xmlns:a16="http://schemas.microsoft.com/office/drawing/2014/main" id="{B26B4BB0-8FD6-4106-A33F-A5AEC98076C3}"/>
+                <a16:creationId xmlns:a16="http://schemas.microsoft.com/office/drawing/2014/main" id="{DE1C2E15-874B-43DB-B4C3-6C4079955FF6}"/>
               </a:ext>
             </a:extLst>
           </p:cNvPr>
@@ -2529,7 +2529,7 @@
                 <a:ea typeface="Aptos"/>
                 <a:cs typeface="Aptos"/>
               </a:rPr>
-              <a:t>6 product lines</a:t>
+              <a:t>US$500K pre-seed</a:t>
             </a:r>
           </a:p>
         </p:txBody>
@@ -2539,7 +2539,7 @@
           <p:cNvPr id="16" name="">
             <a:extLst xmlns:a="http://schemas.openxmlformats.org/drawingml/2006/main">
               <a:ext uri="{FF2B5EF4-FFF2-40B4-BE49-F238E27FC236}">
-                <a16:creationId xmlns:a16="http://schemas.microsoft.com/office/drawing/2014/main" id="{CF4EA0F5-7530-4ED6-B01E-08E34A0F871E}"/>
+                <a16:creationId xmlns:a16="http://schemas.microsoft.com/office/drawing/2014/main" id="{C5AF81D2-A800-4AF4-98CE-05DBCF54C3C2}"/>
               </a:ext>
             </a:extLst>
           </p:cNvPr>
@@ -2574,7 +2574,7 @@
           <p:cNvPr id="17" name="">
             <a:extLst xmlns:a="http://schemas.openxmlformats.org/drawingml/2006/main">
               <a:ext uri="{FF2B5EF4-FFF2-40B4-BE49-F238E27FC236}">
-                <a16:creationId xmlns:a16="http://schemas.microsoft.com/office/drawing/2014/main" id="{F5044D08-CD4F-48B5-8EA0-235D783B3A28}"/>
+                <a16:creationId xmlns:a16="http://schemas.microsoft.com/office/drawing/2014/main" id="{76AA0B1E-2844-4DBD-8EEF-7B9C080D577F}"/>
               </a:ext>
             </a:extLst>
           </p:cNvPr>
@@ -2638,7 +2638,7 @@
           <p:cNvPr id="18" name="">
             <a:extLst xmlns:a="http://schemas.openxmlformats.org/drawingml/2006/main">
               <a:ext uri="{FF2B5EF4-FFF2-40B4-BE49-F238E27FC236}">
-                <a16:creationId xmlns:a16="http://schemas.microsoft.com/office/drawing/2014/main" id="{B2F7A22A-B488-4CC2-979F-35FB2D2A29EC}"/>
+                <a16:creationId xmlns:a16="http://schemas.microsoft.com/office/drawing/2014/main" id="{3D9CCB55-0C36-43E4-BCB4-AC9E15E64733}"/>
               </a:ext>
             </a:extLst>
           </p:cNvPr>
@@ -2692,7 +2692,7 @@
                 <a:ea typeface="Aptos"/>
                 <a:cs typeface="Aptos"/>
               </a:rPr>
-              <a:t>5 technology divisions</a:t>
+              <a:t>18 months runway</a:t>
             </a:r>
           </a:p>
         </p:txBody>
@@ -2702,7 +2702,7 @@
           <p:cNvPr id="19" name="">
             <a:extLst xmlns:a="http://schemas.openxmlformats.org/drawingml/2006/main">
               <a:ext uri="{FF2B5EF4-FFF2-40B4-BE49-F238E27FC236}">
-                <a16:creationId xmlns:a16="http://schemas.microsoft.com/office/drawing/2014/main" id="{B646C760-5410-4157-AA21-EBE77216111E}"/>
+                <a16:creationId xmlns:a16="http://schemas.microsoft.com/office/drawing/2014/main" id="{7A3E2CBC-D636-4CC7-9E6F-E05F03D856BF}"/>
               </a:ext>
             </a:extLst>
           </p:cNvPr>
@@ -2737,7 +2737,7 @@
           <p:cNvPr id="20" name="">
             <a:extLst xmlns:a="http://schemas.openxmlformats.org/drawingml/2006/main">
               <a:ext uri="{FF2B5EF4-FFF2-40B4-BE49-F238E27FC236}">
-                <a16:creationId xmlns:a16="http://schemas.microsoft.com/office/drawing/2014/main" id="{72EB14CB-EE6A-4AE3-91BC-3B326E8062CA}"/>
+                <a16:creationId xmlns:a16="http://schemas.microsoft.com/office/drawing/2014/main" id="{707D4219-F7DE-49ED-8B48-5906950E8DB1}"/>
               </a:ext>
             </a:extLst>
           </p:cNvPr>
@@ -2801,7 +2801,7 @@
           <p:cNvPr id="21" name="">
             <a:extLst xmlns:a="http://schemas.openxmlformats.org/drawingml/2006/main">
               <a:ext uri="{FF2B5EF4-FFF2-40B4-BE49-F238E27FC236}">
-                <a16:creationId xmlns:a16="http://schemas.microsoft.com/office/drawing/2014/main" id="{B17BCF2B-796E-43D6-ACF4-EEE870758285}"/>
+                <a16:creationId xmlns:a16="http://schemas.microsoft.com/office/drawing/2014/main" id="{FC82D9CC-42BB-4C56-9ACB-2E9A36FFA1E6}"/>
               </a:ext>
             </a:extLst>
           </p:cNvPr>
@@ -2855,7 +2855,7 @@
                 <a:ea typeface="Aptos"/>
                 <a:cs typeface="Aptos"/>
               </a:rPr>
-              <a:t>Lean execution team</a:t>
+              <a:t>6 product lines</a:t>
             </a:r>
           </a:p>
         </p:txBody>
@@ -2865,7 +2865,7 @@
           <p:cNvPr id="22" name="">
             <a:extLst xmlns:a="http://schemas.openxmlformats.org/drawingml/2006/main">
               <a:ext uri="{FF2B5EF4-FFF2-40B4-BE49-F238E27FC236}">
-                <a16:creationId xmlns:a16="http://schemas.microsoft.com/office/drawing/2014/main" id="{A3C4F0C2-21F8-424E-AA16-CD813E0E6C3F}"/>
+                <a16:creationId xmlns:a16="http://schemas.microsoft.com/office/drawing/2014/main" id="{56C97566-13F0-4F7C-83A9-B36F4B56E05A}"/>
               </a:ext>
             </a:extLst>
           </p:cNvPr>
@@ -2929,7 +2929,7 @@
           <p:cNvPr id="23" name="">
             <a:extLst xmlns:a="http://schemas.openxmlformats.org/drawingml/2006/main">
               <a:ext uri="{FF2B5EF4-FFF2-40B4-BE49-F238E27FC236}">
-                <a16:creationId xmlns:a16="http://schemas.microsoft.com/office/drawing/2014/main" id="{36DD38EC-9718-4C9E-B1CA-AF64551083ED}"/>
+                <a16:creationId xmlns:a16="http://schemas.microsoft.com/office/drawing/2014/main" id="{01F9DB9C-5997-406D-A53C-618E25D17742}"/>
               </a:ext>
             </a:extLst>
           </p:cNvPr>
@@ -2962,7 +2962,7 @@
           <p:cNvPr id="24" name="">
             <a:extLst xmlns:a="http://schemas.openxmlformats.org/drawingml/2006/main">
               <a:ext uri="{FF2B5EF4-FFF2-40B4-BE49-F238E27FC236}">
-                <a16:creationId xmlns:a16="http://schemas.microsoft.com/office/drawing/2014/main" id="{4582D226-7163-4491-BFE5-3B7507DE44CC}"/>
+                <a16:creationId xmlns:a16="http://schemas.microsoft.com/office/drawing/2014/main" id="{73B8FF06-0960-4F68-937A-5E9669BEFEAD}"/>
               </a:ext>
             </a:extLst>
           </p:cNvPr>
@@ -3026,7 +3026,7 @@
           <p:cNvPr id="25" name="">
             <a:extLst xmlns:a="http://schemas.openxmlformats.org/drawingml/2006/main">
               <a:ext uri="{FF2B5EF4-FFF2-40B4-BE49-F238E27FC236}">
-                <a16:creationId xmlns:a16="http://schemas.microsoft.com/office/drawing/2014/main" id="{FD370C31-A326-4B4C-B87B-255328446342}"/>
+                <a16:creationId xmlns:a16="http://schemas.microsoft.com/office/drawing/2014/main" id="{999C1896-9CA7-4565-8F4F-2D62274E62C2}"/>
               </a:ext>
             </a:extLst>
           </p:cNvPr>
@@ -3088,7 +3088,7 @@
     </p:spTree>
     <p:extLst>
       <p:ext uri="{BB962C8B-B14F-4D97-AF65-F5344CB8AC3E}">
-        <p14:creationId xmlns:p14="http://schemas.microsoft.com/office/powerpoint/2010/main" val="333568612"/>
+        <p14:creationId xmlns:p14="http://schemas.microsoft.com/office/powerpoint/2010/main" val="371041755"/>
       </p:ext>
     </p:extLst>
   </p:cSld>
@@ -3116,7 +3116,7 @@
           <p:nvPr/>
         </p:nvPicPr>
         <p:blipFill>
-          <a:blip xmlns:r="http://schemas.openxmlformats.org/officeDocument/2006/relationships" xmlns:a="http://schemas.openxmlformats.org/drawingml/2006/main" r:embed="R2d7f7afc6adb417b"/>
+          <a:blip xmlns:r="http://schemas.openxmlformats.org/officeDocument/2006/relationships" xmlns:a="http://schemas.openxmlformats.org/drawingml/2006/main" r:embed="R76f5ec486be54f41"/>
           <a:srcRect xmlns:a="http://schemas.openxmlformats.org/drawingml/2006/main" l="0" t="27" r="0" b="27"/>
           <a:stretch xmlns:a="http://schemas.openxmlformats.org/drawingml/2006/main">
             <a:fillRect l="0" t="0" r="0" b="0"/>
@@ -3137,7 +3137,7 @@
           <p:cNvPr id="2" name="">
             <a:extLst xmlns:a="http://schemas.openxmlformats.org/drawingml/2006/main">
               <a:ext uri="{FF2B5EF4-FFF2-40B4-BE49-F238E27FC236}">
-                <a16:creationId xmlns:a16="http://schemas.microsoft.com/office/drawing/2014/main" id="{8F7D3A9D-302D-4BCE-9332-D161FC13E4D6}"/>
+                <a16:creationId xmlns:a16="http://schemas.microsoft.com/office/drawing/2014/main" id="{26676754-D846-4F3E-8D25-DE04DC8C9FCB}"/>
               </a:ext>
             </a:extLst>
           </p:cNvPr>
@@ -3174,7 +3174,7 @@
           <p:cNvPr id="3" name="">
             <a:extLst xmlns:a="http://schemas.openxmlformats.org/drawingml/2006/main">
               <a:ext uri="{FF2B5EF4-FFF2-40B4-BE49-F238E27FC236}">
-                <a16:creationId xmlns:a16="http://schemas.microsoft.com/office/drawing/2014/main" id="{589323BE-D0D4-41A5-A887-603AAA6F7407}"/>
+                <a16:creationId xmlns:a16="http://schemas.microsoft.com/office/drawing/2014/main" id="{5206B7BB-2674-45D5-9A68-11891C02B70D}"/>
               </a:ext>
             </a:extLst>
           </p:cNvPr>
@@ -3211,7 +3211,7 @@
           <p:cNvPr id="4" name="">
             <a:extLst xmlns:a="http://schemas.openxmlformats.org/drawingml/2006/main">
               <a:ext uri="{FF2B5EF4-FFF2-40B4-BE49-F238E27FC236}">
-                <a16:creationId xmlns:a16="http://schemas.microsoft.com/office/drawing/2014/main" id="{B5492AA5-1135-485E-B81C-54605EA01364}"/>
+                <a16:creationId xmlns:a16="http://schemas.microsoft.com/office/drawing/2014/main" id="{B9489367-F47E-451D-8E40-62D79E404F26}"/>
               </a:ext>
             </a:extLst>
           </p:cNvPr>
@@ -3275,7 +3275,7 @@
           <p:cNvPr id="5" name="">
             <a:extLst xmlns:a="http://schemas.openxmlformats.org/drawingml/2006/main">
               <a:ext uri="{FF2B5EF4-FFF2-40B4-BE49-F238E27FC236}">
-                <a16:creationId xmlns:a16="http://schemas.microsoft.com/office/drawing/2014/main" id="{B0DD19AE-8928-4D23-A607-D250E602957D}"/>
+                <a16:creationId xmlns:a16="http://schemas.microsoft.com/office/drawing/2014/main" id="{BEE8F941-4F8D-400C-9738-3B245BEB8A93}"/>
               </a:ext>
             </a:extLst>
           </p:cNvPr>
@@ -3339,7 +3339,7 @@
           <p:cNvPr id="6" name="">
             <a:extLst xmlns:a="http://schemas.openxmlformats.org/drawingml/2006/main">
               <a:ext uri="{FF2B5EF4-FFF2-40B4-BE49-F238E27FC236}">
-                <a16:creationId xmlns:a16="http://schemas.microsoft.com/office/drawing/2014/main" id="{C3C88E91-73BE-4E8E-80B6-53CE2CA76E94}"/>
+                <a16:creationId xmlns:a16="http://schemas.microsoft.com/office/drawing/2014/main" id="{D737F0E3-30F0-45D1-954A-F6072EA5A8CE}"/>
               </a:ext>
             </a:extLst>
           </p:cNvPr>
@@ -3403,7 +3403,7 @@
           <p:cNvPr id="7" name="">
             <a:extLst xmlns:a="http://schemas.openxmlformats.org/drawingml/2006/main">
               <a:ext uri="{FF2B5EF4-FFF2-40B4-BE49-F238E27FC236}">
-                <a16:creationId xmlns:a16="http://schemas.microsoft.com/office/drawing/2014/main" id="{CAF91035-7590-4ACB-949F-CC08D77B5180}"/>
+                <a16:creationId xmlns:a16="http://schemas.microsoft.com/office/drawing/2014/main" id="{7AFB9B88-5258-433A-94D1-DA545811E1C3}"/>
               </a:ext>
             </a:extLst>
           </p:cNvPr>
@@ -3438,7 +3438,7 @@
           <p:cNvPr id="8" name="">
             <a:extLst xmlns:a="http://schemas.openxmlformats.org/drawingml/2006/main">
               <a:ext uri="{FF2B5EF4-FFF2-40B4-BE49-F238E27FC236}">
-                <a16:creationId xmlns:a16="http://schemas.microsoft.com/office/drawing/2014/main" id="{DDA73455-6626-448B-8B16-C2ECE97B37EE}"/>
+                <a16:creationId xmlns:a16="http://schemas.microsoft.com/office/drawing/2014/main" id="{6DB1CA60-26EC-4957-92B6-B25988D3FA1D}"/>
               </a:ext>
             </a:extLst>
           </p:cNvPr>
@@ -3502,7 +3502,7 @@
           <p:cNvPr id="9" name="">
             <a:extLst xmlns:a="http://schemas.openxmlformats.org/drawingml/2006/main">
               <a:ext uri="{FF2B5EF4-FFF2-40B4-BE49-F238E27FC236}">
-                <a16:creationId xmlns:a16="http://schemas.microsoft.com/office/drawing/2014/main" id="{1572A38F-9C83-4403-B3F5-EB9AD963ECAC}"/>
+                <a16:creationId xmlns:a16="http://schemas.microsoft.com/office/drawing/2014/main" id="{7AEFC7FD-3C01-4349-A4CB-5118328A6523}"/>
               </a:ext>
             </a:extLst>
           </p:cNvPr>
@@ -3537,7 +3537,7 @@
           <p:cNvPr id="10" name="">
             <a:extLst xmlns:a="http://schemas.openxmlformats.org/drawingml/2006/main">
               <a:ext uri="{FF2B5EF4-FFF2-40B4-BE49-F238E27FC236}">
-                <a16:creationId xmlns:a16="http://schemas.microsoft.com/office/drawing/2014/main" id="{43A41087-6F20-49FE-A133-431249A13095}"/>
+                <a16:creationId xmlns:a16="http://schemas.microsoft.com/office/drawing/2014/main" id="{A352C8DB-9359-45CA-AF79-A175B121DF77}"/>
               </a:ext>
             </a:extLst>
           </p:cNvPr>
@@ -3601,7 +3601,7 @@
           <p:cNvPr id="11" name="">
             <a:extLst xmlns:a="http://schemas.openxmlformats.org/drawingml/2006/main">
               <a:ext uri="{FF2B5EF4-FFF2-40B4-BE49-F238E27FC236}">
-                <a16:creationId xmlns:a16="http://schemas.microsoft.com/office/drawing/2014/main" id="{08680A12-1722-48B0-A895-E8D94838EDEE}"/>
+                <a16:creationId xmlns:a16="http://schemas.microsoft.com/office/drawing/2014/main" id="{584E1F0A-6631-4AF2-AA80-197E0AE05F5B}"/>
               </a:ext>
             </a:extLst>
           </p:cNvPr>
@@ -3636,7 +3636,7 @@
           <p:cNvPr id="12" name="">
             <a:extLst xmlns:a="http://schemas.openxmlformats.org/drawingml/2006/main">
               <a:ext uri="{FF2B5EF4-FFF2-40B4-BE49-F238E27FC236}">
-                <a16:creationId xmlns:a16="http://schemas.microsoft.com/office/drawing/2014/main" id="{A9B348EE-A3C7-4287-9292-65637EAE21F9}"/>
+                <a16:creationId xmlns:a16="http://schemas.microsoft.com/office/drawing/2014/main" id="{6194D5BE-C05A-41AD-8DAC-B0EA672B7C36}"/>
               </a:ext>
             </a:extLst>
           </p:cNvPr>
@@ -3700,7 +3700,7 @@
           <p:cNvPr id="13" name="">
             <a:extLst xmlns:a="http://schemas.openxmlformats.org/drawingml/2006/main">
               <a:ext uri="{FF2B5EF4-FFF2-40B4-BE49-F238E27FC236}">
-                <a16:creationId xmlns:a16="http://schemas.microsoft.com/office/drawing/2014/main" id="{33C8CEC4-DB68-4FAC-8211-8EA5C2B42D01}"/>
+                <a16:creationId xmlns:a16="http://schemas.microsoft.com/office/drawing/2014/main" id="{7B705FE7-22DB-40B3-8BF5-816E9C4DA54D}"/>
               </a:ext>
             </a:extLst>
           </p:cNvPr>
@@ -3735,7 +3735,7 @@
           <p:cNvPr id="14" name="">
             <a:extLst xmlns:a="http://schemas.openxmlformats.org/drawingml/2006/main">
               <a:ext uri="{FF2B5EF4-FFF2-40B4-BE49-F238E27FC236}">
-                <a16:creationId xmlns:a16="http://schemas.microsoft.com/office/drawing/2014/main" id="{F4B1D2F9-6F10-4058-A56A-0534688A558F}"/>
+                <a16:creationId xmlns:a16="http://schemas.microsoft.com/office/drawing/2014/main" id="{F5732EA2-C62C-400C-A431-5AA2CD507458}"/>
               </a:ext>
             </a:extLst>
           </p:cNvPr>
@@ -3799,7 +3799,7 @@
           <p:cNvPr id="15" name="">
             <a:extLst xmlns:a="http://schemas.openxmlformats.org/drawingml/2006/main">
               <a:ext uri="{FF2B5EF4-FFF2-40B4-BE49-F238E27FC236}">
-                <a16:creationId xmlns:a16="http://schemas.microsoft.com/office/drawing/2014/main" id="{984C69A4-A8E8-4E8A-A677-A3E0C697675F}"/>
+                <a16:creationId xmlns:a16="http://schemas.microsoft.com/office/drawing/2014/main" id="{0499C973-F0AA-491E-9BF4-B9CD1FF1DA26}"/>
               </a:ext>
             </a:extLst>
           </p:cNvPr>
@@ -3863,7 +3863,7 @@
           <p:cNvPr id="16" name="">
             <a:extLst xmlns:a="http://schemas.openxmlformats.org/drawingml/2006/main">
               <a:ext uri="{FF2B5EF4-FFF2-40B4-BE49-F238E27FC236}">
-                <a16:creationId xmlns:a16="http://schemas.microsoft.com/office/drawing/2014/main" id="{AE6709AD-21BF-454D-A6F4-ED919C09FE1E}"/>
+                <a16:creationId xmlns:a16="http://schemas.microsoft.com/office/drawing/2014/main" id="{F8952572-EA04-4987-BC7A-45D031563FAB}"/>
               </a:ext>
             </a:extLst>
           </p:cNvPr>
@@ -3927,7 +3927,7 @@
           <p:cNvPr id="17" name="">
             <a:extLst xmlns:a="http://schemas.openxmlformats.org/drawingml/2006/main">
               <a:ext uri="{FF2B5EF4-FFF2-40B4-BE49-F238E27FC236}">
-                <a16:creationId xmlns:a16="http://schemas.microsoft.com/office/drawing/2014/main" id="{8716E326-8D90-47FC-A722-99585117C63D}"/>
+                <a16:creationId xmlns:a16="http://schemas.microsoft.com/office/drawing/2014/main" id="{A3A05F3B-661B-49D9-9A03-AA584139CE13}"/>
               </a:ext>
             </a:extLst>
           </p:cNvPr>
@@ -3960,7 +3960,7 @@
           <p:cNvPr id="18" name="">
             <a:extLst xmlns:a="http://schemas.openxmlformats.org/drawingml/2006/main">
               <a:ext uri="{FF2B5EF4-FFF2-40B4-BE49-F238E27FC236}">
-                <a16:creationId xmlns:a16="http://schemas.microsoft.com/office/drawing/2014/main" id="{30508320-8341-4FAE-84C8-279FD9F9B4BA}"/>
+                <a16:creationId xmlns:a16="http://schemas.microsoft.com/office/drawing/2014/main" id="{202865CC-7154-432C-B8CA-91CFA922F4E3}"/>
               </a:ext>
             </a:extLst>
           </p:cNvPr>
@@ -4024,7 +4024,7 @@
           <p:cNvPr id="19" name="">
             <a:extLst xmlns:a="http://schemas.openxmlformats.org/drawingml/2006/main">
               <a:ext uri="{FF2B5EF4-FFF2-40B4-BE49-F238E27FC236}">
-                <a16:creationId xmlns:a16="http://schemas.microsoft.com/office/drawing/2014/main" id="{77B1426C-1EEA-421E-9DA8-EBF74AF2C6A9}"/>
+                <a16:creationId xmlns:a16="http://schemas.microsoft.com/office/drawing/2014/main" id="{1A69BD75-7EC0-44D7-8A63-709837E547A2}"/>
               </a:ext>
             </a:extLst>
           </p:cNvPr>
@@ -4086,7 +4086,7 @@
     </p:spTree>
     <p:extLst>
       <p:ext uri="{BB962C8B-B14F-4D97-AF65-F5344CB8AC3E}">
-        <p14:creationId xmlns:p14="http://schemas.microsoft.com/office/powerpoint/2010/main" val="529280487"/>
+        <p14:creationId xmlns:p14="http://schemas.microsoft.com/office/powerpoint/2010/main" val="931587053"/>
       </p:ext>
     </p:extLst>
   </p:cSld>
@@ -4114,7 +4114,7 @@
           <p:nvPr/>
         </p:nvPicPr>
         <p:blipFill>
-          <a:blip xmlns:r="http://schemas.openxmlformats.org/officeDocument/2006/relationships" xmlns:a="http://schemas.openxmlformats.org/drawingml/2006/main" r:embed="Rabe13197a4ad4213"/>
+          <a:blip xmlns:r="http://schemas.openxmlformats.org/officeDocument/2006/relationships" xmlns:a="http://schemas.openxmlformats.org/drawingml/2006/main" r:embed="Rb369a9ff5ff54163"/>
           <a:srcRect xmlns:a="http://schemas.openxmlformats.org/drawingml/2006/main" l="0" t="27" r="0" b="27"/>
           <a:stretch xmlns:a="http://schemas.openxmlformats.org/drawingml/2006/main">
             <a:fillRect l="0" t="0" r="0" b="0"/>
@@ -4135,7 +4135,7 @@
           <p:cNvPr id="2" name="">
             <a:extLst xmlns:a="http://schemas.openxmlformats.org/drawingml/2006/main">
               <a:ext uri="{FF2B5EF4-FFF2-40B4-BE49-F238E27FC236}">
-                <a16:creationId xmlns:a16="http://schemas.microsoft.com/office/drawing/2014/main" id="{93910558-3B26-463E-8DD6-025912E73FC0}"/>
+                <a16:creationId xmlns:a16="http://schemas.microsoft.com/office/drawing/2014/main" id="{56745630-B85A-43B2-9C00-028D19E0B952}"/>
               </a:ext>
             </a:extLst>
           </p:cNvPr>
@@ -4172,7 +4172,7 @@
           <p:cNvPr id="3" name="">
             <a:extLst xmlns:a="http://schemas.openxmlformats.org/drawingml/2006/main">
               <a:ext uri="{FF2B5EF4-FFF2-40B4-BE49-F238E27FC236}">
-                <a16:creationId xmlns:a16="http://schemas.microsoft.com/office/drawing/2014/main" id="{46FEF815-BDB5-441E-A501-116B9E3234E3}"/>
+                <a16:creationId xmlns:a16="http://schemas.microsoft.com/office/drawing/2014/main" id="{56D10BB9-368C-45B9-8903-CC905A184D13}"/>
               </a:ext>
             </a:extLst>
           </p:cNvPr>
@@ -4209,7 +4209,7 @@
           <p:cNvPr id="4" name="">
             <a:extLst xmlns:a="http://schemas.openxmlformats.org/drawingml/2006/main">
               <a:ext uri="{FF2B5EF4-FFF2-40B4-BE49-F238E27FC236}">
-                <a16:creationId xmlns:a16="http://schemas.microsoft.com/office/drawing/2014/main" id="{7260D34E-9854-41EB-9D93-078BB7C9479F}"/>
+                <a16:creationId xmlns:a16="http://schemas.microsoft.com/office/drawing/2014/main" id="{0FDB18CC-B008-4647-A8E1-AAB46CDD3C65}"/>
               </a:ext>
             </a:extLst>
           </p:cNvPr>
@@ -4273,7 +4273,7 @@
           <p:cNvPr id="5" name="">
             <a:extLst xmlns:a="http://schemas.openxmlformats.org/drawingml/2006/main">
               <a:ext uri="{FF2B5EF4-FFF2-40B4-BE49-F238E27FC236}">
-                <a16:creationId xmlns:a16="http://schemas.microsoft.com/office/drawing/2014/main" id="{079F4333-C0BC-4723-B1FF-96733A6F402D}"/>
+                <a16:creationId xmlns:a16="http://schemas.microsoft.com/office/drawing/2014/main" id="{1D25E468-8F8C-4B30-BAAE-0CC2E602DA9A}"/>
               </a:ext>
             </a:extLst>
           </p:cNvPr>
@@ -4337,7 +4337,7 @@
           <p:cNvPr id="6" name="">
             <a:extLst xmlns:a="http://schemas.openxmlformats.org/drawingml/2006/main">
               <a:ext uri="{FF2B5EF4-FFF2-40B4-BE49-F238E27FC236}">
-                <a16:creationId xmlns:a16="http://schemas.microsoft.com/office/drawing/2014/main" id="{EB8E8B55-5304-44D8-AF08-A1330A7C9638}"/>
+                <a16:creationId xmlns:a16="http://schemas.microsoft.com/office/drawing/2014/main" id="{EFD06EBF-4DA8-4CB2-867D-E4EA67C4FC31}"/>
               </a:ext>
             </a:extLst>
           </p:cNvPr>
@@ -4401,7 +4401,7 @@
           <p:cNvPr id="7" name="">
             <a:extLst xmlns:a="http://schemas.openxmlformats.org/drawingml/2006/main">
               <a:ext uri="{FF2B5EF4-FFF2-40B4-BE49-F238E27FC236}">
-                <a16:creationId xmlns:a16="http://schemas.microsoft.com/office/drawing/2014/main" id="{C8C5E6C2-1459-4314-8E35-A58E58A1F08C}"/>
+                <a16:creationId xmlns:a16="http://schemas.microsoft.com/office/drawing/2014/main" id="{B72E66E4-7518-4BA6-B168-4AFA7EE11BF4}"/>
               </a:ext>
             </a:extLst>
           </p:cNvPr>
@@ -4436,7 +4436,7 @@
           <p:cNvPr id="8" name="">
             <a:extLst xmlns:a="http://schemas.openxmlformats.org/drawingml/2006/main">
               <a:ext uri="{FF2B5EF4-FFF2-40B4-BE49-F238E27FC236}">
-                <a16:creationId xmlns:a16="http://schemas.microsoft.com/office/drawing/2014/main" id="{B6576794-E4E5-487C-913D-304AF2C706B8}"/>
+                <a16:creationId xmlns:a16="http://schemas.microsoft.com/office/drawing/2014/main" id="{30D8362C-5587-4AB9-8DC3-BB0920186495}"/>
               </a:ext>
             </a:extLst>
           </p:cNvPr>
@@ -4500,7 +4500,7 @@
           <p:cNvPr id="9" name="">
             <a:extLst xmlns:a="http://schemas.openxmlformats.org/drawingml/2006/main">
               <a:ext uri="{FF2B5EF4-FFF2-40B4-BE49-F238E27FC236}">
-                <a16:creationId xmlns:a16="http://schemas.microsoft.com/office/drawing/2014/main" id="{697150BF-D8C1-4F2E-8438-CF08854708B9}"/>
+                <a16:creationId xmlns:a16="http://schemas.microsoft.com/office/drawing/2014/main" id="{E65C5EB0-1123-4E32-A240-E81D62337F01}"/>
               </a:ext>
             </a:extLst>
           </p:cNvPr>
@@ -4564,7 +4564,7 @@
           <p:cNvPr id="10" name="">
             <a:extLst xmlns:a="http://schemas.openxmlformats.org/drawingml/2006/main">
               <a:ext uri="{FF2B5EF4-FFF2-40B4-BE49-F238E27FC236}">
-                <a16:creationId xmlns:a16="http://schemas.microsoft.com/office/drawing/2014/main" id="{20EF6D4B-6D98-476D-BA14-3C2194085908}"/>
+                <a16:creationId xmlns:a16="http://schemas.microsoft.com/office/drawing/2014/main" id="{538F02B5-67A9-4AA7-9D56-DE858409A514}"/>
               </a:ext>
             </a:extLst>
           </p:cNvPr>
@@ -4597,7 +4597,7 @@
           <p:cNvPr id="11" name="">
             <a:extLst xmlns:a="http://schemas.openxmlformats.org/drawingml/2006/main">
               <a:ext uri="{FF2B5EF4-FFF2-40B4-BE49-F238E27FC236}">
-                <a16:creationId xmlns:a16="http://schemas.microsoft.com/office/drawing/2014/main" id="{E8D9E921-5309-4819-9684-AFE913C86C40}"/>
+                <a16:creationId xmlns:a16="http://schemas.microsoft.com/office/drawing/2014/main" id="{7674FB9C-ED0E-4A3C-8473-3BA0C8964924}"/>
               </a:ext>
             </a:extLst>
           </p:cNvPr>
@@ -4632,7 +4632,7 @@
           <p:cNvPr id="12" name="">
             <a:extLst xmlns:a="http://schemas.openxmlformats.org/drawingml/2006/main">
               <a:ext uri="{FF2B5EF4-FFF2-40B4-BE49-F238E27FC236}">
-                <a16:creationId xmlns:a16="http://schemas.microsoft.com/office/drawing/2014/main" id="{77E10E55-1A27-412C-ABB9-393704D652A6}"/>
+                <a16:creationId xmlns:a16="http://schemas.microsoft.com/office/drawing/2014/main" id="{02319E19-9AFE-4587-B0B0-6EDE327E8D6C}"/>
               </a:ext>
             </a:extLst>
           </p:cNvPr>
@@ -4696,7 +4696,7 @@
           <p:cNvPr id="13" name="">
             <a:extLst xmlns:a="http://schemas.openxmlformats.org/drawingml/2006/main">
               <a:ext uri="{FF2B5EF4-FFF2-40B4-BE49-F238E27FC236}">
-                <a16:creationId xmlns:a16="http://schemas.microsoft.com/office/drawing/2014/main" id="{8768A004-1ADA-4040-A6D2-7F840C2B37EF}"/>
+                <a16:creationId xmlns:a16="http://schemas.microsoft.com/office/drawing/2014/main" id="{96C17868-58B8-4A6E-A453-30AED64EC4EF}"/>
               </a:ext>
             </a:extLst>
           </p:cNvPr>
@@ -4760,7 +4760,7 @@
           <p:cNvPr id="14" name="">
             <a:extLst xmlns:a="http://schemas.openxmlformats.org/drawingml/2006/main">
               <a:ext uri="{FF2B5EF4-FFF2-40B4-BE49-F238E27FC236}">
-                <a16:creationId xmlns:a16="http://schemas.microsoft.com/office/drawing/2014/main" id="{8938A43F-F1D0-42E3-ADA4-6A6567BDC542}"/>
+                <a16:creationId xmlns:a16="http://schemas.microsoft.com/office/drawing/2014/main" id="{0C21DF67-D00C-466F-B0C2-840FC5E3470F}"/>
               </a:ext>
             </a:extLst>
           </p:cNvPr>
@@ -4793,7 +4793,7 @@
           <p:cNvPr id="15" name="">
             <a:extLst xmlns:a="http://schemas.openxmlformats.org/drawingml/2006/main">
               <a:ext uri="{FF2B5EF4-FFF2-40B4-BE49-F238E27FC236}">
-                <a16:creationId xmlns:a16="http://schemas.microsoft.com/office/drawing/2014/main" id="{7C776EC9-6CB3-4651-84FD-AF3C2121D48F}"/>
+                <a16:creationId xmlns:a16="http://schemas.microsoft.com/office/drawing/2014/main" id="{A0658725-51D8-45D9-AD51-38021062FB8D}"/>
               </a:ext>
             </a:extLst>
           </p:cNvPr>
@@ -4828,7 +4828,7 @@
           <p:cNvPr id="16" name="">
             <a:extLst xmlns:a="http://schemas.openxmlformats.org/drawingml/2006/main">
               <a:ext uri="{FF2B5EF4-FFF2-40B4-BE49-F238E27FC236}">
-                <a16:creationId xmlns:a16="http://schemas.microsoft.com/office/drawing/2014/main" id="{675B59B2-2D60-45E6-9C85-2607A1D22038}"/>
+                <a16:creationId xmlns:a16="http://schemas.microsoft.com/office/drawing/2014/main" id="{4449D532-7946-4048-8DB3-DB0ECBF0F0D4}"/>
               </a:ext>
             </a:extLst>
           </p:cNvPr>
@@ -4892,7 +4892,7 @@
           <p:cNvPr id="17" name="">
             <a:extLst xmlns:a="http://schemas.openxmlformats.org/drawingml/2006/main">
               <a:ext uri="{FF2B5EF4-FFF2-40B4-BE49-F238E27FC236}">
-                <a16:creationId xmlns:a16="http://schemas.microsoft.com/office/drawing/2014/main" id="{360E82F1-5BF6-4D2C-8F9B-D797C08D2618}"/>
+                <a16:creationId xmlns:a16="http://schemas.microsoft.com/office/drawing/2014/main" id="{22494EB3-516B-498D-B98B-CCC3CC6FBD5E}"/>
               </a:ext>
             </a:extLst>
           </p:cNvPr>
@@ -4956,7 +4956,7 @@
           <p:cNvPr id="18" name="">
             <a:extLst xmlns:a="http://schemas.openxmlformats.org/drawingml/2006/main">
               <a:ext uri="{FF2B5EF4-FFF2-40B4-BE49-F238E27FC236}">
-                <a16:creationId xmlns:a16="http://schemas.microsoft.com/office/drawing/2014/main" id="{F9D415EC-43CD-417C-B7E7-6FE50218D3A8}"/>
+                <a16:creationId xmlns:a16="http://schemas.microsoft.com/office/drawing/2014/main" id="{EF8B01AD-1DBA-4B60-9BEF-C13F1F9570A4}"/>
               </a:ext>
             </a:extLst>
           </p:cNvPr>
@@ -5020,7 +5020,7 @@
           <p:cNvPr id="19" name="">
             <a:extLst xmlns:a="http://schemas.openxmlformats.org/drawingml/2006/main">
               <a:ext uri="{FF2B5EF4-FFF2-40B4-BE49-F238E27FC236}">
-                <a16:creationId xmlns:a16="http://schemas.microsoft.com/office/drawing/2014/main" id="{F508C45B-86AA-40FA-B141-32B0F25FDD6D}"/>
+                <a16:creationId xmlns:a16="http://schemas.microsoft.com/office/drawing/2014/main" id="{F9C4428D-C7EF-4F40-8C5E-E6E11A9C673A}"/>
               </a:ext>
             </a:extLst>
           </p:cNvPr>
@@ -5053,7 +5053,7 @@
           <p:cNvPr id="20" name="">
             <a:extLst xmlns:a="http://schemas.openxmlformats.org/drawingml/2006/main">
               <a:ext uri="{FF2B5EF4-FFF2-40B4-BE49-F238E27FC236}">
-                <a16:creationId xmlns:a16="http://schemas.microsoft.com/office/drawing/2014/main" id="{EEF40FB1-ECEE-4C7F-AEE5-239C1746E458}"/>
+                <a16:creationId xmlns:a16="http://schemas.microsoft.com/office/drawing/2014/main" id="{3675D1DB-7A2E-44CE-9B31-8B1AD2037CC2}"/>
               </a:ext>
             </a:extLst>
           </p:cNvPr>
@@ -5117,7 +5117,7 @@
           <p:cNvPr id="21" name="">
             <a:extLst xmlns:a="http://schemas.openxmlformats.org/drawingml/2006/main">
               <a:ext uri="{FF2B5EF4-FFF2-40B4-BE49-F238E27FC236}">
-                <a16:creationId xmlns:a16="http://schemas.microsoft.com/office/drawing/2014/main" id="{678C9301-B7E2-44BA-B44B-723F18380FB4}"/>
+                <a16:creationId xmlns:a16="http://schemas.microsoft.com/office/drawing/2014/main" id="{8DAFEB5F-0ECD-4846-BDD0-0EF2F4A81B83}"/>
               </a:ext>
             </a:extLst>
           </p:cNvPr>
@@ -5179,7 +5179,7 @@
     </p:spTree>
     <p:extLst>
       <p:ext uri="{BB962C8B-B14F-4D97-AF65-F5344CB8AC3E}">
-        <p14:creationId xmlns:p14="http://schemas.microsoft.com/office/powerpoint/2010/main" val="386934420"/>
+        <p14:creationId xmlns:p14="http://schemas.microsoft.com/office/powerpoint/2010/main" val="1345985392"/>
       </p:ext>
     </p:extLst>
   </p:cSld>
@@ -5207,7 +5207,7 @@
           <p:nvPr/>
         </p:nvPicPr>
         <p:blipFill>
-          <a:blip xmlns:r="http://schemas.openxmlformats.org/officeDocument/2006/relationships" xmlns:a="http://schemas.openxmlformats.org/drawingml/2006/main" r:embed="Ra2e8a2cab6404ecd"/>
+          <a:blip xmlns:r="http://schemas.openxmlformats.org/officeDocument/2006/relationships" xmlns:a="http://schemas.openxmlformats.org/drawingml/2006/main" r:embed="R233a600dd0984627"/>
           <a:srcRect xmlns:a="http://schemas.openxmlformats.org/drawingml/2006/main" l="0" t="27" r="0" b="27"/>
           <a:stretch xmlns:a="http://schemas.openxmlformats.org/drawingml/2006/main">
             <a:fillRect l="0" t="0" r="0" b="0"/>
@@ -5228,7 +5228,7 @@
           <p:cNvPr id="2" name="">
             <a:extLst xmlns:a="http://schemas.openxmlformats.org/drawingml/2006/main">
               <a:ext uri="{FF2B5EF4-FFF2-40B4-BE49-F238E27FC236}">
-                <a16:creationId xmlns:a16="http://schemas.microsoft.com/office/drawing/2014/main" id="{61643679-49A6-40D1-BF4C-1B8CE0D6948D}"/>
+                <a16:creationId xmlns:a16="http://schemas.microsoft.com/office/drawing/2014/main" id="{27DC8AD4-8AC2-43D7-BC49-4016C9BB04B0}"/>
               </a:ext>
             </a:extLst>
           </p:cNvPr>
@@ -5265,7 +5265,7 @@
           <p:cNvPr id="3" name="">
             <a:extLst xmlns:a="http://schemas.openxmlformats.org/drawingml/2006/main">
               <a:ext uri="{FF2B5EF4-FFF2-40B4-BE49-F238E27FC236}">
-                <a16:creationId xmlns:a16="http://schemas.microsoft.com/office/drawing/2014/main" id="{A6A763F6-1E03-4AF7-84EE-A144E9156810}"/>
+                <a16:creationId xmlns:a16="http://schemas.microsoft.com/office/drawing/2014/main" id="{463EDDFA-7FC1-40A3-AE8F-D3E4A961340E}"/>
               </a:ext>
             </a:extLst>
           </p:cNvPr>
@@ -5302,7 +5302,7 @@
           <p:cNvPr id="4" name="">
             <a:extLst xmlns:a="http://schemas.openxmlformats.org/drawingml/2006/main">
               <a:ext uri="{FF2B5EF4-FFF2-40B4-BE49-F238E27FC236}">
-                <a16:creationId xmlns:a16="http://schemas.microsoft.com/office/drawing/2014/main" id="{99280814-74F3-49B0-A17E-83DE5F579F19}"/>
+                <a16:creationId xmlns:a16="http://schemas.microsoft.com/office/drawing/2014/main" id="{20A9F1C6-9824-4AD9-8A95-75DD20C65219}"/>
               </a:ext>
             </a:extLst>
           </p:cNvPr>
@@ -5366,7 +5366,7 @@
           <p:cNvPr id="5" name="">
             <a:extLst xmlns:a="http://schemas.openxmlformats.org/drawingml/2006/main">
               <a:ext uri="{FF2B5EF4-FFF2-40B4-BE49-F238E27FC236}">
-                <a16:creationId xmlns:a16="http://schemas.microsoft.com/office/drawing/2014/main" id="{D58FE2C5-D157-4BDB-AC22-F37E9476D50D}"/>
+                <a16:creationId xmlns:a16="http://schemas.microsoft.com/office/drawing/2014/main" id="{FD04F09A-F8FB-4E5C-BF4F-157145CAC567}"/>
               </a:ext>
             </a:extLst>
           </p:cNvPr>
@@ -5420,7 +5420,7 @@
                 <a:ea typeface="Aptos Display"/>
                 <a:cs typeface="Aptos Display"/>
               </a:rPr>
-              <a:t>We seek capital and partners to accelerate product, sales and talent</a:t>
+              <a:t>Raising US$500K pre-seed to reach paid pilots and repeatable product</a:t>
             </a:r>
           </a:p>
         </p:txBody>
@@ -5430,7 +5430,7 @@
           <p:cNvPr id="6" name="">
             <a:extLst xmlns:a="http://schemas.openxmlformats.org/drawingml/2006/main">
               <a:ext uri="{FF2B5EF4-FFF2-40B4-BE49-F238E27FC236}">
-                <a16:creationId xmlns:a16="http://schemas.microsoft.com/office/drawing/2014/main" id="{1FEE7966-358B-42CA-9188-41C0E4CAEC1F}"/>
+                <a16:creationId xmlns:a16="http://schemas.microsoft.com/office/drawing/2014/main" id="{17EA3758-0E87-4779-A450-19E3AEDA6D17}"/>
               </a:ext>
             </a:extLst>
           </p:cNvPr>
@@ -5484,7 +5484,7 @@
                 <a:ea typeface="Aptos"/>
                 <a:cs typeface="Aptos"/>
               </a:rPr>
-              <a:t>Tecnotitan is building a multi-division technology company with global ambition from Latin America.</a:t>
+              <a:t>The round funds 18 months to turn AI and software services into proprietary products with initial customers, measurable use cases and a global commercial base.</a:t>
             </a:r>
           </a:p>
         </p:txBody>
@@ -5494,7 +5494,7 @@
           <p:cNvPr id="7" name="">
             <a:extLst xmlns:a="http://schemas.openxmlformats.org/drawingml/2006/main">
               <a:ext uri="{FF2B5EF4-FFF2-40B4-BE49-F238E27FC236}">
-                <a16:creationId xmlns:a16="http://schemas.microsoft.com/office/drawing/2014/main" id="{1938BC7E-F0A1-4340-8B60-7C8D3A359197}"/>
+                <a16:creationId xmlns:a16="http://schemas.microsoft.com/office/drawing/2014/main" id="{226C655C-55FD-4B97-A574-2DA1DAD34EF2}"/>
               </a:ext>
             </a:extLst>
           </p:cNvPr>
@@ -5529,7 +5529,7 @@
           <p:cNvPr id="8" name="">
             <a:extLst xmlns:a="http://schemas.openxmlformats.org/drawingml/2006/main">
               <a:ext uri="{FF2B5EF4-FFF2-40B4-BE49-F238E27FC236}">
-                <a16:creationId xmlns:a16="http://schemas.microsoft.com/office/drawing/2014/main" id="{310526B2-79F4-4E5C-A7D1-5C104162C31D}"/>
+                <a16:creationId xmlns:a16="http://schemas.microsoft.com/office/drawing/2014/main" id="{B2ACBBFC-6201-4775-8E52-D1293DB696C3}"/>
               </a:ext>
             </a:extLst>
           </p:cNvPr>
@@ -5593,7 +5593,7 @@
           <p:cNvPr id="9" name="">
             <a:extLst xmlns:a="http://schemas.openxmlformats.org/drawingml/2006/main">
               <a:ext uri="{FF2B5EF4-FFF2-40B4-BE49-F238E27FC236}">
-                <a16:creationId xmlns:a16="http://schemas.microsoft.com/office/drawing/2014/main" id="{789F7A88-67AF-41B8-9332-FFC3B41202A8}"/>
+                <a16:creationId xmlns:a16="http://schemas.microsoft.com/office/drawing/2014/main" id="{C729093B-8959-4CAB-A190-9A955A654A7F}"/>
               </a:ext>
             </a:extLst>
           </p:cNvPr>
@@ -5647,7 +5647,7 @@
                 <a:ea typeface="Aptos"/>
                 <a:cs typeface="Aptos"/>
               </a:rPr>
-              <a:t>Product</a:t>
+              <a:t>40% product and engineering</a:t>
             </a:r>
           </a:p>
         </p:txBody>
@@ -5657,7 +5657,7 @@
           <p:cNvPr id="10" name="">
             <a:extLst xmlns:a="http://schemas.openxmlformats.org/drawingml/2006/main">
               <a:ext uri="{FF2B5EF4-FFF2-40B4-BE49-F238E27FC236}">
-                <a16:creationId xmlns:a16="http://schemas.microsoft.com/office/drawing/2014/main" id="{A384DAD6-BCB5-493D-BF95-2C54DF144BDF}"/>
+                <a16:creationId xmlns:a16="http://schemas.microsoft.com/office/drawing/2014/main" id="{A1D28621-4FD5-433F-9297-0D643973798F}"/>
               </a:ext>
             </a:extLst>
           </p:cNvPr>
@@ -5692,7 +5692,7 @@
           <p:cNvPr id="11" name="">
             <a:extLst xmlns:a="http://schemas.openxmlformats.org/drawingml/2006/main">
               <a:ext uri="{FF2B5EF4-FFF2-40B4-BE49-F238E27FC236}">
-                <a16:creationId xmlns:a16="http://schemas.microsoft.com/office/drawing/2014/main" id="{6F376FE0-EA08-43E2-AB5E-3FA749D8F6C6}"/>
+                <a16:creationId xmlns:a16="http://schemas.microsoft.com/office/drawing/2014/main" id="{38C651B2-8C75-4075-A203-54A5D08EFE25}"/>
               </a:ext>
             </a:extLst>
           </p:cNvPr>
@@ -5756,7 +5756,7 @@
           <p:cNvPr id="12" name="">
             <a:extLst xmlns:a="http://schemas.openxmlformats.org/drawingml/2006/main">
               <a:ext uri="{FF2B5EF4-FFF2-40B4-BE49-F238E27FC236}">
-                <a16:creationId xmlns:a16="http://schemas.microsoft.com/office/drawing/2014/main" id="{52229DD7-EABD-43F1-A702-0C40818773D2}"/>
+                <a16:creationId xmlns:a16="http://schemas.microsoft.com/office/drawing/2014/main" id="{7558DAED-5F5E-46E5-BA1E-60CA0717435B}"/>
               </a:ext>
             </a:extLst>
           </p:cNvPr>
@@ -5810,7 +5810,7 @@
                 <a:ea typeface="Aptos"/>
                 <a:cs typeface="Aptos"/>
               </a:rPr>
-              <a:t>Sales</a:t>
+              <a:t>25% sales and pilots</a:t>
             </a:r>
           </a:p>
         </p:txBody>
@@ -5820,7 +5820,7 @@
           <p:cNvPr id="13" name="">
             <a:extLst xmlns:a="http://schemas.openxmlformats.org/drawingml/2006/main">
               <a:ext uri="{FF2B5EF4-FFF2-40B4-BE49-F238E27FC236}">
-                <a16:creationId xmlns:a16="http://schemas.microsoft.com/office/drawing/2014/main" id="{9121CF96-EE60-4250-93F4-48E3498AFBEC}"/>
+                <a16:creationId xmlns:a16="http://schemas.microsoft.com/office/drawing/2014/main" id="{DA25C77C-669B-4427-AB4F-5F0848078257}"/>
               </a:ext>
             </a:extLst>
           </p:cNvPr>
@@ -5855,7 +5855,7 @@
           <p:cNvPr id="14" name="">
             <a:extLst xmlns:a="http://schemas.openxmlformats.org/drawingml/2006/main">
               <a:ext uri="{FF2B5EF4-FFF2-40B4-BE49-F238E27FC236}">
-                <a16:creationId xmlns:a16="http://schemas.microsoft.com/office/drawing/2014/main" id="{D40A3202-3AB3-4E7E-82C3-65BF53D553AF}"/>
+                <a16:creationId xmlns:a16="http://schemas.microsoft.com/office/drawing/2014/main" id="{49CE0F9E-78ED-431C-B61F-B6620697B646}"/>
               </a:ext>
             </a:extLst>
           </p:cNvPr>
@@ -5919,7 +5919,7 @@
           <p:cNvPr id="15" name="">
             <a:extLst xmlns:a="http://schemas.openxmlformats.org/drawingml/2006/main">
               <a:ext uri="{FF2B5EF4-FFF2-40B4-BE49-F238E27FC236}">
-                <a16:creationId xmlns:a16="http://schemas.microsoft.com/office/drawing/2014/main" id="{51610230-957F-44B9-B98D-094961D65F7A}"/>
+                <a16:creationId xmlns:a16="http://schemas.microsoft.com/office/drawing/2014/main" id="{4DEF2A49-CC3E-4C26-B0CB-A5CD82675A5D}"/>
               </a:ext>
             </a:extLst>
           </p:cNvPr>
@@ -5973,7 +5973,7 @@
                 <a:ea typeface="Aptos"/>
                 <a:cs typeface="Aptos"/>
               </a:rPr>
-              <a:t>Technical talent</a:t>
+              <a:t>20% AI delivery</a:t>
             </a:r>
           </a:p>
         </p:txBody>
@@ -5983,7 +5983,7 @@
           <p:cNvPr id="16" name="">
             <a:extLst xmlns:a="http://schemas.openxmlformats.org/drawingml/2006/main">
               <a:ext uri="{FF2B5EF4-FFF2-40B4-BE49-F238E27FC236}">
-                <a16:creationId xmlns:a16="http://schemas.microsoft.com/office/drawing/2014/main" id="{82933F91-10AF-4C88-862E-41113CE6BB1E}"/>
+                <a16:creationId xmlns:a16="http://schemas.microsoft.com/office/drawing/2014/main" id="{6B59A5D2-9685-4EA9-9831-1CF60F1DBD52}"/>
               </a:ext>
             </a:extLst>
           </p:cNvPr>
@@ -6018,7 +6018,7 @@
           <p:cNvPr id="17" name="">
             <a:extLst xmlns:a="http://schemas.openxmlformats.org/drawingml/2006/main">
               <a:ext uri="{FF2B5EF4-FFF2-40B4-BE49-F238E27FC236}">
-                <a16:creationId xmlns:a16="http://schemas.microsoft.com/office/drawing/2014/main" id="{6C7EB154-BA55-4067-A3D1-E5FA0B7F8339}"/>
+                <a16:creationId xmlns:a16="http://schemas.microsoft.com/office/drawing/2014/main" id="{68F2B0BC-E7B5-49FB-9B48-622A4C717866}"/>
               </a:ext>
             </a:extLst>
           </p:cNvPr>
@@ -6082,7 +6082,7 @@
           <p:cNvPr id="18" name="">
             <a:extLst xmlns:a="http://schemas.openxmlformats.org/drawingml/2006/main">
               <a:ext uri="{FF2B5EF4-FFF2-40B4-BE49-F238E27FC236}">
-                <a16:creationId xmlns:a16="http://schemas.microsoft.com/office/drawing/2014/main" id="{9915DE0E-B55A-426E-835D-2D9588AC6C89}"/>
+                <a16:creationId xmlns:a16="http://schemas.microsoft.com/office/drawing/2014/main" id="{8733929F-FA1B-4433-8A7F-E1A981329069}"/>
               </a:ext>
             </a:extLst>
           </p:cNvPr>
@@ -6136,7 +6136,7 @@
                 <a:ea typeface="Aptos"/>
                 <a:cs typeface="Aptos"/>
               </a:rPr>
-              <a:t>Data room</a:t>
+              <a:t>15% ops and data room</a:t>
             </a:r>
           </a:p>
         </p:txBody>
@@ -6146,7 +6146,7 @@
           <p:cNvPr id="19" name="">
             <a:extLst xmlns:a="http://schemas.openxmlformats.org/drawingml/2006/main">
               <a:ext uri="{FF2B5EF4-FFF2-40B4-BE49-F238E27FC236}">
-                <a16:creationId xmlns:a16="http://schemas.microsoft.com/office/drawing/2014/main" id="{E658273F-D614-482A-950F-88533F7A0151}"/>
+                <a16:creationId xmlns:a16="http://schemas.microsoft.com/office/drawing/2014/main" id="{A20A9943-D2A9-4601-B6F3-23EED78536EA}"/>
               </a:ext>
             </a:extLst>
           </p:cNvPr>
@@ -6181,7 +6181,7 @@
           <p:cNvPr id="20" name="">
             <a:extLst xmlns:a="http://schemas.openxmlformats.org/drawingml/2006/main">
               <a:ext uri="{FF2B5EF4-FFF2-40B4-BE49-F238E27FC236}">
-                <a16:creationId xmlns:a16="http://schemas.microsoft.com/office/drawing/2014/main" id="{B3F255A7-D91F-4946-B3A3-C281E244246F}"/>
+                <a16:creationId xmlns:a16="http://schemas.microsoft.com/office/drawing/2014/main" id="{D046D99E-AD7F-41E9-9A93-3B52F356E5BC}"/>
               </a:ext>
             </a:extLst>
           </p:cNvPr>
@@ -6245,7 +6245,7 @@
           <p:cNvPr id="21" name="">
             <a:extLst xmlns:a="http://schemas.openxmlformats.org/drawingml/2006/main">
               <a:ext uri="{FF2B5EF4-FFF2-40B4-BE49-F238E27FC236}">
-                <a16:creationId xmlns:a16="http://schemas.microsoft.com/office/drawing/2014/main" id="{45131DDF-821D-455D-B1AF-F320A2C77E86}"/>
+                <a16:creationId xmlns:a16="http://schemas.microsoft.com/office/drawing/2014/main" id="{DC18FB88-E7E2-419E-AF94-23D95FF6BEE9}"/>
               </a:ext>
             </a:extLst>
           </p:cNvPr>
@@ -6309,7 +6309,7 @@
           <p:cNvPr id="22" name="">
             <a:extLst xmlns:a="http://schemas.openxmlformats.org/drawingml/2006/main">
               <a:ext uri="{FF2B5EF4-FFF2-40B4-BE49-F238E27FC236}">
-                <a16:creationId xmlns:a16="http://schemas.microsoft.com/office/drawing/2014/main" id="{32BA6FC1-A526-47FF-A8A4-B1DB7583A8E6}"/>
+                <a16:creationId xmlns:a16="http://schemas.microsoft.com/office/drawing/2014/main" id="{FDD631F2-BFDB-4ABF-B22C-A87997995382}"/>
               </a:ext>
             </a:extLst>
           </p:cNvPr>
@@ -6342,7 +6342,7 @@
           <p:cNvPr id="23" name="">
             <a:extLst xmlns:a="http://schemas.openxmlformats.org/drawingml/2006/main">
               <a:ext uri="{FF2B5EF4-FFF2-40B4-BE49-F238E27FC236}">
-                <a16:creationId xmlns:a16="http://schemas.microsoft.com/office/drawing/2014/main" id="{6607839E-3C89-44DD-B784-D9922FD13D31}"/>
+                <a16:creationId xmlns:a16="http://schemas.microsoft.com/office/drawing/2014/main" id="{D90DE623-9D5C-4D6E-B600-A2066FABA0B8}"/>
               </a:ext>
             </a:extLst>
           </p:cNvPr>
@@ -6406,7 +6406,7 @@
           <p:cNvPr id="24" name="">
             <a:extLst xmlns:a="http://schemas.openxmlformats.org/drawingml/2006/main">
               <a:ext uri="{FF2B5EF4-FFF2-40B4-BE49-F238E27FC236}">
-                <a16:creationId xmlns:a16="http://schemas.microsoft.com/office/drawing/2014/main" id="{C86627F2-5087-4512-B348-3FFBB352962E}"/>
+                <a16:creationId xmlns:a16="http://schemas.microsoft.com/office/drawing/2014/main" id="{913E3DC2-C34D-458B-87F3-EF037F731AA5}"/>
               </a:ext>
             </a:extLst>
           </p:cNvPr>
@@ -6468,7 +6468,7 @@
     </p:spTree>
     <p:extLst>
       <p:ext uri="{BB962C8B-B14F-4D97-AF65-F5344CB8AC3E}">
-        <p14:creationId xmlns:p14="http://schemas.microsoft.com/office/powerpoint/2010/main" val="253448718"/>
+        <p14:creationId xmlns:p14="http://schemas.microsoft.com/office/powerpoint/2010/main" val="422302972"/>
       </p:ext>
     </p:extLst>
   </p:cSld>
@@ -6496,7 +6496,7 @@
           <p:nvPr/>
         </p:nvPicPr>
         <p:blipFill>
-          <a:blip xmlns:r="http://schemas.openxmlformats.org/officeDocument/2006/relationships" xmlns:a="http://schemas.openxmlformats.org/drawingml/2006/main" r:embed="R4318e5283658473a"/>
+          <a:blip xmlns:r="http://schemas.openxmlformats.org/officeDocument/2006/relationships" xmlns:a="http://schemas.openxmlformats.org/drawingml/2006/main" r:embed="R7746b41b4e464638"/>
           <a:srcRect xmlns:a="http://schemas.openxmlformats.org/drawingml/2006/main" l="0" t="27" r="0" b="27"/>
           <a:stretch xmlns:a="http://schemas.openxmlformats.org/drawingml/2006/main">
             <a:fillRect l="0" t="0" r="0" b="0"/>
@@ -6517,7 +6517,7 @@
           <p:cNvPr id="2" name="">
             <a:extLst xmlns:a="http://schemas.openxmlformats.org/drawingml/2006/main">
               <a:ext uri="{FF2B5EF4-FFF2-40B4-BE49-F238E27FC236}">
-                <a16:creationId xmlns:a16="http://schemas.microsoft.com/office/drawing/2014/main" id="{4BBEA7E2-6B3F-43FA-9433-92F0E13BE14F}"/>
+                <a16:creationId xmlns:a16="http://schemas.microsoft.com/office/drawing/2014/main" id="{3D03B7E4-E5E3-4A13-883E-BF07C54950D3}"/>
               </a:ext>
             </a:extLst>
           </p:cNvPr>
@@ -6554,7 +6554,7 @@
           <p:cNvPr id="3" name="">
             <a:extLst xmlns:a="http://schemas.openxmlformats.org/drawingml/2006/main">
               <a:ext uri="{FF2B5EF4-FFF2-40B4-BE49-F238E27FC236}">
-                <a16:creationId xmlns:a16="http://schemas.microsoft.com/office/drawing/2014/main" id="{7ED2E186-23C7-4F24-BB85-93D332285C21}"/>
+                <a16:creationId xmlns:a16="http://schemas.microsoft.com/office/drawing/2014/main" id="{94AF5E8A-0CD6-4ED8-9A49-B1145A527056}"/>
               </a:ext>
             </a:extLst>
           </p:cNvPr>
@@ -6591,7 +6591,7 @@
           <p:cNvPr id="4" name="">
             <a:extLst xmlns:a="http://schemas.openxmlformats.org/drawingml/2006/main">
               <a:ext uri="{FF2B5EF4-FFF2-40B4-BE49-F238E27FC236}">
-                <a16:creationId xmlns:a16="http://schemas.microsoft.com/office/drawing/2014/main" id="{192C9397-7EC2-4801-9FFB-2B5A4250B987}"/>
+                <a16:creationId xmlns:a16="http://schemas.microsoft.com/office/drawing/2014/main" id="{B9D7EFC6-647B-4373-AD36-43A79ACF7CE3}"/>
               </a:ext>
             </a:extLst>
           </p:cNvPr>
@@ -6645,7 +6645,7 @@
                 <a:ea typeface="Aptos"/>
                 <a:cs typeface="Aptos"/>
               </a:rPr>
-              <a:t>THESIS</a:t>
+              <a:t>WHY NOW</a:t>
             </a:r>
           </a:p>
         </p:txBody>
@@ -6655,7 +6655,7 @@
           <p:cNvPr id="5" name="">
             <a:extLst xmlns:a="http://schemas.openxmlformats.org/drawingml/2006/main">
               <a:ext uri="{FF2B5EF4-FFF2-40B4-BE49-F238E27FC236}">
-                <a16:creationId xmlns:a16="http://schemas.microsoft.com/office/drawing/2014/main" id="{A8669E8C-315B-4032-B9E8-DD423BE69483}"/>
+                <a16:creationId xmlns:a16="http://schemas.microsoft.com/office/drawing/2014/main" id="{7F8772CB-EFFC-49BA-B16F-55B00FAF82D1}"/>
               </a:ext>
             </a:extLst>
           </p:cNvPr>
@@ -6709,7 +6709,7 @@
                 <a:ea typeface="Aptos Display"/>
                 <a:cs typeface="Aptos Display"/>
               </a:rPr>
-              <a:t>Companies need builders, not only advisors</a:t>
+              <a:t>Companies need AI implementation, not more slideware</a:t>
             </a:r>
           </a:p>
         </p:txBody>
@@ -6719,7 +6719,7 @@
           <p:cNvPr id="6" name="">
             <a:extLst xmlns:a="http://schemas.openxmlformats.org/drawingml/2006/main">
               <a:ext uri="{FF2B5EF4-FFF2-40B4-BE49-F238E27FC236}">
-                <a16:creationId xmlns:a16="http://schemas.microsoft.com/office/drawing/2014/main" id="{2CFA9174-7F0E-4972-8466-25836227B230}"/>
+                <a16:creationId xmlns:a16="http://schemas.microsoft.com/office/drawing/2014/main" id="{7CCE7D68-8B74-43B7-BBC4-7987F78B04F5}"/>
               </a:ext>
             </a:extLst>
           </p:cNvPr>
@@ -6773,7 +6773,7 @@
                 <a:ea typeface="Aptos"/>
                 <a:cs typeface="Aptos"/>
               </a:rPr>
-              <a:t>Real AI adoption requires diagnosis, software, data, automation and operating culture working as one system.</a:t>
+              <a:t>AI adoption pressure is reaching companies that still run on manual workflows, scattered data and teams without internal capacity to build.</a:t>
             </a:r>
           </a:p>
         </p:txBody>
@@ -6783,7 +6783,7 @@
           <p:cNvPr id="7" name="">
             <a:extLst xmlns:a="http://schemas.openxmlformats.org/drawingml/2006/main">
               <a:ext uri="{FF2B5EF4-FFF2-40B4-BE49-F238E27FC236}">
-                <a16:creationId xmlns:a16="http://schemas.microsoft.com/office/drawing/2014/main" id="{B9C858AA-5109-4847-84F5-E02312D12C69}"/>
+                <a16:creationId xmlns:a16="http://schemas.microsoft.com/office/drawing/2014/main" id="{1A86DAF6-347E-4648-B117-351E4355202B}"/>
               </a:ext>
             </a:extLst>
           </p:cNvPr>
@@ -6818,7 +6818,7 @@
           <p:cNvPr id="8" name="">
             <a:extLst xmlns:a="http://schemas.openxmlformats.org/drawingml/2006/main">
               <a:ext uri="{FF2B5EF4-FFF2-40B4-BE49-F238E27FC236}">
-                <a16:creationId xmlns:a16="http://schemas.microsoft.com/office/drawing/2014/main" id="{5A9A6044-F009-4AF1-B75E-135BDBC9BA35}"/>
+                <a16:creationId xmlns:a16="http://schemas.microsoft.com/office/drawing/2014/main" id="{1FA89310-0198-495D-A755-1E59417B9185}"/>
               </a:ext>
             </a:extLst>
           </p:cNvPr>
@@ -6882,7 +6882,7 @@
           <p:cNvPr id="9" name="">
             <a:extLst xmlns:a="http://schemas.openxmlformats.org/drawingml/2006/main">
               <a:ext uri="{FF2B5EF4-FFF2-40B4-BE49-F238E27FC236}">
-                <a16:creationId xmlns:a16="http://schemas.microsoft.com/office/drawing/2014/main" id="{D25831C8-D164-4B16-8A7C-BD43DCAC2E53}"/>
+                <a16:creationId xmlns:a16="http://schemas.microsoft.com/office/drawing/2014/main" id="{3D93FBC7-9B68-4CD1-B5B6-89979B84DF1A}"/>
               </a:ext>
             </a:extLst>
           </p:cNvPr>
@@ -6936,7 +6936,7 @@
                 <a:ea typeface="Aptos"/>
                 <a:cs typeface="Aptos"/>
               </a:rPr>
-              <a:t>AI + software core</a:t>
+              <a:t>Clear operating pain</a:t>
             </a:r>
           </a:p>
         </p:txBody>
@@ -6946,7 +6946,7 @@
           <p:cNvPr id="10" name="">
             <a:extLst xmlns:a="http://schemas.openxmlformats.org/drawingml/2006/main">
               <a:ext uri="{FF2B5EF4-FFF2-40B4-BE49-F238E27FC236}">
-                <a16:creationId xmlns:a16="http://schemas.microsoft.com/office/drawing/2014/main" id="{50C53170-E3BE-4CD3-A3B4-7C4032D1324C}"/>
+                <a16:creationId xmlns:a16="http://schemas.microsoft.com/office/drawing/2014/main" id="{76050009-407C-495F-8CDC-1803B75704E1}"/>
               </a:ext>
             </a:extLst>
           </p:cNvPr>
@@ -6979,7 +6979,7 @@
           <p:cNvPr id="11" name="">
             <a:extLst xmlns:a="http://schemas.openxmlformats.org/drawingml/2006/main">
               <a:ext uri="{FF2B5EF4-FFF2-40B4-BE49-F238E27FC236}">
-                <a16:creationId xmlns:a16="http://schemas.microsoft.com/office/drawing/2014/main" id="{38654184-9D86-4004-8175-A63AD3CB717B}"/>
+                <a16:creationId xmlns:a16="http://schemas.microsoft.com/office/drawing/2014/main" id="{59C10557-5E65-48CC-95A0-07B8FE6D145E}"/>
               </a:ext>
             </a:extLst>
           </p:cNvPr>
@@ -7014,7 +7014,7 @@
           <p:cNvPr id="12" name="">
             <a:extLst xmlns:a="http://schemas.openxmlformats.org/drawingml/2006/main">
               <a:ext uri="{FF2B5EF4-FFF2-40B4-BE49-F238E27FC236}">
-                <a16:creationId xmlns:a16="http://schemas.microsoft.com/office/drawing/2014/main" id="{2B94F53A-CE3E-41C5-889C-1D0690DCA543}"/>
+                <a16:creationId xmlns:a16="http://schemas.microsoft.com/office/drawing/2014/main" id="{712C5D3A-8031-4370-A9C4-F2CCABCD5052}"/>
               </a:ext>
             </a:extLst>
           </p:cNvPr>
@@ -7078,7 +7078,7 @@
           <p:cNvPr id="13" name="">
             <a:extLst xmlns:a="http://schemas.openxmlformats.org/drawingml/2006/main">
               <a:ext uri="{FF2B5EF4-FFF2-40B4-BE49-F238E27FC236}">
-                <a16:creationId xmlns:a16="http://schemas.microsoft.com/office/drawing/2014/main" id="{525D0F51-DCF0-4F4C-B57C-AF831C4EDADC}"/>
+                <a16:creationId xmlns:a16="http://schemas.microsoft.com/office/drawing/2014/main" id="{96DE90D6-22FB-41B0-8A4F-98C039A6741D}"/>
               </a:ext>
             </a:extLst>
           </p:cNvPr>
@@ -7132,7 +7132,7 @@
                 <a:ea typeface="Aptos"/>
                 <a:cs typeface="Aptos"/>
               </a:rPr>
-              <a:t>Interactive adoption experiences</a:t>
+              <a:t>Rising AI demand</a:t>
             </a:r>
           </a:p>
         </p:txBody>
@@ -7142,7 +7142,7 @@
           <p:cNvPr id="14" name="">
             <a:extLst xmlns:a="http://schemas.openxmlformats.org/drawingml/2006/main">
               <a:ext uri="{FF2B5EF4-FFF2-40B4-BE49-F238E27FC236}">
-                <a16:creationId xmlns:a16="http://schemas.microsoft.com/office/drawing/2014/main" id="{9F2AF909-8FC4-45BA-91DC-9A221F411F50}"/>
+                <a16:creationId xmlns:a16="http://schemas.microsoft.com/office/drawing/2014/main" id="{266339AE-2EB5-4EC8-8921-075B859E872D}"/>
               </a:ext>
             </a:extLst>
           </p:cNvPr>
@@ -7175,7 +7175,7 @@
           <p:cNvPr id="15" name="">
             <a:extLst xmlns:a="http://schemas.openxmlformats.org/drawingml/2006/main">
               <a:ext uri="{FF2B5EF4-FFF2-40B4-BE49-F238E27FC236}">
-                <a16:creationId xmlns:a16="http://schemas.microsoft.com/office/drawing/2014/main" id="{B322AB35-BC8A-4452-9C5C-876DBE602A97}"/>
+                <a16:creationId xmlns:a16="http://schemas.microsoft.com/office/drawing/2014/main" id="{EAF3D855-191D-48E4-8262-FF6DA6398916}"/>
               </a:ext>
             </a:extLst>
           </p:cNvPr>
@@ -7210,7 +7210,7 @@
           <p:cNvPr id="16" name="">
             <a:extLst xmlns:a="http://schemas.openxmlformats.org/drawingml/2006/main">
               <a:ext uri="{FF2B5EF4-FFF2-40B4-BE49-F238E27FC236}">
-                <a16:creationId xmlns:a16="http://schemas.microsoft.com/office/drawing/2014/main" id="{CBA065A7-F099-4F27-B64D-45FD801C8B26}"/>
+                <a16:creationId xmlns:a16="http://schemas.microsoft.com/office/drawing/2014/main" id="{A2BBDA0F-54BA-4C19-B20D-E911A3B8A733}"/>
               </a:ext>
             </a:extLst>
           </p:cNvPr>
@@ -7274,7 +7274,7 @@
           <p:cNvPr id="17" name="">
             <a:extLst xmlns:a="http://schemas.openxmlformats.org/drawingml/2006/main">
               <a:ext uri="{FF2B5EF4-FFF2-40B4-BE49-F238E27FC236}">
-                <a16:creationId xmlns:a16="http://schemas.microsoft.com/office/drawing/2014/main" id="{F2EBE1AD-018B-4073-9548-171A81C10A21}"/>
+                <a16:creationId xmlns:a16="http://schemas.microsoft.com/office/drawing/2014/main" id="{1EC105D5-9056-488F-8B14-31AFB55E0DE6}"/>
               </a:ext>
             </a:extLst>
           </p:cNvPr>
@@ -7328,7 +7328,7 @@
                 <a:ea typeface="Aptos"/>
                 <a:cs typeface="Aptos"/>
               </a:rPr>
-              <a:t>Robotics and automation frontier</a:t>
+              <a:t>Need for technical execution</a:t>
             </a:r>
           </a:p>
         </p:txBody>
@@ -7338,7 +7338,7 @@
           <p:cNvPr id="18" name="">
             <a:extLst xmlns:a="http://schemas.openxmlformats.org/drawingml/2006/main">
               <a:ext uri="{FF2B5EF4-FFF2-40B4-BE49-F238E27FC236}">
-                <a16:creationId xmlns:a16="http://schemas.microsoft.com/office/drawing/2014/main" id="{A3290D69-F5E1-4BA1-8505-08E7417EAD77}"/>
+                <a16:creationId xmlns:a16="http://schemas.microsoft.com/office/drawing/2014/main" id="{FAF332A2-00CE-452F-95F7-5661C9A63549}"/>
               </a:ext>
             </a:extLst>
           </p:cNvPr>
@@ -7402,7 +7402,7 @@
           <p:cNvPr id="19" name="">
             <a:extLst xmlns:a="http://schemas.openxmlformats.org/drawingml/2006/main">
               <a:ext uri="{FF2B5EF4-FFF2-40B4-BE49-F238E27FC236}">
-                <a16:creationId xmlns:a16="http://schemas.microsoft.com/office/drawing/2014/main" id="{6E39A189-D8AF-4AD9-BD6A-F93F03027233}"/>
+                <a16:creationId xmlns:a16="http://schemas.microsoft.com/office/drawing/2014/main" id="{3CBC9ED5-6484-40DF-B8EB-23BE27CF90B3}"/>
               </a:ext>
             </a:extLst>
           </p:cNvPr>
@@ -7435,7 +7435,7 @@
           <p:cNvPr id="20" name="">
             <a:extLst xmlns:a="http://schemas.openxmlformats.org/drawingml/2006/main">
               <a:ext uri="{FF2B5EF4-FFF2-40B4-BE49-F238E27FC236}">
-                <a16:creationId xmlns:a16="http://schemas.microsoft.com/office/drawing/2014/main" id="{A23E2901-17AE-49B4-998B-32E4BFD34588}"/>
+                <a16:creationId xmlns:a16="http://schemas.microsoft.com/office/drawing/2014/main" id="{2ABCB359-F213-44B6-A6D9-2F8457614E5B}"/>
               </a:ext>
             </a:extLst>
           </p:cNvPr>
@@ -7499,7 +7499,7 @@
           <p:cNvPr id="21" name="">
             <a:extLst xmlns:a="http://schemas.openxmlformats.org/drawingml/2006/main">
               <a:ext uri="{FF2B5EF4-FFF2-40B4-BE49-F238E27FC236}">
-                <a16:creationId xmlns:a16="http://schemas.microsoft.com/office/drawing/2014/main" id="{0AA8C8E1-7184-4A18-843D-3C4F7F4D3972}"/>
+                <a16:creationId xmlns:a16="http://schemas.microsoft.com/office/drawing/2014/main" id="{40E7C854-48AF-417B-8B45-62248995FB3A}"/>
               </a:ext>
             </a:extLst>
           </p:cNvPr>
@@ -7561,7 +7561,7 @@
     </p:spTree>
     <p:extLst>
       <p:ext uri="{BB962C8B-B14F-4D97-AF65-F5344CB8AC3E}">
-        <p14:creationId xmlns:p14="http://schemas.microsoft.com/office/powerpoint/2010/main" val="217937463"/>
+        <p14:creationId xmlns:p14="http://schemas.microsoft.com/office/powerpoint/2010/main" val="1346012585"/>
       </p:ext>
     </p:extLst>
   </p:cSld>
@@ -7589,7 +7589,7 @@
           <p:nvPr/>
         </p:nvPicPr>
         <p:blipFill>
-          <a:blip xmlns:r="http://schemas.openxmlformats.org/officeDocument/2006/relationships" xmlns:a="http://schemas.openxmlformats.org/drawingml/2006/main" r:embed="Re98c9cb7ddae46af"/>
+          <a:blip xmlns:r="http://schemas.openxmlformats.org/officeDocument/2006/relationships" xmlns:a="http://schemas.openxmlformats.org/drawingml/2006/main" r:embed="R8901f83834a740d6"/>
           <a:srcRect xmlns:a="http://schemas.openxmlformats.org/drawingml/2006/main" l="0" t="27" r="0" b="27"/>
           <a:stretch xmlns:a="http://schemas.openxmlformats.org/drawingml/2006/main">
             <a:fillRect l="0" t="0" r="0" b="0"/>
@@ -7610,7 +7610,7 @@
           <p:cNvPr id="2" name="">
             <a:extLst xmlns:a="http://schemas.openxmlformats.org/drawingml/2006/main">
               <a:ext uri="{FF2B5EF4-FFF2-40B4-BE49-F238E27FC236}">
-                <a16:creationId xmlns:a16="http://schemas.microsoft.com/office/drawing/2014/main" id="{FC1691F6-1FA1-460A-929D-1BAA4B617F42}"/>
+                <a16:creationId xmlns:a16="http://schemas.microsoft.com/office/drawing/2014/main" id="{0240CFEE-5DD8-44FB-AC96-FA7CC20025CD}"/>
               </a:ext>
             </a:extLst>
           </p:cNvPr>
@@ -7647,7 +7647,7 @@
           <p:cNvPr id="3" name="">
             <a:extLst xmlns:a="http://schemas.openxmlformats.org/drawingml/2006/main">
               <a:ext uri="{FF2B5EF4-FFF2-40B4-BE49-F238E27FC236}">
-                <a16:creationId xmlns:a16="http://schemas.microsoft.com/office/drawing/2014/main" id="{9037F00A-11A0-4045-B3E5-F54D17F601E5}"/>
+                <a16:creationId xmlns:a16="http://schemas.microsoft.com/office/drawing/2014/main" id="{21C9EB2F-B8B6-4E1D-A159-4C7B5F3CDF29}"/>
               </a:ext>
             </a:extLst>
           </p:cNvPr>
@@ -7684,7 +7684,7 @@
           <p:cNvPr id="4" name="">
             <a:extLst xmlns:a="http://schemas.openxmlformats.org/drawingml/2006/main">
               <a:ext uri="{FF2B5EF4-FFF2-40B4-BE49-F238E27FC236}">
-                <a16:creationId xmlns:a16="http://schemas.microsoft.com/office/drawing/2014/main" id="{817C2FF6-808E-4D3A-BD03-A1A8E2F0990B}"/>
+                <a16:creationId xmlns:a16="http://schemas.microsoft.com/office/drawing/2014/main" id="{7258EB07-EA1E-4214-B988-5F2EC2718241}"/>
               </a:ext>
             </a:extLst>
           </p:cNvPr>
@@ -7748,7 +7748,7 @@
           <p:cNvPr id="5" name="">
             <a:extLst xmlns:a="http://schemas.openxmlformats.org/drawingml/2006/main">
               <a:ext uri="{FF2B5EF4-FFF2-40B4-BE49-F238E27FC236}">
-                <a16:creationId xmlns:a16="http://schemas.microsoft.com/office/drawing/2014/main" id="{720980F4-52E9-4576-84AB-730F2B6DDA14}"/>
+                <a16:creationId xmlns:a16="http://schemas.microsoft.com/office/drawing/2014/main" id="{8C6DED74-690C-4945-AE7C-5068452EA396}"/>
               </a:ext>
             </a:extLst>
           </p:cNvPr>
@@ -7812,7 +7812,7 @@
           <p:cNvPr id="6" name="">
             <a:extLst xmlns:a="http://schemas.openxmlformats.org/drawingml/2006/main">
               <a:ext uri="{FF2B5EF4-FFF2-40B4-BE49-F238E27FC236}">
-                <a16:creationId xmlns:a16="http://schemas.microsoft.com/office/drawing/2014/main" id="{7CF7D068-0672-4EAC-8051-39DF2C0AD9C3}"/>
+                <a16:creationId xmlns:a16="http://schemas.microsoft.com/office/drawing/2014/main" id="{571B83E1-E20D-4AC8-9B83-EC4366EB5426}"/>
               </a:ext>
             </a:extLst>
           </p:cNvPr>
@@ -7876,7 +7876,7 @@
           <p:cNvPr id="7" name="">
             <a:extLst xmlns:a="http://schemas.openxmlformats.org/drawingml/2006/main">
               <a:ext uri="{FF2B5EF4-FFF2-40B4-BE49-F238E27FC236}">
-                <a16:creationId xmlns:a16="http://schemas.microsoft.com/office/drawing/2014/main" id="{4B3F43B2-04B1-4E89-A25E-19F420FB5FEA}"/>
+                <a16:creationId xmlns:a16="http://schemas.microsoft.com/office/drawing/2014/main" id="{9A961E3D-9618-4013-9932-17AEE0EFAFFE}"/>
               </a:ext>
             </a:extLst>
           </p:cNvPr>
@@ -7911,7 +7911,7 @@
           <p:cNvPr id="8" name="">
             <a:extLst xmlns:a="http://schemas.openxmlformats.org/drawingml/2006/main">
               <a:ext uri="{FF2B5EF4-FFF2-40B4-BE49-F238E27FC236}">
-                <a16:creationId xmlns:a16="http://schemas.microsoft.com/office/drawing/2014/main" id="{C714246F-669E-450A-9681-5241B82E874B}"/>
+                <a16:creationId xmlns:a16="http://schemas.microsoft.com/office/drawing/2014/main" id="{C55B8DFB-F934-49FE-B7F1-C53BB75610F8}"/>
               </a:ext>
             </a:extLst>
           </p:cNvPr>
@@ -7975,7 +7975,7 @@
           <p:cNvPr id="9" name="">
             <a:extLst xmlns:a="http://schemas.openxmlformats.org/drawingml/2006/main">
               <a:ext uri="{FF2B5EF4-FFF2-40B4-BE49-F238E27FC236}">
-                <a16:creationId xmlns:a16="http://schemas.microsoft.com/office/drawing/2014/main" id="{B0C59B88-88E2-4B51-A78C-4F025B2C64BA}"/>
+                <a16:creationId xmlns:a16="http://schemas.microsoft.com/office/drawing/2014/main" id="{9BE85123-A5FE-4B13-9DF0-3A0D20D26954}"/>
               </a:ext>
             </a:extLst>
           </p:cNvPr>
@@ -8039,7 +8039,7 @@
           <p:cNvPr id="10" name="">
             <a:extLst xmlns:a="http://schemas.openxmlformats.org/drawingml/2006/main">
               <a:ext uri="{FF2B5EF4-FFF2-40B4-BE49-F238E27FC236}">
-                <a16:creationId xmlns:a16="http://schemas.microsoft.com/office/drawing/2014/main" id="{FEC24179-E05C-4EA8-A2BB-76B885D026B1}"/>
+                <a16:creationId xmlns:a16="http://schemas.microsoft.com/office/drawing/2014/main" id="{473A41C4-23EF-4B9D-BEB9-1DB7F49850B3}"/>
               </a:ext>
             </a:extLst>
           </p:cNvPr>
@@ -8074,7 +8074,7 @@
           <p:cNvPr id="11" name="">
             <a:extLst xmlns:a="http://schemas.openxmlformats.org/drawingml/2006/main">
               <a:ext uri="{FF2B5EF4-FFF2-40B4-BE49-F238E27FC236}">
-                <a16:creationId xmlns:a16="http://schemas.microsoft.com/office/drawing/2014/main" id="{ABA5BB3E-E80A-4FB6-A0D1-41D235FCFC93}"/>
+                <a16:creationId xmlns:a16="http://schemas.microsoft.com/office/drawing/2014/main" id="{2C7A6EB1-389D-4F65-91C0-E6414692573B}"/>
               </a:ext>
             </a:extLst>
           </p:cNvPr>
@@ -8138,7 +8138,7 @@
           <p:cNvPr id="12" name="">
             <a:extLst xmlns:a="http://schemas.openxmlformats.org/drawingml/2006/main">
               <a:ext uri="{FF2B5EF4-FFF2-40B4-BE49-F238E27FC236}">
-                <a16:creationId xmlns:a16="http://schemas.microsoft.com/office/drawing/2014/main" id="{CDF55F57-A32D-4EC9-985C-2E43E071D947}"/>
+                <a16:creationId xmlns:a16="http://schemas.microsoft.com/office/drawing/2014/main" id="{4C7B3603-AB98-4FE0-99D4-CC507FF29C3D}"/>
               </a:ext>
             </a:extLst>
           </p:cNvPr>
@@ -8202,7 +8202,7 @@
           <p:cNvPr id="13" name="">
             <a:extLst xmlns:a="http://schemas.openxmlformats.org/drawingml/2006/main">
               <a:ext uri="{FF2B5EF4-FFF2-40B4-BE49-F238E27FC236}">
-                <a16:creationId xmlns:a16="http://schemas.microsoft.com/office/drawing/2014/main" id="{4A610AA6-20A9-4478-B464-202104DA7A31}"/>
+                <a16:creationId xmlns:a16="http://schemas.microsoft.com/office/drawing/2014/main" id="{2C7560F9-ECE1-455E-BCAA-02DABB61B9C7}"/>
               </a:ext>
             </a:extLst>
           </p:cNvPr>
@@ -8237,7 +8237,7 @@
           <p:cNvPr id="14" name="">
             <a:extLst xmlns:a="http://schemas.openxmlformats.org/drawingml/2006/main">
               <a:ext uri="{FF2B5EF4-FFF2-40B4-BE49-F238E27FC236}">
-                <a16:creationId xmlns:a16="http://schemas.microsoft.com/office/drawing/2014/main" id="{6F172D46-998A-4DBA-84C5-F66824534ABB}"/>
+                <a16:creationId xmlns:a16="http://schemas.microsoft.com/office/drawing/2014/main" id="{175E3211-9123-466B-89FC-812DBC2DBFD1}"/>
               </a:ext>
             </a:extLst>
           </p:cNvPr>
@@ -8301,7 +8301,7 @@
           <p:cNvPr id="15" name="">
             <a:extLst xmlns:a="http://schemas.openxmlformats.org/drawingml/2006/main">
               <a:ext uri="{FF2B5EF4-FFF2-40B4-BE49-F238E27FC236}">
-                <a16:creationId xmlns:a16="http://schemas.microsoft.com/office/drawing/2014/main" id="{AA8E37C6-313F-4922-A1D6-8612466D9362}"/>
+                <a16:creationId xmlns:a16="http://schemas.microsoft.com/office/drawing/2014/main" id="{0912365E-AD65-49CD-BAB9-F9B2D9C8643A}"/>
               </a:ext>
             </a:extLst>
           </p:cNvPr>
@@ -8365,7 +8365,7 @@
           <p:cNvPr id="16" name="">
             <a:extLst xmlns:a="http://schemas.openxmlformats.org/drawingml/2006/main">
               <a:ext uri="{FF2B5EF4-FFF2-40B4-BE49-F238E27FC236}">
-                <a16:creationId xmlns:a16="http://schemas.microsoft.com/office/drawing/2014/main" id="{C1CB6BD8-0A5F-4672-9D9F-2DA8C1B556CD}"/>
+                <a16:creationId xmlns:a16="http://schemas.microsoft.com/office/drawing/2014/main" id="{5FFCB068-240E-4F9C-B7B5-0220233A2F5B}"/>
               </a:ext>
             </a:extLst>
           </p:cNvPr>
@@ -8400,7 +8400,7 @@
           <p:cNvPr id="17" name="">
             <a:extLst xmlns:a="http://schemas.openxmlformats.org/drawingml/2006/main">
               <a:ext uri="{FF2B5EF4-FFF2-40B4-BE49-F238E27FC236}">
-                <a16:creationId xmlns:a16="http://schemas.microsoft.com/office/drawing/2014/main" id="{D0DA6552-3905-4D06-AB5D-938929EBAC92}"/>
+                <a16:creationId xmlns:a16="http://schemas.microsoft.com/office/drawing/2014/main" id="{F08C354E-78C6-4DF1-AE53-B3ABFA6C681B}"/>
               </a:ext>
             </a:extLst>
           </p:cNvPr>
@@ -8464,7 +8464,7 @@
           <p:cNvPr id="18" name="">
             <a:extLst xmlns:a="http://schemas.openxmlformats.org/drawingml/2006/main">
               <a:ext uri="{FF2B5EF4-FFF2-40B4-BE49-F238E27FC236}">
-                <a16:creationId xmlns:a16="http://schemas.microsoft.com/office/drawing/2014/main" id="{DA710D8B-695E-4234-96C9-7F40F46CF350}"/>
+                <a16:creationId xmlns:a16="http://schemas.microsoft.com/office/drawing/2014/main" id="{1FC8DC78-3E03-496B-B321-D072232C5B5C}"/>
               </a:ext>
             </a:extLst>
           </p:cNvPr>
@@ -8528,7 +8528,7 @@
           <p:cNvPr id="19" name="">
             <a:extLst xmlns:a="http://schemas.openxmlformats.org/drawingml/2006/main">
               <a:ext uri="{FF2B5EF4-FFF2-40B4-BE49-F238E27FC236}">
-                <a16:creationId xmlns:a16="http://schemas.microsoft.com/office/drawing/2014/main" id="{3E023C37-B0E2-4FE3-812C-8591956442A0}"/>
+                <a16:creationId xmlns:a16="http://schemas.microsoft.com/office/drawing/2014/main" id="{875C7FF1-C687-4249-9B94-8C092C1ACE17}"/>
               </a:ext>
             </a:extLst>
           </p:cNvPr>
@@ -8592,7 +8592,7 @@
           <p:cNvPr id="20" name="">
             <a:extLst xmlns:a="http://schemas.openxmlformats.org/drawingml/2006/main">
               <a:ext uri="{FF2B5EF4-FFF2-40B4-BE49-F238E27FC236}">
-                <a16:creationId xmlns:a16="http://schemas.microsoft.com/office/drawing/2014/main" id="{9EFF4158-B7C9-4987-8C04-0BBAF80E446A}"/>
+                <a16:creationId xmlns:a16="http://schemas.microsoft.com/office/drawing/2014/main" id="{94FEDEB1-2334-4502-904A-97A142F9D935}"/>
               </a:ext>
             </a:extLst>
           </p:cNvPr>
@@ -8625,7 +8625,7 @@
           <p:cNvPr id="21" name="">
             <a:extLst xmlns:a="http://schemas.openxmlformats.org/drawingml/2006/main">
               <a:ext uri="{FF2B5EF4-FFF2-40B4-BE49-F238E27FC236}">
-                <a16:creationId xmlns:a16="http://schemas.microsoft.com/office/drawing/2014/main" id="{E33902B9-685B-465E-B264-1D3F50051365}"/>
+                <a16:creationId xmlns:a16="http://schemas.microsoft.com/office/drawing/2014/main" id="{49E5CBEF-6A20-4A73-869F-75FB49CEDE05}"/>
               </a:ext>
             </a:extLst>
           </p:cNvPr>
@@ -8658,7 +8658,7 @@
           <p:cNvPr id="22" name="">
             <a:extLst xmlns:a="http://schemas.openxmlformats.org/drawingml/2006/main">
               <a:ext uri="{FF2B5EF4-FFF2-40B4-BE49-F238E27FC236}">
-                <a16:creationId xmlns:a16="http://schemas.microsoft.com/office/drawing/2014/main" id="{F43B5D79-7052-45BE-ADDE-4DBD1C12B2D7}"/>
+                <a16:creationId xmlns:a16="http://schemas.microsoft.com/office/drawing/2014/main" id="{E56D830B-5475-4791-8F97-A979F90382AA}"/>
               </a:ext>
             </a:extLst>
           </p:cNvPr>
@@ -8722,7 +8722,7 @@
           <p:cNvPr id="23" name="">
             <a:extLst xmlns:a="http://schemas.openxmlformats.org/drawingml/2006/main">
               <a:ext uri="{FF2B5EF4-FFF2-40B4-BE49-F238E27FC236}">
-                <a16:creationId xmlns:a16="http://schemas.microsoft.com/office/drawing/2014/main" id="{9B506297-6852-4A87-9C5F-CA5606064FB4}"/>
+                <a16:creationId xmlns:a16="http://schemas.microsoft.com/office/drawing/2014/main" id="{D7DA1D8C-7900-4DFA-92A8-7A821FE5E00D}"/>
               </a:ext>
             </a:extLst>
           </p:cNvPr>
@@ -8755,7 +8755,7 @@
           <p:cNvPr id="24" name="">
             <a:extLst xmlns:a="http://schemas.openxmlformats.org/drawingml/2006/main">
               <a:ext uri="{FF2B5EF4-FFF2-40B4-BE49-F238E27FC236}">
-                <a16:creationId xmlns:a16="http://schemas.microsoft.com/office/drawing/2014/main" id="{512F593A-8D2D-4BDA-8E99-CCF3EB5CCCC3}"/>
+                <a16:creationId xmlns:a16="http://schemas.microsoft.com/office/drawing/2014/main" id="{DD13DC2D-7593-44FD-9BCC-B05EC37F4CE9}"/>
               </a:ext>
             </a:extLst>
           </p:cNvPr>
@@ -8788,7 +8788,7 @@
           <p:cNvPr id="25" name="">
             <a:extLst xmlns:a="http://schemas.openxmlformats.org/drawingml/2006/main">
               <a:ext uri="{FF2B5EF4-FFF2-40B4-BE49-F238E27FC236}">
-                <a16:creationId xmlns:a16="http://schemas.microsoft.com/office/drawing/2014/main" id="{87B647FA-BB52-47E0-88CB-57BD21F4FCBD}"/>
+                <a16:creationId xmlns:a16="http://schemas.microsoft.com/office/drawing/2014/main" id="{36EE1175-4670-4644-97A9-3F307EE03D78}"/>
               </a:ext>
             </a:extLst>
           </p:cNvPr>
@@ -8852,7 +8852,7 @@
           <p:cNvPr id="26" name="">
             <a:extLst xmlns:a="http://schemas.openxmlformats.org/drawingml/2006/main">
               <a:ext uri="{FF2B5EF4-FFF2-40B4-BE49-F238E27FC236}">
-                <a16:creationId xmlns:a16="http://schemas.microsoft.com/office/drawing/2014/main" id="{C0A21B74-4B8E-4777-A6B9-46AAB35090C3}"/>
+                <a16:creationId xmlns:a16="http://schemas.microsoft.com/office/drawing/2014/main" id="{CEFFB2DF-7BEC-43C2-820D-DFE5CFE6577D}"/>
               </a:ext>
             </a:extLst>
           </p:cNvPr>
@@ -8885,7 +8885,7 @@
           <p:cNvPr id="27" name="">
             <a:extLst xmlns:a="http://schemas.openxmlformats.org/drawingml/2006/main">
               <a:ext uri="{FF2B5EF4-FFF2-40B4-BE49-F238E27FC236}">
-                <a16:creationId xmlns:a16="http://schemas.microsoft.com/office/drawing/2014/main" id="{E29853D6-4B88-42AC-B411-CE40286495CE}"/>
+                <a16:creationId xmlns:a16="http://schemas.microsoft.com/office/drawing/2014/main" id="{63B20B2F-0AA2-4189-A5D2-41AEB51DFDB1}"/>
               </a:ext>
             </a:extLst>
           </p:cNvPr>
@@ -8918,7 +8918,7 @@
           <p:cNvPr id="28" name="">
             <a:extLst xmlns:a="http://schemas.openxmlformats.org/drawingml/2006/main">
               <a:ext uri="{FF2B5EF4-FFF2-40B4-BE49-F238E27FC236}">
-                <a16:creationId xmlns:a16="http://schemas.microsoft.com/office/drawing/2014/main" id="{E39859A8-A7AE-48CA-BD1B-6574B70C94EA}"/>
+                <a16:creationId xmlns:a16="http://schemas.microsoft.com/office/drawing/2014/main" id="{886E325E-CD53-472A-9BE0-D1B1ECF9DE11}"/>
               </a:ext>
             </a:extLst>
           </p:cNvPr>
@@ -8982,7 +8982,7 @@
           <p:cNvPr id="29" name="">
             <a:extLst xmlns:a="http://schemas.openxmlformats.org/drawingml/2006/main">
               <a:ext uri="{FF2B5EF4-FFF2-40B4-BE49-F238E27FC236}">
-                <a16:creationId xmlns:a16="http://schemas.microsoft.com/office/drawing/2014/main" id="{37C58CF5-3D85-4A12-9DCB-5DDBE5B47B9C}"/>
+                <a16:creationId xmlns:a16="http://schemas.microsoft.com/office/drawing/2014/main" id="{1458D380-F662-41BB-8FFF-D94306A56B61}"/>
               </a:ext>
             </a:extLst>
           </p:cNvPr>
@@ -9015,7 +9015,7 @@
           <p:cNvPr id="30" name="">
             <a:extLst xmlns:a="http://schemas.openxmlformats.org/drawingml/2006/main">
               <a:ext uri="{FF2B5EF4-FFF2-40B4-BE49-F238E27FC236}">
-                <a16:creationId xmlns:a16="http://schemas.microsoft.com/office/drawing/2014/main" id="{D712F35C-7789-4DCE-9F17-AC8950A615D4}"/>
+                <a16:creationId xmlns:a16="http://schemas.microsoft.com/office/drawing/2014/main" id="{CE0215D9-EB9B-4FD2-8897-B051394823AD}"/>
               </a:ext>
             </a:extLst>
           </p:cNvPr>
@@ -9079,7 +9079,7 @@
           <p:cNvPr id="31" name="">
             <a:extLst xmlns:a="http://schemas.openxmlformats.org/drawingml/2006/main">
               <a:ext uri="{FF2B5EF4-FFF2-40B4-BE49-F238E27FC236}">
-                <a16:creationId xmlns:a16="http://schemas.microsoft.com/office/drawing/2014/main" id="{7CB6A78E-70FB-4D1A-82C2-360A818A59AC}"/>
+                <a16:creationId xmlns:a16="http://schemas.microsoft.com/office/drawing/2014/main" id="{F27050FF-D8BC-4517-984C-1C4DB47C9E77}"/>
               </a:ext>
             </a:extLst>
           </p:cNvPr>
@@ -9141,7 +9141,7 @@
     </p:spTree>
     <p:extLst>
       <p:ext uri="{BB962C8B-B14F-4D97-AF65-F5344CB8AC3E}">
-        <p14:creationId xmlns:p14="http://schemas.microsoft.com/office/powerpoint/2010/main" val="1316377506"/>
+        <p14:creationId xmlns:p14="http://schemas.microsoft.com/office/powerpoint/2010/main" val="567156687"/>
       </p:ext>
     </p:extLst>
   </p:cSld>
@@ -9169,7 +9169,7 @@
           <p:nvPr/>
         </p:nvPicPr>
         <p:blipFill>
-          <a:blip xmlns:r="http://schemas.openxmlformats.org/officeDocument/2006/relationships" xmlns:a="http://schemas.openxmlformats.org/drawingml/2006/main" r:embed="R1f76bdfecb5b4725"/>
+          <a:blip xmlns:r="http://schemas.openxmlformats.org/officeDocument/2006/relationships" xmlns:a="http://schemas.openxmlformats.org/drawingml/2006/main" r:embed="Ree5704b491d44731"/>
           <a:srcRect xmlns:a="http://schemas.openxmlformats.org/drawingml/2006/main" l="0" t="7813" r="0" b="7813"/>
           <a:stretch xmlns:a="http://schemas.openxmlformats.org/drawingml/2006/main">
             <a:fillRect l="0" t="0" r="0" b="0"/>
@@ -9190,7 +9190,7 @@
           <p:cNvPr id="2" name="">
             <a:extLst xmlns:a="http://schemas.openxmlformats.org/drawingml/2006/main">
               <a:ext uri="{FF2B5EF4-FFF2-40B4-BE49-F238E27FC236}">
-                <a16:creationId xmlns:a16="http://schemas.microsoft.com/office/drawing/2014/main" id="{6911B456-C345-4774-B56F-D1BB9D13775E}"/>
+                <a16:creationId xmlns:a16="http://schemas.microsoft.com/office/drawing/2014/main" id="{73207E84-C720-4233-A057-6144CA82502B}"/>
               </a:ext>
             </a:extLst>
           </p:cNvPr>
@@ -9227,7 +9227,7 @@
           <p:cNvPr id="3" name="">
             <a:extLst xmlns:a="http://schemas.openxmlformats.org/drawingml/2006/main">
               <a:ext uri="{FF2B5EF4-FFF2-40B4-BE49-F238E27FC236}">
-                <a16:creationId xmlns:a16="http://schemas.microsoft.com/office/drawing/2014/main" id="{9CF8CFC1-FF4C-4B68-B418-65536A4A5D6C}"/>
+                <a16:creationId xmlns:a16="http://schemas.microsoft.com/office/drawing/2014/main" id="{5E332B07-AA1C-4856-B593-3F9ADEEFA00F}"/>
               </a:ext>
             </a:extLst>
           </p:cNvPr>
@@ -9264,7 +9264,7 @@
           <p:cNvPr id="4" name="">
             <a:extLst xmlns:a="http://schemas.openxmlformats.org/drawingml/2006/main">
               <a:ext uri="{FF2B5EF4-FFF2-40B4-BE49-F238E27FC236}">
-                <a16:creationId xmlns:a16="http://schemas.microsoft.com/office/drawing/2014/main" id="{29103135-DADA-4DD4-B0B9-3AEDCC573083}"/>
+                <a16:creationId xmlns:a16="http://schemas.microsoft.com/office/drawing/2014/main" id="{56756EE1-88E5-4915-9DDF-509425C5505B}"/>
               </a:ext>
             </a:extLst>
           </p:cNvPr>
@@ -9328,7 +9328,7 @@
           <p:cNvPr id="5" name="">
             <a:extLst xmlns:a="http://schemas.openxmlformats.org/drawingml/2006/main">
               <a:ext uri="{FF2B5EF4-FFF2-40B4-BE49-F238E27FC236}">
-                <a16:creationId xmlns:a16="http://schemas.microsoft.com/office/drawing/2014/main" id="{27D621BB-9FBD-4345-98E5-423FD6A3694C}"/>
+                <a16:creationId xmlns:a16="http://schemas.microsoft.com/office/drawing/2014/main" id="{1D6F89AD-FF97-4D07-BBF9-E12E3B5ACC56}"/>
               </a:ext>
             </a:extLst>
           </p:cNvPr>
@@ -9392,7 +9392,7 @@
           <p:cNvPr id="6" name="">
             <a:extLst xmlns:a="http://schemas.openxmlformats.org/drawingml/2006/main">
               <a:ext uri="{FF2B5EF4-FFF2-40B4-BE49-F238E27FC236}">
-                <a16:creationId xmlns:a16="http://schemas.microsoft.com/office/drawing/2014/main" id="{21F996A2-9B20-4C68-92A4-F927E29D1454}"/>
+                <a16:creationId xmlns:a16="http://schemas.microsoft.com/office/drawing/2014/main" id="{8CBC6681-D792-40C2-AD4F-CE06924A4F05}"/>
               </a:ext>
             </a:extLst>
           </p:cNvPr>
@@ -9456,7 +9456,7 @@
           <p:cNvPr id="7" name="">
             <a:extLst xmlns:a="http://schemas.openxmlformats.org/drawingml/2006/main">
               <a:ext uri="{FF2B5EF4-FFF2-40B4-BE49-F238E27FC236}">
-                <a16:creationId xmlns:a16="http://schemas.microsoft.com/office/drawing/2014/main" id="{E080A98C-7BF4-4AE6-9D36-C70F9ED49FC7}"/>
+                <a16:creationId xmlns:a16="http://schemas.microsoft.com/office/drawing/2014/main" id="{E7A1409B-9B98-468D-8942-F01875CD74E3}"/>
               </a:ext>
             </a:extLst>
           </p:cNvPr>
@@ -9491,7 +9491,7 @@
           <p:cNvPr id="8" name="">
             <a:extLst xmlns:a="http://schemas.openxmlformats.org/drawingml/2006/main">
               <a:ext uri="{FF2B5EF4-FFF2-40B4-BE49-F238E27FC236}">
-                <a16:creationId xmlns:a16="http://schemas.microsoft.com/office/drawing/2014/main" id="{ABE1E036-27EA-4D8C-A0DA-F8FB61ACDFE1}"/>
+                <a16:creationId xmlns:a16="http://schemas.microsoft.com/office/drawing/2014/main" id="{40525231-8F13-4E2A-976D-DB4C707A037A}"/>
               </a:ext>
             </a:extLst>
           </p:cNvPr>
@@ -9555,7 +9555,7 @@
           <p:cNvPr id="9" name="">
             <a:extLst xmlns:a="http://schemas.openxmlformats.org/drawingml/2006/main">
               <a:ext uri="{FF2B5EF4-FFF2-40B4-BE49-F238E27FC236}">
-                <a16:creationId xmlns:a16="http://schemas.microsoft.com/office/drawing/2014/main" id="{F594526F-2DD2-4F86-809E-9798DD4E9645}"/>
+                <a16:creationId xmlns:a16="http://schemas.microsoft.com/office/drawing/2014/main" id="{BEBC22C6-6749-4108-B184-E76FF16C92C4}"/>
               </a:ext>
             </a:extLst>
           </p:cNvPr>
@@ -9619,7 +9619,7 @@
           <p:cNvPr id="10" name="">
             <a:extLst xmlns:a="http://schemas.openxmlformats.org/drawingml/2006/main">
               <a:ext uri="{FF2B5EF4-FFF2-40B4-BE49-F238E27FC236}">
-                <a16:creationId xmlns:a16="http://schemas.microsoft.com/office/drawing/2014/main" id="{D7142A1C-A7F6-4804-9D0A-4D2FAF3D8DCB}"/>
+                <a16:creationId xmlns:a16="http://schemas.microsoft.com/office/drawing/2014/main" id="{44D7C20E-756C-48C6-BAA3-CF474AD22C69}"/>
               </a:ext>
             </a:extLst>
           </p:cNvPr>
@@ -9652,7 +9652,7 @@
           <p:cNvPr id="11" name="">
             <a:extLst xmlns:a="http://schemas.openxmlformats.org/drawingml/2006/main">
               <a:ext uri="{FF2B5EF4-FFF2-40B4-BE49-F238E27FC236}">
-                <a16:creationId xmlns:a16="http://schemas.microsoft.com/office/drawing/2014/main" id="{1D5C8847-0B9F-43DE-ABF4-ACC5D47B4F15}"/>
+                <a16:creationId xmlns:a16="http://schemas.microsoft.com/office/drawing/2014/main" id="{CDA43F48-AE8D-46D1-B692-2080FD892FE2}"/>
               </a:ext>
             </a:extLst>
           </p:cNvPr>
@@ -9687,7 +9687,7 @@
           <p:cNvPr id="12" name="">
             <a:extLst xmlns:a="http://schemas.openxmlformats.org/drawingml/2006/main">
               <a:ext uri="{FF2B5EF4-FFF2-40B4-BE49-F238E27FC236}">
-                <a16:creationId xmlns:a16="http://schemas.microsoft.com/office/drawing/2014/main" id="{AC154572-35C9-4650-AD49-4123C07BDAB5}"/>
+                <a16:creationId xmlns:a16="http://schemas.microsoft.com/office/drawing/2014/main" id="{C23174F6-E7C6-4E53-813C-F7E37298C42F}"/>
               </a:ext>
             </a:extLst>
           </p:cNvPr>
@@ -9751,7 +9751,7 @@
           <p:cNvPr id="13" name="">
             <a:extLst xmlns:a="http://schemas.openxmlformats.org/drawingml/2006/main">
               <a:ext uri="{FF2B5EF4-FFF2-40B4-BE49-F238E27FC236}">
-                <a16:creationId xmlns:a16="http://schemas.microsoft.com/office/drawing/2014/main" id="{DDE96119-F16A-4CF1-8298-3A5644BC5C50}"/>
+                <a16:creationId xmlns:a16="http://schemas.microsoft.com/office/drawing/2014/main" id="{B8F6AEA8-46CD-4E39-A3DC-1856928A4AFC}"/>
               </a:ext>
             </a:extLst>
           </p:cNvPr>
@@ -9815,7 +9815,7 @@
           <p:cNvPr id="14" name="">
             <a:extLst xmlns:a="http://schemas.openxmlformats.org/drawingml/2006/main">
               <a:ext uri="{FF2B5EF4-FFF2-40B4-BE49-F238E27FC236}">
-                <a16:creationId xmlns:a16="http://schemas.microsoft.com/office/drawing/2014/main" id="{19E08D87-73BE-46D1-87FA-D8DA43AD1349}"/>
+                <a16:creationId xmlns:a16="http://schemas.microsoft.com/office/drawing/2014/main" id="{B147C9CE-6801-4A19-BE57-6FA8EC762703}"/>
               </a:ext>
             </a:extLst>
           </p:cNvPr>
@@ -9848,7 +9848,7 @@
           <p:cNvPr id="15" name="">
             <a:extLst xmlns:a="http://schemas.openxmlformats.org/drawingml/2006/main">
               <a:ext uri="{FF2B5EF4-FFF2-40B4-BE49-F238E27FC236}">
-                <a16:creationId xmlns:a16="http://schemas.microsoft.com/office/drawing/2014/main" id="{82A12603-00A4-4817-A0DA-1ED86933B763}"/>
+                <a16:creationId xmlns:a16="http://schemas.microsoft.com/office/drawing/2014/main" id="{AE35B031-6BE5-497B-8794-99A09039B03E}"/>
               </a:ext>
             </a:extLst>
           </p:cNvPr>
@@ -9883,7 +9883,7 @@
           <p:cNvPr id="16" name="">
             <a:extLst xmlns:a="http://schemas.openxmlformats.org/drawingml/2006/main">
               <a:ext uri="{FF2B5EF4-FFF2-40B4-BE49-F238E27FC236}">
-                <a16:creationId xmlns:a16="http://schemas.microsoft.com/office/drawing/2014/main" id="{55FD0933-2695-4E8D-8FB8-33A58106A916}"/>
+                <a16:creationId xmlns:a16="http://schemas.microsoft.com/office/drawing/2014/main" id="{7CC3CC2F-DF22-4C2E-9B65-3CA49382DE69}"/>
               </a:ext>
             </a:extLst>
           </p:cNvPr>
@@ -9947,7 +9947,7 @@
           <p:cNvPr id="17" name="">
             <a:extLst xmlns:a="http://schemas.openxmlformats.org/drawingml/2006/main">
               <a:ext uri="{FF2B5EF4-FFF2-40B4-BE49-F238E27FC236}">
-                <a16:creationId xmlns:a16="http://schemas.microsoft.com/office/drawing/2014/main" id="{29BC2D28-5D19-4C01-BAFF-A7A9227BA691}"/>
+                <a16:creationId xmlns:a16="http://schemas.microsoft.com/office/drawing/2014/main" id="{9EECC082-A760-4D0F-9051-6124B0F7894C}"/>
               </a:ext>
             </a:extLst>
           </p:cNvPr>
@@ -10011,7 +10011,7 @@
           <p:cNvPr id="18" name="">
             <a:extLst xmlns:a="http://schemas.openxmlformats.org/drawingml/2006/main">
               <a:ext uri="{FF2B5EF4-FFF2-40B4-BE49-F238E27FC236}">
-                <a16:creationId xmlns:a16="http://schemas.microsoft.com/office/drawing/2014/main" id="{C081EF2F-E088-43AD-9336-A78063F42674}"/>
+                <a16:creationId xmlns:a16="http://schemas.microsoft.com/office/drawing/2014/main" id="{28DB01DB-AE2C-414B-A1C9-341948B793AF}"/>
               </a:ext>
             </a:extLst>
           </p:cNvPr>
@@ -10044,7 +10044,7 @@
           <p:cNvPr id="19" name="">
             <a:extLst xmlns:a="http://schemas.openxmlformats.org/drawingml/2006/main">
               <a:ext uri="{FF2B5EF4-FFF2-40B4-BE49-F238E27FC236}">
-                <a16:creationId xmlns:a16="http://schemas.microsoft.com/office/drawing/2014/main" id="{60F0E619-6009-48C0-893E-57045E37DD1F}"/>
+                <a16:creationId xmlns:a16="http://schemas.microsoft.com/office/drawing/2014/main" id="{96083053-5338-47AB-AB10-9295D73EC4A9}"/>
               </a:ext>
             </a:extLst>
           </p:cNvPr>
@@ -10079,7 +10079,7 @@
           <p:cNvPr id="20" name="">
             <a:extLst xmlns:a="http://schemas.openxmlformats.org/drawingml/2006/main">
               <a:ext uri="{FF2B5EF4-FFF2-40B4-BE49-F238E27FC236}">
-                <a16:creationId xmlns:a16="http://schemas.microsoft.com/office/drawing/2014/main" id="{11F72C5D-BA90-4223-B0A7-E1164B6D4711}"/>
+                <a16:creationId xmlns:a16="http://schemas.microsoft.com/office/drawing/2014/main" id="{A5BFD60B-9476-4495-98A7-64DCF9303533}"/>
               </a:ext>
             </a:extLst>
           </p:cNvPr>
@@ -10143,7 +10143,7 @@
           <p:cNvPr id="21" name="">
             <a:extLst xmlns:a="http://schemas.openxmlformats.org/drawingml/2006/main">
               <a:ext uri="{FF2B5EF4-FFF2-40B4-BE49-F238E27FC236}">
-                <a16:creationId xmlns:a16="http://schemas.microsoft.com/office/drawing/2014/main" id="{2846EE3A-2D11-4DB2-9C37-3152BF3BD511}"/>
+                <a16:creationId xmlns:a16="http://schemas.microsoft.com/office/drawing/2014/main" id="{57FB3FFF-0C6D-4555-B0F4-39B51818BB48}"/>
               </a:ext>
             </a:extLst>
           </p:cNvPr>
@@ -10207,7 +10207,7 @@
           <p:cNvPr id="22" name="">
             <a:extLst xmlns:a="http://schemas.openxmlformats.org/drawingml/2006/main">
               <a:ext uri="{FF2B5EF4-FFF2-40B4-BE49-F238E27FC236}">
-                <a16:creationId xmlns:a16="http://schemas.microsoft.com/office/drawing/2014/main" id="{ED453CCB-A734-497C-833F-C564E34E6D6E}"/>
+                <a16:creationId xmlns:a16="http://schemas.microsoft.com/office/drawing/2014/main" id="{DE93C1F5-F4A4-4B91-9DEC-4A8A5EE42F52}"/>
               </a:ext>
             </a:extLst>
           </p:cNvPr>
@@ -10271,7 +10271,7 @@
           <p:cNvPr id="23" name="">
             <a:extLst xmlns:a="http://schemas.openxmlformats.org/drawingml/2006/main">
               <a:ext uri="{FF2B5EF4-FFF2-40B4-BE49-F238E27FC236}">
-                <a16:creationId xmlns:a16="http://schemas.microsoft.com/office/drawing/2014/main" id="{C849E381-5950-468A-8C3D-90936CFC3319}"/>
+                <a16:creationId xmlns:a16="http://schemas.microsoft.com/office/drawing/2014/main" id="{19A17028-10A6-4FC1-97AD-6E94BC9C586A}"/>
               </a:ext>
             </a:extLst>
           </p:cNvPr>
@@ -10335,7 +10335,7 @@
           <p:cNvPr id="24" name="">
             <a:extLst xmlns:a="http://schemas.openxmlformats.org/drawingml/2006/main">
               <a:ext uri="{FF2B5EF4-FFF2-40B4-BE49-F238E27FC236}">
-                <a16:creationId xmlns:a16="http://schemas.microsoft.com/office/drawing/2014/main" id="{D8813098-7C68-48D4-9077-C741887862A1}"/>
+                <a16:creationId xmlns:a16="http://schemas.microsoft.com/office/drawing/2014/main" id="{EA84BD61-0908-4254-92EF-C361DF4D8175}"/>
               </a:ext>
             </a:extLst>
           </p:cNvPr>
@@ -10368,7 +10368,7 @@
           <p:cNvPr id="25" name="">
             <a:extLst xmlns:a="http://schemas.openxmlformats.org/drawingml/2006/main">
               <a:ext uri="{FF2B5EF4-FFF2-40B4-BE49-F238E27FC236}">
-                <a16:creationId xmlns:a16="http://schemas.microsoft.com/office/drawing/2014/main" id="{B730891D-CBD8-4081-AFF7-D8807F4528C8}"/>
+                <a16:creationId xmlns:a16="http://schemas.microsoft.com/office/drawing/2014/main" id="{54BE6AE7-839A-455E-B8A5-80073BCDC1EE}"/>
               </a:ext>
             </a:extLst>
           </p:cNvPr>
@@ -10432,7 +10432,7 @@
           <p:cNvPr id="26" name="">
             <a:extLst xmlns:a="http://schemas.openxmlformats.org/drawingml/2006/main">
               <a:ext uri="{FF2B5EF4-FFF2-40B4-BE49-F238E27FC236}">
-                <a16:creationId xmlns:a16="http://schemas.microsoft.com/office/drawing/2014/main" id="{96D44B53-9075-460B-B75C-F0CACCEA881A}"/>
+                <a16:creationId xmlns:a16="http://schemas.microsoft.com/office/drawing/2014/main" id="{BDCA33B3-A2E4-48D6-B19D-8DA62648D02C}"/>
               </a:ext>
             </a:extLst>
           </p:cNvPr>
@@ -10494,7 +10494,7 @@
     </p:spTree>
     <p:extLst>
       <p:ext uri="{BB962C8B-B14F-4D97-AF65-F5344CB8AC3E}">
-        <p14:creationId xmlns:p14="http://schemas.microsoft.com/office/powerpoint/2010/main" val="1064008699"/>
+        <p14:creationId xmlns:p14="http://schemas.microsoft.com/office/powerpoint/2010/main" val="954342033"/>
       </p:ext>
     </p:extLst>
   </p:cSld>
@@ -10522,7 +10522,7 @@
           <p:nvPr/>
         </p:nvPicPr>
         <p:blipFill>
-          <a:blip xmlns:r="http://schemas.openxmlformats.org/officeDocument/2006/relationships" xmlns:a="http://schemas.openxmlformats.org/drawingml/2006/main" r:embed="Rcbe0aa9acfb64ad3"/>
+          <a:blip xmlns:r="http://schemas.openxmlformats.org/officeDocument/2006/relationships" xmlns:a="http://schemas.openxmlformats.org/drawingml/2006/main" r:embed="Rd43bf31a521c405c"/>
           <a:srcRect xmlns:a="http://schemas.openxmlformats.org/drawingml/2006/main" l="0" t="7813" r="0" b="7813"/>
           <a:stretch xmlns:a="http://schemas.openxmlformats.org/drawingml/2006/main">
             <a:fillRect l="0" t="0" r="0" b="0"/>
@@ -10543,7 +10543,7 @@
           <p:cNvPr id="2" name="">
             <a:extLst xmlns:a="http://schemas.openxmlformats.org/drawingml/2006/main">
               <a:ext uri="{FF2B5EF4-FFF2-40B4-BE49-F238E27FC236}">
-                <a16:creationId xmlns:a16="http://schemas.microsoft.com/office/drawing/2014/main" id="{B601BE71-8571-4272-A446-A990185890FB}"/>
+                <a16:creationId xmlns:a16="http://schemas.microsoft.com/office/drawing/2014/main" id="{36CA018E-80AF-4FCC-AC7E-3BE5005607B9}"/>
               </a:ext>
             </a:extLst>
           </p:cNvPr>
@@ -10580,7 +10580,7 @@
           <p:cNvPr id="3" name="">
             <a:extLst xmlns:a="http://schemas.openxmlformats.org/drawingml/2006/main">
               <a:ext uri="{FF2B5EF4-FFF2-40B4-BE49-F238E27FC236}">
-                <a16:creationId xmlns:a16="http://schemas.microsoft.com/office/drawing/2014/main" id="{C9AA3B20-8ED8-4160-BF65-68E9D457F335}"/>
+                <a16:creationId xmlns:a16="http://schemas.microsoft.com/office/drawing/2014/main" id="{3E77C1E6-BF25-437C-86A1-BCC9112CA7D6}"/>
               </a:ext>
             </a:extLst>
           </p:cNvPr>
@@ -10617,7 +10617,7 @@
           <p:cNvPr id="4" name="">
             <a:extLst xmlns:a="http://schemas.openxmlformats.org/drawingml/2006/main">
               <a:ext uri="{FF2B5EF4-FFF2-40B4-BE49-F238E27FC236}">
-                <a16:creationId xmlns:a16="http://schemas.microsoft.com/office/drawing/2014/main" id="{B7875E7B-1369-405C-8157-31BA803AC1E8}"/>
+                <a16:creationId xmlns:a16="http://schemas.microsoft.com/office/drawing/2014/main" id="{F98E735A-F756-4D7D-A23E-D7687D5062BC}"/>
               </a:ext>
             </a:extLst>
           </p:cNvPr>
@@ -10681,7 +10681,7 @@
           <p:cNvPr id="5" name="">
             <a:extLst xmlns:a="http://schemas.openxmlformats.org/drawingml/2006/main">
               <a:ext uri="{FF2B5EF4-FFF2-40B4-BE49-F238E27FC236}">
-                <a16:creationId xmlns:a16="http://schemas.microsoft.com/office/drawing/2014/main" id="{9BEC3186-EF50-4668-86E0-274EC586F557}"/>
+                <a16:creationId xmlns:a16="http://schemas.microsoft.com/office/drawing/2014/main" id="{DA8118E5-00CA-4F87-8963-D6755D0C7A28}"/>
               </a:ext>
             </a:extLst>
           </p:cNvPr>
@@ -10745,7 +10745,7 @@
           <p:cNvPr id="6" name="">
             <a:extLst xmlns:a="http://schemas.openxmlformats.org/drawingml/2006/main">
               <a:ext uri="{FF2B5EF4-FFF2-40B4-BE49-F238E27FC236}">
-                <a16:creationId xmlns:a16="http://schemas.microsoft.com/office/drawing/2014/main" id="{A5538910-43E4-4D7C-8100-8FDB5CFB0EA2}"/>
+                <a16:creationId xmlns:a16="http://schemas.microsoft.com/office/drawing/2014/main" id="{1535A882-8068-4748-9254-7019FB5EDF32}"/>
               </a:ext>
             </a:extLst>
           </p:cNvPr>
@@ -10809,7 +10809,7 @@
           <p:cNvPr id="7" name="">
             <a:extLst xmlns:a="http://schemas.openxmlformats.org/drawingml/2006/main">
               <a:ext uri="{FF2B5EF4-FFF2-40B4-BE49-F238E27FC236}">
-                <a16:creationId xmlns:a16="http://schemas.microsoft.com/office/drawing/2014/main" id="{2892CE69-F746-49CB-A9EE-98A646B27091}"/>
+                <a16:creationId xmlns:a16="http://schemas.microsoft.com/office/drawing/2014/main" id="{46616C03-9E8D-4FEE-AED3-E92BFBA7082C}"/>
               </a:ext>
             </a:extLst>
           </p:cNvPr>
@@ -10844,7 +10844,7 @@
           <p:cNvPr id="8" name="">
             <a:extLst xmlns:a="http://schemas.openxmlformats.org/drawingml/2006/main">
               <a:ext uri="{FF2B5EF4-FFF2-40B4-BE49-F238E27FC236}">
-                <a16:creationId xmlns:a16="http://schemas.microsoft.com/office/drawing/2014/main" id="{1965B7B5-CC71-4356-A187-393915F526CE}"/>
+                <a16:creationId xmlns:a16="http://schemas.microsoft.com/office/drawing/2014/main" id="{224610CA-405C-4F3E-BC7D-6F656B46CDFB}"/>
               </a:ext>
             </a:extLst>
           </p:cNvPr>
@@ -10908,7 +10908,7 @@
           <p:cNvPr id="9" name="">
             <a:extLst xmlns:a="http://schemas.openxmlformats.org/drawingml/2006/main">
               <a:ext uri="{FF2B5EF4-FFF2-40B4-BE49-F238E27FC236}">
-                <a16:creationId xmlns:a16="http://schemas.microsoft.com/office/drawing/2014/main" id="{70C8DBF3-927A-4B75-A341-28ACE9664D3B}"/>
+                <a16:creationId xmlns:a16="http://schemas.microsoft.com/office/drawing/2014/main" id="{E81B02F2-65D8-46A9-8157-D20B4574E808}"/>
               </a:ext>
             </a:extLst>
           </p:cNvPr>
@@ -10943,7 +10943,7 @@
           <p:cNvPr id="10" name="">
             <a:extLst xmlns:a="http://schemas.openxmlformats.org/drawingml/2006/main">
               <a:ext uri="{FF2B5EF4-FFF2-40B4-BE49-F238E27FC236}">
-                <a16:creationId xmlns:a16="http://schemas.microsoft.com/office/drawing/2014/main" id="{AD9EE698-6D3F-4FEB-B044-3CE2F3BF051D}"/>
+                <a16:creationId xmlns:a16="http://schemas.microsoft.com/office/drawing/2014/main" id="{A41F6DF0-D2BB-4062-BE7C-D46423E4C581}"/>
               </a:ext>
             </a:extLst>
           </p:cNvPr>
@@ -11007,7 +11007,7 @@
           <p:cNvPr id="11" name="">
             <a:extLst xmlns:a="http://schemas.openxmlformats.org/drawingml/2006/main">
               <a:ext uri="{FF2B5EF4-FFF2-40B4-BE49-F238E27FC236}">
-                <a16:creationId xmlns:a16="http://schemas.microsoft.com/office/drawing/2014/main" id="{6B22DD1D-1872-474E-9587-1177FA7EB2CB}"/>
+                <a16:creationId xmlns:a16="http://schemas.microsoft.com/office/drawing/2014/main" id="{80E572F8-6AEC-4863-B68A-1B88EAF13DF8}"/>
               </a:ext>
             </a:extLst>
           </p:cNvPr>
@@ -11042,7 +11042,7 @@
           <p:cNvPr id="12" name="">
             <a:extLst xmlns:a="http://schemas.openxmlformats.org/drawingml/2006/main">
               <a:ext uri="{FF2B5EF4-FFF2-40B4-BE49-F238E27FC236}">
-                <a16:creationId xmlns:a16="http://schemas.microsoft.com/office/drawing/2014/main" id="{865FEAF4-AC28-49A0-99F4-1D9C2A862273}"/>
+                <a16:creationId xmlns:a16="http://schemas.microsoft.com/office/drawing/2014/main" id="{E6E44602-0CCB-49CA-8424-1C9CD0905D57}"/>
               </a:ext>
             </a:extLst>
           </p:cNvPr>
@@ -11106,7 +11106,7 @@
           <p:cNvPr id="13" name="">
             <a:extLst xmlns:a="http://schemas.openxmlformats.org/drawingml/2006/main">
               <a:ext uri="{FF2B5EF4-FFF2-40B4-BE49-F238E27FC236}">
-                <a16:creationId xmlns:a16="http://schemas.microsoft.com/office/drawing/2014/main" id="{6F71CD91-00C2-4B33-8612-8D25AC310E26}"/>
+                <a16:creationId xmlns:a16="http://schemas.microsoft.com/office/drawing/2014/main" id="{0028340D-B005-45ED-9BB4-F2E740A71493}"/>
               </a:ext>
             </a:extLst>
           </p:cNvPr>
@@ -11141,7 +11141,7 @@
           <p:cNvPr id="14" name="">
             <a:extLst xmlns:a="http://schemas.openxmlformats.org/drawingml/2006/main">
               <a:ext uri="{FF2B5EF4-FFF2-40B4-BE49-F238E27FC236}">
-                <a16:creationId xmlns:a16="http://schemas.microsoft.com/office/drawing/2014/main" id="{8B14DD45-3E3A-4B3B-80B7-58BE2277205D}"/>
+                <a16:creationId xmlns:a16="http://schemas.microsoft.com/office/drawing/2014/main" id="{B4F4729A-29CF-48AF-BA1B-DEEDE38A0B74}"/>
               </a:ext>
             </a:extLst>
           </p:cNvPr>
@@ -11205,7 +11205,7 @@
           <p:cNvPr id="15" name="">
             <a:extLst xmlns:a="http://schemas.openxmlformats.org/drawingml/2006/main">
               <a:ext uri="{FF2B5EF4-FFF2-40B4-BE49-F238E27FC236}">
-                <a16:creationId xmlns:a16="http://schemas.microsoft.com/office/drawing/2014/main" id="{011560D4-A8BC-4F0C-944E-851D5BC8DDE9}"/>
+                <a16:creationId xmlns:a16="http://schemas.microsoft.com/office/drawing/2014/main" id="{13BDA8EF-CD45-4AB1-8A0C-7DD3E7D09C96}"/>
               </a:ext>
             </a:extLst>
           </p:cNvPr>
@@ -11240,7 +11240,7 @@
           <p:cNvPr id="16" name="">
             <a:extLst xmlns:a="http://schemas.openxmlformats.org/drawingml/2006/main">
               <a:ext uri="{FF2B5EF4-FFF2-40B4-BE49-F238E27FC236}">
-                <a16:creationId xmlns:a16="http://schemas.microsoft.com/office/drawing/2014/main" id="{86B4B6C3-8450-49C0-BAEB-2D0082CE1C91}"/>
+                <a16:creationId xmlns:a16="http://schemas.microsoft.com/office/drawing/2014/main" id="{895F607F-4EF6-478E-96ED-0E209D696780}"/>
               </a:ext>
             </a:extLst>
           </p:cNvPr>
@@ -11304,7 +11304,7 @@
           <p:cNvPr id="17" name="">
             <a:extLst xmlns:a="http://schemas.openxmlformats.org/drawingml/2006/main">
               <a:ext uri="{FF2B5EF4-FFF2-40B4-BE49-F238E27FC236}">
-                <a16:creationId xmlns:a16="http://schemas.microsoft.com/office/drawing/2014/main" id="{24C1ACDC-2CDC-4A20-949A-8F0EA42AD1FA}"/>
+                <a16:creationId xmlns:a16="http://schemas.microsoft.com/office/drawing/2014/main" id="{42BDC7FD-2EC5-4911-95E3-840FEDC1772B}"/>
               </a:ext>
             </a:extLst>
           </p:cNvPr>
@@ -11339,7 +11339,7 @@
           <p:cNvPr id="18" name="">
             <a:extLst xmlns:a="http://schemas.openxmlformats.org/drawingml/2006/main">
               <a:ext uri="{FF2B5EF4-FFF2-40B4-BE49-F238E27FC236}">
-                <a16:creationId xmlns:a16="http://schemas.microsoft.com/office/drawing/2014/main" id="{CB38D27A-AA9C-4C6A-A1CB-0ACFD3FC2EC2}"/>
+                <a16:creationId xmlns:a16="http://schemas.microsoft.com/office/drawing/2014/main" id="{77CD25E3-E732-4308-A9BC-DC3AAF4C3680}"/>
               </a:ext>
             </a:extLst>
           </p:cNvPr>
@@ -11403,7 +11403,7 @@
           <p:cNvPr id="19" name="">
             <a:extLst xmlns:a="http://schemas.openxmlformats.org/drawingml/2006/main">
               <a:ext uri="{FF2B5EF4-FFF2-40B4-BE49-F238E27FC236}">
-                <a16:creationId xmlns:a16="http://schemas.microsoft.com/office/drawing/2014/main" id="{05404DD8-5A2C-409F-99FE-7B0517D267C1}"/>
+                <a16:creationId xmlns:a16="http://schemas.microsoft.com/office/drawing/2014/main" id="{A891B1B9-D9F3-4F91-BFE1-5361FE6EE424}"/>
               </a:ext>
             </a:extLst>
           </p:cNvPr>
@@ -11467,7 +11467,7 @@
           <p:cNvPr id="20" name="">
             <a:extLst xmlns:a="http://schemas.openxmlformats.org/drawingml/2006/main">
               <a:ext uri="{FF2B5EF4-FFF2-40B4-BE49-F238E27FC236}">
-                <a16:creationId xmlns:a16="http://schemas.microsoft.com/office/drawing/2014/main" id="{D52080B7-3D45-4704-A282-AC0CD842C296}"/>
+                <a16:creationId xmlns:a16="http://schemas.microsoft.com/office/drawing/2014/main" id="{3CBB1D89-0040-4E11-8EBE-BC75D54A06FA}"/>
               </a:ext>
             </a:extLst>
           </p:cNvPr>
@@ -11500,7 +11500,7 @@
           <p:cNvPr id="21" name="">
             <a:extLst xmlns:a="http://schemas.openxmlformats.org/drawingml/2006/main">
               <a:ext uri="{FF2B5EF4-FFF2-40B4-BE49-F238E27FC236}">
-                <a16:creationId xmlns:a16="http://schemas.microsoft.com/office/drawing/2014/main" id="{ED977039-7582-46BF-8E70-F716DEF8C525}"/>
+                <a16:creationId xmlns:a16="http://schemas.microsoft.com/office/drawing/2014/main" id="{A1B8CD46-4D11-45C9-848D-340B01931A2C}"/>
               </a:ext>
             </a:extLst>
           </p:cNvPr>
@@ -11564,7 +11564,7 @@
           <p:cNvPr id="22" name="">
             <a:extLst xmlns:a="http://schemas.openxmlformats.org/drawingml/2006/main">
               <a:ext uri="{FF2B5EF4-FFF2-40B4-BE49-F238E27FC236}">
-                <a16:creationId xmlns:a16="http://schemas.microsoft.com/office/drawing/2014/main" id="{214595A0-35F8-4ED9-A9FF-CF3D0C9514EA}"/>
+                <a16:creationId xmlns:a16="http://schemas.microsoft.com/office/drawing/2014/main" id="{1A534A17-BCC6-43A0-B772-E4284131F408}"/>
               </a:ext>
             </a:extLst>
           </p:cNvPr>
@@ -11626,7 +11626,7 @@
     </p:spTree>
     <p:extLst>
       <p:ext uri="{BB962C8B-B14F-4D97-AF65-F5344CB8AC3E}">
-        <p14:creationId xmlns:p14="http://schemas.microsoft.com/office/powerpoint/2010/main" val="140338930"/>
+        <p14:creationId xmlns:p14="http://schemas.microsoft.com/office/powerpoint/2010/main" val="888790875"/>
       </p:ext>
     </p:extLst>
   </p:cSld>
@@ -11654,7 +11654,7 @@
           <p:nvPr/>
         </p:nvPicPr>
         <p:blipFill>
-          <a:blip xmlns:r="http://schemas.openxmlformats.org/officeDocument/2006/relationships" xmlns:a="http://schemas.openxmlformats.org/drawingml/2006/main" r:embed="R0d866b4c22a540d6"/>
+          <a:blip xmlns:r="http://schemas.openxmlformats.org/officeDocument/2006/relationships" xmlns:a="http://schemas.openxmlformats.org/drawingml/2006/main" r:embed="Rd75ecfa8b18f473d"/>
           <a:srcRect xmlns:a="http://schemas.openxmlformats.org/drawingml/2006/main" l="0" t="27" r="0" b="27"/>
           <a:stretch xmlns:a="http://schemas.openxmlformats.org/drawingml/2006/main">
             <a:fillRect l="0" t="0" r="0" b="0"/>
@@ -11675,7 +11675,7 @@
           <p:cNvPr id="2" name="">
             <a:extLst xmlns:a="http://schemas.openxmlformats.org/drawingml/2006/main">
               <a:ext uri="{FF2B5EF4-FFF2-40B4-BE49-F238E27FC236}">
-                <a16:creationId xmlns:a16="http://schemas.microsoft.com/office/drawing/2014/main" id="{A2B69A38-AE44-4EE7-867A-165B4E50DA88}"/>
+                <a16:creationId xmlns:a16="http://schemas.microsoft.com/office/drawing/2014/main" id="{41BF1439-6DE3-4B0B-B368-7CCBFEA84E82}"/>
               </a:ext>
             </a:extLst>
           </p:cNvPr>
@@ -11712,7 +11712,7 @@
           <p:cNvPr id="3" name="">
             <a:extLst xmlns:a="http://schemas.openxmlformats.org/drawingml/2006/main">
               <a:ext uri="{FF2B5EF4-FFF2-40B4-BE49-F238E27FC236}">
-                <a16:creationId xmlns:a16="http://schemas.microsoft.com/office/drawing/2014/main" id="{4B4AB4D7-742D-4192-BA39-FB72D16C91F8}"/>
+                <a16:creationId xmlns:a16="http://schemas.microsoft.com/office/drawing/2014/main" id="{5E3E778D-0D89-41A3-BAAF-E9C4D56C9AC2}"/>
               </a:ext>
             </a:extLst>
           </p:cNvPr>
@@ -11749,7 +11749,7 @@
           <p:cNvPr id="4" name="">
             <a:extLst xmlns:a="http://schemas.openxmlformats.org/drawingml/2006/main">
               <a:ext uri="{FF2B5EF4-FFF2-40B4-BE49-F238E27FC236}">
-                <a16:creationId xmlns:a16="http://schemas.microsoft.com/office/drawing/2014/main" id="{398CB0E6-B1C3-4640-ADB9-313517F3B3B8}"/>
+                <a16:creationId xmlns:a16="http://schemas.microsoft.com/office/drawing/2014/main" id="{0F0DC5D9-FE7E-4338-BC54-716744FA589D}"/>
               </a:ext>
             </a:extLst>
           </p:cNvPr>
@@ -11813,7 +11813,7 @@
           <p:cNvPr id="5" name="">
             <a:extLst xmlns:a="http://schemas.openxmlformats.org/drawingml/2006/main">
               <a:ext uri="{FF2B5EF4-FFF2-40B4-BE49-F238E27FC236}">
-                <a16:creationId xmlns:a16="http://schemas.microsoft.com/office/drawing/2014/main" id="{2828129A-013D-4D6E-801E-319C5C8A6258}"/>
+                <a16:creationId xmlns:a16="http://schemas.microsoft.com/office/drawing/2014/main" id="{B0426C67-3044-45CC-90EB-87712FC2818C}"/>
               </a:ext>
             </a:extLst>
           </p:cNvPr>
@@ -11877,7 +11877,7 @@
           <p:cNvPr id="6" name="">
             <a:extLst xmlns:a="http://schemas.openxmlformats.org/drawingml/2006/main">
               <a:ext uri="{FF2B5EF4-FFF2-40B4-BE49-F238E27FC236}">
-                <a16:creationId xmlns:a16="http://schemas.microsoft.com/office/drawing/2014/main" id="{CF98C863-8E89-4885-AF78-18EF2CD1B0D1}"/>
+                <a16:creationId xmlns:a16="http://schemas.microsoft.com/office/drawing/2014/main" id="{5EF96272-4C92-45A8-B460-54DF9E32C5AB}"/>
               </a:ext>
             </a:extLst>
           </p:cNvPr>
@@ -11941,7 +11941,7 @@
           <p:cNvPr id="7" name="">
             <a:extLst xmlns:a="http://schemas.openxmlformats.org/drawingml/2006/main">
               <a:ext uri="{FF2B5EF4-FFF2-40B4-BE49-F238E27FC236}">
-                <a16:creationId xmlns:a16="http://schemas.microsoft.com/office/drawing/2014/main" id="{61CFAEE0-F4C1-43DB-ABEF-E0D2C1854E8C}"/>
+                <a16:creationId xmlns:a16="http://schemas.microsoft.com/office/drawing/2014/main" id="{2E015673-C58A-4C1F-A6D1-8D7A8BFD367A}"/>
               </a:ext>
             </a:extLst>
           </p:cNvPr>
@@ -11976,7 +11976,7 @@
           <p:cNvPr id="8" name="">
             <a:extLst xmlns:a="http://schemas.openxmlformats.org/drawingml/2006/main">
               <a:ext uri="{FF2B5EF4-FFF2-40B4-BE49-F238E27FC236}">
-                <a16:creationId xmlns:a16="http://schemas.microsoft.com/office/drawing/2014/main" id="{1BFB190A-EB4B-4E99-992E-6FC722C837F7}"/>
+                <a16:creationId xmlns:a16="http://schemas.microsoft.com/office/drawing/2014/main" id="{34B362B0-3832-42BA-A48E-CB029E042DDC}"/>
               </a:ext>
             </a:extLst>
           </p:cNvPr>
@@ -12040,7 +12040,7 @@
           <p:cNvPr id="9" name="">
             <a:extLst xmlns:a="http://schemas.openxmlformats.org/drawingml/2006/main">
               <a:ext uri="{FF2B5EF4-FFF2-40B4-BE49-F238E27FC236}">
-                <a16:creationId xmlns:a16="http://schemas.microsoft.com/office/drawing/2014/main" id="{71611CF4-055A-4467-A436-5B2C4D12B2C6}"/>
+                <a16:creationId xmlns:a16="http://schemas.microsoft.com/office/drawing/2014/main" id="{DA896306-E41A-4236-9BCF-BC49CF44C52B}"/>
               </a:ext>
             </a:extLst>
           </p:cNvPr>
@@ -12104,7 +12104,7 @@
           <p:cNvPr id="10" name="">
             <a:extLst xmlns:a="http://schemas.openxmlformats.org/drawingml/2006/main">
               <a:ext uri="{FF2B5EF4-FFF2-40B4-BE49-F238E27FC236}">
-                <a16:creationId xmlns:a16="http://schemas.microsoft.com/office/drawing/2014/main" id="{31F085B9-687E-4869-AF62-F20CD74AFF5D}"/>
+                <a16:creationId xmlns:a16="http://schemas.microsoft.com/office/drawing/2014/main" id="{38000B07-3010-423F-8EEF-167C9E15FA43}"/>
               </a:ext>
             </a:extLst>
           </p:cNvPr>
@@ -12137,7 +12137,7 @@
           <p:cNvPr id="11" name="">
             <a:extLst xmlns:a="http://schemas.openxmlformats.org/drawingml/2006/main">
               <a:ext uri="{FF2B5EF4-FFF2-40B4-BE49-F238E27FC236}">
-                <a16:creationId xmlns:a16="http://schemas.microsoft.com/office/drawing/2014/main" id="{E825A765-6F68-427F-A7B4-D5CF2599D8D6}"/>
+                <a16:creationId xmlns:a16="http://schemas.microsoft.com/office/drawing/2014/main" id="{CB0E3E40-371B-45A9-BA46-09A65F78C87B}"/>
               </a:ext>
             </a:extLst>
           </p:cNvPr>
@@ -12172,7 +12172,7 @@
           <p:cNvPr id="12" name="">
             <a:extLst xmlns:a="http://schemas.openxmlformats.org/drawingml/2006/main">
               <a:ext uri="{FF2B5EF4-FFF2-40B4-BE49-F238E27FC236}">
-                <a16:creationId xmlns:a16="http://schemas.microsoft.com/office/drawing/2014/main" id="{BABADFE3-96A8-44E2-83E2-3AE0640CC32B}"/>
+                <a16:creationId xmlns:a16="http://schemas.microsoft.com/office/drawing/2014/main" id="{F1C33950-1A6E-4CCB-ABFD-755E78447F72}"/>
               </a:ext>
             </a:extLst>
           </p:cNvPr>
@@ -12236,7 +12236,7 @@
           <p:cNvPr id="13" name="">
             <a:extLst xmlns:a="http://schemas.openxmlformats.org/drawingml/2006/main">
               <a:ext uri="{FF2B5EF4-FFF2-40B4-BE49-F238E27FC236}">
-                <a16:creationId xmlns:a16="http://schemas.microsoft.com/office/drawing/2014/main" id="{4CC4EE5C-143B-494B-9A05-137CCC98DD1B}"/>
+                <a16:creationId xmlns:a16="http://schemas.microsoft.com/office/drawing/2014/main" id="{2766EFE9-10D6-4FE6-BED1-B41D35B13C35}"/>
               </a:ext>
             </a:extLst>
           </p:cNvPr>
@@ -12300,7 +12300,7 @@
           <p:cNvPr id="14" name="">
             <a:extLst xmlns:a="http://schemas.openxmlformats.org/drawingml/2006/main">
               <a:ext uri="{FF2B5EF4-FFF2-40B4-BE49-F238E27FC236}">
-                <a16:creationId xmlns:a16="http://schemas.microsoft.com/office/drawing/2014/main" id="{9173603B-A801-4C4C-AA12-8AAA253A0442}"/>
+                <a16:creationId xmlns:a16="http://schemas.microsoft.com/office/drawing/2014/main" id="{EEAD62C1-7F97-4DA3-9FF3-914CE5387AF4}"/>
               </a:ext>
             </a:extLst>
           </p:cNvPr>
@@ -12333,7 +12333,7 @@
           <p:cNvPr id="15" name="">
             <a:extLst xmlns:a="http://schemas.openxmlformats.org/drawingml/2006/main">
               <a:ext uri="{FF2B5EF4-FFF2-40B4-BE49-F238E27FC236}">
-                <a16:creationId xmlns:a16="http://schemas.microsoft.com/office/drawing/2014/main" id="{D16B0E89-1C13-4896-BEBC-03CD2AE389BB}"/>
+                <a16:creationId xmlns:a16="http://schemas.microsoft.com/office/drawing/2014/main" id="{6BD27B86-64C7-4F6F-A16E-414F1F4F5EA0}"/>
               </a:ext>
             </a:extLst>
           </p:cNvPr>
@@ -12368,7 +12368,7 @@
           <p:cNvPr id="16" name="">
             <a:extLst xmlns:a="http://schemas.openxmlformats.org/drawingml/2006/main">
               <a:ext uri="{FF2B5EF4-FFF2-40B4-BE49-F238E27FC236}">
-                <a16:creationId xmlns:a16="http://schemas.microsoft.com/office/drawing/2014/main" id="{E9F5D226-C69A-4E5D-9727-D43AFB9B3BB8}"/>
+                <a16:creationId xmlns:a16="http://schemas.microsoft.com/office/drawing/2014/main" id="{0B5D0781-2DAC-48D2-9ED0-161AC266EEBB}"/>
               </a:ext>
             </a:extLst>
           </p:cNvPr>
@@ -12432,7 +12432,7 @@
           <p:cNvPr id="17" name="">
             <a:extLst xmlns:a="http://schemas.openxmlformats.org/drawingml/2006/main">
               <a:ext uri="{FF2B5EF4-FFF2-40B4-BE49-F238E27FC236}">
-                <a16:creationId xmlns:a16="http://schemas.microsoft.com/office/drawing/2014/main" id="{82F27AF9-73F7-4DA7-B1D4-42AAF1936E4D}"/>
+                <a16:creationId xmlns:a16="http://schemas.microsoft.com/office/drawing/2014/main" id="{EC45B2BF-6A79-4D95-B873-ED1539E0454E}"/>
               </a:ext>
             </a:extLst>
           </p:cNvPr>
@@ -12496,7 +12496,7 @@
           <p:cNvPr id="18" name="">
             <a:extLst xmlns:a="http://schemas.openxmlformats.org/drawingml/2006/main">
               <a:ext uri="{FF2B5EF4-FFF2-40B4-BE49-F238E27FC236}">
-                <a16:creationId xmlns:a16="http://schemas.microsoft.com/office/drawing/2014/main" id="{0880BE61-6DE6-4281-B52C-5184B3C552DC}"/>
+                <a16:creationId xmlns:a16="http://schemas.microsoft.com/office/drawing/2014/main" id="{2CAD6D17-C237-4998-A0DD-1C2D3B7F2E02}"/>
               </a:ext>
             </a:extLst>
           </p:cNvPr>
@@ -12529,7 +12529,7 @@
           <p:cNvPr id="19" name="">
             <a:extLst xmlns:a="http://schemas.openxmlformats.org/drawingml/2006/main">
               <a:ext uri="{FF2B5EF4-FFF2-40B4-BE49-F238E27FC236}">
-                <a16:creationId xmlns:a16="http://schemas.microsoft.com/office/drawing/2014/main" id="{D1E8B2C5-6589-4ADF-8FF0-E3CE91D6D339}"/>
+                <a16:creationId xmlns:a16="http://schemas.microsoft.com/office/drawing/2014/main" id="{A3BF9E2F-EB00-406C-A746-8B5383656B18}"/>
               </a:ext>
             </a:extLst>
           </p:cNvPr>
@@ -12564,7 +12564,7 @@
           <p:cNvPr id="20" name="">
             <a:extLst xmlns:a="http://schemas.openxmlformats.org/drawingml/2006/main">
               <a:ext uri="{FF2B5EF4-FFF2-40B4-BE49-F238E27FC236}">
-                <a16:creationId xmlns:a16="http://schemas.microsoft.com/office/drawing/2014/main" id="{DC792000-793F-4E2F-9AFD-7084F7FF0DB7}"/>
+                <a16:creationId xmlns:a16="http://schemas.microsoft.com/office/drawing/2014/main" id="{DA6CF7E6-24B4-4912-BD36-76B605338832}"/>
               </a:ext>
             </a:extLst>
           </p:cNvPr>
@@ -12628,7 +12628,7 @@
           <p:cNvPr id="21" name="">
             <a:extLst xmlns:a="http://schemas.openxmlformats.org/drawingml/2006/main">
               <a:ext uri="{FF2B5EF4-FFF2-40B4-BE49-F238E27FC236}">
-                <a16:creationId xmlns:a16="http://schemas.microsoft.com/office/drawing/2014/main" id="{6C52805E-5F6F-4567-BA29-29C1B3B37CF4}"/>
+                <a16:creationId xmlns:a16="http://schemas.microsoft.com/office/drawing/2014/main" id="{850CD501-5597-4824-8A10-C13F9721A388}"/>
               </a:ext>
             </a:extLst>
           </p:cNvPr>
@@ -12692,7 +12692,7 @@
           <p:cNvPr id="22" name="">
             <a:extLst xmlns:a="http://schemas.openxmlformats.org/drawingml/2006/main">
               <a:ext uri="{FF2B5EF4-FFF2-40B4-BE49-F238E27FC236}">
-                <a16:creationId xmlns:a16="http://schemas.microsoft.com/office/drawing/2014/main" id="{CBCF797C-F80F-4766-BB23-49CBA0FF2FC0}"/>
+                <a16:creationId xmlns:a16="http://schemas.microsoft.com/office/drawing/2014/main" id="{6AB96BB8-9CD9-4517-87B5-785E93CFE6CC}"/>
               </a:ext>
             </a:extLst>
           </p:cNvPr>
@@ -12756,7 +12756,7 @@
           <p:cNvPr id="23" name="">
             <a:extLst xmlns:a="http://schemas.openxmlformats.org/drawingml/2006/main">
               <a:ext uri="{FF2B5EF4-FFF2-40B4-BE49-F238E27FC236}">
-                <a16:creationId xmlns:a16="http://schemas.microsoft.com/office/drawing/2014/main" id="{A1BAEBDE-93D1-4CEF-9AC1-210F2446FA76}"/>
+                <a16:creationId xmlns:a16="http://schemas.microsoft.com/office/drawing/2014/main" id="{1DE2094F-D708-4D33-8128-12EEFC5DC0A8}"/>
               </a:ext>
             </a:extLst>
           </p:cNvPr>
@@ -12820,7 +12820,7 @@
           <p:cNvPr id="24" name="">
             <a:extLst xmlns:a="http://schemas.openxmlformats.org/drawingml/2006/main">
               <a:ext uri="{FF2B5EF4-FFF2-40B4-BE49-F238E27FC236}">
-                <a16:creationId xmlns:a16="http://schemas.microsoft.com/office/drawing/2014/main" id="{8FEE5716-134F-4C81-B7F0-1B8CFA850CD1}"/>
+                <a16:creationId xmlns:a16="http://schemas.microsoft.com/office/drawing/2014/main" id="{ACA1CCF5-F646-4A2F-917F-9CD08CFF57F0}"/>
               </a:ext>
             </a:extLst>
           </p:cNvPr>
@@ -12853,7 +12853,7 @@
           <p:cNvPr id="25" name="">
             <a:extLst xmlns:a="http://schemas.openxmlformats.org/drawingml/2006/main">
               <a:ext uri="{FF2B5EF4-FFF2-40B4-BE49-F238E27FC236}">
-                <a16:creationId xmlns:a16="http://schemas.microsoft.com/office/drawing/2014/main" id="{07C103A2-BBE3-4D30-B734-5F67198FA2D8}"/>
+                <a16:creationId xmlns:a16="http://schemas.microsoft.com/office/drawing/2014/main" id="{ED21C6B7-51E3-4AAE-927F-9D0A630062D2}"/>
               </a:ext>
             </a:extLst>
           </p:cNvPr>
@@ -12917,7 +12917,7 @@
           <p:cNvPr id="26" name="">
             <a:extLst xmlns:a="http://schemas.openxmlformats.org/drawingml/2006/main">
               <a:ext uri="{FF2B5EF4-FFF2-40B4-BE49-F238E27FC236}">
-                <a16:creationId xmlns:a16="http://schemas.microsoft.com/office/drawing/2014/main" id="{07BB1531-8497-49A0-82F1-10D2793D9A11}"/>
+                <a16:creationId xmlns:a16="http://schemas.microsoft.com/office/drawing/2014/main" id="{E3150EB0-A143-4265-BC1B-BCB31A27ECF3}"/>
               </a:ext>
             </a:extLst>
           </p:cNvPr>
@@ -12979,7 +12979,7 @@
     </p:spTree>
     <p:extLst>
       <p:ext uri="{BB962C8B-B14F-4D97-AF65-F5344CB8AC3E}">
-        <p14:creationId xmlns:p14="http://schemas.microsoft.com/office/powerpoint/2010/main" val="328042313"/>
+        <p14:creationId xmlns:p14="http://schemas.microsoft.com/office/powerpoint/2010/main" val="2076787950"/>
       </p:ext>
     </p:extLst>
   </p:cSld>
@@ -13007,7 +13007,7 @@
           <p:nvPr/>
         </p:nvPicPr>
         <p:blipFill>
-          <a:blip xmlns:r="http://schemas.openxmlformats.org/officeDocument/2006/relationships" xmlns:a="http://schemas.openxmlformats.org/drawingml/2006/main" r:embed="Rad6fb19fffc14168"/>
+          <a:blip xmlns:r="http://schemas.openxmlformats.org/officeDocument/2006/relationships" xmlns:a="http://schemas.openxmlformats.org/drawingml/2006/main" r:embed="Re05215777ef24cfc"/>
           <a:srcRect xmlns:a="http://schemas.openxmlformats.org/drawingml/2006/main" l="0" t="27" r="0" b="27"/>
           <a:stretch xmlns:a="http://schemas.openxmlformats.org/drawingml/2006/main">
             <a:fillRect l="0" t="0" r="0" b="0"/>
@@ -13028,7 +13028,7 @@
           <p:cNvPr id="2" name="">
             <a:extLst xmlns:a="http://schemas.openxmlformats.org/drawingml/2006/main">
               <a:ext uri="{FF2B5EF4-FFF2-40B4-BE49-F238E27FC236}">
-                <a16:creationId xmlns:a16="http://schemas.microsoft.com/office/drawing/2014/main" id="{A7C861C1-0A61-4F2F-A137-82F047E9B1A9}"/>
+                <a16:creationId xmlns:a16="http://schemas.microsoft.com/office/drawing/2014/main" id="{60DF1025-BE6C-436B-BFF1-3CEA82263D3D}"/>
               </a:ext>
             </a:extLst>
           </p:cNvPr>
@@ -13065,7 +13065,7 @@
           <p:cNvPr id="3" name="">
             <a:extLst xmlns:a="http://schemas.openxmlformats.org/drawingml/2006/main">
               <a:ext uri="{FF2B5EF4-FFF2-40B4-BE49-F238E27FC236}">
-                <a16:creationId xmlns:a16="http://schemas.microsoft.com/office/drawing/2014/main" id="{BAF03FE4-F9B4-46A3-A464-DE46B5319620}"/>
+                <a16:creationId xmlns:a16="http://schemas.microsoft.com/office/drawing/2014/main" id="{AE44BAF6-0BED-4C03-BD87-1E7F1F3043E4}"/>
               </a:ext>
             </a:extLst>
           </p:cNvPr>
@@ -13102,7 +13102,7 @@
           <p:cNvPr id="4" name="">
             <a:extLst xmlns:a="http://schemas.openxmlformats.org/drawingml/2006/main">
               <a:ext uri="{FF2B5EF4-FFF2-40B4-BE49-F238E27FC236}">
-                <a16:creationId xmlns:a16="http://schemas.microsoft.com/office/drawing/2014/main" id="{FF2ADE9C-D95C-4000-A521-1E6DD3906394}"/>
+                <a16:creationId xmlns:a16="http://schemas.microsoft.com/office/drawing/2014/main" id="{3156AADD-D3C9-46F6-BE5B-948DC1C62C95}"/>
               </a:ext>
             </a:extLst>
           </p:cNvPr>
@@ -13166,7 +13166,7 @@
           <p:cNvPr id="5" name="">
             <a:extLst xmlns:a="http://schemas.openxmlformats.org/drawingml/2006/main">
               <a:ext uri="{FF2B5EF4-FFF2-40B4-BE49-F238E27FC236}">
-                <a16:creationId xmlns:a16="http://schemas.microsoft.com/office/drawing/2014/main" id="{9438A923-7B93-4F0D-98A9-120D1956F05B}"/>
+                <a16:creationId xmlns:a16="http://schemas.microsoft.com/office/drawing/2014/main" id="{2971BD50-FD49-4E97-9F44-E1D11605A62D}"/>
               </a:ext>
             </a:extLst>
           </p:cNvPr>
@@ -13230,7 +13230,7 @@
           <p:cNvPr id="6" name="">
             <a:extLst xmlns:a="http://schemas.openxmlformats.org/drawingml/2006/main">
               <a:ext uri="{FF2B5EF4-FFF2-40B4-BE49-F238E27FC236}">
-                <a16:creationId xmlns:a16="http://schemas.microsoft.com/office/drawing/2014/main" id="{66CEA40C-D552-4D3D-86C7-DA1DCD81AA94}"/>
+                <a16:creationId xmlns:a16="http://schemas.microsoft.com/office/drawing/2014/main" id="{D7F85F82-D493-4945-9755-5B3082D9415B}"/>
               </a:ext>
             </a:extLst>
           </p:cNvPr>
@@ -13294,7 +13294,7 @@
           <p:cNvPr id="7" name="">
             <a:extLst xmlns:a="http://schemas.openxmlformats.org/drawingml/2006/main">
               <a:ext uri="{FF2B5EF4-FFF2-40B4-BE49-F238E27FC236}">
-                <a16:creationId xmlns:a16="http://schemas.microsoft.com/office/drawing/2014/main" id="{24E29944-6B30-4857-85A8-14E35EB97F0B}"/>
+                <a16:creationId xmlns:a16="http://schemas.microsoft.com/office/drawing/2014/main" id="{5A753DC5-13E0-4F0D-B4E7-15F52828CCB6}"/>
               </a:ext>
             </a:extLst>
           </p:cNvPr>
@@ -13329,7 +13329,7 @@
           <p:cNvPr id="8" name="">
             <a:extLst xmlns:a="http://schemas.openxmlformats.org/drawingml/2006/main">
               <a:ext uri="{FF2B5EF4-FFF2-40B4-BE49-F238E27FC236}">
-                <a16:creationId xmlns:a16="http://schemas.microsoft.com/office/drawing/2014/main" id="{31159329-6EBB-4383-BBD8-11A86D66DC21}"/>
+                <a16:creationId xmlns:a16="http://schemas.microsoft.com/office/drawing/2014/main" id="{68828F50-308B-43C0-9325-7F23502BCB93}"/>
               </a:ext>
             </a:extLst>
           </p:cNvPr>
@@ -13416,7 +13416,7 @@
           <p:cNvPr id="9" name="">
             <a:extLst xmlns:a="http://schemas.openxmlformats.org/drawingml/2006/main">
               <a:ext uri="{FF2B5EF4-FFF2-40B4-BE49-F238E27FC236}">
-                <a16:creationId xmlns:a16="http://schemas.microsoft.com/office/drawing/2014/main" id="{58514203-06AA-4B5E-AA20-AF174BC0E435}"/>
+                <a16:creationId xmlns:a16="http://schemas.microsoft.com/office/drawing/2014/main" id="{6D2942EF-8E2A-4035-9C37-A667EAD8F520}"/>
               </a:ext>
             </a:extLst>
           </p:cNvPr>
@@ -13480,7 +13480,7 @@
           <p:cNvPr id="10" name="">
             <a:extLst xmlns:a="http://schemas.openxmlformats.org/drawingml/2006/main">
               <a:ext uri="{FF2B5EF4-FFF2-40B4-BE49-F238E27FC236}">
-                <a16:creationId xmlns:a16="http://schemas.microsoft.com/office/drawing/2014/main" id="{F9F8C4D2-9A31-44E7-AEF1-912E6351D2F5}"/>
+                <a16:creationId xmlns:a16="http://schemas.microsoft.com/office/drawing/2014/main" id="{B9132EB7-C878-47F9-AE0D-BC85835121D3}"/>
               </a:ext>
             </a:extLst>
           </p:cNvPr>
@@ -13515,7 +13515,7 @@
           <p:cNvPr id="11" name="">
             <a:extLst xmlns:a="http://schemas.openxmlformats.org/drawingml/2006/main">
               <a:ext uri="{FF2B5EF4-FFF2-40B4-BE49-F238E27FC236}">
-                <a16:creationId xmlns:a16="http://schemas.microsoft.com/office/drawing/2014/main" id="{8BF5DFCA-F0FA-41E8-9B72-0B0D6DB9C336}"/>
+                <a16:creationId xmlns:a16="http://schemas.microsoft.com/office/drawing/2014/main" id="{3377CFE8-3EE9-4095-A2B3-995F1CB6C0E3}"/>
               </a:ext>
             </a:extLst>
           </p:cNvPr>
@@ -13579,7 +13579,7 @@
           <p:cNvPr id="12" name="">
             <a:extLst xmlns:a="http://schemas.openxmlformats.org/drawingml/2006/main">
               <a:ext uri="{FF2B5EF4-FFF2-40B4-BE49-F238E27FC236}">
-                <a16:creationId xmlns:a16="http://schemas.microsoft.com/office/drawing/2014/main" id="{F1197852-A6AB-47CF-A367-B58E9D3DD063}"/>
+                <a16:creationId xmlns:a16="http://schemas.microsoft.com/office/drawing/2014/main" id="{E4DBEBDD-B978-4FDA-8CEF-4D6A1D3E98B3}"/>
               </a:ext>
             </a:extLst>
           </p:cNvPr>
@@ -13612,7 +13612,7 @@
           <p:cNvPr id="13" name="">
             <a:extLst xmlns:a="http://schemas.openxmlformats.org/drawingml/2006/main">
               <a:ext uri="{FF2B5EF4-FFF2-40B4-BE49-F238E27FC236}">
-                <a16:creationId xmlns:a16="http://schemas.microsoft.com/office/drawing/2014/main" id="{5150BAD5-A666-49F7-AA52-7D37E109FD29}"/>
+                <a16:creationId xmlns:a16="http://schemas.microsoft.com/office/drawing/2014/main" id="{D035ED0F-06AF-4F12-95BF-3D9197FF65B5}"/>
               </a:ext>
             </a:extLst>
           </p:cNvPr>
@@ -13647,7 +13647,7 @@
           <p:cNvPr id="14" name="">
             <a:extLst xmlns:a="http://schemas.openxmlformats.org/drawingml/2006/main">
               <a:ext uri="{FF2B5EF4-FFF2-40B4-BE49-F238E27FC236}">
-                <a16:creationId xmlns:a16="http://schemas.microsoft.com/office/drawing/2014/main" id="{7A50FE18-1478-4A82-A318-99E490E2B0D5}"/>
+                <a16:creationId xmlns:a16="http://schemas.microsoft.com/office/drawing/2014/main" id="{C38C35FA-DC27-4F3E-9550-B370D9253B1F}"/>
               </a:ext>
             </a:extLst>
           </p:cNvPr>
@@ -13711,7 +13711,7 @@
           <p:cNvPr id="15" name="">
             <a:extLst xmlns:a="http://schemas.openxmlformats.org/drawingml/2006/main">
               <a:ext uri="{FF2B5EF4-FFF2-40B4-BE49-F238E27FC236}">
-                <a16:creationId xmlns:a16="http://schemas.microsoft.com/office/drawing/2014/main" id="{C4033A3E-3456-4892-9FD1-F364FB5E7BE6}"/>
+                <a16:creationId xmlns:a16="http://schemas.microsoft.com/office/drawing/2014/main" id="{570C36B7-FCBD-414D-BA21-0293F2205E31}"/>
               </a:ext>
             </a:extLst>
           </p:cNvPr>
@@ -13744,7 +13744,7 @@
           <p:cNvPr id="16" name="">
             <a:extLst xmlns:a="http://schemas.openxmlformats.org/drawingml/2006/main">
               <a:ext uri="{FF2B5EF4-FFF2-40B4-BE49-F238E27FC236}">
-                <a16:creationId xmlns:a16="http://schemas.microsoft.com/office/drawing/2014/main" id="{2885E714-78A3-4DCA-AA43-029B6745991A}"/>
+                <a16:creationId xmlns:a16="http://schemas.microsoft.com/office/drawing/2014/main" id="{5E9EF001-FBC3-43E6-9F20-3E3E1AC6204B}"/>
               </a:ext>
             </a:extLst>
           </p:cNvPr>
@@ -13779,7 +13779,7 @@
           <p:cNvPr id="17" name="">
             <a:extLst xmlns:a="http://schemas.openxmlformats.org/drawingml/2006/main">
               <a:ext uri="{FF2B5EF4-FFF2-40B4-BE49-F238E27FC236}">
-                <a16:creationId xmlns:a16="http://schemas.microsoft.com/office/drawing/2014/main" id="{C2E3544C-6EE0-4C19-9102-D2E578596B00}"/>
+                <a16:creationId xmlns:a16="http://schemas.microsoft.com/office/drawing/2014/main" id="{CED32322-DA4F-4C83-82E0-6D7A37DAE63F}"/>
               </a:ext>
             </a:extLst>
           </p:cNvPr>
@@ -13843,7 +13843,7 @@
           <p:cNvPr id="18" name="">
             <a:extLst xmlns:a="http://schemas.openxmlformats.org/drawingml/2006/main">
               <a:ext uri="{FF2B5EF4-FFF2-40B4-BE49-F238E27FC236}">
-                <a16:creationId xmlns:a16="http://schemas.microsoft.com/office/drawing/2014/main" id="{64AA5AEB-9537-4D3F-BCE6-8FE878AD3179}"/>
+                <a16:creationId xmlns:a16="http://schemas.microsoft.com/office/drawing/2014/main" id="{312B3A9C-5EC4-48D2-80F9-74137CA5D0E6}"/>
               </a:ext>
             </a:extLst>
           </p:cNvPr>
@@ -13876,7 +13876,7 @@
           <p:cNvPr id="19" name="">
             <a:extLst xmlns:a="http://schemas.openxmlformats.org/drawingml/2006/main">
               <a:ext uri="{FF2B5EF4-FFF2-40B4-BE49-F238E27FC236}">
-                <a16:creationId xmlns:a16="http://schemas.microsoft.com/office/drawing/2014/main" id="{09BB63FD-C3C1-4A57-9B20-E35E4AEFF2EC}"/>
+                <a16:creationId xmlns:a16="http://schemas.microsoft.com/office/drawing/2014/main" id="{DCA9891E-8CA0-4F89-9B46-88BE599C39C6}"/>
               </a:ext>
             </a:extLst>
           </p:cNvPr>
@@ -13911,7 +13911,7 @@
           <p:cNvPr id="20" name="">
             <a:extLst xmlns:a="http://schemas.openxmlformats.org/drawingml/2006/main">
               <a:ext uri="{FF2B5EF4-FFF2-40B4-BE49-F238E27FC236}">
-                <a16:creationId xmlns:a16="http://schemas.microsoft.com/office/drawing/2014/main" id="{D41FCE11-44DC-4E4C-BA7A-71CDABBB9A4A}"/>
+                <a16:creationId xmlns:a16="http://schemas.microsoft.com/office/drawing/2014/main" id="{13D82E6E-F2DD-43F6-A275-16F20032E676}"/>
               </a:ext>
             </a:extLst>
           </p:cNvPr>
@@ -13975,7 +13975,7 @@
           <p:cNvPr id="21" name="">
             <a:extLst xmlns:a="http://schemas.openxmlformats.org/drawingml/2006/main">
               <a:ext uri="{FF2B5EF4-FFF2-40B4-BE49-F238E27FC236}">
-                <a16:creationId xmlns:a16="http://schemas.microsoft.com/office/drawing/2014/main" id="{8B8D470A-6369-456E-95E7-D6D58CABA4B4}"/>
+                <a16:creationId xmlns:a16="http://schemas.microsoft.com/office/drawing/2014/main" id="{CB4B5024-92EE-44F7-9D6F-0AD612D9A574}"/>
               </a:ext>
             </a:extLst>
           </p:cNvPr>
@@ -14008,7 +14008,7 @@
           <p:cNvPr id="22" name="">
             <a:extLst xmlns:a="http://schemas.openxmlformats.org/drawingml/2006/main">
               <a:ext uri="{FF2B5EF4-FFF2-40B4-BE49-F238E27FC236}">
-                <a16:creationId xmlns:a16="http://schemas.microsoft.com/office/drawing/2014/main" id="{A4B2DFAA-3152-4264-A09D-A671C31DDC93}"/>
+                <a16:creationId xmlns:a16="http://schemas.microsoft.com/office/drawing/2014/main" id="{C756E23A-943A-42EF-AD74-91CF47EE3828}"/>
               </a:ext>
             </a:extLst>
           </p:cNvPr>
@@ -14043,7 +14043,7 @@
           <p:cNvPr id="23" name="">
             <a:extLst xmlns:a="http://schemas.openxmlformats.org/drawingml/2006/main">
               <a:ext uri="{FF2B5EF4-FFF2-40B4-BE49-F238E27FC236}">
-                <a16:creationId xmlns:a16="http://schemas.microsoft.com/office/drawing/2014/main" id="{4188E74A-9F9E-4E2B-9654-516F7979A150}"/>
+                <a16:creationId xmlns:a16="http://schemas.microsoft.com/office/drawing/2014/main" id="{8511A26D-1F2C-4114-A3C2-2F98ED5380BC}"/>
               </a:ext>
             </a:extLst>
           </p:cNvPr>
@@ -14107,7 +14107,7 @@
           <p:cNvPr id="24" name="">
             <a:extLst xmlns:a="http://schemas.openxmlformats.org/drawingml/2006/main">
               <a:ext uri="{FF2B5EF4-FFF2-40B4-BE49-F238E27FC236}">
-                <a16:creationId xmlns:a16="http://schemas.microsoft.com/office/drawing/2014/main" id="{2F3C58A8-21B2-4C6F-94D1-8FBE73D8A7FB}"/>
+                <a16:creationId xmlns:a16="http://schemas.microsoft.com/office/drawing/2014/main" id="{0853E2C0-8500-4E29-814E-65D49AED6A80}"/>
               </a:ext>
             </a:extLst>
           </p:cNvPr>
@@ -14140,7 +14140,7 @@
           <p:cNvPr id="25" name="">
             <a:extLst xmlns:a="http://schemas.openxmlformats.org/drawingml/2006/main">
               <a:ext uri="{FF2B5EF4-FFF2-40B4-BE49-F238E27FC236}">
-                <a16:creationId xmlns:a16="http://schemas.microsoft.com/office/drawing/2014/main" id="{89B58E49-DF82-43FA-8603-90CC0C8BFE85}"/>
+                <a16:creationId xmlns:a16="http://schemas.microsoft.com/office/drawing/2014/main" id="{3B7F7BD7-6F07-472F-BF6A-B9891B5868C4}"/>
               </a:ext>
             </a:extLst>
           </p:cNvPr>
@@ -14173,7 +14173,7 @@
           <p:cNvPr id="26" name="">
             <a:extLst xmlns:a="http://schemas.openxmlformats.org/drawingml/2006/main">
               <a:ext uri="{FF2B5EF4-FFF2-40B4-BE49-F238E27FC236}">
-                <a16:creationId xmlns:a16="http://schemas.microsoft.com/office/drawing/2014/main" id="{789EDA6C-615B-42BC-B142-93814E57B000}"/>
+                <a16:creationId xmlns:a16="http://schemas.microsoft.com/office/drawing/2014/main" id="{9444D44B-B3D7-423D-9BFF-A83D38EF2C66}"/>
               </a:ext>
             </a:extLst>
           </p:cNvPr>
@@ -14237,7 +14237,7 @@
           <p:cNvPr id="27" name="">
             <a:extLst xmlns:a="http://schemas.openxmlformats.org/drawingml/2006/main">
               <a:ext uri="{FF2B5EF4-FFF2-40B4-BE49-F238E27FC236}">
-                <a16:creationId xmlns:a16="http://schemas.microsoft.com/office/drawing/2014/main" id="{279C4EFC-25BB-40DD-B583-BD9A1C407D55}"/>
+                <a16:creationId xmlns:a16="http://schemas.microsoft.com/office/drawing/2014/main" id="{3FEF940B-E4B7-40B5-8D3C-8F4EFE7169EE}"/>
               </a:ext>
             </a:extLst>
           </p:cNvPr>
@@ -14270,7 +14270,7 @@
           <p:cNvPr id="28" name="">
             <a:extLst xmlns:a="http://schemas.openxmlformats.org/drawingml/2006/main">
               <a:ext uri="{FF2B5EF4-FFF2-40B4-BE49-F238E27FC236}">
-                <a16:creationId xmlns:a16="http://schemas.microsoft.com/office/drawing/2014/main" id="{E49FEEE9-71B0-4069-B8AB-91A987EE316F}"/>
+                <a16:creationId xmlns:a16="http://schemas.microsoft.com/office/drawing/2014/main" id="{44BC7DE4-98EB-4122-AC48-F3B14F08913E}"/>
               </a:ext>
             </a:extLst>
           </p:cNvPr>
@@ -14334,7 +14334,7 @@
           <p:cNvPr id="29" name="">
             <a:extLst xmlns:a="http://schemas.openxmlformats.org/drawingml/2006/main">
               <a:ext uri="{FF2B5EF4-FFF2-40B4-BE49-F238E27FC236}">
-                <a16:creationId xmlns:a16="http://schemas.microsoft.com/office/drawing/2014/main" id="{88ED960A-5D9C-47A4-B92B-3D211F6AEF95}"/>
+                <a16:creationId xmlns:a16="http://schemas.microsoft.com/office/drawing/2014/main" id="{F542AB52-37E3-4435-A592-BCD7078E77A3}"/>
               </a:ext>
             </a:extLst>
           </p:cNvPr>
@@ -14396,7 +14396,7 @@
     </p:spTree>
     <p:extLst>
       <p:ext uri="{BB962C8B-B14F-4D97-AF65-F5344CB8AC3E}">
-        <p14:creationId xmlns:p14="http://schemas.microsoft.com/office/powerpoint/2010/main" val="1364221588"/>
+        <p14:creationId xmlns:p14="http://schemas.microsoft.com/office/powerpoint/2010/main" val="277645759"/>
       </p:ext>
     </p:extLst>
   </p:cSld>
@@ -14424,7 +14424,7 @@
           <p:nvPr/>
         </p:nvPicPr>
         <p:blipFill>
-          <a:blip xmlns:r="http://schemas.openxmlformats.org/officeDocument/2006/relationships" xmlns:a="http://schemas.openxmlformats.org/drawingml/2006/main" r:embed="Rc9ee20fafd5f43bf"/>
+          <a:blip xmlns:r="http://schemas.openxmlformats.org/officeDocument/2006/relationships" xmlns:a="http://schemas.openxmlformats.org/drawingml/2006/main" r:embed="R83f7292f46e9404b"/>
           <a:srcRect xmlns:a="http://schemas.openxmlformats.org/drawingml/2006/main" l="0" t="27" r="0" b="27"/>
           <a:stretch xmlns:a="http://schemas.openxmlformats.org/drawingml/2006/main">
             <a:fillRect l="0" t="0" r="0" b="0"/>
@@ -14445,7 +14445,7 @@
           <p:cNvPr id="2" name="">
             <a:extLst xmlns:a="http://schemas.openxmlformats.org/drawingml/2006/main">
               <a:ext uri="{FF2B5EF4-FFF2-40B4-BE49-F238E27FC236}">
-                <a16:creationId xmlns:a16="http://schemas.microsoft.com/office/drawing/2014/main" id="{04BEC5C6-4698-4ABC-A419-1CEED1EA241E}"/>
+                <a16:creationId xmlns:a16="http://schemas.microsoft.com/office/drawing/2014/main" id="{0901D28F-2288-410B-9BEA-4AD2E26D9ADA}"/>
               </a:ext>
             </a:extLst>
           </p:cNvPr>
@@ -14482,7 +14482,7 @@
           <p:cNvPr id="3" name="">
             <a:extLst xmlns:a="http://schemas.openxmlformats.org/drawingml/2006/main">
               <a:ext uri="{FF2B5EF4-FFF2-40B4-BE49-F238E27FC236}">
-                <a16:creationId xmlns:a16="http://schemas.microsoft.com/office/drawing/2014/main" id="{E50FC56C-F525-4869-999B-E8273CD9C36C}"/>
+                <a16:creationId xmlns:a16="http://schemas.microsoft.com/office/drawing/2014/main" id="{FF58CFD5-EE77-4813-AE8F-6D6F7AC743ED}"/>
               </a:ext>
             </a:extLst>
           </p:cNvPr>
@@ -14519,7 +14519,7 @@
           <p:cNvPr id="4" name="">
             <a:extLst xmlns:a="http://schemas.openxmlformats.org/drawingml/2006/main">
               <a:ext uri="{FF2B5EF4-FFF2-40B4-BE49-F238E27FC236}">
-                <a16:creationId xmlns:a16="http://schemas.microsoft.com/office/drawing/2014/main" id="{9B658055-1880-40C6-BCEE-9BFC187B6CB2}"/>
+                <a16:creationId xmlns:a16="http://schemas.microsoft.com/office/drawing/2014/main" id="{B207EE0A-ABA7-4034-9C06-877F386CF27D}"/>
               </a:ext>
             </a:extLst>
           </p:cNvPr>
@@ -14583,7 +14583,7 @@
           <p:cNvPr id="5" name="">
             <a:extLst xmlns:a="http://schemas.openxmlformats.org/drawingml/2006/main">
               <a:ext uri="{FF2B5EF4-FFF2-40B4-BE49-F238E27FC236}">
-                <a16:creationId xmlns:a16="http://schemas.microsoft.com/office/drawing/2014/main" id="{77B476FD-B1EE-4755-8519-01CDFBE39868}"/>
+                <a16:creationId xmlns:a16="http://schemas.microsoft.com/office/drawing/2014/main" id="{AC37B681-B19E-4B4A-90BD-2527427777C1}"/>
               </a:ext>
             </a:extLst>
           </p:cNvPr>
@@ -14647,7 +14647,7 @@
           <p:cNvPr id="6" name="">
             <a:extLst xmlns:a="http://schemas.openxmlformats.org/drawingml/2006/main">
               <a:ext uri="{FF2B5EF4-FFF2-40B4-BE49-F238E27FC236}">
-                <a16:creationId xmlns:a16="http://schemas.microsoft.com/office/drawing/2014/main" id="{E85CB8D7-E2A5-401C-93B4-0719CAEC4494}"/>
+                <a16:creationId xmlns:a16="http://schemas.microsoft.com/office/drawing/2014/main" id="{175236C5-9F9A-4819-A172-D3B71DEA613B}"/>
               </a:ext>
             </a:extLst>
           </p:cNvPr>
@@ -14711,7 +14711,7 @@
           <p:cNvPr id="7" name="">
             <a:extLst xmlns:a="http://schemas.openxmlformats.org/drawingml/2006/main">
               <a:ext uri="{FF2B5EF4-FFF2-40B4-BE49-F238E27FC236}">
-                <a16:creationId xmlns:a16="http://schemas.microsoft.com/office/drawing/2014/main" id="{391A90D0-B430-49A2-B4E6-DCF04021DAD0}"/>
+                <a16:creationId xmlns:a16="http://schemas.microsoft.com/office/drawing/2014/main" id="{BB00F183-4D43-4AC1-B9CD-3101AFBF4548}"/>
               </a:ext>
             </a:extLst>
           </p:cNvPr>
@@ -14746,7 +14746,7 @@
           <p:cNvPr id="8" name="">
             <a:extLst xmlns:a="http://schemas.openxmlformats.org/drawingml/2006/main">
               <a:ext uri="{FF2B5EF4-FFF2-40B4-BE49-F238E27FC236}">
-                <a16:creationId xmlns:a16="http://schemas.microsoft.com/office/drawing/2014/main" id="{00FF3DBB-965F-4C1A-B935-48C6704BABD2}"/>
+                <a16:creationId xmlns:a16="http://schemas.microsoft.com/office/drawing/2014/main" id="{ED2F7DA7-3FD5-4CD2-AAE4-356F035E6C62}"/>
               </a:ext>
             </a:extLst>
           </p:cNvPr>
@@ -14810,7 +14810,7 @@
           <p:cNvPr id="9" name="">
             <a:extLst xmlns:a="http://schemas.openxmlformats.org/drawingml/2006/main">
               <a:ext uri="{FF2B5EF4-FFF2-40B4-BE49-F238E27FC236}">
-                <a16:creationId xmlns:a16="http://schemas.microsoft.com/office/drawing/2014/main" id="{F5530180-7B3F-41BF-9329-A21C7E6E8C07}"/>
+                <a16:creationId xmlns:a16="http://schemas.microsoft.com/office/drawing/2014/main" id="{F7B7E0DC-DF83-49B8-A3AC-079D4BAABFF6}"/>
               </a:ext>
             </a:extLst>
           </p:cNvPr>
@@ -14874,7 +14874,7 @@
           <p:cNvPr id="10" name="">
             <a:extLst xmlns:a="http://schemas.openxmlformats.org/drawingml/2006/main">
               <a:ext uri="{FF2B5EF4-FFF2-40B4-BE49-F238E27FC236}">
-                <a16:creationId xmlns:a16="http://schemas.microsoft.com/office/drawing/2014/main" id="{06CBBFDB-164A-4747-89F0-FA447E97F87D}"/>
+                <a16:creationId xmlns:a16="http://schemas.microsoft.com/office/drawing/2014/main" id="{5BEC0B8E-C304-423F-83E7-DDFAA11053F7}"/>
               </a:ext>
             </a:extLst>
           </p:cNvPr>
@@ -14907,7 +14907,7 @@
           <p:cNvPr id="11" name="">
             <a:extLst xmlns:a="http://schemas.openxmlformats.org/drawingml/2006/main">
               <a:ext uri="{FF2B5EF4-FFF2-40B4-BE49-F238E27FC236}">
-                <a16:creationId xmlns:a16="http://schemas.microsoft.com/office/drawing/2014/main" id="{BA353077-E36C-4E5A-807F-DFF0E4AFF8BC}"/>
+                <a16:creationId xmlns:a16="http://schemas.microsoft.com/office/drawing/2014/main" id="{484D9729-5022-4E89-8850-BCAEC31F2706}"/>
               </a:ext>
             </a:extLst>
           </p:cNvPr>
@@ -14942,7 +14942,7 @@
           <p:cNvPr id="12" name="">
             <a:extLst xmlns:a="http://schemas.openxmlformats.org/drawingml/2006/main">
               <a:ext uri="{FF2B5EF4-FFF2-40B4-BE49-F238E27FC236}">
-                <a16:creationId xmlns:a16="http://schemas.microsoft.com/office/drawing/2014/main" id="{F4F95D22-C3C1-44BD-8C74-424C1F062B40}"/>
+                <a16:creationId xmlns:a16="http://schemas.microsoft.com/office/drawing/2014/main" id="{60266161-6668-41AA-A7CA-F61103795AC3}"/>
               </a:ext>
             </a:extLst>
           </p:cNvPr>
@@ -15006,7 +15006,7 @@
           <p:cNvPr id="13" name="">
             <a:extLst xmlns:a="http://schemas.openxmlformats.org/drawingml/2006/main">
               <a:ext uri="{FF2B5EF4-FFF2-40B4-BE49-F238E27FC236}">
-                <a16:creationId xmlns:a16="http://schemas.microsoft.com/office/drawing/2014/main" id="{058D43C1-AE79-4936-A7A2-65BE17DE7047}"/>
+                <a16:creationId xmlns:a16="http://schemas.microsoft.com/office/drawing/2014/main" id="{6A4F3E4E-DE62-4336-A327-49865974E723}"/>
               </a:ext>
             </a:extLst>
           </p:cNvPr>
@@ -15070,7 +15070,7 @@
           <p:cNvPr id="14" name="">
             <a:extLst xmlns:a="http://schemas.openxmlformats.org/drawingml/2006/main">
               <a:ext uri="{FF2B5EF4-FFF2-40B4-BE49-F238E27FC236}">
-                <a16:creationId xmlns:a16="http://schemas.microsoft.com/office/drawing/2014/main" id="{F58A2176-001D-465D-ABFB-23B2CFD36151}"/>
+                <a16:creationId xmlns:a16="http://schemas.microsoft.com/office/drawing/2014/main" id="{9ADBCA53-EFFA-4EC3-8453-4FE1690CD4AA}"/>
               </a:ext>
             </a:extLst>
           </p:cNvPr>
@@ -15103,7 +15103,7 @@
           <p:cNvPr id="15" name="">
             <a:extLst xmlns:a="http://schemas.openxmlformats.org/drawingml/2006/main">
               <a:ext uri="{FF2B5EF4-FFF2-40B4-BE49-F238E27FC236}">
-                <a16:creationId xmlns:a16="http://schemas.microsoft.com/office/drawing/2014/main" id="{3DBEF094-01D6-49DF-8C1D-198E7142CC0A}"/>
+                <a16:creationId xmlns:a16="http://schemas.microsoft.com/office/drawing/2014/main" id="{C01675B4-5EC1-42C9-AACA-29543A9E3ECF}"/>
               </a:ext>
             </a:extLst>
           </p:cNvPr>
@@ -15138,7 +15138,7 @@
           <p:cNvPr id="16" name="">
             <a:extLst xmlns:a="http://schemas.openxmlformats.org/drawingml/2006/main">
               <a:ext uri="{FF2B5EF4-FFF2-40B4-BE49-F238E27FC236}">
-                <a16:creationId xmlns:a16="http://schemas.microsoft.com/office/drawing/2014/main" id="{DB0704C0-A7D4-4DBD-BC3B-9203CE057EBC}"/>
+                <a16:creationId xmlns:a16="http://schemas.microsoft.com/office/drawing/2014/main" id="{1D438CAC-BE4E-4919-BC8C-8295E06D3CC9}"/>
               </a:ext>
             </a:extLst>
           </p:cNvPr>
@@ -15202,7 +15202,7 @@
           <p:cNvPr id="17" name="">
             <a:extLst xmlns:a="http://schemas.openxmlformats.org/drawingml/2006/main">
               <a:ext uri="{FF2B5EF4-FFF2-40B4-BE49-F238E27FC236}">
-                <a16:creationId xmlns:a16="http://schemas.microsoft.com/office/drawing/2014/main" id="{4B09FAF0-4D69-4914-A3BA-9BD1B25FDB2A}"/>
+                <a16:creationId xmlns:a16="http://schemas.microsoft.com/office/drawing/2014/main" id="{799534F6-5B66-4112-A16B-E86C2F4575FB}"/>
               </a:ext>
             </a:extLst>
           </p:cNvPr>
@@ -15266,7 +15266,7 @@
           <p:cNvPr id="18" name="">
             <a:extLst xmlns:a="http://schemas.openxmlformats.org/drawingml/2006/main">
               <a:ext uri="{FF2B5EF4-FFF2-40B4-BE49-F238E27FC236}">
-                <a16:creationId xmlns:a16="http://schemas.microsoft.com/office/drawing/2014/main" id="{F00CA3EC-00E7-4426-A1DD-4662DF45AB40}"/>
+                <a16:creationId xmlns:a16="http://schemas.microsoft.com/office/drawing/2014/main" id="{7EB15F93-BAC7-4610-9EEB-5D2553283080}"/>
               </a:ext>
             </a:extLst>
           </p:cNvPr>
@@ -15299,7 +15299,7 @@
           <p:cNvPr id="19" name="">
             <a:extLst xmlns:a="http://schemas.openxmlformats.org/drawingml/2006/main">
               <a:ext uri="{FF2B5EF4-FFF2-40B4-BE49-F238E27FC236}">
-                <a16:creationId xmlns:a16="http://schemas.microsoft.com/office/drawing/2014/main" id="{6588E873-EE39-4364-96FB-A8B9A8E6B0BF}"/>
+                <a16:creationId xmlns:a16="http://schemas.microsoft.com/office/drawing/2014/main" id="{110A8450-881D-4036-AF75-CAA9837CE298}"/>
               </a:ext>
             </a:extLst>
           </p:cNvPr>
@@ -15334,7 +15334,7 @@
           <p:cNvPr id="20" name="">
             <a:extLst xmlns:a="http://schemas.openxmlformats.org/drawingml/2006/main">
               <a:ext uri="{FF2B5EF4-FFF2-40B4-BE49-F238E27FC236}">
-                <a16:creationId xmlns:a16="http://schemas.microsoft.com/office/drawing/2014/main" id="{0FBECC94-1DB3-4CAF-9205-6132F8CF7F28}"/>
+                <a16:creationId xmlns:a16="http://schemas.microsoft.com/office/drawing/2014/main" id="{BEDEC75D-D3C2-4D41-9B36-2B5AD85C2828}"/>
               </a:ext>
             </a:extLst>
           </p:cNvPr>
@@ -15398,7 +15398,7 @@
           <p:cNvPr id="21" name="">
             <a:extLst xmlns:a="http://schemas.openxmlformats.org/drawingml/2006/main">
               <a:ext uri="{FF2B5EF4-FFF2-40B4-BE49-F238E27FC236}">
-                <a16:creationId xmlns:a16="http://schemas.microsoft.com/office/drawing/2014/main" id="{D0A6E6EE-6D4E-4056-830C-9A90F2DFE5ED}"/>
+                <a16:creationId xmlns:a16="http://schemas.microsoft.com/office/drawing/2014/main" id="{557F3544-A344-4067-BC7B-909D561827D2}"/>
               </a:ext>
             </a:extLst>
           </p:cNvPr>
@@ -15462,7 +15462,7 @@
           <p:cNvPr id="22" name="">
             <a:extLst xmlns:a="http://schemas.openxmlformats.org/drawingml/2006/main">
               <a:ext uri="{FF2B5EF4-FFF2-40B4-BE49-F238E27FC236}">
-                <a16:creationId xmlns:a16="http://schemas.microsoft.com/office/drawing/2014/main" id="{60582F19-6503-4F82-B808-5A4C83F1E216}"/>
+                <a16:creationId xmlns:a16="http://schemas.microsoft.com/office/drawing/2014/main" id="{E70893F0-4D61-42DF-9BF4-490F888700FA}"/>
               </a:ext>
             </a:extLst>
           </p:cNvPr>
@@ -15526,7 +15526,7 @@
           <p:cNvPr id="23" name="">
             <a:extLst xmlns:a="http://schemas.openxmlformats.org/drawingml/2006/main">
               <a:ext uri="{FF2B5EF4-FFF2-40B4-BE49-F238E27FC236}">
-                <a16:creationId xmlns:a16="http://schemas.microsoft.com/office/drawing/2014/main" id="{C7ADCD0B-1A76-4060-B4BC-48DD227ED463}"/>
+                <a16:creationId xmlns:a16="http://schemas.microsoft.com/office/drawing/2014/main" id="{C44A0C65-0832-4DAD-8B45-F249E99EAA7A}"/>
               </a:ext>
             </a:extLst>
           </p:cNvPr>
@@ -15590,7 +15590,7 @@
           <p:cNvPr id="24" name="">
             <a:extLst xmlns:a="http://schemas.openxmlformats.org/drawingml/2006/main">
               <a:ext uri="{FF2B5EF4-FFF2-40B4-BE49-F238E27FC236}">
-                <a16:creationId xmlns:a16="http://schemas.microsoft.com/office/drawing/2014/main" id="{319B5B18-A5FE-4BE0-A8EB-994E165BAFE7}"/>
+                <a16:creationId xmlns:a16="http://schemas.microsoft.com/office/drawing/2014/main" id="{935F9FF0-E60E-4856-98CB-3A4C2B302529}"/>
               </a:ext>
             </a:extLst>
           </p:cNvPr>
@@ -15623,7 +15623,7 @@
           <p:cNvPr id="25" name="">
             <a:extLst xmlns:a="http://schemas.openxmlformats.org/drawingml/2006/main">
               <a:ext uri="{FF2B5EF4-FFF2-40B4-BE49-F238E27FC236}">
-                <a16:creationId xmlns:a16="http://schemas.microsoft.com/office/drawing/2014/main" id="{230BCA4F-50FF-4E42-B52E-5E9FD35CD347}"/>
+                <a16:creationId xmlns:a16="http://schemas.microsoft.com/office/drawing/2014/main" id="{801A6EE9-43A5-4129-B05C-BAFAC3396BEA}"/>
               </a:ext>
             </a:extLst>
           </p:cNvPr>
@@ -15687,7 +15687,7 @@
           <p:cNvPr id="26" name="">
             <a:extLst xmlns:a="http://schemas.openxmlformats.org/drawingml/2006/main">
               <a:ext uri="{FF2B5EF4-FFF2-40B4-BE49-F238E27FC236}">
-                <a16:creationId xmlns:a16="http://schemas.microsoft.com/office/drawing/2014/main" id="{7CD94B32-5758-43E9-BB2B-023A22D801F6}"/>
+                <a16:creationId xmlns:a16="http://schemas.microsoft.com/office/drawing/2014/main" id="{D5C7D495-B5CF-4D3F-A789-7C6A42F4402F}"/>
               </a:ext>
             </a:extLst>
           </p:cNvPr>
@@ -15749,7 +15749,7 @@
     </p:spTree>
     <p:extLst>
       <p:ext uri="{BB962C8B-B14F-4D97-AF65-F5344CB8AC3E}">
-        <p14:creationId xmlns:p14="http://schemas.microsoft.com/office/powerpoint/2010/main" val="780585432"/>
+        <p14:creationId xmlns:p14="http://schemas.microsoft.com/office/powerpoint/2010/main" val="510101226"/>
       </p:ext>
     </p:extLst>
   </p:cSld>
@@ -15777,7 +15777,7 @@
           <p:nvPr/>
         </p:nvPicPr>
         <p:blipFill>
-          <a:blip xmlns:r="http://schemas.openxmlformats.org/officeDocument/2006/relationships" xmlns:a="http://schemas.openxmlformats.org/drawingml/2006/main" r:embed="R6ab6c187ec6f4d7a"/>
+          <a:blip xmlns:r="http://schemas.openxmlformats.org/officeDocument/2006/relationships" xmlns:a="http://schemas.openxmlformats.org/drawingml/2006/main" r:embed="R8f1e0d65d4b94773"/>
           <a:srcRect xmlns:a="http://schemas.openxmlformats.org/drawingml/2006/main" l="0" t="7813" r="0" b="7813"/>
           <a:stretch xmlns:a="http://schemas.openxmlformats.org/drawingml/2006/main">
             <a:fillRect l="0" t="0" r="0" b="0"/>
@@ -15798,7 +15798,7 @@
           <p:cNvPr id="2" name="">
             <a:extLst xmlns:a="http://schemas.openxmlformats.org/drawingml/2006/main">
               <a:ext uri="{FF2B5EF4-FFF2-40B4-BE49-F238E27FC236}">
-                <a16:creationId xmlns:a16="http://schemas.microsoft.com/office/drawing/2014/main" id="{9CCF58A0-F056-4B57-93D8-56B77B804AA2}"/>
+                <a16:creationId xmlns:a16="http://schemas.microsoft.com/office/drawing/2014/main" id="{16937A97-9362-47C8-B9DE-70FBC7463E8A}"/>
               </a:ext>
             </a:extLst>
           </p:cNvPr>
@@ -15835,7 +15835,7 @@
           <p:cNvPr id="3" name="">
             <a:extLst xmlns:a="http://schemas.openxmlformats.org/drawingml/2006/main">
               <a:ext uri="{FF2B5EF4-FFF2-40B4-BE49-F238E27FC236}">
-                <a16:creationId xmlns:a16="http://schemas.microsoft.com/office/drawing/2014/main" id="{E52BF351-2042-423C-971D-736C127CA547}"/>
+                <a16:creationId xmlns:a16="http://schemas.microsoft.com/office/drawing/2014/main" id="{0FFED115-36C6-481F-800F-0C113317A6A6}"/>
               </a:ext>
             </a:extLst>
           </p:cNvPr>
@@ -15872,7 +15872,7 @@
           <p:cNvPr id="4" name="">
             <a:extLst xmlns:a="http://schemas.openxmlformats.org/drawingml/2006/main">
               <a:ext uri="{FF2B5EF4-FFF2-40B4-BE49-F238E27FC236}">
-                <a16:creationId xmlns:a16="http://schemas.microsoft.com/office/drawing/2014/main" id="{A7206497-4CD5-4D09-B4E1-A6B6650246A6}"/>
+                <a16:creationId xmlns:a16="http://schemas.microsoft.com/office/drawing/2014/main" id="{97907F0D-03D9-4D0F-B6FF-76457C407257}"/>
               </a:ext>
             </a:extLst>
           </p:cNvPr>
@@ -15936,7 +15936,7 @@
           <p:cNvPr id="5" name="">
             <a:extLst xmlns:a="http://schemas.openxmlformats.org/drawingml/2006/main">
               <a:ext uri="{FF2B5EF4-FFF2-40B4-BE49-F238E27FC236}">
-                <a16:creationId xmlns:a16="http://schemas.microsoft.com/office/drawing/2014/main" id="{5C29C88A-B065-46DF-9ABB-8AE5B57E3742}"/>
+                <a16:creationId xmlns:a16="http://schemas.microsoft.com/office/drawing/2014/main" id="{91718400-5C28-42EA-8888-0DC69A724B2B}"/>
               </a:ext>
             </a:extLst>
           </p:cNvPr>
@@ -16000,7 +16000,7 @@
           <p:cNvPr id="6" name="">
             <a:extLst xmlns:a="http://schemas.openxmlformats.org/drawingml/2006/main">
               <a:ext uri="{FF2B5EF4-FFF2-40B4-BE49-F238E27FC236}">
-                <a16:creationId xmlns:a16="http://schemas.microsoft.com/office/drawing/2014/main" id="{EEE2FBE4-A530-4816-90D2-7CF45D6E9E19}"/>
+                <a16:creationId xmlns:a16="http://schemas.microsoft.com/office/drawing/2014/main" id="{BC455772-383D-4184-98E3-79340BEB9E03}"/>
               </a:ext>
             </a:extLst>
           </p:cNvPr>
@@ -16064,7 +16064,7 @@
           <p:cNvPr id="7" name="">
             <a:extLst xmlns:a="http://schemas.openxmlformats.org/drawingml/2006/main">
               <a:ext uri="{FF2B5EF4-FFF2-40B4-BE49-F238E27FC236}">
-                <a16:creationId xmlns:a16="http://schemas.microsoft.com/office/drawing/2014/main" id="{6D8EE0F6-DB27-42CA-83A5-B13488EE85C8}"/>
+                <a16:creationId xmlns:a16="http://schemas.microsoft.com/office/drawing/2014/main" id="{78CADD15-9BD5-44D4-BA28-1521531B2512}"/>
               </a:ext>
             </a:extLst>
           </p:cNvPr>
@@ -16099,7 +16099,7 @@
           <p:cNvPr id="8" name="">
             <a:extLst xmlns:a="http://schemas.openxmlformats.org/drawingml/2006/main">
               <a:ext uri="{FF2B5EF4-FFF2-40B4-BE49-F238E27FC236}">
-                <a16:creationId xmlns:a16="http://schemas.microsoft.com/office/drawing/2014/main" id="{632EA092-E86F-4181-9A65-F338FF4007BB}"/>
+                <a16:creationId xmlns:a16="http://schemas.microsoft.com/office/drawing/2014/main" id="{2B8D3FE1-1795-4F71-9379-B399C893A307}"/>
               </a:ext>
             </a:extLst>
           </p:cNvPr>
@@ -16163,7 +16163,7 @@
           <p:cNvPr id="9" name="">
             <a:extLst xmlns:a="http://schemas.openxmlformats.org/drawingml/2006/main">
               <a:ext uri="{FF2B5EF4-FFF2-40B4-BE49-F238E27FC236}">
-                <a16:creationId xmlns:a16="http://schemas.microsoft.com/office/drawing/2014/main" id="{704237C5-75F6-44D3-A3EA-BFD966B0F735}"/>
+                <a16:creationId xmlns:a16="http://schemas.microsoft.com/office/drawing/2014/main" id="{FA5F9156-313B-44D2-B067-7C7F43E98F5B}"/>
               </a:ext>
             </a:extLst>
           </p:cNvPr>
@@ -16227,7 +16227,7 @@
           <p:cNvPr id="10" name="">
             <a:extLst xmlns:a="http://schemas.openxmlformats.org/drawingml/2006/main">
               <a:ext uri="{FF2B5EF4-FFF2-40B4-BE49-F238E27FC236}">
-                <a16:creationId xmlns:a16="http://schemas.microsoft.com/office/drawing/2014/main" id="{4F43FB8D-C795-4434-8028-040ABCA234B4}"/>
+                <a16:creationId xmlns:a16="http://schemas.microsoft.com/office/drawing/2014/main" id="{CCFE97F5-6496-4049-A900-A14180454BB6}"/>
               </a:ext>
             </a:extLst>
           </p:cNvPr>
@@ -16262,7 +16262,7 @@
           <p:cNvPr id="11" name="">
             <a:extLst xmlns:a="http://schemas.openxmlformats.org/drawingml/2006/main">
               <a:ext uri="{FF2B5EF4-FFF2-40B4-BE49-F238E27FC236}">
-                <a16:creationId xmlns:a16="http://schemas.microsoft.com/office/drawing/2014/main" id="{E50F7B0E-7DEB-44FF-86F5-30A1C0570B59}"/>
+                <a16:creationId xmlns:a16="http://schemas.microsoft.com/office/drawing/2014/main" id="{82C32096-1EFD-49C8-98EE-0DD5135AAB69}"/>
               </a:ext>
             </a:extLst>
           </p:cNvPr>
@@ -16326,7 +16326,7 @@
           <p:cNvPr id="12" name="">
             <a:extLst xmlns:a="http://schemas.openxmlformats.org/drawingml/2006/main">
               <a:ext uri="{FF2B5EF4-FFF2-40B4-BE49-F238E27FC236}">
-                <a16:creationId xmlns:a16="http://schemas.microsoft.com/office/drawing/2014/main" id="{6FC43706-03C5-4051-B482-A7D202CA2983}"/>
+                <a16:creationId xmlns:a16="http://schemas.microsoft.com/office/drawing/2014/main" id="{04FA21D3-2B00-480D-806E-9AC7B528BD48}"/>
               </a:ext>
             </a:extLst>
           </p:cNvPr>
@@ -16390,7 +16390,7 @@
           <p:cNvPr id="13" name="">
             <a:extLst xmlns:a="http://schemas.openxmlformats.org/drawingml/2006/main">
               <a:ext uri="{FF2B5EF4-FFF2-40B4-BE49-F238E27FC236}">
-                <a16:creationId xmlns:a16="http://schemas.microsoft.com/office/drawing/2014/main" id="{DCC190E6-53BF-4F5B-89CD-9D7607863018}"/>
+                <a16:creationId xmlns:a16="http://schemas.microsoft.com/office/drawing/2014/main" id="{A8FC7D15-384B-4529-BE9C-AF736BFAD298}"/>
               </a:ext>
             </a:extLst>
           </p:cNvPr>
@@ -16425,7 +16425,7 @@
           <p:cNvPr id="14" name="">
             <a:extLst xmlns:a="http://schemas.openxmlformats.org/drawingml/2006/main">
               <a:ext uri="{FF2B5EF4-FFF2-40B4-BE49-F238E27FC236}">
-                <a16:creationId xmlns:a16="http://schemas.microsoft.com/office/drawing/2014/main" id="{6BDBEBBF-AF2B-4B4B-AFF2-E61628206D47}"/>
+                <a16:creationId xmlns:a16="http://schemas.microsoft.com/office/drawing/2014/main" id="{A23D0DBD-836E-4695-AB5C-658FF5338BC1}"/>
               </a:ext>
             </a:extLst>
           </p:cNvPr>
@@ -16489,7 +16489,7 @@
           <p:cNvPr id="15" name="">
             <a:extLst xmlns:a="http://schemas.openxmlformats.org/drawingml/2006/main">
               <a:ext uri="{FF2B5EF4-FFF2-40B4-BE49-F238E27FC236}">
-                <a16:creationId xmlns:a16="http://schemas.microsoft.com/office/drawing/2014/main" id="{2A91D0CD-45A0-4427-AADE-CF00D53B0B79}"/>
+                <a16:creationId xmlns:a16="http://schemas.microsoft.com/office/drawing/2014/main" id="{27FECADB-9F27-41DE-A38D-CD594A1EF305}"/>
               </a:ext>
             </a:extLst>
           </p:cNvPr>
@@ -16553,7 +16553,7 @@
           <p:cNvPr id="16" name="">
             <a:extLst xmlns:a="http://schemas.openxmlformats.org/drawingml/2006/main">
               <a:ext uri="{FF2B5EF4-FFF2-40B4-BE49-F238E27FC236}">
-                <a16:creationId xmlns:a16="http://schemas.microsoft.com/office/drawing/2014/main" id="{5D72CA79-0A1F-47FC-87DC-4BE2C0495AE7}"/>
+                <a16:creationId xmlns:a16="http://schemas.microsoft.com/office/drawing/2014/main" id="{872B5D53-36E9-492D-864A-B334B1F32F57}"/>
               </a:ext>
             </a:extLst>
           </p:cNvPr>
@@ -16588,7 +16588,7 @@
           <p:cNvPr id="17" name="">
             <a:extLst xmlns:a="http://schemas.openxmlformats.org/drawingml/2006/main">
               <a:ext uri="{FF2B5EF4-FFF2-40B4-BE49-F238E27FC236}">
-                <a16:creationId xmlns:a16="http://schemas.microsoft.com/office/drawing/2014/main" id="{CF44AA9E-0DC9-474B-839A-A64389ECCC1F}"/>
+                <a16:creationId xmlns:a16="http://schemas.microsoft.com/office/drawing/2014/main" id="{68F83725-DBC8-4FE2-BD9A-D3CF43AAEA2E}"/>
               </a:ext>
             </a:extLst>
           </p:cNvPr>
@@ -16652,7 +16652,7 @@
           <p:cNvPr id="18" name="">
             <a:extLst xmlns:a="http://schemas.openxmlformats.org/drawingml/2006/main">
               <a:ext uri="{FF2B5EF4-FFF2-40B4-BE49-F238E27FC236}">
-                <a16:creationId xmlns:a16="http://schemas.microsoft.com/office/drawing/2014/main" id="{A9474CE6-B5D8-477E-AF51-8BF8BEFBECBC}"/>
+                <a16:creationId xmlns:a16="http://schemas.microsoft.com/office/drawing/2014/main" id="{CA013E68-6CF1-495E-B4C5-F916D4DC5E5F}"/>
               </a:ext>
             </a:extLst>
           </p:cNvPr>
@@ -16716,7 +16716,7 @@
           <p:cNvPr id="19" name="">
             <a:extLst xmlns:a="http://schemas.openxmlformats.org/drawingml/2006/main">
               <a:ext uri="{FF2B5EF4-FFF2-40B4-BE49-F238E27FC236}">
-                <a16:creationId xmlns:a16="http://schemas.microsoft.com/office/drawing/2014/main" id="{AE552234-456D-4925-953A-9AABB9F2CBE0}"/>
+                <a16:creationId xmlns:a16="http://schemas.microsoft.com/office/drawing/2014/main" id="{48274DCB-ACBB-4D0E-81C5-6A53FBAF3CB2}"/>
               </a:ext>
             </a:extLst>
           </p:cNvPr>
@@ -16751,7 +16751,7 @@
           <p:cNvPr id="20" name="">
             <a:extLst xmlns:a="http://schemas.openxmlformats.org/drawingml/2006/main">
               <a:ext uri="{FF2B5EF4-FFF2-40B4-BE49-F238E27FC236}">
-                <a16:creationId xmlns:a16="http://schemas.microsoft.com/office/drawing/2014/main" id="{ED344630-F362-4834-ABF1-972C94D48751}"/>
+                <a16:creationId xmlns:a16="http://schemas.microsoft.com/office/drawing/2014/main" id="{8C16B879-96E8-4F0E-A7A6-64873B31E507}"/>
               </a:ext>
             </a:extLst>
           </p:cNvPr>
@@ -16815,7 +16815,7 @@
           <p:cNvPr id="21" name="">
             <a:extLst xmlns:a="http://schemas.openxmlformats.org/drawingml/2006/main">
               <a:ext uri="{FF2B5EF4-FFF2-40B4-BE49-F238E27FC236}">
-                <a16:creationId xmlns:a16="http://schemas.microsoft.com/office/drawing/2014/main" id="{49FBE5A5-C1F2-43E7-A478-197EBEECA823}"/>
+                <a16:creationId xmlns:a16="http://schemas.microsoft.com/office/drawing/2014/main" id="{A4F3E0D0-20C0-40ED-BE72-72C1D56BCED3}"/>
               </a:ext>
             </a:extLst>
           </p:cNvPr>
@@ -16879,7 +16879,7 @@
           <p:cNvPr id="22" name="">
             <a:extLst xmlns:a="http://schemas.openxmlformats.org/drawingml/2006/main">
               <a:ext uri="{FF2B5EF4-FFF2-40B4-BE49-F238E27FC236}">
-                <a16:creationId xmlns:a16="http://schemas.microsoft.com/office/drawing/2014/main" id="{7495787D-ACA8-4161-BA6A-9C994CE10A55}"/>
+                <a16:creationId xmlns:a16="http://schemas.microsoft.com/office/drawing/2014/main" id="{1EF6BEC5-E6FE-477F-8758-74CEFCD9D204}"/>
               </a:ext>
             </a:extLst>
           </p:cNvPr>
@@ -16912,7 +16912,7 @@
           <p:cNvPr id="23" name="">
             <a:extLst xmlns:a="http://schemas.openxmlformats.org/drawingml/2006/main">
               <a:ext uri="{FF2B5EF4-FFF2-40B4-BE49-F238E27FC236}">
-                <a16:creationId xmlns:a16="http://schemas.microsoft.com/office/drawing/2014/main" id="{81E5F99C-5E78-4B8E-8D19-404F1F9513A4}"/>
+                <a16:creationId xmlns:a16="http://schemas.microsoft.com/office/drawing/2014/main" id="{D73CFA00-3AEB-415F-AA75-47F941642B9B}"/>
               </a:ext>
             </a:extLst>
           </p:cNvPr>
@@ -16947,7 +16947,7 @@
           <p:cNvPr id="24" name="">
             <a:extLst xmlns:a="http://schemas.openxmlformats.org/drawingml/2006/main">
               <a:ext uri="{FF2B5EF4-FFF2-40B4-BE49-F238E27FC236}">
-                <a16:creationId xmlns:a16="http://schemas.microsoft.com/office/drawing/2014/main" id="{8BF99DA8-F665-4ECA-842D-167A4B7ECF7D}"/>
+                <a16:creationId xmlns:a16="http://schemas.microsoft.com/office/drawing/2014/main" id="{070048FE-A16D-4668-A9A5-DE1E460F2B0A}"/>
               </a:ext>
             </a:extLst>
           </p:cNvPr>
@@ -17011,7 +17011,7 @@
           <p:cNvPr id="25" name="">
             <a:extLst xmlns:a="http://schemas.openxmlformats.org/drawingml/2006/main">
               <a:ext uri="{FF2B5EF4-FFF2-40B4-BE49-F238E27FC236}">
-                <a16:creationId xmlns:a16="http://schemas.microsoft.com/office/drawing/2014/main" id="{6975F4BC-F249-4199-BBEE-9BA6A52426F4}"/>
+                <a16:creationId xmlns:a16="http://schemas.microsoft.com/office/drawing/2014/main" id="{2E3079F9-559B-45B9-AEA1-AEE6386AB6BA}"/>
               </a:ext>
             </a:extLst>
           </p:cNvPr>
@@ -17075,7 +17075,7 @@
           <p:cNvPr id="26" name="">
             <a:extLst xmlns:a="http://schemas.openxmlformats.org/drawingml/2006/main">
               <a:ext uri="{FF2B5EF4-FFF2-40B4-BE49-F238E27FC236}">
-                <a16:creationId xmlns:a16="http://schemas.microsoft.com/office/drawing/2014/main" id="{889E8277-61DE-46DE-9253-2F905E95024B}"/>
+                <a16:creationId xmlns:a16="http://schemas.microsoft.com/office/drawing/2014/main" id="{78C99E71-7C4E-4A95-ACB2-00FA9D580F85}"/>
               </a:ext>
             </a:extLst>
           </p:cNvPr>
@@ -17108,7 +17108,7 @@
           <p:cNvPr id="27" name="">
             <a:extLst xmlns:a="http://schemas.openxmlformats.org/drawingml/2006/main">
               <a:ext uri="{FF2B5EF4-FFF2-40B4-BE49-F238E27FC236}">
-                <a16:creationId xmlns:a16="http://schemas.microsoft.com/office/drawing/2014/main" id="{C248D63E-5ECA-404A-BB9C-E12E665CC2B2}"/>
+                <a16:creationId xmlns:a16="http://schemas.microsoft.com/office/drawing/2014/main" id="{E4413004-60A0-468E-8504-91DD959B7970}"/>
               </a:ext>
             </a:extLst>
           </p:cNvPr>
@@ -17143,7 +17143,7 @@
           <p:cNvPr id="28" name="">
             <a:extLst xmlns:a="http://schemas.openxmlformats.org/drawingml/2006/main">
               <a:ext uri="{FF2B5EF4-FFF2-40B4-BE49-F238E27FC236}">
-                <a16:creationId xmlns:a16="http://schemas.microsoft.com/office/drawing/2014/main" id="{86F828FB-B1A0-42B4-8C83-66931EA2B23E}"/>
+                <a16:creationId xmlns:a16="http://schemas.microsoft.com/office/drawing/2014/main" id="{A9D39083-DD46-452B-A5AE-9659B44EFD64}"/>
               </a:ext>
             </a:extLst>
           </p:cNvPr>
@@ -17207,7 +17207,7 @@
           <p:cNvPr id="29" name="">
             <a:extLst xmlns:a="http://schemas.openxmlformats.org/drawingml/2006/main">
               <a:ext uri="{FF2B5EF4-FFF2-40B4-BE49-F238E27FC236}">
-                <a16:creationId xmlns:a16="http://schemas.microsoft.com/office/drawing/2014/main" id="{0C20E8B3-5F82-450C-B6A0-2FF2653708BE}"/>
+                <a16:creationId xmlns:a16="http://schemas.microsoft.com/office/drawing/2014/main" id="{D30EA04D-8CDA-43CD-8A93-2A4C67BE2A58}"/>
               </a:ext>
             </a:extLst>
           </p:cNvPr>
@@ -17271,7 +17271,7 @@
           <p:cNvPr id="30" name="">
             <a:extLst xmlns:a="http://schemas.openxmlformats.org/drawingml/2006/main">
               <a:ext uri="{FF2B5EF4-FFF2-40B4-BE49-F238E27FC236}">
-                <a16:creationId xmlns:a16="http://schemas.microsoft.com/office/drawing/2014/main" id="{A2105933-85CC-4375-AB39-F7517FC86234}"/>
+                <a16:creationId xmlns:a16="http://schemas.microsoft.com/office/drawing/2014/main" id="{EA8C8C1C-0624-4173-90A9-15DFDEF4CF18}"/>
               </a:ext>
             </a:extLst>
           </p:cNvPr>
@@ -17304,7 +17304,7 @@
           <p:cNvPr id="31" name="">
             <a:extLst xmlns:a="http://schemas.openxmlformats.org/drawingml/2006/main">
               <a:ext uri="{FF2B5EF4-FFF2-40B4-BE49-F238E27FC236}">
-                <a16:creationId xmlns:a16="http://schemas.microsoft.com/office/drawing/2014/main" id="{E3EC9BC9-6C65-4C9D-B41E-87883C968196}"/>
+                <a16:creationId xmlns:a16="http://schemas.microsoft.com/office/drawing/2014/main" id="{9EF7FBC3-00DE-4536-ADC3-E9C3B376DBB7}"/>
               </a:ext>
             </a:extLst>
           </p:cNvPr>
@@ -17339,7 +17339,7 @@
           <p:cNvPr id="32" name="">
             <a:extLst xmlns:a="http://schemas.openxmlformats.org/drawingml/2006/main">
               <a:ext uri="{FF2B5EF4-FFF2-40B4-BE49-F238E27FC236}">
-                <a16:creationId xmlns:a16="http://schemas.microsoft.com/office/drawing/2014/main" id="{DC93BE73-052C-4BCC-BBA5-B1631E34ED33}"/>
+                <a16:creationId xmlns:a16="http://schemas.microsoft.com/office/drawing/2014/main" id="{A6B684B3-13AB-4C04-9194-E88C23BEDF87}"/>
               </a:ext>
             </a:extLst>
           </p:cNvPr>
@@ -17403,7 +17403,7 @@
           <p:cNvPr id="33" name="">
             <a:extLst xmlns:a="http://schemas.openxmlformats.org/drawingml/2006/main">
               <a:ext uri="{FF2B5EF4-FFF2-40B4-BE49-F238E27FC236}">
-                <a16:creationId xmlns:a16="http://schemas.microsoft.com/office/drawing/2014/main" id="{32466882-1BF8-4397-BD3B-C4BE4526F111}"/>
+                <a16:creationId xmlns:a16="http://schemas.microsoft.com/office/drawing/2014/main" id="{4B505459-DC28-49C1-AFB0-3D36499DF406}"/>
               </a:ext>
             </a:extLst>
           </p:cNvPr>
@@ -17467,7 +17467,7 @@
           <p:cNvPr id="34" name="">
             <a:extLst xmlns:a="http://schemas.openxmlformats.org/drawingml/2006/main">
               <a:ext uri="{FF2B5EF4-FFF2-40B4-BE49-F238E27FC236}">
-                <a16:creationId xmlns:a16="http://schemas.microsoft.com/office/drawing/2014/main" id="{6222B951-0748-45C4-9F75-7316CA866C3A}"/>
+                <a16:creationId xmlns:a16="http://schemas.microsoft.com/office/drawing/2014/main" id="{D390B800-0E19-4E27-90AA-CCC15E58CC47}"/>
               </a:ext>
             </a:extLst>
           </p:cNvPr>
@@ -17531,7 +17531,7 @@
           <p:cNvPr id="35" name="">
             <a:extLst xmlns:a="http://schemas.openxmlformats.org/drawingml/2006/main">
               <a:ext uri="{FF2B5EF4-FFF2-40B4-BE49-F238E27FC236}">
-                <a16:creationId xmlns:a16="http://schemas.microsoft.com/office/drawing/2014/main" id="{BB017F02-A54C-4014-89A4-593ED5D4C5D7}"/>
+                <a16:creationId xmlns:a16="http://schemas.microsoft.com/office/drawing/2014/main" id="{87E6F8C0-5394-4969-B268-3BCBC444BAA3}"/>
               </a:ext>
             </a:extLst>
           </p:cNvPr>
@@ -17564,7 +17564,7 @@
           <p:cNvPr id="36" name="">
             <a:extLst xmlns:a="http://schemas.openxmlformats.org/drawingml/2006/main">
               <a:ext uri="{FF2B5EF4-FFF2-40B4-BE49-F238E27FC236}">
-                <a16:creationId xmlns:a16="http://schemas.microsoft.com/office/drawing/2014/main" id="{980A021B-40E9-4985-9963-D3AFCB92225C}"/>
+                <a16:creationId xmlns:a16="http://schemas.microsoft.com/office/drawing/2014/main" id="{F62F1026-EA18-4F03-9038-D6AE1010FCC4}"/>
               </a:ext>
             </a:extLst>
           </p:cNvPr>
@@ -17628,7 +17628,7 @@
           <p:cNvPr id="37" name="">
             <a:extLst xmlns:a="http://schemas.openxmlformats.org/drawingml/2006/main">
               <a:ext uri="{FF2B5EF4-FFF2-40B4-BE49-F238E27FC236}">
-                <a16:creationId xmlns:a16="http://schemas.microsoft.com/office/drawing/2014/main" id="{C3D00DA5-844C-4F66-890E-89390BA96B03}"/>
+                <a16:creationId xmlns:a16="http://schemas.microsoft.com/office/drawing/2014/main" id="{1DDB8F72-1F8E-408A-8F71-0E621C566442}"/>
               </a:ext>
             </a:extLst>
           </p:cNvPr>
@@ -17690,7 +17690,7 @@
     </p:spTree>
     <p:extLst>
       <p:ext uri="{BB962C8B-B14F-4D97-AF65-F5344CB8AC3E}">
-        <p14:creationId xmlns:p14="http://schemas.microsoft.com/office/powerpoint/2010/main" val="1118116218"/>
+        <p14:creationId xmlns:p14="http://schemas.microsoft.com/office/powerpoint/2010/main" val="1597864610"/>
       </p:ext>
     </p:extLst>
   </p:cSld>

</xml_diff>